<commit_message>
Address repository check review feedback
</commit_message>
<xml_diff>
--- a/docs/lessons/assets/cah-007-repository-checks.pptx
+++ b/docs/lessons/assets/cah-007-repository-checks.pptx
@@ -2,22 +2,22 @@
 <file path=ppt/presentation.xml><?xml version="1.0" encoding="utf-8"?>
 <p:presentation xmlns:p="http://schemas.openxmlformats.org/presentationml/2006/main">
   <p:sldMasterIdLst>
-    <p:sldMasterId xmlns:r="http://schemas.openxmlformats.org/officeDocument/2006/relationships" id="2147483648" r:id="Rd428e85819b24b78"/>
+    <p:sldMasterId xmlns:r="http://schemas.openxmlformats.org/officeDocument/2006/relationships" id="2147483648" r:id="R937586dc47694e2c"/>
   </p:sldMasterIdLst>
   <p:notesMasterIdLst>
-    <p:notesMasterId xmlns:r="http://schemas.openxmlformats.org/officeDocument/2006/relationships" r:id="R82c5754984aa408a"/>
+    <p:notesMasterId xmlns:r="http://schemas.openxmlformats.org/officeDocument/2006/relationships" r:id="R8aa5f248d4074cc8"/>
   </p:notesMasterIdLst>
   <p:sldIdLst>
-    <p:sldId xmlns:r="http://schemas.openxmlformats.org/officeDocument/2006/relationships" id="256" r:id="R9d2ac45832214265"/>
-    <p:sldId xmlns:r="http://schemas.openxmlformats.org/officeDocument/2006/relationships" id="257" r:id="R4176f9b884af40fb"/>
-    <p:sldId xmlns:r="http://schemas.openxmlformats.org/officeDocument/2006/relationships" id="258" r:id="R4dbc06b9a52144fa"/>
-    <p:sldId xmlns:r="http://schemas.openxmlformats.org/officeDocument/2006/relationships" id="259" r:id="Rda4c9e7a7fa84526"/>
-    <p:sldId xmlns:r="http://schemas.openxmlformats.org/officeDocument/2006/relationships" id="260" r:id="R635f42d570a448f2"/>
-    <p:sldId xmlns:r="http://schemas.openxmlformats.org/officeDocument/2006/relationships" id="261" r:id="R2d2492bf69d94875"/>
-    <p:sldId xmlns:r="http://schemas.openxmlformats.org/officeDocument/2006/relationships" id="262" r:id="R8e8493f1cd194555"/>
-    <p:sldId xmlns:r="http://schemas.openxmlformats.org/officeDocument/2006/relationships" id="263" r:id="R816f4bae08014c6a"/>
-    <p:sldId xmlns:r="http://schemas.openxmlformats.org/officeDocument/2006/relationships" id="264" r:id="R8d5b62b476174cc5"/>
-    <p:sldId xmlns:r="http://schemas.openxmlformats.org/officeDocument/2006/relationships" id="265" r:id="Rded37daa004f4be9"/>
+    <p:sldId xmlns:r="http://schemas.openxmlformats.org/officeDocument/2006/relationships" id="256" r:id="R62f5435192384cf6"/>
+    <p:sldId xmlns:r="http://schemas.openxmlformats.org/officeDocument/2006/relationships" id="257" r:id="Ra32c5fe1879b48fb"/>
+    <p:sldId xmlns:r="http://schemas.openxmlformats.org/officeDocument/2006/relationships" id="258" r:id="Raf750adcd7614f86"/>
+    <p:sldId xmlns:r="http://schemas.openxmlformats.org/officeDocument/2006/relationships" id="259" r:id="R067d5e5b2cc8466c"/>
+    <p:sldId xmlns:r="http://schemas.openxmlformats.org/officeDocument/2006/relationships" id="260" r:id="R85889bdde92c4fba"/>
+    <p:sldId xmlns:r="http://schemas.openxmlformats.org/officeDocument/2006/relationships" id="261" r:id="R93edffad19974c29"/>
+    <p:sldId xmlns:r="http://schemas.openxmlformats.org/officeDocument/2006/relationships" id="262" r:id="Rd62dfa7dabcc43ee"/>
+    <p:sldId xmlns:r="http://schemas.openxmlformats.org/officeDocument/2006/relationships" id="263" r:id="R05aa4f2168354731"/>
+    <p:sldId xmlns:r="http://schemas.openxmlformats.org/officeDocument/2006/relationships" id="264" r:id="R8b14569200ef4154"/>
+    <p:sldId xmlns:r="http://schemas.openxmlformats.org/officeDocument/2006/relationships" id="265" r:id="Rc933d6468b4f4ef8"/>
   </p:sldIdLst>
   <p:sldSz cx="12192000" cy="6858000"/>
   <p:notesSz cx="6858000" cy="9144000"/>
@@ -1204,7 +1204,7 @@
   </p:cSld>
   <p:clrMap bg1="lt1" tx1="dk1" bg2="lt2" tx2="dk2" accent1="accent1" accent2="accent2" accent3="accent3" accent4="accent4" accent5="accent5" accent6="accent6" hlink="hlink" folHlink="folHlink"/>
   <p:sldLayoutIdLst>
-    <p:sldLayoutId xmlns:r="http://schemas.openxmlformats.org/officeDocument/2006/relationships" id="2147483649" r:id="R148c33be0d1547d0"/>
+    <p:sldLayoutId xmlns:r="http://schemas.openxmlformats.org/officeDocument/2006/relationships" id="2147483649" r:id="R59099ec8fc834eac"/>
   </p:sldLayoutIdLst>
   <p:txStyles>
     <p:titleStyle>
@@ -1759,7 +1759,7 @@
           <p:nvPr/>
         </p:nvPicPr>
         <p:blipFill>
-          <a:blip xmlns:r="http://schemas.openxmlformats.org/officeDocument/2006/relationships" xmlns:a="http://schemas.openxmlformats.org/drawingml/2006/main" r:embed="Recb73dc808514755"/>
+          <a:blip xmlns:r="http://schemas.openxmlformats.org/officeDocument/2006/relationships" xmlns:a="http://schemas.openxmlformats.org/drawingml/2006/main" r:embed="Rdf5e09b6da5045bc"/>
           <a:srcRect xmlns:a="http://schemas.openxmlformats.org/drawingml/2006/main" l="0" t="27" r="0" b="27"/>
           <a:stretch xmlns:a="http://schemas.openxmlformats.org/drawingml/2006/main">
             <a:fillRect l="0" t="0" r="0" b="0"/>
@@ -1780,7 +1780,7 @@
           <p:cNvPr id="2" name="cover-shade">
             <a:extLst xmlns:a="http://schemas.openxmlformats.org/drawingml/2006/main">
               <a:ext uri="{FF2B5EF4-FFF2-40B4-BE49-F238E27FC236}">
-                <a16:creationId xmlns:a16="http://schemas.microsoft.com/office/drawing/2014/main" id="{2C5998AF-3340-47D6-9C80-2BFEE62D1844}"/>
+                <a16:creationId xmlns:a16="http://schemas.microsoft.com/office/drawing/2014/main" id="{5BDFD1DA-BF97-4844-8242-4911C10411F7}"/>
               </a:ext>
             </a:extLst>
           </p:cNvPr>
@@ -1811,7 +1811,7 @@
           <p:cNvPr id="3" name="cover-cyan">
             <a:extLst xmlns:a="http://schemas.openxmlformats.org/drawingml/2006/main">
               <a:ext uri="{FF2B5EF4-FFF2-40B4-BE49-F238E27FC236}">
-                <a16:creationId xmlns:a16="http://schemas.microsoft.com/office/drawing/2014/main" id="{9212926D-36BB-4DFE-8F75-1A2A5DEFB65E}"/>
+                <a16:creationId xmlns:a16="http://schemas.microsoft.com/office/drawing/2014/main" id="{4C4B4D6F-F068-4986-8AAB-4338AB8E154F}"/>
               </a:ext>
             </a:extLst>
           </p:cNvPr>
@@ -1842,7 +1842,7 @@
           <p:cNvPr id="4" name="cover-kicker">
             <a:extLst xmlns:a="http://schemas.openxmlformats.org/drawingml/2006/main">
               <a:ext uri="{FF2B5EF4-FFF2-40B4-BE49-F238E27FC236}">
-                <a16:creationId xmlns:a16="http://schemas.microsoft.com/office/drawing/2014/main" id="{3C35A48E-E462-46B3-B575-D133D4E5B073}"/>
+                <a16:creationId xmlns:a16="http://schemas.microsoft.com/office/drawing/2014/main" id="{DC70A89E-B9EB-4F3F-A74C-E1D8EF9229FE}"/>
               </a:ext>
             </a:extLst>
           </p:cNvPr>
@@ -1887,7 +1887,7 @@
           <p:cNvPr id="5" name="cover-title">
             <a:extLst xmlns:a="http://schemas.openxmlformats.org/drawingml/2006/main">
               <a:ext uri="{FF2B5EF4-FFF2-40B4-BE49-F238E27FC236}">
-                <a16:creationId xmlns:a16="http://schemas.microsoft.com/office/drawing/2014/main" id="{9587EBDF-3146-4EF9-850F-C853D9C03D68}"/>
+                <a16:creationId xmlns:a16="http://schemas.microsoft.com/office/drawing/2014/main" id="{59D2C747-A66C-457D-949C-C93B500FF1E5}"/>
               </a:ext>
             </a:extLst>
           </p:cNvPr>
@@ -1933,7 +1933,7 @@
           <p:cNvPr id="6" name="cover-subtitle">
             <a:extLst xmlns:a="http://schemas.openxmlformats.org/drawingml/2006/main">
               <a:ext uri="{FF2B5EF4-FFF2-40B4-BE49-F238E27FC236}">
-                <a16:creationId xmlns:a16="http://schemas.microsoft.com/office/drawing/2014/main" id="{6C86CFEA-C006-43C3-879B-75F595CAD536}"/>
+                <a16:creationId xmlns:a16="http://schemas.microsoft.com/office/drawing/2014/main" id="{6939DEEA-3692-4EAE-9EF6-7A6EA74699DB}"/>
               </a:ext>
             </a:extLst>
           </p:cNvPr>
@@ -1978,7 +1978,7 @@
           <p:cNvPr id="7" name="cover-command">
             <a:extLst xmlns:a="http://schemas.openxmlformats.org/drawingml/2006/main">
               <a:ext uri="{FF2B5EF4-FFF2-40B4-BE49-F238E27FC236}">
-                <a16:creationId xmlns:a16="http://schemas.microsoft.com/office/drawing/2014/main" id="{C51E1F62-BBAF-442C-896C-1B09FD476FAB}"/>
+                <a16:creationId xmlns:a16="http://schemas.microsoft.com/office/drawing/2014/main" id="{EEA24576-389D-460A-A10E-9C1AE3C1C788}"/>
               </a:ext>
             </a:extLst>
           </p:cNvPr>
@@ -2013,7 +2013,7 @@
           <p:cNvPr id="8" name="cover-command-text">
             <a:extLst xmlns:a="http://schemas.openxmlformats.org/drawingml/2006/main">
               <a:ext uri="{FF2B5EF4-FFF2-40B4-BE49-F238E27FC236}">
-                <a16:creationId xmlns:a16="http://schemas.microsoft.com/office/drawing/2014/main" id="{0795476C-117F-4AC2-9AC1-2BCED6023F0D}"/>
+                <a16:creationId xmlns:a16="http://schemas.microsoft.com/office/drawing/2014/main" id="{87626A9B-8F7B-4E19-A45C-E0851BA1AD2F}"/>
               </a:ext>
             </a:extLst>
           </p:cNvPr>
@@ -2058,7 +2058,7 @@
           <p:cNvPr id="9" name="cover-caption">
             <a:extLst xmlns:a="http://schemas.openxmlformats.org/drawingml/2006/main">
               <a:ext uri="{FF2B5EF4-FFF2-40B4-BE49-F238E27FC236}">
-                <a16:creationId xmlns:a16="http://schemas.microsoft.com/office/drawing/2014/main" id="{F150E7FE-CB99-4E1C-AC06-57231AEFD7B6}"/>
+                <a16:creationId xmlns:a16="http://schemas.microsoft.com/office/drawing/2014/main" id="{C6331326-BB35-4037-87A1-A70DAEE292BA}"/>
               </a:ext>
             </a:extLst>
           </p:cNvPr>
@@ -2103,7 +2103,7 @@
           <p:cNvPr id="10" name="cover-footer">
             <a:extLst xmlns:a="http://schemas.openxmlformats.org/drawingml/2006/main">
               <a:ext uri="{FF2B5EF4-FFF2-40B4-BE49-F238E27FC236}">
-                <a16:creationId xmlns:a16="http://schemas.microsoft.com/office/drawing/2014/main" id="{8C20D312-64C7-45B7-AD80-612022097806}"/>
+                <a16:creationId xmlns:a16="http://schemas.microsoft.com/office/drawing/2014/main" id="{0B552393-8305-4BBA-BD6A-9E1B4AA6B435}"/>
               </a:ext>
             </a:extLst>
           </p:cNvPr>
@@ -2146,7 +2146,7 @@
     </p:spTree>
     <p:extLst>
       <p:ext uri="{BB962C8B-B14F-4D97-AF65-F5344CB8AC3E}">
-        <p14:creationId xmlns:p14="http://schemas.microsoft.com/office/powerpoint/2010/main" val="2080176804"/>
+        <p14:creationId xmlns:p14="http://schemas.microsoft.com/office/powerpoint/2010/main" val="199380473"/>
       </p:ext>
     </p:extLst>
   </p:cSld>
@@ -2177,7 +2177,7 @@
           <p:cNvPr id="1" name="close-bg">
             <a:extLst xmlns:a="http://schemas.openxmlformats.org/drawingml/2006/main">
               <a:ext uri="{FF2B5EF4-FFF2-40B4-BE49-F238E27FC236}">
-                <a16:creationId xmlns:a16="http://schemas.microsoft.com/office/drawing/2014/main" id="{5E52DFD5-0958-4CB2-B236-9600CA4131D9}"/>
+                <a16:creationId xmlns:a16="http://schemas.microsoft.com/office/drawing/2014/main" id="{3AABA33C-357C-4B5E-BFFE-4825DA560ECC}"/>
               </a:ext>
             </a:extLst>
           </p:cNvPr>
@@ -2252,7 +2252,7 @@
           <p:cNvPr id="4" name="close-arrow">
             <a:extLst xmlns:a="http://schemas.openxmlformats.org/drawingml/2006/main">
               <a:ext uri="{FF2B5EF4-FFF2-40B4-BE49-F238E27FC236}">
-                <a16:creationId xmlns:a16="http://schemas.microsoft.com/office/drawing/2014/main" id="{0D8AFEBB-D4E6-46C6-9D96-736CCA9E277C}"/>
+                <a16:creationId xmlns:a16="http://schemas.microsoft.com/office/drawing/2014/main" id="{E3D8B76B-E755-45FF-8B90-5D5428506F1F}"/>
               </a:ext>
             </a:extLst>
           </p:cNvPr>
@@ -2283,7 +2283,7 @@
           <p:cNvPr id="5" name="close-check-ring">
             <a:extLst xmlns:a="http://schemas.openxmlformats.org/drawingml/2006/main">
               <a:ext uri="{FF2B5EF4-FFF2-40B4-BE49-F238E27FC236}">
-                <a16:creationId xmlns:a16="http://schemas.microsoft.com/office/drawing/2014/main" id="{48745D0E-5980-43FE-80E0-2ACE96D2908B}"/>
+                <a16:creationId xmlns:a16="http://schemas.microsoft.com/office/drawing/2014/main" id="{7E363D83-AED5-480A-B0B9-982B58B06C2E}"/>
               </a:ext>
             </a:extLst>
           </p:cNvPr>
@@ -2316,7 +2316,7 @@
           <p:cNvPr id="6" name="close-check">
             <a:extLst xmlns:a="http://schemas.openxmlformats.org/drawingml/2006/main">
               <a:ext uri="{FF2B5EF4-FFF2-40B4-BE49-F238E27FC236}">
-                <a16:creationId xmlns:a16="http://schemas.microsoft.com/office/drawing/2014/main" id="{80EEF9F0-6792-4A3F-8D90-AEA0B4A95908}"/>
+                <a16:creationId xmlns:a16="http://schemas.microsoft.com/office/drawing/2014/main" id="{A9EC794F-00D8-497F-A61E-108745FEF9F5}"/>
               </a:ext>
             </a:extLst>
           </p:cNvPr>
@@ -2361,7 +2361,7 @@
           <p:cNvPr id="7" name="close-kicker">
             <a:extLst xmlns:a="http://schemas.openxmlformats.org/drawingml/2006/main">
               <a:ext uri="{FF2B5EF4-FFF2-40B4-BE49-F238E27FC236}">
-                <a16:creationId xmlns:a16="http://schemas.microsoft.com/office/drawing/2014/main" id="{A94618DC-6C47-410B-87C9-E4CD1A7CB099}"/>
+                <a16:creationId xmlns:a16="http://schemas.microsoft.com/office/drawing/2014/main" id="{71E27262-9E22-4E1D-84E4-E76B5CFAD13C}"/>
               </a:ext>
             </a:extLst>
           </p:cNvPr>
@@ -2406,7 +2406,7 @@
           <p:cNvPr id="8" name="close-title">
             <a:extLst xmlns:a="http://schemas.openxmlformats.org/drawingml/2006/main">
               <a:ext uri="{FF2B5EF4-FFF2-40B4-BE49-F238E27FC236}">
-                <a16:creationId xmlns:a16="http://schemas.microsoft.com/office/drawing/2014/main" id="{B20DA335-110A-44ED-9BFF-085F32E4F42B}"/>
+                <a16:creationId xmlns:a16="http://schemas.microsoft.com/office/drawing/2014/main" id="{C85814F0-B2B5-44E2-AC83-70A6BD879D40}"/>
               </a:ext>
             </a:extLst>
           </p:cNvPr>
@@ -2452,7 +2452,7 @@
           <p:cNvPr id="9" name="close-subtitle">
             <a:extLst xmlns:a="http://schemas.openxmlformats.org/drawingml/2006/main">
               <a:ext uri="{FF2B5EF4-FFF2-40B4-BE49-F238E27FC236}">
-                <a16:creationId xmlns:a16="http://schemas.microsoft.com/office/drawing/2014/main" id="{5B8A049F-ED5D-417B-82BA-FB436419BC2C}"/>
+                <a16:creationId xmlns:a16="http://schemas.microsoft.com/office/drawing/2014/main" id="{7FEE0366-51A1-4BFE-8D94-B74B0FBF412B}"/>
               </a:ext>
             </a:extLst>
           </p:cNvPr>
@@ -2497,7 +2497,7 @@
           <p:cNvPr id="10" name="close-num-0">
             <a:extLst xmlns:a="http://schemas.openxmlformats.org/drawingml/2006/main">
               <a:ext uri="{FF2B5EF4-FFF2-40B4-BE49-F238E27FC236}">
-                <a16:creationId xmlns:a16="http://schemas.microsoft.com/office/drawing/2014/main" id="{3B5E07D6-F40C-4609-9947-C970949CEB15}"/>
+                <a16:creationId xmlns:a16="http://schemas.microsoft.com/office/drawing/2014/main" id="{41466FDE-254C-4B25-B8FF-CDFC43E875D1}"/>
               </a:ext>
             </a:extLst>
           </p:cNvPr>
@@ -2542,7 +2542,7 @@
           <p:cNvPr id="11" name="close-body-0">
             <a:extLst xmlns:a="http://schemas.openxmlformats.org/drawingml/2006/main">
               <a:ext uri="{FF2B5EF4-FFF2-40B4-BE49-F238E27FC236}">
-                <a16:creationId xmlns:a16="http://schemas.microsoft.com/office/drawing/2014/main" id="{90123EE4-90B9-4413-B748-91ACE661058E}"/>
+                <a16:creationId xmlns:a16="http://schemas.microsoft.com/office/drawing/2014/main" id="{61C112A0-015F-462D-809A-A0EA8FA836A0}"/>
               </a:ext>
             </a:extLst>
           </p:cNvPr>
@@ -2587,7 +2587,7 @@
           <p:cNvPr id="12" name="close-num-1">
             <a:extLst xmlns:a="http://schemas.openxmlformats.org/drawingml/2006/main">
               <a:ext uri="{FF2B5EF4-FFF2-40B4-BE49-F238E27FC236}">
-                <a16:creationId xmlns:a16="http://schemas.microsoft.com/office/drawing/2014/main" id="{68E8C2F8-8089-45C6-BD77-DDBE84F51D72}"/>
+                <a16:creationId xmlns:a16="http://schemas.microsoft.com/office/drawing/2014/main" id="{1F827BCB-CC22-4470-9C38-E9A593CAE157}"/>
               </a:ext>
             </a:extLst>
           </p:cNvPr>
@@ -2632,7 +2632,7 @@
           <p:cNvPr id="13" name="close-body-1">
             <a:extLst xmlns:a="http://schemas.openxmlformats.org/drawingml/2006/main">
               <a:ext uri="{FF2B5EF4-FFF2-40B4-BE49-F238E27FC236}">
-                <a16:creationId xmlns:a16="http://schemas.microsoft.com/office/drawing/2014/main" id="{BDA92DB4-5954-4397-9477-DE8E87047707}"/>
+                <a16:creationId xmlns:a16="http://schemas.microsoft.com/office/drawing/2014/main" id="{F6C79B62-3CCE-417A-ACFF-8901B119D46D}"/>
               </a:ext>
             </a:extLst>
           </p:cNvPr>
@@ -2677,7 +2677,7 @@
           <p:cNvPr id="14" name="close-num-2">
             <a:extLst xmlns:a="http://schemas.openxmlformats.org/drawingml/2006/main">
               <a:ext uri="{FF2B5EF4-FFF2-40B4-BE49-F238E27FC236}">
-                <a16:creationId xmlns:a16="http://schemas.microsoft.com/office/drawing/2014/main" id="{C8C664F9-67D7-4629-B16C-0D741CF2A7B1}"/>
+                <a16:creationId xmlns:a16="http://schemas.microsoft.com/office/drawing/2014/main" id="{0822D808-C5D4-401C-BB86-D535A241FFC4}"/>
               </a:ext>
             </a:extLst>
           </p:cNvPr>
@@ -2722,7 +2722,7 @@
           <p:cNvPr id="15" name="close-body-2">
             <a:extLst xmlns:a="http://schemas.openxmlformats.org/drawingml/2006/main">
               <a:ext uri="{FF2B5EF4-FFF2-40B4-BE49-F238E27FC236}">
-                <a16:creationId xmlns:a16="http://schemas.microsoft.com/office/drawing/2014/main" id="{813307EC-BDC1-4247-A0C5-43B8DA4896CB}"/>
+                <a16:creationId xmlns:a16="http://schemas.microsoft.com/office/drawing/2014/main" id="{C2952B3F-4140-4A59-BA2B-A1D1AEC0B81F}"/>
               </a:ext>
             </a:extLst>
           </p:cNvPr>
@@ -2767,7 +2767,7 @@
           <p:cNvPr id="16" name="close-next">
             <a:extLst xmlns:a="http://schemas.openxmlformats.org/drawingml/2006/main">
               <a:ext uri="{FF2B5EF4-FFF2-40B4-BE49-F238E27FC236}">
-                <a16:creationId xmlns:a16="http://schemas.microsoft.com/office/drawing/2014/main" id="{A64D27AA-0A27-4421-9FA6-9FB0AC2466C1}"/>
+                <a16:creationId xmlns:a16="http://schemas.microsoft.com/office/drawing/2014/main" id="{34DB04DD-1A8E-44C4-AAC7-2BE34BD2DAA3}"/>
               </a:ext>
             </a:extLst>
           </p:cNvPr>
@@ -2802,7 +2802,7 @@
           <p:cNvPr id="17" name="close-next-kicker">
             <a:extLst xmlns:a="http://schemas.openxmlformats.org/drawingml/2006/main">
               <a:ext uri="{FF2B5EF4-FFF2-40B4-BE49-F238E27FC236}">
-                <a16:creationId xmlns:a16="http://schemas.microsoft.com/office/drawing/2014/main" id="{C917EEB1-8EBE-480A-935C-52E64555E54E}"/>
+                <a16:creationId xmlns:a16="http://schemas.microsoft.com/office/drawing/2014/main" id="{3E253F1C-3146-4B15-A14D-3ED37F1BD16B}"/>
               </a:ext>
             </a:extLst>
           </p:cNvPr>
@@ -2847,7 +2847,7 @@
           <p:cNvPr id="18" name="close-next-body">
             <a:extLst xmlns:a="http://schemas.openxmlformats.org/drawingml/2006/main">
               <a:ext uri="{FF2B5EF4-FFF2-40B4-BE49-F238E27FC236}">
-                <a16:creationId xmlns:a16="http://schemas.microsoft.com/office/drawing/2014/main" id="{5781AB84-0769-4154-A0D4-DB8DF607167C}"/>
+                <a16:creationId xmlns:a16="http://schemas.microsoft.com/office/drawing/2014/main" id="{923535E1-DAEB-4372-A3D8-3DD13C6D69C6}"/>
               </a:ext>
             </a:extLst>
           </p:cNvPr>
@@ -2892,7 +2892,7 @@
           <p:cNvPr id="19" name="close-fun">
             <a:extLst xmlns:a="http://schemas.openxmlformats.org/drawingml/2006/main">
               <a:ext uri="{FF2B5EF4-FFF2-40B4-BE49-F238E27FC236}">
-                <a16:creationId xmlns:a16="http://schemas.microsoft.com/office/drawing/2014/main" id="{A7DD4A18-9325-4400-9FCB-ED7EEDB30C83}"/>
+                <a16:creationId xmlns:a16="http://schemas.microsoft.com/office/drawing/2014/main" id="{BE0C9C2A-EED7-49A2-9C85-01F46CF74104}"/>
               </a:ext>
             </a:extLst>
           </p:cNvPr>
@@ -2935,7 +2935,7 @@
     </p:spTree>
     <p:extLst>
       <p:ext uri="{BB962C8B-B14F-4D97-AF65-F5344CB8AC3E}">
-        <p14:creationId xmlns:p14="http://schemas.microsoft.com/office/powerpoint/2010/main" val="388774696"/>
+        <p14:creationId xmlns:p14="http://schemas.microsoft.com/office/powerpoint/2010/main" val="52754784"/>
       </p:ext>
     </p:extLst>
   </p:cSld>
@@ -2966,7 +2966,7 @@
           <p:cNvPr id="1" name="kicker-2">
             <a:extLst xmlns:a="http://schemas.openxmlformats.org/drawingml/2006/main">
               <a:ext uri="{FF2B5EF4-FFF2-40B4-BE49-F238E27FC236}">
-                <a16:creationId xmlns:a16="http://schemas.microsoft.com/office/drawing/2014/main" id="{69C0658A-2243-4C10-B356-A17642E9678F}"/>
+                <a16:creationId xmlns:a16="http://schemas.microsoft.com/office/drawing/2014/main" id="{B296A870-BCE9-480D-8066-4F87D202CFCB}"/>
               </a:ext>
             </a:extLst>
           </p:cNvPr>
@@ -3011,7 +3011,7 @@
           <p:cNvPr id="2" name="title-2">
             <a:extLst xmlns:a="http://schemas.openxmlformats.org/drawingml/2006/main">
               <a:ext uri="{FF2B5EF4-FFF2-40B4-BE49-F238E27FC236}">
-                <a16:creationId xmlns:a16="http://schemas.microsoft.com/office/drawing/2014/main" id="{944C9541-7E9C-4F5C-B4E8-0BABCA7BD719}"/>
+                <a16:creationId xmlns:a16="http://schemas.microsoft.com/office/drawing/2014/main" id="{ED1181EB-9F0B-43AA-A721-CD7FECF160F0}"/>
               </a:ext>
             </a:extLst>
           </p:cNvPr>
@@ -3078,7 +3078,7 @@
           <p:cNvPr id="4" name="number-2">
             <a:extLst xmlns:a="http://schemas.openxmlformats.org/drawingml/2006/main">
               <a:ext uri="{FF2B5EF4-FFF2-40B4-BE49-F238E27FC236}">
-                <a16:creationId xmlns:a16="http://schemas.microsoft.com/office/drawing/2014/main" id="{1C4B4498-D150-471B-BEEE-FFB1266697E2}"/>
+                <a16:creationId xmlns:a16="http://schemas.microsoft.com/office/drawing/2014/main" id="{EB016D1B-1163-4285-96DD-5A6FBFF11392}"/>
               </a:ext>
             </a:extLst>
           </p:cNvPr>
@@ -3145,7 +3145,7 @@
           <p:cNvPr id="6" name="solo-dot-0">
             <a:extLst xmlns:a="http://schemas.openxmlformats.org/drawingml/2006/main">
               <a:ext uri="{FF2B5EF4-FFF2-40B4-BE49-F238E27FC236}">
-                <a16:creationId xmlns:a16="http://schemas.microsoft.com/office/drawing/2014/main" id="{3F77FF6F-058E-4306-AE5B-CC7AD2711BB8}"/>
+                <a16:creationId xmlns:a16="http://schemas.microsoft.com/office/drawing/2014/main" id="{6CF75D15-B394-4143-B947-74C17CBC15BD}"/>
               </a:ext>
             </a:extLst>
           </p:cNvPr>
@@ -3198,7 +3198,7 @@
           <p:cNvPr id="8" name="solo-dot-1">
             <a:extLst xmlns:a="http://schemas.openxmlformats.org/drawingml/2006/main">
               <a:ext uri="{FF2B5EF4-FFF2-40B4-BE49-F238E27FC236}">
-                <a16:creationId xmlns:a16="http://schemas.microsoft.com/office/drawing/2014/main" id="{7C236EEF-B831-4628-BB46-63FD42BB3236}"/>
+                <a16:creationId xmlns:a16="http://schemas.microsoft.com/office/drawing/2014/main" id="{29FE0531-ED15-461B-B4DC-A33BEACBB316}"/>
               </a:ext>
             </a:extLst>
           </p:cNvPr>
@@ -3251,7 +3251,7 @@
           <p:cNvPr id="10" name="solo-dot-2">
             <a:extLst xmlns:a="http://schemas.openxmlformats.org/drawingml/2006/main">
               <a:ext uri="{FF2B5EF4-FFF2-40B4-BE49-F238E27FC236}">
-                <a16:creationId xmlns:a16="http://schemas.microsoft.com/office/drawing/2014/main" id="{7B2DBF09-9827-4C59-8739-08D03D6CC154}"/>
+                <a16:creationId xmlns:a16="http://schemas.microsoft.com/office/drawing/2014/main" id="{C87B4676-C91E-4DF4-ACD2-9B4E9D836031}"/>
               </a:ext>
             </a:extLst>
           </p:cNvPr>
@@ -3304,7 +3304,7 @@
           <p:cNvPr id="12" name="solo-dot-3">
             <a:extLst xmlns:a="http://schemas.openxmlformats.org/drawingml/2006/main">
               <a:ext uri="{FF2B5EF4-FFF2-40B4-BE49-F238E27FC236}">
-                <a16:creationId xmlns:a16="http://schemas.microsoft.com/office/drawing/2014/main" id="{A2BB0A4D-D79C-4C97-A6B3-59CE4DA39EC2}"/>
+                <a16:creationId xmlns:a16="http://schemas.microsoft.com/office/drawing/2014/main" id="{9D65D914-57F4-400A-A5EC-96C58E9D90C9}"/>
               </a:ext>
             </a:extLst>
           </p:cNvPr>
@@ -3357,7 +3357,7 @@
           <p:cNvPr id="14" name="solo-dot-4">
             <a:extLst xmlns:a="http://schemas.openxmlformats.org/drawingml/2006/main">
               <a:ext uri="{FF2B5EF4-FFF2-40B4-BE49-F238E27FC236}">
-                <a16:creationId xmlns:a16="http://schemas.microsoft.com/office/drawing/2014/main" id="{C746B074-91D4-437E-80F2-9C4AD3A5C5F4}"/>
+                <a16:creationId xmlns:a16="http://schemas.microsoft.com/office/drawing/2014/main" id="{2C25E82D-953E-4487-AE04-D9D0150A5A80}"/>
               </a:ext>
             </a:extLst>
           </p:cNvPr>
@@ -3410,7 +3410,7 @@
           <p:cNvPr id="16" name="solo-dot-5">
             <a:extLst xmlns:a="http://schemas.openxmlformats.org/drawingml/2006/main">
               <a:ext uri="{FF2B5EF4-FFF2-40B4-BE49-F238E27FC236}">
-                <a16:creationId xmlns:a16="http://schemas.microsoft.com/office/drawing/2014/main" id="{27A06BDF-30CE-4F35-B166-F9C009FDB62C}"/>
+                <a16:creationId xmlns:a16="http://schemas.microsoft.com/office/drawing/2014/main" id="{14698919-E8C6-42F3-A459-4B1F9256A780}"/>
               </a:ext>
             </a:extLst>
           </p:cNvPr>
@@ -3463,7 +3463,7 @@
           <p:cNvPr id="18" name="solo-dot-6">
             <a:extLst xmlns:a="http://schemas.openxmlformats.org/drawingml/2006/main">
               <a:ext uri="{FF2B5EF4-FFF2-40B4-BE49-F238E27FC236}">
-                <a16:creationId xmlns:a16="http://schemas.microsoft.com/office/drawing/2014/main" id="{D6CE2B99-A203-4AB1-9931-35345F5B57D3}"/>
+                <a16:creationId xmlns:a16="http://schemas.microsoft.com/office/drawing/2014/main" id="{2ACC0418-1661-4EBF-9892-68FBCA9E09A8}"/>
               </a:ext>
             </a:extLst>
           </p:cNvPr>
@@ -3516,7 +3516,7 @@
           <p:cNvPr id="20" name="orchestra-arrow">
             <a:extLst xmlns:a="http://schemas.openxmlformats.org/drawingml/2006/main">
               <a:ext uri="{FF2B5EF4-FFF2-40B4-BE49-F238E27FC236}">
-                <a16:creationId xmlns:a16="http://schemas.microsoft.com/office/drawing/2014/main" id="{2F868A64-577C-4EA7-B7A9-2A7390F54734}"/>
+                <a16:creationId xmlns:a16="http://schemas.microsoft.com/office/drawing/2014/main" id="{75551FD0-60D3-45C0-A34A-C9BB54DAF516}"/>
               </a:ext>
             </a:extLst>
           </p:cNvPr>
@@ -3547,7 +3547,7 @@
           <p:cNvPr id="21" name="orchestra-check-ring">
             <a:extLst xmlns:a="http://schemas.openxmlformats.org/drawingml/2006/main">
               <a:ext uri="{FF2B5EF4-FFF2-40B4-BE49-F238E27FC236}">
-                <a16:creationId xmlns:a16="http://schemas.microsoft.com/office/drawing/2014/main" id="{40F4247F-7680-4B27-9194-A58EC1568F05}"/>
+                <a16:creationId xmlns:a16="http://schemas.microsoft.com/office/drawing/2014/main" id="{6F6EEF39-EDD0-4549-8992-4F6665500DEC}"/>
               </a:ext>
             </a:extLst>
           </p:cNvPr>
@@ -3580,7 +3580,7 @@
           <p:cNvPr id="22" name="orchestra-check">
             <a:extLst xmlns:a="http://schemas.openxmlformats.org/drawingml/2006/main">
               <a:ext uri="{FF2B5EF4-FFF2-40B4-BE49-F238E27FC236}">
-                <a16:creationId xmlns:a16="http://schemas.microsoft.com/office/drawing/2014/main" id="{29F5AE73-D730-4703-A01A-C62BB2C90D20}"/>
+                <a16:creationId xmlns:a16="http://schemas.microsoft.com/office/drawing/2014/main" id="{049916D1-13B2-4FF5-84EF-2438E3001394}"/>
               </a:ext>
             </a:extLst>
           </p:cNvPr>
@@ -3625,7 +3625,7 @@
           <p:cNvPr id="23" name="orchestra-baton">
             <a:extLst xmlns:a="http://schemas.openxmlformats.org/drawingml/2006/main">
               <a:ext uri="{FF2B5EF4-FFF2-40B4-BE49-F238E27FC236}">
-                <a16:creationId xmlns:a16="http://schemas.microsoft.com/office/drawing/2014/main" id="{4433CEB9-388D-455D-81A1-EBB2B110EBB9}"/>
+                <a16:creationId xmlns:a16="http://schemas.microsoft.com/office/drawing/2014/main" id="{EE1FAFA9-BBB5-4CD3-B7EE-E054E5832081}"/>
               </a:ext>
             </a:extLst>
           </p:cNvPr>
@@ -3656,7 +3656,7 @@
           <p:cNvPr id="24" name="orchestra-baton-tip">
             <a:extLst xmlns:a="http://schemas.openxmlformats.org/drawingml/2006/main">
               <a:ext uri="{FF2B5EF4-FFF2-40B4-BE49-F238E27FC236}">
-                <a16:creationId xmlns:a16="http://schemas.microsoft.com/office/drawing/2014/main" id="{C4CD5493-2771-44A3-9033-6324F8DBE1A5}"/>
+                <a16:creationId xmlns:a16="http://schemas.microsoft.com/office/drawing/2014/main" id="{4E250688-980D-4F5E-B6FE-653D2885CA3B}"/>
               </a:ext>
             </a:extLst>
           </p:cNvPr>
@@ -3687,7 +3687,7 @@
           <p:cNvPr id="25" name="solo-label-0">
             <a:extLst xmlns:a="http://schemas.openxmlformats.org/drawingml/2006/main">
               <a:ext uri="{FF2B5EF4-FFF2-40B4-BE49-F238E27FC236}">
-                <a16:creationId xmlns:a16="http://schemas.microsoft.com/office/drawing/2014/main" id="{3A47C76C-EEF5-4052-9968-333CDDB58F89}"/>
+                <a16:creationId xmlns:a16="http://schemas.microsoft.com/office/drawing/2014/main" id="{4EE5637D-8919-4BF4-8727-76DF66B89999}"/>
               </a:ext>
             </a:extLst>
           </p:cNvPr>
@@ -3732,7 +3732,7 @@
           <p:cNvPr id="26" name="solo-note-0">
             <a:extLst xmlns:a="http://schemas.openxmlformats.org/drawingml/2006/main">
               <a:ext uri="{FF2B5EF4-FFF2-40B4-BE49-F238E27FC236}">
-                <a16:creationId xmlns:a16="http://schemas.microsoft.com/office/drawing/2014/main" id="{06A32471-7C68-4628-BC95-1732B3011A76}"/>
+                <a16:creationId xmlns:a16="http://schemas.microsoft.com/office/drawing/2014/main" id="{2F6CF753-83B8-408A-95FC-B73058CD5C52}"/>
               </a:ext>
             </a:extLst>
           </p:cNvPr>
@@ -3777,7 +3777,7 @@
           <p:cNvPr id="27" name="solo-label-1">
             <a:extLst xmlns:a="http://schemas.openxmlformats.org/drawingml/2006/main">
               <a:ext uri="{FF2B5EF4-FFF2-40B4-BE49-F238E27FC236}">
-                <a16:creationId xmlns:a16="http://schemas.microsoft.com/office/drawing/2014/main" id="{29727E8F-78AC-4222-BD9D-9713AEF2852F}"/>
+                <a16:creationId xmlns:a16="http://schemas.microsoft.com/office/drawing/2014/main" id="{EADCFF07-2056-420A-B441-4A53C9299582}"/>
               </a:ext>
             </a:extLst>
           </p:cNvPr>
@@ -3822,7 +3822,7 @@
           <p:cNvPr id="28" name="solo-note-1">
             <a:extLst xmlns:a="http://schemas.openxmlformats.org/drawingml/2006/main">
               <a:ext uri="{FF2B5EF4-FFF2-40B4-BE49-F238E27FC236}">
-                <a16:creationId xmlns:a16="http://schemas.microsoft.com/office/drawing/2014/main" id="{90B61C17-7CF5-4FEC-B32A-4988AB714685}"/>
+                <a16:creationId xmlns:a16="http://schemas.microsoft.com/office/drawing/2014/main" id="{93799AC8-0652-4949-B4B1-3FCADB058722}"/>
               </a:ext>
             </a:extLst>
           </p:cNvPr>
@@ -3867,7 +3867,7 @@
           <p:cNvPr id="29" name="solo-label-2">
             <a:extLst xmlns:a="http://schemas.openxmlformats.org/drawingml/2006/main">
               <a:ext uri="{FF2B5EF4-FFF2-40B4-BE49-F238E27FC236}">
-                <a16:creationId xmlns:a16="http://schemas.microsoft.com/office/drawing/2014/main" id="{2ED8419D-CC72-43FB-898F-AD85A1F7929E}"/>
+                <a16:creationId xmlns:a16="http://schemas.microsoft.com/office/drawing/2014/main" id="{4D436F39-C79E-470E-AE5B-61D8514AA2AF}"/>
               </a:ext>
             </a:extLst>
           </p:cNvPr>
@@ -3912,7 +3912,7 @@
           <p:cNvPr id="30" name="solo-note-2">
             <a:extLst xmlns:a="http://schemas.openxmlformats.org/drawingml/2006/main">
               <a:ext uri="{FF2B5EF4-FFF2-40B4-BE49-F238E27FC236}">
-                <a16:creationId xmlns:a16="http://schemas.microsoft.com/office/drawing/2014/main" id="{E0C98C5B-3005-4BC1-97E2-C838EC464923}"/>
+                <a16:creationId xmlns:a16="http://schemas.microsoft.com/office/drawing/2014/main" id="{BC9641F3-9F86-4E13-B6D4-ED3C0744C43E}"/>
               </a:ext>
             </a:extLst>
           </p:cNvPr>
@@ -3957,7 +3957,7 @@
           <p:cNvPr id="31" name="solo-label-3">
             <a:extLst xmlns:a="http://schemas.openxmlformats.org/drawingml/2006/main">
               <a:ext uri="{FF2B5EF4-FFF2-40B4-BE49-F238E27FC236}">
-                <a16:creationId xmlns:a16="http://schemas.microsoft.com/office/drawing/2014/main" id="{E36C94F1-38D8-475A-B3CC-404D39692616}"/>
+                <a16:creationId xmlns:a16="http://schemas.microsoft.com/office/drawing/2014/main" id="{E27DE9B7-A061-45F1-A338-AE2285A1B47E}"/>
               </a:ext>
             </a:extLst>
           </p:cNvPr>
@@ -4002,7 +4002,7 @@
           <p:cNvPr id="32" name="solo-note-3">
             <a:extLst xmlns:a="http://schemas.openxmlformats.org/drawingml/2006/main">
               <a:ext uri="{FF2B5EF4-FFF2-40B4-BE49-F238E27FC236}">
-                <a16:creationId xmlns:a16="http://schemas.microsoft.com/office/drawing/2014/main" id="{AD1CDF26-8746-4FE2-B852-84A9C057F268}"/>
+                <a16:creationId xmlns:a16="http://schemas.microsoft.com/office/drawing/2014/main" id="{C61B03C8-FE15-44CC-8B31-F0471B656812}"/>
               </a:ext>
             </a:extLst>
           </p:cNvPr>
@@ -4047,7 +4047,7 @@
           <p:cNvPr id="33" name="solo-label-4">
             <a:extLst xmlns:a="http://schemas.openxmlformats.org/drawingml/2006/main">
               <a:ext uri="{FF2B5EF4-FFF2-40B4-BE49-F238E27FC236}">
-                <a16:creationId xmlns:a16="http://schemas.microsoft.com/office/drawing/2014/main" id="{0D388C4D-88B9-4466-A512-2020CC99A293}"/>
+                <a16:creationId xmlns:a16="http://schemas.microsoft.com/office/drawing/2014/main" id="{3833DB86-3AF9-4486-8CAB-07E2EA57E229}"/>
               </a:ext>
             </a:extLst>
           </p:cNvPr>
@@ -4092,7 +4092,7 @@
           <p:cNvPr id="34" name="solo-note-4">
             <a:extLst xmlns:a="http://schemas.openxmlformats.org/drawingml/2006/main">
               <a:ext uri="{FF2B5EF4-FFF2-40B4-BE49-F238E27FC236}">
-                <a16:creationId xmlns:a16="http://schemas.microsoft.com/office/drawing/2014/main" id="{4DE02818-95A0-4AAC-AC02-89373DAF839C}"/>
+                <a16:creationId xmlns:a16="http://schemas.microsoft.com/office/drawing/2014/main" id="{E1040F11-1205-4312-ADF5-E96C9B917AD0}"/>
               </a:ext>
             </a:extLst>
           </p:cNvPr>
@@ -4137,7 +4137,7 @@
           <p:cNvPr id="35" name="solo-label-5">
             <a:extLst xmlns:a="http://schemas.openxmlformats.org/drawingml/2006/main">
               <a:ext uri="{FF2B5EF4-FFF2-40B4-BE49-F238E27FC236}">
-                <a16:creationId xmlns:a16="http://schemas.microsoft.com/office/drawing/2014/main" id="{3D3A7A54-95CB-4F36-9FE1-5C10C2D2F23B}"/>
+                <a16:creationId xmlns:a16="http://schemas.microsoft.com/office/drawing/2014/main" id="{CE04CF43-E9E2-477A-9E87-1F7E62EDA12F}"/>
               </a:ext>
             </a:extLst>
           </p:cNvPr>
@@ -4182,7 +4182,7 @@
           <p:cNvPr id="36" name="solo-note-5">
             <a:extLst xmlns:a="http://schemas.openxmlformats.org/drawingml/2006/main">
               <a:ext uri="{FF2B5EF4-FFF2-40B4-BE49-F238E27FC236}">
-                <a16:creationId xmlns:a16="http://schemas.microsoft.com/office/drawing/2014/main" id="{BFFFB38D-E04D-4303-95FF-866130DFB8FB}"/>
+                <a16:creationId xmlns:a16="http://schemas.microsoft.com/office/drawing/2014/main" id="{994EBB4B-2337-4A98-B5AA-72FA6ED13F10}"/>
               </a:ext>
             </a:extLst>
           </p:cNvPr>
@@ -4227,7 +4227,7 @@
           <p:cNvPr id="37" name="solo-label-6">
             <a:extLst xmlns:a="http://schemas.openxmlformats.org/drawingml/2006/main">
               <a:ext uri="{FF2B5EF4-FFF2-40B4-BE49-F238E27FC236}">
-                <a16:creationId xmlns:a16="http://schemas.microsoft.com/office/drawing/2014/main" id="{CAED938E-F59C-4A91-81C6-E64067BA1C3D}"/>
+                <a16:creationId xmlns:a16="http://schemas.microsoft.com/office/drawing/2014/main" id="{ADFE73AE-DF5F-44D5-AB33-E1F5D4BF3639}"/>
               </a:ext>
             </a:extLst>
           </p:cNvPr>
@@ -4272,7 +4272,7 @@
           <p:cNvPr id="38" name="solo-note-6">
             <a:extLst xmlns:a="http://schemas.openxmlformats.org/drawingml/2006/main">
               <a:ext uri="{FF2B5EF4-FFF2-40B4-BE49-F238E27FC236}">
-                <a16:creationId xmlns:a16="http://schemas.microsoft.com/office/drawing/2014/main" id="{24109D46-1F69-4667-AF8B-A42AEC27F999}"/>
+                <a16:creationId xmlns:a16="http://schemas.microsoft.com/office/drawing/2014/main" id="{146DA8D3-D661-4797-A4E4-BFE0783A85DF}"/>
               </a:ext>
             </a:extLst>
           </p:cNvPr>
@@ -4317,7 +4317,7 @@
           <p:cNvPr id="39" name="orchestra-caption">
             <a:extLst xmlns:a="http://schemas.openxmlformats.org/drawingml/2006/main">
               <a:ext uri="{FF2B5EF4-FFF2-40B4-BE49-F238E27FC236}">
-                <a16:creationId xmlns:a16="http://schemas.microsoft.com/office/drawing/2014/main" id="{CBD359EA-4072-4B72-B671-9AAB76AC01EC}"/>
+                <a16:creationId xmlns:a16="http://schemas.microsoft.com/office/drawing/2014/main" id="{409939DC-0DF0-493A-8162-C85E809FB48F}"/>
               </a:ext>
             </a:extLst>
           </p:cNvPr>
@@ -4363,7 +4363,7 @@
           <p:cNvPr id="40" name="orchestra-punchline">
             <a:extLst xmlns:a="http://schemas.openxmlformats.org/drawingml/2006/main">
               <a:ext uri="{FF2B5EF4-FFF2-40B4-BE49-F238E27FC236}">
-                <a16:creationId xmlns:a16="http://schemas.microsoft.com/office/drawing/2014/main" id="{058F0000-A5F9-4B65-8A9C-DB01F06E5079}"/>
+                <a16:creationId xmlns:a16="http://schemas.microsoft.com/office/drawing/2014/main" id="{89E419F9-B295-4411-BF94-5F1BAD5A2408}"/>
               </a:ext>
             </a:extLst>
           </p:cNvPr>
@@ -4394,7 +4394,7 @@
           <p:cNvPr id="41" name="orchestra-punchline-text">
             <a:extLst xmlns:a="http://schemas.openxmlformats.org/drawingml/2006/main">
               <a:ext uri="{FF2B5EF4-FFF2-40B4-BE49-F238E27FC236}">
-                <a16:creationId xmlns:a16="http://schemas.microsoft.com/office/drawing/2014/main" id="{E928690E-3E73-4600-885D-51E30F5FD601}"/>
+                <a16:creationId xmlns:a16="http://schemas.microsoft.com/office/drawing/2014/main" id="{8F24F51E-6CD2-4B29-93F2-F25D319B7747}"/>
               </a:ext>
             </a:extLst>
           </p:cNvPr>
@@ -4437,7 +4437,7 @@
     </p:spTree>
     <p:extLst>
       <p:ext uri="{BB962C8B-B14F-4D97-AF65-F5344CB8AC3E}">
-        <p14:creationId xmlns:p14="http://schemas.microsoft.com/office/powerpoint/2010/main" val="1162271063"/>
+        <p14:creationId xmlns:p14="http://schemas.microsoft.com/office/powerpoint/2010/main" val="1187932504"/>
       </p:ext>
     </p:extLst>
   </p:cSld>
@@ -4468,7 +4468,7 @@
           <p:cNvPr id="1" name="kicker-3">
             <a:extLst xmlns:a="http://schemas.openxmlformats.org/drawingml/2006/main">
               <a:ext uri="{FF2B5EF4-FFF2-40B4-BE49-F238E27FC236}">
-                <a16:creationId xmlns:a16="http://schemas.microsoft.com/office/drawing/2014/main" id="{36289CFC-B1E9-44C6-9E5F-39D4B11FABA6}"/>
+                <a16:creationId xmlns:a16="http://schemas.microsoft.com/office/drawing/2014/main" id="{55DBA4A9-FE9D-4DAF-B462-73A961299489}"/>
               </a:ext>
             </a:extLst>
           </p:cNvPr>
@@ -4513,7 +4513,7 @@
           <p:cNvPr id="2" name="title-3">
             <a:extLst xmlns:a="http://schemas.openxmlformats.org/drawingml/2006/main">
               <a:ext uri="{FF2B5EF4-FFF2-40B4-BE49-F238E27FC236}">
-                <a16:creationId xmlns:a16="http://schemas.microsoft.com/office/drawing/2014/main" id="{40C1EAF7-BF1D-4BE3-875D-2A405286F5C7}"/>
+                <a16:creationId xmlns:a16="http://schemas.microsoft.com/office/drawing/2014/main" id="{DC728A72-C715-4920-9B19-FD198FE2E0E4}"/>
               </a:ext>
             </a:extLst>
           </p:cNvPr>
@@ -4580,7 +4580,7 @@
           <p:cNvPr id="4" name="number-3">
             <a:extLst xmlns:a="http://schemas.openxmlformats.org/drawingml/2006/main">
               <a:ext uri="{FF2B5EF4-FFF2-40B4-BE49-F238E27FC236}">
-                <a16:creationId xmlns:a16="http://schemas.microsoft.com/office/drawing/2014/main" id="{F65171D4-D3C0-4188-8655-48DEEB96C716}"/>
+                <a16:creationId xmlns:a16="http://schemas.microsoft.com/office/drawing/2014/main" id="{75C656D6-1A5C-42EE-90D8-7A5208D8D9DA}"/>
               </a:ext>
             </a:extLst>
           </p:cNvPr>
@@ -4647,7 +4647,7 @@
           <p:cNvPr id="6" name="station-group-0">
             <a:extLst xmlns:a="http://schemas.openxmlformats.org/drawingml/2006/main">
               <a:ext uri="{FF2B5EF4-FFF2-40B4-BE49-F238E27FC236}">
-                <a16:creationId xmlns:a16="http://schemas.microsoft.com/office/drawing/2014/main" id="{3F565B17-6B1B-45E6-8AA7-D976438AD223}"/>
+                <a16:creationId xmlns:a16="http://schemas.microsoft.com/office/drawing/2014/main" id="{273F3606-6C61-4293-AA89-8ED3443F4B5D}"/>
               </a:ext>
             </a:extLst>
           </p:cNvPr>
@@ -4692,7 +4692,7 @@
           <p:cNvPr id="7" name="station-dot-0-0">
             <a:extLst xmlns:a="http://schemas.openxmlformats.org/drawingml/2006/main">
               <a:ext uri="{FF2B5EF4-FFF2-40B4-BE49-F238E27FC236}">
-                <a16:creationId xmlns:a16="http://schemas.microsoft.com/office/drawing/2014/main" id="{47FD91CC-95A6-4409-9D52-511E267FC276}"/>
+                <a16:creationId xmlns:a16="http://schemas.microsoft.com/office/drawing/2014/main" id="{46663232-0D28-4F31-8E04-92C83DECEFCE}"/>
               </a:ext>
             </a:extLst>
           </p:cNvPr>
@@ -4725,7 +4725,7 @@
           <p:cNvPr id="8" name="station-label-0-0">
             <a:extLst xmlns:a="http://schemas.openxmlformats.org/drawingml/2006/main">
               <a:ext uri="{FF2B5EF4-FFF2-40B4-BE49-F238E27FC236}">
-                <a16:creationId xmlns:a16="http://schemas.microsoft.com/office/drawing/2014/main" id="{0F0DF56C-81EC-4CC8-AF86-91B96E2BB887}"/>
+                <a16:creationId xmlns:a16="http://schemas.microsoft.com/office/drawing/2014/main" id="{CC0D9648-2CE7-4BAE-BE13-063AF1BC2DC3}"/>
               </a:ext>
             </a:extLst>
           </p:cNvPr>
@@ -4760,7 +4760,7 @@
               </a:defRPr>
             </a:pPr>
             <a:r>
-              <a:t>lockfile</a:t>
+              <a:t>lock + environment</a:t>
             </a:r>
           </a:p>
         </p:txBody>
@@ -4770,7 +4770,7 @@
           <p:cNvPr id="9" name="station-dot-0-1">
             <a:extLst xmlns:a="http://schemas.openxmlformats.org/drawingml/2006/main">
               <a:ext uri="{FF2B5EF4-FFF2-40B4-BE49-F238E27FC236}">
-                <a16:creationId xmlns:a16="http://schemas.microsoft.com/office/drawing/2014/main" id="{176FEE0A-2F90-40BF-8CF4-109D6A8D8FC8}"/>
+                <a16:creationId xmlns:a16="http://schemas.microsoft.com/office/drawing/2014/main" id="{9CA86018-EAB8-4A81-9A1A-D04E79D75E5A}"/>
               </a:ext>
             </a:extLst>
           </p:cNvPr>
@@ -4803,7 +4803,7 @@
           <p:cNvPr id="10" name="station-label-0-1">
             <a:extLst xmlns:a="http://schemas.openxmlformats.org/drawingml/2006/main">
               <a:ext uri="{FF2B5EF4-FFF2-40B4-BE49-F238E27FC236}">
-                <a16:creationId xmlns:a16="http://schemas.microsoft.com/office/drawing/2014/main" id="{3AE1D741-7C66-4F8C-9823-6CD7993D3E40}"/>
+                <a16:creationId xmlns:a16="http://schemas.microsoft.com/office/drawing/2014/main" id="{9FAE0214-0824-4025-8A8B-AEE364979EE3}"/>
               </a:ext>
             </a:extLst>
           </p:cNvPr>
@@ -4848,7 +4848,7 @@
           <p:cNvPr id="11" name="station-dot-0-2">
             <a:extLst xmlns:a="http://schemas.openxmlformats.org/drawingml/2006/main">
               <a:ext uri="{FF2B5EF4-FFF2-40B4-BE49-F238E27FC236}">
-                <a16:creationId xmlns:a16="http://schemas.microsoft.com/office/drawing/2014/main" id="{29E0490F-7056-4185-8554-EC2B78C7A77C}"/>
+                <a16:creationId xmlns:a16="http://schemas.microsoft.com/office/drawing/2014/main" id="{7DFE8E46-1279-4244-A6D0-18B8710A37A1}"/>
               </a:ext>
             </a:extLst>
           </p:cNvPr>
@@ -4881,7 +4881,7 @@
           <p:cNvPr id="12" name="station-label-0-2">
             <a:extLst xmlns:a="http://schemas.openxmlformats.org/drawingml/2006/main">
               <a:ext uri="{FF2B5EF4-FFF2-40B4-BE49-F238E27FC236}">
-                <a16:creationId xmlns:a16="http://schemas.microsoft.com/office/drawing/2014/main" id="{3CB22131-5F3D-4AD9-A714-F98E3B61D073}"/>
+                <a16:creationId xmlns:a16="http://schemas.microsoft.com/office/drawing/2014/main" id="{600AFBD3-E2FE-49E9-83D3-C8DD29462A3E}"/>
               </a:ext>
             </a:extLst>
           </p:cNvPr>
@@ -4926,7 +4926,7 @@
           <p:cNvPr id="13" name="station-dot-0-3">
             <a:extLst xmlns:a="http://schemas.openxmlformats.org/drawingml/2006/main">
               <a:ext uri="{FF2B5EF4-FFF2-40B4-BE49-F238E27FC236}">
-                <a16:creationId xmlns:a16="http://schemas.microsoft.com/office/drawing/2014/main" id="{C206EA78-BB69-4115-B865-23DD57122F5B}"/>
+                <a16:creationId xmlns:a16="http://schemas.microsoft.com/office/drawing/2014/main" id="{17508F93-96C5-4666-97BA-DB148C69A173}"/>
               </a:ext>
             </a:extLst>
           </p:cNvPr>
@@ -4959,7 +4959,7 @@
           <p:cNvPr id="14" name="station-label-0-3">
             <a:extLst xmlns:a="http://schemas.openxmlformats.org/drawingml/2006/main">
               <a:ext uri="{FF2B5EF4-FFF2-40B4-BE49-F238E27FC236}">
-                <a16:creationId xmlns:a16="http://schemas.microsoft.com/office/drawing/2014/main" id="{19F536B2-49D8-4E1A-B072-382B43139F6A}"/>
+                <a16:creationId xmlns:a16="http://schemas.microsoft.com/office/drawing/2014/main" id="{CE08F5C4-07EF-4CC6-89C6-18FE3826DFD5}"/>
               </a:ext>
             </a:extLst>
           </p:cNvPr>
@@ -5026,7 +5026,7 @@
           <p:cNvPr id="16" name="station-group-1">
             <a:extLst xmlns:a="http://schemas.openxmlformats.org/drawingml/2006/main">
               <a:ext uri="{FF2B5EF4-FFF2-40B4-BE49-F238E27FC236}">
-                <a16:creationId xmlns:a16="http://schemas.microsoft.com/office/drawing/2014/main" id="{86E467AA-6F7A-4CF7-B288-E85CA3719466}"/>
+                <a16:creationId xmlns:a16="http://schemas.microsoft.com/office/drawing/2014/main" id="{7352ADFF-2631-47F6-9C85-699BAE4D7BF2}"/>
               </a:ext>
             </a:extLst>
           </p:cNvPr>
@@ -5071,7 +5071,7 @@
           <p:cNvPr id="17" name="station-dot-1-0">
             <a:extLst xmlns:a="http://schemas.openxmlformats.org/drawingml/2006/main">
               <a:ext uri="{FF2B5EF4-FFF2-40B4-BE49-F238E27FC236}">
-                <a16:creationId xmlns:a16="http://schemas.microsoft.com/office/drawing/2014/main" id="{79C52BB9-C4FF-4CBD-A53B-EE8760BCE03F}"/>
+                <a16:creationId xmlns:a16="http://schemas.microsoft.com/office/drawing/2014/main" id="{BDAACEBE-695C-44E6-A056-BE1385A54E26}"/>
               </a:ext>
             </a:extLst>
           </p:cNvPr>
@@ -5104,7 +5104,7 @@
           <p:cNvPr id="18" name="station-label-1-0">
             <a:extLst xmlns:a="http://schemas.openxmlformats.org/drawingml/2006/main">
               <a:ext uri="{FF2B5EF4-FFF2-40B4-BE49-F238E27FC236}">
-                <a16:creationId xmlns:a16="http://schemas.microsoft.com/office/drawing/2014/main" id="{2D351D76-9F3B-4C41-B2AC-877B97BEA2F4}"/>
+                <a16:creationId xmlns:a16="http://schemas.microsoft.com/office/drawing/2014/main" id="{C1FEDACF-2214-4578-A247-21F321CCDDDF}"/>
               </a:ext>
             </a:extLst>
           </p:cNvPr>
@@ -5149,7 +5149,7 @@
           <p:cNvPr id="19" name="station-dot-1-1">
             <a:extLst xmlns:a="http://schemas.openxmlformats.org/drawingml/2006/main">
               <a:ext uri="{FF2B5EF4-FFF2-40B4-BE49-F238E27FC236}">
-                <a16:creationId xmlns:a16="http://schemas.microsoft.com/office/drawing/2014/main" id="{252DC3F0-33C4-4B02-87DF-4C168062EBFE}"/>
+                <a16:creationId xmlns:a16="http://schemas.microsoft.com/office/drawing/2014/main" id="{994FABFE-D23B-46D9-A9BC-14811B304D70}"/>
               </a:ext>
             </a:extLst>
           </p:cNvPr>
@@ -5182,7 +5182,7 @@
           <p:cNvPr id="20" name="station-label-1-1">
             <a:extLst xmlns:a="http://schemas.openxmlformats.org/drawingml/2006/main">
               <a:ext uri="{FF2B5EF4-FFF2-40B4-BE49-F238E27FC236}">
-                <a16:creationId xmlns:a16="http://schemas.microsoft.com/office/drawing/2014/main" id="{23952680-FB5E-4E1A-B62F-D21AFC67E827}"/>
+                <a16:creationId xmlns:a16="http://schemas.microsoft.com/office/drawing/2014/main" id="{27A8E026-9447-4DAB-A8F9-5DC974512F47}"/>
               </a:ext>
             </a:extLst>
           </p:cNvPr>
@@ -5249,7 +5249,7 @@
           <p:cNvPr id="22" name="station-group-2">
             <a:extLst xmlns:a="http://schemas.openxmlformats.org/drawingml/2006/main">
               <a:ext uri="{FF2B5EF4-FFF2-40B4-BE49-F238E27FC236}">
-                <a16:creationId xmlns:a16="http://schemas.microsoft.com/office/drawing/2014/main" id="{2B5F6628-F448-4519-8C77-17219379DA91}"/>
+                <a16:creationId xmlns:a16="http://schemas.microsoft.com/office/drawing/2014/main" id="{0FB1A39E-5FB6-4727-9B91-5F144B1813F3}"/>
               </a:ext>
             </a:extLst>
           </p:cNvPr>
@@ -5294,7 +5294,7 @@
           <p:cNvPr id="23" name="station-dot-2-0">
             <a:extLst xmlns:a="http://schemas.openxmlformats.org/drawingml/2006/main">
               <a:ext uri="{FF2B5EF4-FFF2-40B4-BE49-F238E27FC236}">
-                <a16:creationId xmlns:a16="http://schemas.microsoft.com/office/drawing/2014/main" id="{35D0F0DE-74B8-4FB4-972B-A5B4CD715B4A}"/>
+                <a16:creationId xmlns:a16="http://schemas.microsoft.com/office/drawing/2014/main" id="{AB7EC97D-A4CA-4325-82C3-E70524C9EE27}"/>
               </a:ext>
             </a:extLst>
           </p:cNvPr>
@@ -5327,7 +5327,7 @@
           <p:cNvPr id="24" name="station-label-2-0">
             <a:extLst xmlns:a="http://schemas.openxmlformats.org/drawingml/2006/main">
               <a:ext uri="{FF2B5EF4-FFF2-40B4-BE49-F238E27FC236}">
-                <a16:creationId xmlns:a16="http://schemas.microsoft.com/office/drawing/2014/main" id="{0D71C111-ACEF-406E-BE0B-4AD588630A9D}"/>
+                <a16:creationId xmlns:a16="http://schemas.microsoft.com/office/drawing/2014/main" id="{970F7E8E-2CCD-4F2E-9C22-954A33781152}"/>
               </a:ext>
             </a:extLst>
           </p:cNvPr>
@@ -5372,7 +5372,7 @@
           <p:cNvPr id="25" name="station-dot-2-1">
             <a:extLst xmlns:a="http://schemas.openxmlformats.org/drawingml/2006/main">
               <a:ext uri="{FF2B5EF4-FFF2-40B4-BE49-F238E27FC236}">
-                <a16:creationId xmlns:a16="http://schemas.microsoft.com/office/drawing/2014/main" id="{ECFE3B7A-8626-4325-A26A-C4C10F0DD85B}"/>
+                <a16:creationId xmlns:a16="http://schemas.microsoft.com/office/drawing/2014/main" id="{B8B23E87-9DE0-4C01-B522-7D30155233A6}"/>
               </a:ext>
             </a:extLst>
           </p:cNvPr>
@@ -5405,7 +5405,7 @@
           <p:cNvPr id="26" name="station-label-2-1">
             <a:extLst xmlns:a="http://schemas.openxmlformats.org/drawingml/2006/main">
               <a:ext uri="{FF2B5EF4-FFF2-40B4-BE49-F238E27FC236}">
-                <a16:creationId xmlns:a16="http://schemas.microsoft.com/office/drawing/2014/main" id="{CF66690D-F438-4CAD-A7BE-90A882E5C46F}"/>
+                <a16:creationId xmlns:a16="http://schemas.microsoft.com/office/drawing/2014/main" id="{48902407-B540-4FCC-8D30-FC7D6739B5A8}"/>
               </a:ext>
             </a:extLst>
           </p:cNvPr>
@@ -5450,7 +5450,7 @@
           <p:cNvPr id="27" name="station-dot-2-2">
             <a:extLst xmlns:a="http://schemas.openxmlformats.org/drawingml/2006/main">
               <a:ext uri="{FF2B5EF4-FFF2-40B4-BE49-F238E27FC236}">
-                <a16:creationId xmlns:a16="http://schemas.microsoft.com/office/drawing/2014/main" id="{82EDA0E9-D755-4526-87F0-EA47365C459A}"/>
+                <a16:creationId xmlns:a16="http://schemas.microsoft.com/office/drawing/2014/main" id="{74AFFCC7-92D6-41CB-BA8E-BB89D0A3308C}"/>
               </a:ext>
             </a:extLst>
           </p:cNvPr>
@@ -5483,7 +5483,7 @@
           <p:cNvPr id="28" name="station-label-2-2">
             <a:extLst xmlns:a="http://schemas.openxmlformats.org/drawingml/2006/main">
               <a:ext uri="{FF2B5EF4-FFF2-40B4-BE49-F238E27FC236}">
-                <a16:creationId xmlns:a16="http://schemas.microsoft.com/office/drawing/2014/main" id="{C8BBED10-0B70-4129-A969-A5265422F48C}"/>
+                <a16:creationId xmlns:a16="http://schemas.microsoft.com/office/drawing/2014/main" id="{FC1830F8-5D1B-40F9-BFF4-7FF1D296A51B}"/>
               </a:ext>
             </a:extLst>
           </p:cNvPr>
@@ -5550,7 +5550,7 @@
           <p:cNvPr id="30" name="station-group-3">
             <a:extLst xmlns:a="http://schemas.openxmlformats.org/drawingml/2006/main">
               <a:ext uri="{FF2B5EF4-FFF2-40B4-BE49-F238E27FC236}">
-                <a16:creationId xmlns:a16="http://schemas.microsoft.com/office/drawing/2014/main" id="{556EAF61-80A7-4DBD-97E6-F7D0E8DFA0B1}"/>
+                <a16:creationId xmlns:a16="http://schemas.microsoft.com/office/drawing/2014/main" id="{DF6C3A9D-A98F-48A3-9104-A27A358E3866}"/>
               </a:ext>
             </a:extLst>
           </p:cNvPr>
@@ -5595,7 +5595,7 @@
           <p:cNvPr id="31" name="station-dot-3-0">
             <a:extLst xmlns:a="http://schemas.openxmlformats.org/drawingml/2006/main">
               <a:ext uri="{FF2B5EF4-FFF2-40B4-BE49-F238E27FC236}">
-                <a16:creationId xmlns:a16="http://schemas.microsoft.com/office/drawing/2014/main" id="{7903F9DA-DC24-4382-8DAE-342024D07DAD}"/>
+                <a16:creationId xmlns:a16="http://schemas.microsoft.com/office/drawing/2014/main" id="{A6E5158B-69C8-4EF4-87D9-B1822B6F550C}"/>
               </a:ext>
             </a:extLst>
           </p:cNvPr>
@@ -5628,7 +5628,7 @@
           <p:cNvPr id="32" name="station-label-3-0">
             <a:extLst xmlns:a="http://schemas.openxmlformats.org/drawingml/2006/main">
               <a:ext uri="{FF2B5EF4-FFF2-40B4-BE49-F238E27FC236}">
-                <a16:creationId xmlns:a16="http://schemas.microsoft.com/office/drawing/2014/main" id="{EA65A283-869F-44E8-BB5C-4498517AE080}"/>
+                <a16:creationId xmlns:a16="http://schemas.microsoft.com/office/drawing/2014/main" id="{B777981A-C2C4-460B-8203-637B6216A0AA}"/>
               </a:ext>
             </a:extLst>
           </p:cNvPr>
@@ -5673,7 +5673,7 @@
           <p:cNvPr id="33" name="station-dot-3-1">
             <a:extLst xmlns:a="http://schemas.openxmlformats.org/drawingml/2006/main">
               <a:ext uri="{FF2B5EF4-FFF2-40B4-BE49-F238E27FC236}">
-                <a16:creationId xmlns:a16="http://schemas.microsoft.com/office/drawing/2014/main" id="{3389ED81-47B1-4D26-92B5-AA231FAB39B6}"/>
+                <a16:creationId xmlns:a16="http://schemas.microsoft.com/office/drawing/2014/main" id="{E077724A-F211-46B5-A8BE-7266255E0794}"/>
               </a:ext>
             </a:extLst>
           </p:cNvPr>
@@ -5706,7 +5706,7 @@
           <p:cNvPr id="34" name="station-label-3-1">
             <a:extLst xmlns:a="http://schemas.openxmlformats.org/drawingml/2006/main">
               <a:ext uri="{FF2B5EF4-FFF2-40B4-BE49-F238E27FC236}">
-                <a16:creationId xmlns:a16="http://schemas.microsoft.com/office/drawing/2014/main" id="{C5835B8F-B746-4459-AA48-6E2546BF3981}"/>
+                <a16:creationId xmlns:a16="http://schemas.microsoft.com/office/drawing/2014/main" id="{C9F941D9-C393-47CD-B59C-D19F7C893BD8}"/>
               </a:ext>
             </a:extLst>
           </p:cNvPr>
@@ -5751,7 +5751,7 @@
           <p:cNvPr id="35" name="spine-fail">
             <a:extLst xmlns:a="http://schemas.openxmlformats.org/drawingml/2006/main">
               <a:ext uri="{FF2B5EF4-FFF2-40B4-BE49-F238E27FC236}">
-                <a16:creationId xmlns:a16="http://schemas.microsoft.com/office/drawing/2014/main" id="{148EBBA6-E9B8-4020-9BD9-DF34DBBCA76E}"/>
+                <a16:creationId xmlns:a16="http://schemas.microsoft.com/office/drawing/2014/main" id="{035A0273-A8B1-4B92-BFC2-25E9D1DC3546}"/>
               </a:ext>
             </a:extLst>
           </p:cNvPr>
@@ -5786,7 +5786,7 @@
           <p:cNvPr id="36" name="spine-fail-icon">
             <a:extLst xmlns:a="http://schemas.openxmlformats.org/drawingml/2006/main">
               <a:ext uri="{FF2B5EF4-FFF2-40B4-BE49-F238E27FC236}">
-                <a16:creationId xmlns:a16="http://schemas.microsoft.com/office/drawing/2014/main" id="{974DF767-5BAB-46F9-A511-976024201F2E}"/>
+                <a16:creationId xmlns:a16="http://schemas.microsoft.com/office/drawing/2014/main" id="{B9862960-81A9-45A2-90F6-01708BC1084C}"/>
               </a:ext>
             </a:extLst>
           </p:cNvPr>
@@ -5831,7 +5831,7 @@
           <p:cNvPr id="37" name="spine-fail-text">
             <a:extLst xmlns:a="http://schemas.openxmlformats.org/drawingml/2006/main">
               <a:ext uri="{FF2B5EF4-FFF2-40B4-BE49-F238E27FC236}">
-                <a16:creationId xmlns:a16="http://schemas.microsoft.com/office/drawing/2014/main" id="{F0D7C1F4-CA6D-441F-AC3F-4A931BF1C736}"/>
+                <a16:creationId xmlns:a16="http://schemas.microsoft.com/office/drawing/2014/main" id="{021803D5-5944-4194-B27D-8F85E9C3F085}"/>
               </a:ext>
             </a:extLst>
           </p:cNvPr>
@@ -5877,7 +5877,7 @@
           <p:cNvPr id="38" name="spine-pass">
             <a:extLst xmlns:a="http://schemas.openxmlformats.org/drawingml/2006/main">
               <a:ext uri="{FF2B5EF4-FFF2-40B4-BE49-F238E27FC236}">
-                <a16:creationId xmlns:a16="http://schemas.microsoft.com/office/drawing/2014/main" id="{944472B5-A2E3-4275-BEE9-B997475699CB}"/>
+                <a16:creationId xmlns:a16="http://schemas.microsoft.com/office/drawing/2014/main" id="{0B7D5DAE-74F8-4978-B5F1-5C57F026D4F5}"/>
               </a:ext>
             </a:extLst>
           </p:cNvPr>
@@ -5912,7 +5912,7 @@
           <p:cNvPr id="39" name="spine-pass-icon">
             <a:extLst xmlns:a="http://schemas.openxmlformats.org/drawingml/2006/main">
               <a:ext uri="{FF2B5EF4-FFF2-40B4-BE49-F238E27FC236}">
-                <a16:creationId xmlns:a16="http://schemas.microsoft.com/office/drawing/2014/main" id="{72ECCD7F-B3E7-474E-A383-FB093E83BF11}"/>
+                <a16:creationId xmlns:a16="http://schemas.microsoft.com/office/drawing/2014/main" id="{2E8D5B72-D79B-41A9-9251-9F95D25181E2}"/>
               </a:ext>
             </a:extLst>
           </p:cNvPr>
@@ -5957,7 +5957,7 @@
           <p:cNvPr id="40" name="spine-pass-text">
             <a:extLst xmlns:a="http://schemas.openxmlformats.org/drawingml/2006/main">
               <a:ext uri="{FF2B5EF4-FFF2-40B4-BE49-F238E27FC236}">
-                <a16:creationId xmlns:a16="http://schemas.microsoft.com/office/drawing/2014/main" id="{05DC0FF3-A184-4377-8495-2469FDDF21E3}"/>
+                <a16:creationId xmlns:a16="http://schemas.microsoft.com/office/drawing/2014/main" id="{30FAE219-CEA2-476D-8B58-FE9996E83D32}"/>
               </a:ext>
             </a:extLst>
           </p:cNvPr>
@@ -6001,7 +6001,7 @@
     </p:spTree>
     <p:extLst>
       <p:ext uri="{BB962C8B-B14F-4D97-AF65-F5344CB8AC3E}">
-        <p14:creationId xmlns:p14="http://schemas.microsoft.com/office/powerpoint/2010/main" val="1549232325"/>
+        <p14:creationId xmlns:p14="http://schemas.microsoft.com/office/powerpoint/2010/main" val="2062341230"/>
       </p:ext>
     </p:extLst>
   </p:cSld>
@@ -6032,7 +6032,7 @@
           <p:cNvPr id="1" name="kicker-4">
             <a:extLst xmlns:a="http://schemas.openxmlformats.org/drawingml/2006/main">
               <a:ext uri="{FF2B5EF4-FFF2-40B4-BE49-F238E27FC236}">
-                <a16:creationId xmlns:a16="http://schemas.microsoft.com/office/drawing/2014/main" id="{46050C10-6928-44A4-B99B-B2646BD0C479}"/>
+                <a16:creationId xmlns:a16="http://schemas.microsoft.com/office/drawing/2014/main" id="{AFA36575-BE3F-494C-A3BB-784D24E41E3E}"/>
               </a:ext>
             </a:extLst>
           </p:cNvPr>
@@ -6077,7 +6077,7 @@
           <p:cNvPr id="2" name="title-4">
             <a:extLst xmlns:a="http://schemas.openxmlformats.org/drawingml/2006/main">
               <a:ext uri="{FF2B5EF4-FFF2-40B4-BE49-F238E27FC236}">
-                <a16:creationId xmlns:a16="http://schemas.microsoft.com/office/drawing/2014/main" id="{F15F1A11-6484-409A-9DD9-DBDDF3500451}"/>
+                <a16:creationId xmlns:a16="http://schemas.microsoft.com/office/drawing/2014/main" id="{315ADD27-6B2A-4424-ACC7-9686AC848093}"/>
               </a:ext>
             </a:extLst>
           </p:cNvPr>
@@ -6144,7 +6144,7 @@
           <p:cNvPr id="4" name="number-4">
             <a:extLst xmlns:a="http://schemas.openxmlformats.org/drawingml/2006/main">
               <a:ext uri="{FF2B5EF4-FFF2-40B4-BE49-F238E27FC236}">
-                <a16:creationId xmlns:a16="http://schemas.microsoft.com/office/drawing/2014/main" id="{145C457B-D96A-46C0-B5CA-6D4E39E1E06B}"/>
+                <a16:creationId xmlns:a16="http://schemas.microsoft.com/office/drawing/2014/main" id="{6D5CFFE5-ACA5-4745-B2D8-3D2612E7137E}"/>
               </a:ext>
             </a:extLst>
           </p:cNvPr>
@@ -6211,7 +6211,7 @@
           <p:cNvPr id="6" name="airlock-arrow">
             <a:extLst xmlns:a="http://schemas.openxmlformats.org/drawingml/2006/main">
               <a:ext uri="{FF2B5EF4-FFF2-40B4-BE49-F238E27FC236}">
-                <a16:creationId xmlns:a16="http://schemas.microsoft.com/office/drawing/2014/main" id="{99716F61-8B8D-4871-AB03-C262D07F0C46}"/>
+                <a16:creationId xmlns:a16="http://schemas.microsoft.com/office/drawing/2014/main" id="{3E14D694-E811-47A2-A6C9-D3FC54523E6A}"/>
               </a:ext>
             </a:extLst>
           </p:cNvPr>
@@ -6242,7 +6242,7 @@
           <p:cNvPr id="7" name="setup-island">
             <a:extLst xmlns:a="http://schemas.openxmlformats.org/drawingml/2006/main">
               <a:ext uri="{FF2B5EF4-FFF2-40B4-BE49-F238E27FC236}">
-                <a16:creationId xmlns:a16="http://schemas.microsoft.com/office/drawing/2014/main" id="{3942FC4B-AFDE-4A34-926B-3A2BE8BC6F2F}"/>
+                <a16:creationId xmlns:a16="http://schemas.microsoft.com/office/drawing/2014/main" id="{0B7EF870-6AA3-49A6-9811-3F1DD7BF398A}"/>
               </a:ext>
             </a:extLst>
           </p:cNvPr>
@@ -6277,7 +6277,7 @@
           <p:cNvPr id="8" name="check-island">
             <a:extLst xmlns:a="http://schemas.openxmlformats.org/drawingml/2006/main">
               <a:ext uri="{FF2B5EF4-FFF2-40B4-BE49-F238E27FC236}">
-                <a16:creationId xmlns:a16="http://schemas.microsoft.com/office/drawing/2014/main" id="{079DB91C-FE3B-46CF-906B-800CEEA9FA37}"/>
+                <a16:creationId xmlns:a16="http://schemas.microsoft.com/office/drawing/2014/main" id="{17A99439-E441-49B7-BFC0-D4AD88E205D0}"/>
               </a:ext>
             </a:extLst>
           </p:cNvPr>
@@ -6312,7 +6312,7 @@
           <p:cNvPr id="9" name="airlock-door">
             <a:extLst xmlns:a="http://schemas.openxmlformats.org/drawingml/2006/main">
               <a:ext uri="{FF2B5EF4-FFF2-40B4-BE49-F238E27FC236}">
-                <a16:creationId xmlns:a16="http://schemas.microsoft.com/office/drawing/2014/main" id="{B2B0AAF8-97C8-4B39-B27D-C2DA5186B075}"/>
+                <a16:creationId xmlns:a16="http://schemas.microsoft.com/office/drawing/2014/main" id="{29EA2643-C09F-4FA3-9464-B41F5746CDA7}"/>
               </a:ext>
             </a:extLst>
           </p:cNvPr>
@@ -6343,7 +6343,7 @@
           <p:cNvPr id="10" name="airlock-lock">
             <a:extLst xmlns:a="http://schemas.openxmlformats.org/drawingml/2006/main">
               <a:ext uri="{FF2B5EF4-FFF2-40B4-BE49-F238E27FC236}">
-                <a16:creationId xmlns:a16="http://schemas.microsoft.com/office/drawing/2014/main" id="{815E771E-A856-4928-A380-546D3C5F6A8E}"/>
+                <a16:creationId xmlns:a16="http://schemas.microsoft.com/office/drawing/2014/main" id="{3354A0AB-FA91-44DE-A576-A76875E9CB79}"/>
               </a:ext>
             </a:extLst>
           </p:cNvPr>
@@ -6374,7 +6374,7 @@
           <p:cNvPr id="11" name="airlock-keyhole">
             <a:extLst xmlns:a="http://schemas.openxmlformats.org/drawingml/2006/main">
               <a:ext uri="{FF2B5EF4-FFF2-40B4-BE49-F238E27FC236}">
-                <a16:creationId xmlns:a16="http://schemas.microsoft.com/office/drawing/2014/main" id="{DF5AE351-4988-4BC1-947C-7AE43EC13AFD}"/>
+                <a16:creationId xmlns:a16="http://schemas.microsoft.com/office/drawing/2014/main" id="{3471CDBF-BE90-4BF6-BF49-39DA285828B1}"/>
               </a:ext>
             </a:extLst>
           </p:cNvPr>
@@ -6405,7 +6405,7 @@
           <p:cNvPr id="12" name="airlock-cross">
             <a:extLst xmlns:a="http://schemas.openxmlformats.org/drawingml/2006/main">
               <a:ext uri="{FF2B5EF4-FFF2-40B4-BE49-F238E27FC236}">
-                <a16:creationId xmlns:a16="http://schemas.microsoft.com/office/drawing/2014/main" id="{3D8FE4BF-E4F5-418B-8AD5-EE2136BEBE74}"/>
+                <a16:creationId xmlns:a16="http://schemas.microsoft.com/office/drawing/2014/main" id="{FDDBC0D5-0B4D-41E4-AC74-6252014D6A15}"/>
               </a:ext>
             </a:extLst>
           </p:cNvPr>
@@ -6450,7 +6450,7 @@
           <p:cNvPr id="13" name="setup-label">
             <a:extLst xmlns:a="http://schemas.openxmlformats.org/drawingml/2006/main">
               <a:ext uri="{FF2B5EF4-FFF2-40B4-BE49-F238E27FC236}">
-                <a16:creationId xmlns:a16="http://schemas.microsoft.com/office/drawing/2014/main" id="{55AD8D0F-322E-4CCF-8B04-E54936280223}"/>
+                <a16:creationId xmlns:a16="http://schemas.microsoft.com/office/drawing/2014/main" id="{8C519B78-92A1-421D-BE1A-ED989BF195E7}"/>
               </a:ext>
             </a:extLst>
           </p:cNvPr>
@@ -6495,7 +6495,7 @@
           <p:cNvPr id="14" name="setup-title">
             <a:extLst xmlns:a="http://schemas.openxmlformats.org/drawingml/2006/main">
               <a:ext uri="{FF2B5EF4-FFF2-40B4-BE49-F238E27FC236}">
-                <a16:creationId xmlns:a16="http://schemas.microsoft.com/office/drawing/2014/main" id="{B3737A57-3B6E-4610-8EB1-26F4106AF8A3}"/>
+                <a16:creationId xmlns:a16="http://schemas.microsoft.com/office/drawing/2014/main" id="{D3E7CFC8-B2A5-4E3C-9FAA-B84CE18467C1}"/>
               </a:ext>
             </a:extLst>
           </p:cNvPr>
@@ -6540,7 +6540,7 @@
           <p:cNvPr id="15" name="setup-command-1">
             <a:extLst xmlns:a="http://schemas.openxmlformats.org/drawingml/2006/main">
               <a:ext uri="{FF2B5EF4-FFF2-40B4-BE49-F238E27FC236}">
-                <a16:creationId xmlns:a16="http://schemas.microsoft.com/office/drawing/2014/main" id="{05700BBB-6015-40B5-ACA7-6F3F3BB0C9B8}"/>
+                <a16:creationId xmlns:a16="http://schemas.microsoft.com/office/drawing/2014/main" id="{A5A32461-C557-4B35-B31C-1783AA762670}"/>
               </a:ext>
             </a:extLst>
           </p:cNvPr>
@@ -6585,7 +6585,7 @@
           <p:cNvPr id="16" name="setup-command-2">
             <a:extLst xmlns:a="http://schemas.openxmlformats.org/drawingml/2006/main">
               <a:ext uri="{FF2B5EF4-FFF2-40B4-BE49-F238E27FC236}">
-                <a16:creationId xmlns:a16="http://schemas.microsoft.com/office/drawing/2014/main" id="{8C0A26B9-5703-44FC-99F3-1ED2AA31616C}"/>
+                <a16:creationId xmlns:a16="http://schemas.microsoft.com/office/drawing/2014/main" id="{45F03783-538C-4FA6-805A-EDD63299E600}"/>
               </a:ext>
             </a:extLst>
           </p:cNvPr>
@@ -6630,7 +6630,7 @@
           <p:cNvPr id="17" name="setup-command-3">
             <a:extLst xmlns:a="http://schemas.openxmlformats.org/drawingml/2006/main">
               <a:ext uri="{FF2B5EF4-FFF2-40B4-BE49-F238E27FC236}">
-                <a16:creationId xmlns:a16="http://schemas.microsoft.com/office/drawing/2014/main" id="{DD49538A-31F4-4627-8668-918069E5D712}"/>
+                <a16:creationId xmlns:a16="http://schemas.microsoft.com/office/drawing/2014/main" id="{A5B0A69D-69A8-4EA0-94C9-D2751A03A536}"/>
               </a:ext>
             </a:extLst>
           </p:cNvPr>
@@ -6675,7 +6675,7 @@
           <p:cNvPr id="18" name="setup-caption">
             <a:extLst xmlns:a="http://schemas.openxmlformats.org/drawingml/2006/main">
               <a:ext uri="{FF2B5EF4-FFF2-40B4-BE49-F238E27FC236}">
-                <a16:creationId xmlns:a16="http://schemas.microsoft.com/office/drawing/2014/main" id="{995F920B-1123-4468-888D-E1D90A0C5F8C}"/>
+                <a16:creationId xmlns:a16="http://schemas.microsoft.com/office/drawing/2014/main" id="{223F6D90-FB63-4883-9341-DCA4CB90206C}"/>
               </a:ext>
             </a:extLst>
           </p:cNvPr>
@@ -6721,7 +6721,7 @@
           <p:cNvPr id="19" name="check-label">
             <a:extLst xmlns:a="http://schemas.openxmlformats.org/drawingml/2006/main">
               <a:ext uri="{FF2B5EF4-FFF2-40B4-BE49-F238E27FC236}">
-                <a16:creationId xmlns:a16="http://schemas.microsoft.com/office/drawing/2014/main" id="{182F0058-960C-4B4A-BA63-4CFE4CD6D498}"/>
+                <a16:creationId xmlns:a16="http://schemas.microsoft.com/office/drawing/2014/main" id="{94C8EB80-B3B5-4A72-8134-F6318C769D5C}"/>
               </a:ext>
             </a:extLst>
           </p:cNvPr>
@@ -6766,7 +6766,7 @@
           <p:cNvPr id="20" name="check-title">
             <a:extLst xmlns:a="http://schemas.openxmlformats.org/drawingml/2006/main">
               <a:ext uri="{FF2B5EF4-FFF2-40B4-BE49-F238E27FC236}">
-                <a16:creationId xmlns:a16="http://schemas.microsoft.com/office/drawing/2014/main" id="{DF0505C5-DC11-485D-8B47-46A927313583}"/>
+                <a16:creationId xmlns:a16="http://schemas.microsoft.com/office/drawing/2014/main" id="{8CAA68FC-DA01-489B-9F9C-E19AC5883BF6}"/>
               </a:ext>
             </a:extLst>
           </p:cNvPr>
@@ -6811,7 +6811,7 @@
           <p:cNvPr id="21" name="check-list">
             <a:extLst xmlns:a="http://schemas.openxmlformats.org/drawingml/2006/main">
               <a:ext uri="{FF2B5EF4-FFF2-40B4-BE49-F238E27FC236}">
-                <a16:creationId xmlns:a16="http://schemas.microsoft.com/office/drawing/2014/main" id="{30FABE83-737C-4B08-BEEF-239AB1BCEFAA}"/>
+                <a16:creationId xmlns:a16="http://schemas.microsoft.com/office/drawing/2014/main" id="{2CD5F18C-59FE-4336-9BE7-19CA1BBEF7A3}"/>
               </a:ext>
             </a:extLst>
           </p:cNvPr>
@@ -6847,10 +6847,10 @@
             </a:pPr>
             <a:r>
               <a:t>credentials unset
-common network APIs blocked
-UV_OFFLINE=1
-NPM_CONFIG_OFFLINE=true
---offline + --frozen</a:t>
+network guards active
+uv sync --check
+uv run --no-sync
+offline + frozen</a:t>
             </a:r>
           </a:p>
         </p:txBody>
@@ -6860,7 +6860,7 @@
           <p:cNvPr id="22" name="airlock-caption">
             <a:extLst xmlns:a="http://schemas.openxmlformats.org/drawingml/2006/main">
               <a:ext uri="{FF2B5EF4-FFF2-40B4-BE49-F238E27FC236}">
-                <a16:creationId xmlns:a16="http://schemas.microsoft.com/office/drawing/2014/main" id="{70E539BF-D56D-454C-8BB0-FE2DD087064C}"/>
+                <a16:creationId xmlns:a16="http://schemas.microsoft.com/office/drawing/2014/main" id="{EDF7069D-D88F-4B17-9074-9FFDCDECF386}"/>
               </a:ext>
             </a:extLst>
           </p:cNvPr>
@@ -6905,7 +6905,7 @@
           <p:cNvPr id="23" name="airlock-note">
             <a:extLst xmlns:a="http://schemas.openxmlformats.org/drawingml/2006/main">
               <a:ext uri="{FF2B5EF4-FFF2-40B4-BE49-F238E27FC236}">
-                <a16:creationId xmlns:a16="http://schemas.microsoft.com/office/drawing/2014/main" id="{7F764050-3602-4DEA-990F-1DD8C52E3C27}"/>
+                <a16:creationId xmlns:a16="http://schemas.microsoft.com/office/drawing/2014/main" id="{FDCBB07C-CB75-4A65-9AF9-612ABDA9AE86}"/>
               </a:ext>
             </a:extLst>
           </p:cNvPr>
@@ -6948,7 +6948,7 @@
     </p:spTree>
     <p:extLst>
       <p:ext uri="{BB962C8B-B14F-4D97-AF65-F5344CB8AC3E}">
-        <p14:creationId xmlns:p14="http://schemas.microsoft.com/office/powerpoint/2010/main" val="946144322"/>
+        <p14:creationId xmlns:p14="http://schemas.microsoft.com/office/powerpoint/2010/main" val="748579617"/>
       </p:ext>
     </p:extLst>
   </p:cSld>
@@ -6979,7 +6979,7 @@
           <p:cNvPr id="1" name="kicker-5">
             <a:extLst xmlns:a="http://schemas.openxmlformats.org/drawingml/2006/main">
               <a:ext uri="{FF2B5EF4-FFF2-40B4-BE49-F238E27FC236}">
-                <a16:creationId xmlns:a16="http://schemas.microsoft.com/office/drawing/2014/main" id="{B28FEB0E-A8AF-4D5F-91A6-FD216DC94372}"/>
+                <a16:creationId xmlns:a16="http://schemas.microsoft.com/office/drawing/2014/main" id="{ACC9000A-9E81-4766-A108-904C43AE35D1}"/>
               </a:ext>
             </a:extLst>
           </p:cNvPr>
@@ -7024,7 +7024,7 @@
           <p:cNvPr id="2" name="title-5">
             <a:extLst xmlns:a="http://schemas.openxmlformats.org/drawingml/2006/main">
               <a:ext uri="{FF2B5EF4-FFF2-40B4-BE49-F238E27FC236}">
-                <a16:creationId xmlns:a16="http://schemas.microsoft.com/office/drawing/2014/main" id="{A791578E-852F-483D-AB04-84C5AACDDE66}"/>
+                <a16:creationId xmlns:a16="http://schemas.microsoft.com/office/drawing/2014/main" id="{8E25ACF5-EC3D-4F55-9EA1-791A8D3DF88E}"/>
               </a:ext>
             </a:extLst>
           </p:cNvPr>
@@ -7091,7 +7091,7 @@
           <p:cNvPr id="4" name="number-5">
             <a:extLst xmlns:a="http://schemas.openxmlformats.org/drawingml/2006/main">
               <a:ext uri="{FF2B5EF4-FFF2-40B4-BE49-F238E27FC236}">
-                <a16:creationId xmlns:a16="http://schemas.microsoft.com/office/drawing/2014/main" id="{39DE4954-0D1D-414A-B1DE-5BDEF85CBA35}"/>
+                <a16:creationId xmlns:a16="http://schemas.microsoft.com/office/drawing/2014/main" id="{7210FB53-02E1-4FC4-90E5-649F000A0440}"/>
               </a:ext>
             </a:extLst>
           </p:cNvPr>
@@ -7246,7 +7246,7 @@
           <p:cNvPr id="10" name="seam-ring-0">
             <a:extLst xmlns:a="http://schemas.openxmlformats.org/drawingml/2006/main">
               <a:ext uri="{FF2B5EF4-FFF2-40B4-BE49-F238E27FC236}">
-                <a16:creationId xmlns:a16="http://schemas.microsoft.com/office/drawing/2014/main" id="{999BF6D4-2DA1-4A9C-8092-40861C31DA85}"/>
+                <a16:creationId xmlns:a16="http://schemas.microsoft.com/office/drawing/2014/main" id="{2231DDC8-F88C-4D27-9782-9699BEDCE5B5}"/>
               </a:ext>
             </a:extLst>
           </p:cNvPr>
@@ -7279,7 +7279,7 @@
           <p:cNvPr id="11" name="seam-box-0">
             <a:extLst xmlns:a="http://schemas.openxmlformats.org/drawingml/2006/main">
               <a:ext uri="{FF2B5EF4-FFF2-40B4-BE49-F238E27FC236}">
-                <a16:creationId xmlns:a16="http://schemas.microsoft.com/office/drawing/2014/main" id="{8A36A6D4-B6AB-4A02-9D1F-52C9F3351388}"/>
+                <a16:creationId xmlns:a16="http://schemas.microsoft.com/office/drawing/2014/main" id="{FCF2D998-0B3E-4FCD-AD9A-ED3CC64AD56A}"/>
               </a:ext>
             </a:extLst>
           </p:cNvPr>
@@ -7314,7 +7314,7 @@
           <p:cNvPr id="12" name="seam-heading-0">
             <a:extLst xmlns:a="http://schemas.openxmlformats.org/drawingml/2006/main">
               <a:ext uri="{FF2B5EF4-FFF2-40B4-BE49-F238E27FC236}">
-                <a16:creationId xmlns:a16="http://schemas.microsoft.com/office/drawing/2014/main" id="{AD1B9C04-FB32-4342-ACDF-900FFC2B6A51}"/>
+                <a16:creationId xmlns:a16="http://schemas.microsoft.com/office/drawing/2014/main" id="{A45D7DAF-12AF-42CF-972E-D2893D7EDFCB}"/>
               </a:ext>
             </a:extLst>
           </p:cNvPr>
@@ -7359,7 +7359,7 @@
           <p:cNvPr id="13" name="seam-body-0">
             <a:extLst xmlns:a="http://schemas.openxmlformats.org/drawingml/2006/main">
               <a:ext uri="{FF2B5EF4-FFF2-40B4-BE49-F238E27FC236}">
-                <a16:creationId xmlns:a16="http://schemas.microsoft.com/office/drawing/2014/main" id="{F2CF28F9-8831-431B-A0E3-5E5EE0521A23}"/>
+                <a16:creationId xmlns:a16="http://schemas.microsoft.com/office/drawing/2014/main" id="{A085F50C-665F-4EF3-A10A-57DE06DE730A}"/>
               </a:ext>
             </a:extLst>
           </p:cNvPr>
@@ -7405,7 +7405,7 @@
           <p:cNvPr id="14" name="seam-ring-1">
             <a:extLst xmlns:a="http://schemas.openxmlformats.org/drawingml/2006/main">
               <a:ext uri="{FF2B5EF4-FFF2-40B4-BE49-F238E27FC236}">
-                <a16:creationId xmlns:a16="http://schemas.microsoft.com/office/drawing/2014/main" id="{8209CF97-5D71-40E6-B5FF-7A8A0F988A23}"/>
+                <a16:creationId xmlns:a16="http://schemas.microsoft.com/office/drawing/2014/main" id="{1A064165-8BA7-44BC-84FD-04F8DBFC5DE2}"/>
               </a:ext>
             </a:extLst>
           </p:cNvPr>
@@ -7438,7 +7438,7 @@
           <p:cNvPr id="15" name="seam-box-1">
             <a:extLst xmlns:a="http://schemas.openxmlformats.org/drawingml/2006/main">
               <a:ext uri="{FF2B5EF4-FFF2-40B4-BE49-F238E27FC236}">
-                <a16:creationId xmlns:a16="http://schemas.microsoft.com/office/drawing/2014/main" id="{C1AFEE93-385B-4396-AAFB-A44A217D30D0}"/>
+                <a16:creationId xmlns:a16="http://schemas.microsoft.com/office/drawing/2014/main" id="{CFF31DAC-64B7-4556-9C00-BFA6ADAAAA2C}"/>
               </a:ext>
             </a:extLst>
           </p:cNvPr>
@@ -7473,7 +7473,7 @@
           <p:cNvPr id="16" name="seam-heading-1">
             <a:extLst xmlns:a="http://schemas.openxmlformats.org/drawingml/2006/main">
               <a:ext uri="{FF2B5EF4-FFF2-40B4-BE49-F238E27FC236}">
-                <a16:creationId xmlns:a16="http://schemas.microsoft.com/office/drawing/2014/main" id="{06676C5C-9683-4BD6-880E-B68FE854AB59}"/>
+                <a16:creationId xmlns:a16="http://schemas.microsoft.com/office/drawing/2014/main" id="{D5F62FF8-3758-4C09-88D2-322D3E27145A}"/>
               </a:ext>
             </a:extLst>
           </p:cNvPr>
@@ -7508,7 +7508,7 @@
               </a:defRPr>
             </a:pPr>
             <a:r>
-              <a:t>NETWORK POLICY</a:t>
+              <a:t>LOCK + NETWORK</a:t>
             </a:r>
           </a:p>
         </p:txBody>
@@ -7518,7 +7518,7 @@
           <p:cNvPr id="17" name="seam-body-1">
             <a:extLst xmlns:a="http://schemas.openxmlformats.org/drawingml/2006/main">
               <a:ext uri="{FF2B5EF4-FFF2-40B4-BE49-F238E27FC236}">
-                <a16:creationId xmlns:a16="http://schemas.microsoft.com/office/drawing/2014/main" id="{FEAFBADE-E543-4E11-8CF0-F08F4AF41CEC}"/>
+                <a16:creationId xmlns:a16="http://schemas.microsoft.com/office/drawing/2014/main" id="{29CF7D31-32C4-4CE9-8EEA-4A2D3B2AFAE6}"/>
               </a:ext>
             </a:extLst>
           </p:cNvPr>
@@ -7553,8 +7553,8 @@
               </a:defRPr>
             </a:pPr>
             <a:r>
-              <a:t>Synthetic imports and fetch
-must be rejected</a:t>
+              <a:t>Full lock graph + source
+policy fail synthetically</a:t>
             </a:r>
           </a:p>
         </p:txBody>
@@ -7564,7 +7564,7 @@
           <p:cNvPr id="18" name="seam-ring-2">
             <a:extLst xmlns:a="http://schemas.openxmlformats.org/drawingml/2006/main">
               <a:ext uri="{FF2B5EF4-FFF2-40B4-BE49-F238E27FC236}">
-                <a16:creationId xmlns:a16="http://schemas.microsoft.com/office/drawing/2014/main" id="{CC741B0C-DE2E-49CD-8D93-078631AE67CF}"/>
+                <a16:creationId xmlns:a16="http://schemas.microsoft.com/office/drawing/2014/main" id="{48A8A6D5-8573-4773-9F89-A31DCEE55093}"/>
               </a:ext>
             </a:extLst>
           </p:cNvPr>
@@ -7597,7 +7597,7 @@
           <p:cNvPr id="19" name="seam-box-2">
             <a:extLst xmlns:a="http://schemas.openxmlformats.org/drawingml/2006/main">
               <a:ext uri="{FF2B5EF4-FFF2-40B4-BE49-F238E27FC236}">
-                <a16:creationId xmlns:a16="http://schemas.microsoft.com/office/drawing/2014/main" id="{C187CB9E-DFF5-4961-B712-27AB0388B082}"/>
+                <a16:creationId xmlns:a16="http://schemas.microsoft.com/office/drawing/2014/main" id="{EE5DBF93-F037-446D-A846-1B61AAB62D78}"/>
               </a:ext>
             </a:extLst>
           </p:cNvPr>
@@ -7632,7 +7632,7 @@
           <p:cNvPr id="20" name="seam-heading-2">
             <a:extLst xmlns:a="http://schemas.openxmlformats.org/drawingml/2006/main">
               <a:ext uri="{FF2B5EF4-FFF2-40B4-BE49-F238E27FC236}">
-                <a16:creationId xmlns:a16="http://schemas.microsoft.com/office/drawing/2014/main" id="{7C4B7CED-683A-4F14-877D-A432B41D58EA}"/>
+                <a16:creationId xmlns:a16="http://schemas.microsoft.com/office/drawing/2014/main" id="{68DE0423-1E76-4064-BE4A-9918DBF3D08A}"/>
               </a:ext>
             </a:extLst>
           </p:cNvPr>
@@ -7677,7 +7677,7 @@
           <p:cNvPr id="21" name="seam-body-2">
             <a:extLst xmlns:a="http://schemas.openxmlformats.org/drawingml/2006/main">
               <a:ext uri="{FF2B5EF4-FFF2-40B4-BE49-F238E27FC236}">
-                <a16:creationId xmlns:a16="http://schemas.microsoft.com/office/drawing/2014/main" id="{AC5F45A8-ED96-4FB6-A2F0-3E40F8C42397}"/>
+                <a16:creationId xmlns:a16="http://schemas.microsoft.com/office/drawing/2014/main" id="{87C70017-D59C-4CB5-8A66-87DB20987301}"/>
               </a:ext>
             </a:extLst>
           </p:cNvPr>
@@ -7723,7 +7723,7 @@
           <p:cNvPr id="22" name="seam-ring-3">
             <a:extLst xmlns:a="http://schemas.openxmlformats.org/drawingml/2006/main">
               <a:ext uri="{FF2B5EF4-FFF2-40B4-BE49-F238E27FC236}">
-                <a16:creationId xmlns:a16="http://schemas.microsoft.com/office/drawing/2014/main" id="{7901492F-A280-43F6-9B55-10729FFE2745}"/>
+                <a16:creationId xmlns:a16="http://schemas.microsoft.com/office/drawing/2014/main" id="{B7AC35AB-2413-4EF4-995D-9454511027A6}"/>
               </a:ext>
             </a:extLst>
           </p:cNvPr>
@@ -7756,7 +7756,7 @@
           <p:cNvPr id="23" name="seam-box-3">
             <a:extLst xmlns:a="http://schemas.openxmlformats.org/drawingml/2006/main">
               <a:ext uri="{FF2B5EF4-FFF2-40B4-BE49-F238E27FC236}">
-                <a16:creationId xmlns:a16="http://schemas.microsoft.com/office/drawing/2014/main" id="{E0DA26CC-786A-462F-9D77-B24F3BE8B302}"/>
+                <a16:creationId xmlns:a16="http://schemas.microsoft.com/office/drawing/2014/main" id="{CDBCAF35-5BAC-42BD-A35D-AA8859C516E8}"/>
               </a:ext>
             </a:extLst>
           </p:cNvPr>
@@ -7791,7 +7791,7 @@
           <p:cNvPr id="24" name="seam-heading-3">
             <a:extLst xmlns:a="http://schemas.openxmlformats.org/drawingml/2006/main">
               <a:ext uri="{FF2B5EF4-FFF2-40B4-BE49-F238E27FC236}">
-                <a16:creationId xmlns:a16="http://schemas.microsoft.com/office/drawing/2014/main" id="{C9A966B4-86CB-4BBB-A849-525CC9293FE1}"/>
+                <a16:creationId xmlns:a16="http://schemas.microsoft.com/office/drawing/2014/main" id="{CDCE6591-E675-49E6-B02F-8275644D4A0B}"/>
               </a:ext>
             </a:extLst>
           </p:cNvPr>
@@ -7836,7 +7836,7 @@
           <p:cNvPr id="25" name="seam-body-3">
             <a:extLst xmlns:a="http://schemas.openxmlformats.org/drawingml/2006/main">
               <a:ext uri="{FF2B5EF4-FFF2-40B4-BE49-F238E27FC236}">
-                <a16:creationId xmlns:a16="http://schemas.microsoft.com/office/drawing/2014/main" id="{96CAA593-3DD5-4402-A10D-B6AC57E60C43}"/>
+                <a16:creationId xmlns:a16="http://schemas.microsoft.com/office/drawing/2014/main" id="{910D7018-7295-4CCA-BD99-3351AD74D9EF}"/>
               </a:ext>
             </a:extLst>
           </p:cNvPr>
@@ -7882,7 +7882,7 @@
           <p:cNvPr id="26" name="seam-python">
             <a:extLst xmlns:a="http://schemas.openxmlformats.org/drawingml/2006/main">
               <a:ext uri="{FF2B5EF4-FFF2-40B4-BE49-F238E27FC236}">
-                <a16:creationId xmlns:a16="http://schemas.microsoft.com/office/drawing/2014/main" id="{239AACA7-A640-4F3E-A501-50E61F9A3747}"/>
+                <a16:creationId xmlns:a16="http://schemas.microsoft.com/office/drawing/2014/main" id="{256E6958-ACA4-4D4A-86DA-1B13E5351DF8}"/>
               </a:ext>
             </a:extLst>
           </p:cNvPr>
@@ -7927,7 +7927,7 @@
           <p:cNvPr id="27" name="seam-tui">
             <a:extLst xmlns:a="http://schemas.openxmlformats.org/drawingml/2006/main">
               <a:ext uri="{FF2B5EF4-FFF2-40B4-BE49-F238E27FC236}">
-                <a16:creationId xmlns:a16="http://schemas.microsoft.com/office/drawing/2014/main" id="{78C02B01-7B03-4B9D-8FB2-A456DA7ABE16}"/>
+                <a16:creationId xmlns:a16="http://schemas.microsoft.com/office/drawing/2014/main" id="{D0AC0B8E-3B7E-43F6-B09B-C2C6616D8E06}"/>
               </a:ext>
             </a:extLst>
           </p:cNvPr>
@@ -7972,7 +7972,7 @@
           <p:cNvPr id="28" name="seam-footer">
             <a:extLst xmlns:a="http://schemas.openxmlformats.org/drawingml/2006/main">
               <a:ext uri="{FF2B5EF4-FFF2-40B4-BE49-F238E27FC236}">
-                <a16:creationId xmlns:a16="http://schemas.microsoft.com/office/drawing/2014/main" id="{182C4A7D-0ED4-4FAD-BF64-68CF32F502BD}"/>
+                <a16:creationId xmlns:a16="http://schemas.microsoft.com/office/drawing/2014/main" id="{77AC4F11-CEDA-492A-984F-621F1C031C1E}"/>
               </a:ext>
             </a:extLst>
           </p:cNvPr>
@@ -8003,7 +8003,7 @@
           <p:cNvPr id="29" name="seam-footer-text">
             <a:extLst xmlns:a="http://schemas.openxmlformats.org/drawingml/2006/main">
               <a:ext uri="{FF2B5EF4-FFF2-40B4-BE49-F238E27FC236}">
-                <a16:creationId xmlns:a16="http://schemas.microsoft.com/office/drawing/2014/main" id="{D0012DDD-F763-4AF1-83D5-1C2121264E78}"/>
+                <a16:creationId xmlns:a16="http://schemas.microsoft.com/office/drawing/2014/main" id="{F5749E4C-E42B-4B24-B73B-F5850C700CD8}"/>
               </a:ext>
             </a:extLst>
           </p:cNvPr>
@@ -8046,7 +8046,7 @@
     </p:spTree>
     <p:extLst>
       <p:ext uri="{BB962C8B-B14F-4D97-AF65-F5344CB8AC3E}">
-        <p14:creationId xmlns:p14="http://schemas.microsoft.com/office/powerpoint/2010/main" val="1928558380"/>
+        <p14:creationId xmlns:p14="http://schemas.microsoft.com/office/powerpoint/2010/main" val="1627273324"/>
       </p:ext>
     </p:extLst>
   </p:cSld>
@@ -8077,7 +8077,7 @@
           <p:cNvPr id="1" name="kicker-6">
             <a:extLst xmlns:a="http://schemas.openxmlformats.org/drawingml/2006/main">
               <a:ext uri="{FF2B5EF4-FFF2-40B4-BE49-F238E27FC236}">
-                <a16:creationId xmlns:a16="http://schemas.microsoft.com/office/drawing/2014/main" id="{4B17380F-7AA6-492D-B761-133F305A0A0F}"/>
+                <a16:creationId xmlns:a16="http://schemas.microsoft.com/office/drawing/2014/main" id="{43F55FFE-4C74-4B70-91A8-CC6F628AD909}"/>
               </a:ext>
             </a:extLst>
           </p:cNvPr>
@@ -8122,7 +8122,7 @@
           <p:cNvPr id="2" name="title-6">
             <a:extLst xmlns:a="http://schemas.openxmlformats.org/drawingml/2006/main">
               <a:ext uri="{FF2B5EF4-FFF2-40B4-BE49-F238E27FC236}">
-                <a16:creationId xmlns:a16="http://schemas.microsoft.com/office/drawing/2014/main" id="{1FD0DEC2-91A8-41FD-A96E-382895176990}"/>
+                <a16:creationId xmlns:a16="http://schemas.microsoft.com/office/drawing/2014/main" id="{BB8CC27F-2D9B-44DA-A0BC-75379114B54F}"/>
               </a:ext>
             </a:extLst>
           </p:cNvPr>
@@ -8189,7 +8189,7 @@
           <p:cNvPr id="4" name="number-6">
             <a:extLst xmlns:a="http://schemas.openxmlformats.org/drawingml/2006/main">
               <a:ext uri="{FF2B5EF4-FFF2-40B4-BE49-F238E27FC236}">
-                <a16:creationId xmlns:a16="http://schemas.microsoft.com/office/drawing/2014/main" id="{0FCBB5C8-642D-473A-9424-F7411F9C7C6A}"/>
+                <a16:creationId xmlns:a16="http://schemas.microsoft.com/office/drawing/2014/main" id="{D2B7F43C-B93B-4F34-BE71-C76A9E8183CE}"/>
               </a:ext>
             </a:extLst>
           </p:cNvPr>
@@ -8234,7 +8234,7 @@
           <p:cNvPr id="5" name="ci-arrow">
             <a:extLst xmlns:a="http://schemas.openxmlformats.org/drawingml/2006/main">
               <a:ext uri="{FF2B5EF4-FFF2-40B4-BE49-F238E27FC236}">
-                <a16:creationId xmlns:a16="http://schemas.microsoft.com/office/drawing/2014/main" id="{F7F0702A-69BE-4C49-8E4E-86390C22685B}"/>
+                <a16:creationId xmlns:a16="http://schemas.microsoft.com/office/drawing/2014/main" id="{E7665944-6F2A-4B85-8220-1661B7A1658F}"/>
               </a:ext>
             </a:extLst>
           </p:cNvPr>
@@ -8287,7 +8287,7 @@
           <p:cNvPr id="7" name="ci-setup">
             <a:extLst xmlns:a="http://schemas.openxmlformats.org/drawingml/2006/main">
               <a:ext uri="{FF2B5EF4-FFF2-40B4-BE49-F238E27FC236}">
-                <a16:creationId xmlns:a16="http://schemas.microsoft.com/office/drawing/2014/main" id="{40A203A3-DE09-4969-B84F-D972D3F0A5C5}"/>
+                <a16:creationId xmlns:a16="http://schemas.microsoft.com/office/drawing/2014/main" id="{AFF22DDB-C244-4FE4-8513-EAF8D51029B8}"/>
               </a:ext>
             </a:extLst>
           </p:cNvPr>
@@ -8322,7 +8322,7 @@
           <p:cNvPr id="8" name="ci-command">
             <a:extLst xmlns:a="http://schemas.openxmlformats.org/drawingml/2006/main">
               <a:ext uri="{FF2B5EF4-FFF2-40B4-BE49-F238E27FC236}">
-                <a16:creationId xmlns:a16="http://schemas.microsoft.com/office/drawing/2014/main" id="{C8C770B1-7604-46B1-97A4-CA539A3D1703}"/>
+                <a16:creationId xmlns:a16="http://schemas.microsoft.com/office/drawing/2014/main" id="{BAFEB842-801E-4161-9795-8CCCA1CA5F6F}"/>
               </a:ext>
             </a:extLst>
           </p:cNvPr>
@@ -8357,7 +8357,7 @@
           <p:cNvPr id="9" name="ci-left-kicker">
             <a:extLst xmlns:a="http://schemas.openxmlformats.org/drawingml/2006/main">
               <a:ext uri="{FF2B5EF4-FFF2-40B4-BE49-F238E27FC236}">
-                <a16:creationId xmlns:a16="http://schemas.microsoft.com/office/drawing/2014/main" id="{3B75AA1E-17A8-4E96-96BF-266BC79D169A}"/>
+                <a16:creationId xmlns:a16="http://schemas.microsoft.com/office/drawing/2014/main" id="{AA6E9DED-439F-43DA-87E3-5A5FCF808C6D}"/>
               </a:ext>
             </a:extLst>
           </p:cNvPr>
@@ -8402,7 +8402,7 @@
           <p:cNvPr id="10" name="ci-left-title">
             <a:extLst xmlns:a="http://schemas.openxmlformats.org/drawingml/2006/main">
               <a:ext uri="{FF2B5EF4-FFF2-40B4-BE49-F238E27FC236}">
-                <a16:creationId xmlns:a16="http://schemas.microsoft.com/office/drawing/2014/main" id="{EE6304CF-C1E0-42F9-92F7-9F3C295098A4}"/>
+                <a16:creationId xmlns:a16="http://schemas.microsoft.com/office/drawing/2014/main" id="{E0E81428-26AD-4DF9-994F-4CE7ACA7F6E0}"/>
               </a:ext>
             </a:extLst>
           </p:cNvPr>
@@ -8447,7 +8447,7 @@
           <p:cNvPr id="11" name="ci-left-list">
             <a:extLst xmlns:a="http://schemas.openxmlformats.org/drawingml/2006/main">
               <a:ext uri="{FF2B5EF4-FFF2-40B4-BE49-F238E27FC236}">
-                <a16:creationId xmlns:a16="http://schemas.microsoft.com/office/drawing/2014/main" id="{23622C10-2E71-4EFF-8F73-DD3781466E21}"/>
+                <a16:creationId xmlns:a16="http://schemas.microsoft.com/office/drawing/2014/main" id="{F17598B5-4449-4CD6-8312-593706C41176}"/>
               </a:ext>
             </a:extLst>
           </p:cNvPr>
@@ -8497,7 +8497,7 @@
           <p:cNvPr id="12" name="ci-right-kicker">
             <a:extLst xmlns:a="http://schemas.openxmlformats.org/drawingml/2006/main">
               <a:ext uri="{FF2B5EF4-FFF2-40B4-BE49-F238E27FC236}">
-                <a16:creationId xmlns:a16="http://schemas.microsoft.com/office/drawing/2014/main" id="{7D5B335B-CEA0-4625-B36A-535810EE5F3E}"/>
+                <a16:creationId xmlns:a16="http://schemas.microsoft.com/office/drawing/2014/main" id="{E89578F9-8347-465C-9E5B-2D2D5E096C7F}"/>
               </a:ext>
             </a:extLst>
           </p:cNvPr>
@@ -8542,7 +8542,7 @@
           <p:cNvPr id="13" name="ci-right-command">
             <a:extLst xmlns:a="http://schemas.openxmlformats.org/drawingml/2006/main">
               <a:ext uri="{FF2B5EF4-FFF2-40B4-BE49-F238E27FC236}">
-                <a16:creationId xmlns:a16="http://schemas.microsoft.com/office/drawing/2014/main" id="{AC80335B-92E1-4C80-B050-A61525DECB18}"/>
+                <a16:creationId xmlns:a16="http://schemas.microsoft.com/office/drawing/2014/main" id="{7A6AE12A-2702-41A4-A9AC-8BA2CC49C1F5}"/>
               </a:ext>
             </a:extLst>
           </p:cNvPr>
@@ -8609,7 +8609,7 @@
           <p:cNvPr id="15" name="ci-right-caption">
             <a:extLst xmlns:a="http://schemas.openxmlformats.org/drawingml/2006/main">
               <a:ext uri="{FF2B5EF4-FFF2-40B4-BE49-F238E27FC236}">
-                <a16:creationId xmlns:a16="http://schemas.microsoft.com/office/drawing/2014/main" id="{A14C72EC-6706-405B-9301-23727EC49CCD}"/>
+                <a16:creationId xmlns:a16="http://schemas.microsoft.com/office/drawing/2014/main" id="{7FB31738-5C50-418E-B87E-E7C6C4D759BA}"/>
               </a:ext>
             </a:extLst>
           </p:cNvPr>
@@ -8655,7 +8655,7 @@
           <p:cNvPr id="16" name="ci-footer">
             <a:extLst xmlns:a="http://schemas.openxmlformats.org/drawingml/2006/main">
               <a:ext uri="{FF2B5EF4-FFF2-40B4-BE49-F238E27FC236}">
-                <a16:creationId xmlns:a16="http://schemas.microsoft.com/office/drawing/2014/main" id="{22DADFEA-CF1D-4856-90D5-83698E276A4F}"/>
+                <a16:creationId xmlns:a16="http://schemas.microsoft.com/office/drawing/2014/main" id="{97543948-42D6-4E4A-A559-8DEA26373DAE}"/>
               </a:ext>
             </a:extLst>
           </p:cNvPr>
@@ -8698,7 +8698,7 @@
     </p:spTree>
     <p:extLst>
       <p:ext uri="{BB962C8B-B14F-4D97-AF65-F5344CB8AC3E}">
-        <p14:creationId xmlns:p14="http://schemas.microsoft.com/office/powerpoint/2010/main" val="1159120414"/>
+        <p14:creationId xmlns:p14="http://schemas.microsoft.com/office/powerpoint/2010/main" val="1879814007"/>
       </p:ext>
     </p:extLst>
   </p:cSld>
@@ -8729,7 +8729,7 @@
           <p:cNvPr id="1" name="kicker-7">
             <a:extLst xmlns:a="http://schemas.openxmlformats.org/drawingml/2006/main">
               <a:ext uri="{FF2B5EF4-FFF2-40B4-BE49-F238E27FC236}">
-                <a16:creationId xmlns:a16="http://schemas.microsoft.com/office/drawing/2014/main" id="{00A724E8-52CC-4C0D-8B22-3E033CF734BA}"/>
+                <a16:creationId xmlns:a16="http://schemas.microsoft.com/office/drawing/2014/main" id="{2D4C6F90-3C5E-4521-A91F-F8CBFD9EB6D8}"/>
               </a:ext>
             </a:extLst>
           </p:cNvPr>
@@ -8774,7 +8774,7 @@
           <p:cNvPr id="2" name="title-7">
             <a:extLst xmlns:a="http://schemas.openxmlformats.org/drawingml/2006/main">
               <a:ext uri="{FF2B5EF4-FFF2-40B4-BE49-F238E27FC236}">
-                <a16:creationId xmlns:a16="http://schemas.microsoft.com/office/drawing/2014/main" id="{9724D7D3-845B-4BCA-983F-F9BE7548840B}"/>
+                <a16:creationId xmlns:a16="http://schemas.microsoft.com/office/drawing/2014/main" id="{299A68C4-68EB-4338-954E-BEAE4E6BF9AE}"/>
               </a:ext>
             </a:extLst>
           </p:cNvPr>
@@ -8841,7 +8841,7 @@
           <p:cNvPr id="4" name="number-7">
             <a:extLst xmlns:a="http://schemas.openxmlformats.org/drawingml/2006/main">
               <a:ext uri="{FF2B5EF4-FFF2-40B4-BE49-F238E27FC236}">
-                <a16:creationId xmlns:a16="http://schemas.microsoft.com/office/drawing/2014/main" id="{515AAC60-6C65-4965-ACD1-FBE8A70D561F}"/>
+                <a16:creationId xmlns:a16="http://schemas.microsoft.com/office/drawing/2014/main" id="{77B105FB-B62B-41B8-A488-590505C68CC5}"/>
               </a:ext>
             </a:extLst>
           </p:cNvPr>
@@ -8908,7 +8908,7 @@
           <p:cNvPr id="6" name="lab-bulb-0">
             <a:extLst xmlns:a="http://schemas.openxmlformats.org/drawingml/2006/main">
               <a:ext uri="{FF2B5EF4-FFF2-40B4-BE49-F238E27FC236}">
-                <a16:creationId xmlns:a16="http://schemas.microsoft.com/office/drawing/2014/main" id="{137B6525-E5D1-4B72-AF52-E3A928A41CC9}"/>
+                <a16:creationId xmlns:a16="http://schemas.microsoft.com/office/drawing/2014/main" id="{9D788C39-56F3-49E7-A02F-21765266C560}"/>
               </a:ext>
             </a:extLst>
           </p:cNvPr>
@@ -8939,7 +8939,7 @@
           <p:cNvPr id="7" name="lab-flag-0">
             <a:extLst xmlns:a="http://schemas.openxmlformats.org/drawingml/2006/main">
               <a:ext uri="{FF2B5EF4-FFF2-40B4-BE49-F238E27FC236}">
-                <a16:creationId xmlns:a16="http://schemas.microsoft.com/office/drawing/2014/main" id="{C01075F5-64E5-4031-9137-8CF9DA06197E}"/>
+                <a16:creationId xmlns:a16="http://schemas.microsoft.com/office/drawing/2014/main" id="{45EA7C0E-12C1-4882-943D-BAC59FC1424F}"/>
               </a:ext>
             </a:extLst>
           </p:cNvPr>
@@ -8974,7 +8974,7 @@
           <p:cNvPr id="8" name="lab-icon-0">
             <a:extLst xmlns:a="http://schemas.openxmlformats.org/drawingml/2006/main">
               <a:ext uri="{FF2B5EF4-FFF2-40B4-BE49-F238E27FC236}">
-                <a16:creationId xmlns:a16="http://schemas.microsoft.com/office/drawing/2014/main" id="{CA7A4807-1EAC-492B-B4D4-CCC3744F4BB8}"/>
+                <a16:creationId xmlns:a16="http://schemas.microsoft.com/office/drawing/2014/main" id="{2905D9BB-FC0A-4A7D-BDCB-91F8F1365322}"/>
               </a:ext>
             </a:extLst>
           </p:cNvPr>
@@ -9019,7 +9019,7 @@
           <p:cNvPr id="9" name="lab-heading-0">
             <a:extLst xmlns:a="http://schemas.openxmlformats.org/drawingml/2006/main">
               <a:ext uri="{FF2B5EF4-FFF2-40B4-BE49-F238E27FC236}">
-                <a16:creationId xmlns:a16="http://schemas.microsoft.com/office/drawing/2014/main" id="{4A89FFA2-1FA3-4D89-9C27-9662D4BFDBFB}"/>
+                <a16:creationId xmlns:a16="http://schemas.microsoft.com/office/drawing/2014/main" id="{E4BC36A4-D45E-4506-8186-926BC10684D2}"/>
               </a:ext>
             </a:extLst>
           </p:cNvPr>
@@ -9064,7 +9064,7 @@
           <p:cNvPr id="10" name="lab-failure-0">
             <a:extLst xmlns:a="http://schemas.openxmlformats.org/drawingml/2006/main">
               <a:ext uri="{FF2B5EF4-FFF2-40B4-BE49-F238E27FC236}">
-                <a16:creationId xmlns:a16="http://schemas.microsoft.com/office/drawing/2014/main" id="{93AF1F82-6C25-4D15-8E20-8C1A97DC7675}"/>
+                <a16:creationId xmlns:a16="http://schemas.microsoft.com/office/drawing/2014/main" id="{51C57580-99DB-4F4D-B00C-3D601BF3DB7E}"/>
               </a:ext>
             </a:extLst>
           </p:cNvPr>
@@ -9109,7 +9109,7 @@
           <p:cNvPr id="11" name="lab-stop-0">
             <a:extLst xmlns:a="http://schemas.openxmlformats.org/drawingml/2006/main">
               <a:ext uri="{FF2B5EF4-FFF2-40B4-BE49-F238E27FC236}">
-                <a16:creationId xmlns:a16="http://schemas.microsoft.com/office/drawing/2014/main" id="{2D8E0D44-9199-493D-AE1A-CA518939B9FE}"/>
+                <a16:creationId xmlns:a16="http://schemas.microsoft.com/office/drawing/2014/main" id="{6910B525-8A47-4986-B7BE-765B9A8103B6}"/>
               </a:ext>
             </a:extLst>
           </p:cNvPr>
@@ -9176,7 +9176,7 @@
           <p:cNvPr id="13" name="lab-bulb-1">
             <a:extLst xmlns:a="http://schemas.openxmlformats.org/drawingml/2006/main">
               <a:ext uri="{FF2B5EF4-FFF2-40B4-BE49-F238E27FC236}">
-                <a16:creationId xmlns:a16="http://schemas.microsoft.com/office/drawing/2014/main" id="{D4C7741D-60D1-45BE-AA7F-656430952983}"/>
+                <a16:creationId xmlns:a16="http://schemas.microsoft.com/office/drawing/2014/main" id="{76879BCB-897B-417B-9846-8C018DF9E153}"/>
               </a:ext>
             </a:extLst>
           </p:cNvPr>
@@ -9207,7 +9207,7 @@
           <p:cNvPr id="14" name="lab-flag-1">
             <a:extLst xmlns:a="http://schemas.openxmlformats.org/drawingml/2006/main">
               <a:ext uri="{FF2B5EF4-FFF2-40B4-BE49-F238E27FC236}">
-                <a16:creationId xmlns:a16="http://schemas.microsoft.com/office/drawing/2014/main" id="{F00EE6B3-198E-4B09-9380-12AAC71A1C0E}"/>
+                <a16:creationId xmlns:a16="http://schemas.microsoft.com/office/drawing/2014/main" id="{F6EC77D6-9CE5-4DE8-856D-EAC26F7BE4D0}"/>
               </a:ext>
             </a:extLst>
           </p:cNvPr>
@@ -9242,7 +9242,7 @@
           <p:cNvPr id="15" name="lab-icon-1">
             <a:extLst xmlns:a="http://schemas.openxmlformats.org/drawingml/2006/main">
               <a:ext uri="{FF2B5EF4-FFF2-40B4-BE49-F238E27FC236}">
-                <a16:creationId xmlns:a16="http://schemas.microsoft.com/office/drawing/2014/main" id="{97E7E3F5-2E02-4A1E-B8E2-7D1513186CAC}"/>
+                <a16:creationId xmlns:a16="http://schemas.microsoft.com/office/drawing/2014/main" id="{C7687521-86E8-4A10-A665-AF94703D7B99}"/>
               </a:ext>
             </a:extLst>
           </p:cNvPr>
@@ -9287,7 +9287,7 @@
           <p:cNvPr id="16" name="lab-heading-1">
             <a:extLst xmlns:a="http://schemas.openxmlformats.org/drawingml/2006/main">
               <a:ext uri="{FF2B5EF4-FFF2-40B4-BE49-F238E27FC236}">
-                <a16:creationId xmlns:a16="http://schemas.microsoft.com/office/drawing/2014/main" id="{D85DDAE5-5FE7-4A4E-9EDD-05E14FC743B9}"/>
+                <a16:creationId xmlns:a16="http://schemas.microsoft.com/office/drawing/2014/main" id="{83E0A27D-61DA-45F7-A6EF-507B02203A7A}"/>
               </a:ext>
             </a:extLst>
           </p:cNvPr>
@@ -9332,7 +9332,7 @@
           <p:cNvPr id="17" name="lab-failure-1">
             <a:extLst xmlns:a="http://schemas.openxmlformats.org/drawingml/2006/main">
               <a:ext uri="{FF2B5EF4-FFF2-40B4-BE49-F238E27FC236}">
-                <a16:creationId xmlns:a16="http://schemas.microsoft.com/office/drawing/2014/main" id="{1CAC0ED4-C468-4B9B-9921-8BEB1EF708FA}"/>
+                <a16:creationId xmlns:a16="http://schemas.microsoft.com/office/drawing/2014/main" id="{6003D00E-1995-41A8-863B-392749563E80}"/>
               </a:ext>
             </a:extLst>
           </p:cNvPr>
@@ -9377,7 +9377,7 @@
           <p:cNvPr id="18" name="lab-stop-1">
             <a:extLst xmlns:a="http://schemas.openxmlformats.org/drawingml/2006/main">
               <a:ext uri="{FF2B5EF4-FFF2-40B4-BE49-F238E27FC236}">
-                <a16:creationId xmlns:a16="http://schemas.microsoft.com/office/drawing/2014/main" id="{55FD9903-3D5E-47FE-8785-89D307022137}"/>
+                <a16:creationId xmlns:a16="http://schemas.microsoft.com/office/drawing/2014/main" id="{5A9517D1-AE02-46FF-917B-7880539B8678}"/>
               </a:ext>
             </a:extLst>
           </p:cNvPr>
@@ -9444,7 +9444,7 @@
           <p:cNvPr id="20" name="lab-bulb-2">
             <a:extLst xmlns:a="http://schemas.openxmlformats.org/drawingml/2006/main">
               <a:ext uri="{FF2B5EF4-FFF2-40B4-BE49-F238E27FC236}">
-                <a16:creationId xmlns:a16="http://schemas.microsoft.com/office/drawing/2014/main" id="{3F1B8D67-C565-44F3-B14E-ECD4C1360FA9}"/>
+                <a16:creationId xmlns:a16="http://schemas.microsoft.com/office/drawing/2014/main" id="{3337612A-BE39-4634-B189-E0B44B376230}"/>
               </a:ext>
             </a:extLst>
           </p:cNvPr>
@@ -9475,7 +9475,7 @@
           <p:cNvPr id="21" name="lab-flag-2">
             <a:extLst xmlns:a="http://schemas.openxmlformats.org/drawingml/2006/main">
               <a:ext uri="{FF2B5EF4-FFF2-40B4-BE49-F238E27FC236}">
-                <a16:creationId xmlns:a16="http://schemas.microsoft.com/office/drawing/2014/main" id="{80690A10-B4EA-4B18-A7DC-424FAA9C037E}"/>
+                <a16:creationId xmlns:a16="http://schemas.microsoft.com/office/drawing/2014/main" id="{ED08948B-AF7B-4329-8BEE-6F75E04A4B3C}"/>
               </a:ext>
             </a:extLst>
           </p:cNvPr>
@@ -9510,7 +9510,7 @@
           <p:cNvPr id="22" name="lab-icon-2">
             <a:extLst xmlns:a="http://schemas.openxmlformats.org/drawingml/2006/main">
               <a:ext uri="{FF2B5EF4-FFF2-40B4-BE49-F238E27FC236}">
-                <a16:creationId xmlns:a16="http://schemas.microsoft.com/office/drawing/2014/main" id="{41416BCE-FFC5-4EA2-A8FA-72FF2479D919}"/>
+                <a16:creationId xmlns:a16="http://schemas.microsoft.com/office/drawing/2014/main" id="{7BE493FF-0C4E-4E4C-8D1F-E06E572844F9}"/>
               </a:ext>
             </a:extLst>
           </p:cNvPr>
@@ -9555,7 +9555,7 @@
           <p:cNvPr id="23" name="lab-heading-2">
             <a:extLst xmlns:a="http://schemas.openxmlformats.org/drawingml/2006/main">
               <a:ext uri="{FF2B5EF4-FFF2-40B4-BE49-F238E27FC236}">
-                <a16:creationId xmlns:a16="http://schemas.microsoft.com/office/drawing/2014/main" id="{9042149F-CDEF-4B84-BA78-38424575B0B5}"/>
+                <a16:creationId xmlns:a16="http://schemas.microsoft.com/office/drawing/2014/main" id="{C798A91D-1945-4A1E-BD8B-70E609AF5F2C}"/>
               </a:ext>
             </a:extLst>
           </p:cNvPr>
@@ -9600,7 +9600,7 @@
           <p:cNvPr id="24" name="lab-failure-2">
             <a:extLst xmlns:a="http://schemas.openxmlformats.org/drawingml/2006/main">
               <a:ext uri="{FF2B5EF4-FFF2-40B4-BE49-F238E27FC236}">
-                <a16:creationId xmlns:a16="http://schemas.microsoft.com/office/drawing/2014/main" id="{5443DD54-428A-4216-8528-EC2330D62177}"/>
+                <a16:creationId xmlns:a16="http://schemas.microsoft.com/office/drawing/2014/main" id="{932404CE-1042-4753-ABB4-981DECB20239}"/>
               </a:ext>
             </a:extLst>
           </p:cNvPr>
@@ -9645,7 +9645,7 @@
           <p:cNvPr id="25" name="lab-stop-2">
             <a:extLst xmlns:a="http://schemas.openxmlformats.org/drawingml/2006/main">
               <a:ext uri="{FF2B5EF4-FFF2-40B4-BE49-F238E27FC236}">
-                <a16:creationId xmlns:a16="http://schemas.microsoft.com/office/drawing/2014/main" id="{3FFC0EB2-F734-443B-AFE7-7EBACA87CDE6}"/>
+                <a16:creationId xmlns:a16="http://schemas.microsoft.com/office/drawing/2014/main" id="{327CC484-FBF7-4C1E-A383-0740CAEF22C0}"/>
               </a:ext>
             </a:extLst>
           </p:cNvPr>
@@ -9712,7 +9712,7 @@
           <p:cNvPr id="27" name="lab-bulb-3">
             <a:extLst xmlns:a="http://schemas.openxmlformats.org/drawingml/2006/main">
               <a:ext uri="{FF2B5EF4-FFF2-40B4-BE49-F238E27FC236}">
-                <a16:creationId xmlns:a16="http://schemas.microsoft.com/office/drawing/2014/main" id="{8473A9D8-1CD2-45E1-AA5B-0176B35533E0}"/>
+                <a16:creationId xmlns:a16="http://schemas.microsoft.com/office/drawing/2014/main" id="{FA5B6E49-6066-4BFA-B4C8-B6652D701E44}"/>
               </a:ext>
             </a:extLst>
           </p:cNvPr>
@@ -9743,7 +9743,7 @@
           <p:cNvPr id="28" name="lab-flag-3">
             <a:extLst xmlns:a="http://schemas.openxmlformats.org/drawingml/2006/main">
               <a:ext uri="{FF2B5EF4-FFF2-40B4-BE49-F238E27FC236}">
-                <a16:creationId xmlns:a16="http://schemas.microsoft.com/office/drawing/2014/main" id="{9B8BA186-D464-44EF-8C97-55E6EF7A574E}"/>
+                <a16:creationId xmlns:a16="http://schemas.microsoft.com/office/drawing/2014/main" id="{93D469C5-094C-451F-A002-2A83B01BEC13}"/>
               </a:ext>
             </a:extLst>
           </p:cNvPr>
@@ -9778,7 +9778,7 @@
           <p:cNvPr id="29" name="lab-icon-3">
             <a:extLst xmlns:a="http://schemas.openxmlformats.org/drawingml/2006/main">
               <a:ext uri="{FF2B5EF4-FFF2-40B4-BE49-F238E27FC236}">
-                <a16:creationId xmlns:a16="http://schemas.microsoft.com/office/drawing/2014/main" id="{C681743A-6FF6-441B-9BB7-AA7291385C1F}"/>
+                <a16:creationId xmlns:a16="http://schemas.microsoft.com/office/drawing/2014/main" id="{80B33F51-3995-423D-A120-6B7A13D339C6}"/>
               </a:ext>
             </a:extLst>
           </p:cNvPr>
@@ -9823,7 +9823,7 @@
           <p:cNvPr id="30" name="lab-heading-3">
             <a:extLst xmlns:a="http://schemas.openxmlformats.org/drawingml/2006/main">
               <a:ext uri="{FF2B5EF4-FFF2-40B4-BE49-F238E27FC236}">
-                <a16:creationId xmlns:a16="http://schemas.microsoft.com/office/drawing/2014/main" id="{B4E61C3A-538C-48D6-AA96-44CFF971308F}"/>
+                <a16:creationId xmlns:a16="http://schemas.microsoft.com/office/drawing/2014/main" id="{0E60649B-C720-450C-AE9D-FE9C78FA19EC}"/>
               </a:ext>
             </a:extLst>
           </p:cNvPr>
@@ -9868,7 +9868,7 @@
           <p:cNvPr id="31" name="lab-failure-3">
             <a:extLst xmlns:a="http://schemas.openxmlformats.org/drawingml/2006/main">
               <a:ext uri="{FF2B5EF4-FFF2-40B4-BE49-F238E27FC236}">
-                <a16:creationId xmlns:a16="http://schemas.microsoft.com/office/drawing/2014/main" id="{F38EA6DF-4D59-4B7D-90D3-773AFA0E6206}"/>
+                <a16:creationId xmlns:a16="http://schemas.microsoft.com/office/drawing/2014/main" id="{789A3FEC-2E2F-4DE7-8E93-5E15B0B36C6A}"/>
               </a:ext>
             </a:extLst>
           </p:cNvPr>
@@ -9913,7 +9913,7 @@
           <p:cNvPr id="32" name="lab-stop-3">
             <a:extLst xmlns:a="http://schemas.openxmlformats.org/drawingml/2006/main">
               <a:ext uri="{FF2B5EF4-FFF2-40B4-BE49-F238E27FC236}">
-                <a16:creationId xmlns:a16="http://schemas.microsoft.com/office/drawing/2014/main" id="{EDC4110F-BB21-4C35-987F-CDD9FC027BB6}"/>
+                <a16:creationId xmlns:a16="http://schemas.microsoft.com/office/drawing/2014/main" id="{8A1CD6C5-8353-4C98-B71B-8D73B21C5709}"/>
               </a:ext>
             </a:extLst>
           </p:cNvPr>
@@ -9958,7 +9958,7 @@
           <p:cNvPr id="33" name="lab-command">
             <a:extLst xmlns:a="http://schemas.openxmlformats.org/drawingml/2006/main">
               <a:ext uri="{FF2B5EF4-FFF2-40B4-BE49-F238E27FC236}">
-                <a16:creationId xmlns:a16="http://schemas.microsoft.com/office/drawing/2014/main" id="{6455CFC4-2233-443A-819C-7719834F3B19}"/>
+                <a16:creationId xmlns:a16="http://schemas.microsoft.com/office/drawing/2014/main" id="{9391FDAE-547D-48BF-AC1B-26FC08F34040}"/>
               </a:ext>
             </a:extLst>
           </p:cNvPr>
@@ -9991,7 +9991,7 @@
           <p:cNvPr id="34" name="lab-command-text">
             <a:extLst xmlns:a="http://schemas.openxmlformats.org/drawingml/2006/main">
               <a:ext uri="{FF2B5EF4-FFF2-40B4-BE49-F238E27FC236}">
-                <a16:creationId xmlns:a16="http://schemas.microsoft.com/office/drawing/2014/main" id="{A67FCD45-61A0-4232-944D-D3E882EC9037}"/>
+                <a16:creationId xmlns:a16="http://schemas.microsoft.com/office/drawing/2014/main" id="{73AB8276-1B92-4AC8-8D14-E3786C762F13}"/>
               </a:ext>
             </a:extLst>
           </p:cNvPr>
@@ -10036,7 +10036,7 @@
           <p:cNvPr id="35" name="lab-note">
             <a:extLst xmlns:a="http://schemas.openxmlformats.org/drawingml/2006/main">
               <a:ext uri="{FF2B5EF4-FFF2-40B4-BE49-F238E27FC236}">
-                <a16:creationId xmlns:a16="http://schemas.microsoft.com/office/drawing/2014/main" id="{D70A9C91-918E-4DD2-8443-A82733194E7A}"/>
+                <a16:creationId xmlns:a16="http://schemas.microsoft.com/office/drawing/2014/main" id="{D6B2464F-87A8-4E21-8E67-60B7B7FE1C12}"/>
               </a:ext>
             </a:extLst>
           </p:cNvPr>
@@ -10079,7 +10079,7 @@
     </p:spTree>
     <p:extLst>
       <p:ext uri="{BB962C8B-B14F-4D97-AF65-F5344CB8AC3E}">
-        <p14:creationId xmlns:p14="http://schemas.microsoft.com/office/powerpoint/2010/main" val="1372856267"/>
+        <p14:creationId xmlns:p14="http://schemas.microsoft.com/office/powerpoint/2010/main" val="940679249"/>
       </p:ext>
     </p:extLst>
   </p:cSld>
@@ -10110,7 +10110,7 @@
           <p:cNvPr id="1" name="kicker-8">
             <a:extLst xmlns:a="http://schemas.openxmlformats.org/drawingml/2006/main">
               <a:ext uri="{FF2B5EF4-FFF2-40B4-BE49-F238E27FC236}">
-                <a16:creationId xmlns:a16="http://schemas.microsoft.com/office/drawing/2014/main" id="{90F6C176-8B50-47AC-85A1-B74F64E93259}"/>
+                <a16:creationId xmlns:a16="http://schemas.microsoft.com/office/drawing/2014/main" id="{6CEFDD92-1674-4B4F-BA58-7BF0184B2112}"/>
               </a:ext>
             </a:extLst>
           </p:cNvPr>
@@ -10155,7 +10155,7 @@
           <p:cNvPr id="2" name="title-8">
             <a:extLst xmlns:a="http://schemas.openxmlformats.org/drawingml/2006/main">
               <a:ext uri="{FF2B5EF4-FFF2-40B4-BE49-F238E27FC236}">
-                <a16:creationId xmlns:a16="http://schemas.microsoft.com/office/drawing/2014/main" id="{077199C9-C541-41CC-A96F-0A7B74E8101E}"/>
+                <a16:creationId xmlns:a16="http://schemas.microsoft.com/office/drawing/2014/main" id="{E55C992D-E9D1-4AE3-8DC7-4EE2E9D24644}"/>
               </a:ext>
             </a:extLst>
           </p:cNvPr>
@@ -10222,7 +10222,7 @@
           <p:cNvPr id="4" name="number-8">
             <a:extLst xmlns:a="http://schemas.openxmlformats.org/drawingml/2006/main">
               <a:ext uri="{FF2B5EF4-FFF2-40B4-BE49-F238E27FC236}">
-                <a16:creationId xmlns:a16="http://schemas.microsoft.com/office/drawing/2014/main" id="{4D3AA34A-F693-43E3-B040-56A2F29BE608}"/>
+                <a16:creationId xmlns:a16="http://schemas.microsoft.com/office/drawing/2014/main" id="{AC5CBD75-7B38-4BC5-900A-EAC21CC24ACB}"/>
               </a:ext>
             </a:extLst>
           </p:cNvPr>
@@ -10421,7 +10421,7 @@
           <p:cNvPr id="12" name="prod-local-dot">
             <a:extLst xmlns:a="http://schemas.openxmlformats.org/drawingml/2006/main">
               <a:ext uri="{FF2B5EF4-FFF2-40B4-BE49-F238E27FC236}">
-                <a16:creationId xmlns:a16="http://schemas.microsoft.com/office/drawing/2014/main" id="{3A9C00EA-9412-419A-8D53-516E94A1D229}"/>
+                <a16:creationId xmlns:a16="http://schemas.microsoft.com/office/drawing/2014/main" id="{AA14D6F4-D1DD-422B-9E28-3DAA784E3876}"/>
               </a:ext>
             </a:extLst>
           </p:cNvPr>
@@ -10452,7 +10452,7 @@
           <p:cNvPr id="13" name="prod-ci-dot">
             <a:extLst xmlns:a="http://schemas.openxmlformats.org/drawingml/2006/main">
               <a:ext uri="{FF2B5EF4-FFF2-40B4-BE49-F238E27FC236}">
-                <a16:creationId xmlns:a16="http://schemas.microsoft.com/office/drawing/2014/main" id="{C9FCA1AF-5CDE-4F9D-A3C1-AD35C6191AE9}"/>
+                <a16:creationId xmlns:a16="http://schemas.microsoft.com/office/drawing/2014/main" id="{AF489A07-DE02-46C2-98D2-01D5B47CE838}"/>
               </a:ext>
             </a:extLst>
           </p:cNvPr>
@@ -10483,7 +10483,7 @@
           <p:cNvPr id="14" name="prod-scale-dot">
             <a:extLst xmlns:a="http://schemas.openxmlformats.org/drawingml/2006/main">
               <a:ext uri="{FF2B5EF4-FFF2-40B4-BE49-F238E27FC236}">
-                <a16:creationId xmlns:a16="http://schemas.microsoft.com/office/drawing/2014/main" id="{7B933C3E-D0FA-4AB4-BF3E-D40A8A3A3528}"/>
+                <a16:creationId xmlns:a16="http://schemas.microsoft.com/office/drawing/2014/main" id="{3E37ACA5-7812-4B12-BA06-4EDE9F4F9A61}"/>
               </a:ext>
             </a:extLst>
           </p:cNvPr>
@@ -10514,7 +10514,7 @@
           <p:cNvPr id="15" name="prod-enterprise-dot">
             <a:extLst xmlns:a="http://schemas.openxmlformats.org/drawingml/2006/main">
               <a:ext uri="{FF2B5EF4-FFF2-40B4-BE49-F238E27FC236}">
-                <a16:creationId xmlns:a16="http://schemas.microsoft.com/office/drawing/2014/main" id="{7B056D41-B8EA-466C-8874-F20DA76EE4DF}"/>
+                <a16:creationId xmlns:a16="http://schemas.microsoft.com/office/drawing/2014/main" id="{FD104B5C-ADB8-4DC6-9F3D-559DC20B47C0}"/>
               </a:ext>
             </a:extLst>
           </p:cNvPr>
@@ -10545,7 +10545,7 @@
           <p:cNvPr id="16" name="prod-local-title">
             <a:extLst xmlns:a="http://schemas.openxmlformats.org/drawingml/2006/main">
               <a:ext uri="{FF2B5EF4-FFF2-40B4-BE49-F238E27FC236}">
-                <a16:creationId xmlns:a16="http://schemas.microsoft.com/office/drawing/2014/main" id="{398142CF-32ED-4A18-9384-E85C606A3634}"/>
+                <a16:creationId xmlns:a16="http://schemas.microsoft.com/office/drawing/2014/main" id="{E221F8D6-C6D7-46F6-BEE6-DCF84AC97BEB}"/>
               </a:ext>
             </a:extLst>
           </p:cNvPr>
@@ -10590,7 +10590,7 @@
           <p:cNvPr id="17" name="prod-local-body">
             <a:extLst xmlns:a="http://schemas.openxmlformats.org/drawingml/2006/main">
               <a:ext uri="{FF2B5EF4-FFF2-40B4-BE49-F238E27FC236}">
-                <a16:creationId xmlns:a16="http://schemas.microsoft.com/office/drawing/2014/main" id="{70F2A376-E4CF-4891-B1B9-E3FCF841622D}"/>
+                <a16:creationId xmlns:a16="http://schemas.microsoft.com/office/drawing/2014/main" id="{20EAEDAB-E265-4DDB-AD7D-590E11BD8FD1}"/>
               </a:ext>
             </a:extLst>
           </p:cNvPr>
@@ -10637,7 +10637,7 @@
           <p:cNvPr id="18" name="prod-ci-title">
             <a:extLst xmlns:a="http://schemas.openxmlformats.org/drawingml/2006/main">
               <a:ext uri="{FF2B5EF4-FFF2-40B4-BE49-F238E27FC236}">
-                <a16:creationId xmlns:a16="http://schemas.microsoft.com/office/drawing/2014/main" id="{47130F5A-1002-42E2-AE4D-184B35D252A8}"/>
+                <a16:creationId xmlns:a16="http://schemas.microsoft.com/office/drawing/2014/main" id="{D6B83A3C-3DD7-49EA-8C1B-BA5BCE0DB643}"/>
               </a:ext>
             </a:extLst>
           </p:cNvPr>
@@ -10682,7 +10682,7 @@
           <p:cNvPr id="19" name="prod-ci-body">
             <a:extLst xmlns:a="http://schemas.openxmlformats.org/drawingml/2006/main">
               <a:ext uri="{FF2B5EF4-FFF2-40B4-BE49-F238E27FC236}">
-                <a16:creationId xmlns:a16="http://schemas.microsoft.com/office/drawing/2014/main" id="{1D94E3AC-14C7-4D92-A8CC-33F7583A8B81}"/>
+                <a16:creationId xmlns:a16="http://schemas.microsoft.com/office/drawing/2014/main" id="{DD286C9C-AED6-4F06-855B-F4ECEFA54173}"/>
               </a:ext>
             </a:extLst>
           </p:cNvPr>
@@ -10729,7 +10729,7 @@
           <p:cNvPr id="20" name="prod-scale-title">
             <a:extLst xmlns:a="http://schemas.openxmlformats.org/drawingml/2006/main">
               <a:ext uri="{FF2B5EF4-FFF2-40B4-BE49-F238E27FC236}">
-                <a16:creationId xmlns:a16="http://schemas.microsoft.com/office/drawing/2014/main" id="{909950CD-CCC4-4B17-9A5C-6E98AD73F7F4}"/>
+                <a16:creationId xmlns:a16="http://schemas.microsoft.com/office/drawing/2014/main" id="{1BE5E2C0-88AF-42DA-8D07-4110BA165912}"/>
               </a:ext>
             </a:extLst>
           </p:cNvPr>
@@ -10774,7 +10774,7 @@
           <p:cNvPr id="21" name="prod-scale-body">
             <a:extLst xmlns:a="http://schemas.openxmlformats.org/drawingml/2006/main">
               <a:ext uri="{FF2B5EF4-FFF2-40B4-BE49-F238E27FC236}">
-                <a16:creationId xmlns:a16="http://schemas.microsoft.com/office/drawing/2014/main" id="{A6B0FD6B-8079-4418-9465-50C2BE16873C}"/>
+                <a16:creationId xmlns:a16="http://schemas.microsoft.com/office/drawing/2014/main" id="{2CCA0B26-BD09-49E8-9BBE-6798BA92635E}"/>
               </a:ext>
             </a:extLst>
           </p:cNvPr>
@@ -10821,7 +10821,7 @@
           <p:cNvPr id="22" name="prod-enterprise-title">
             <a:extLst xmlns:a="http://schemas.openxmlformats.org/drawingml/2006/main">
               <a:ext uri="{FF2B5EF4-FFF2-40B4-BE49-F238E27FC236}">
-                <a16:creationId xmlns:a16="http://schemas.microsoft.com/office/drawing/2014/main" id="{AC8F65C2-4BD2-40A9-8079-224319130B04}"/>
+                <a16:creationId xmlns:a16="http://schemas.microsoft.com/office/drawing/2014/main" id="{1ADFFF3D-D7F6-4ABC-9DFA-DC7E4EA3F76A}"/>
               </a:ext>
             </a:extLst>
           </p:cNvPr>
@@ -10866,7 +10866,7 @@
           <p:cNvPr id="23" name="prod-enterprise-body">
             <a:extLst xmlns:a="http://schemas.openxmlformats.org/drawingml/2006/main">
               <a:ext uri="{FF2B5EF4-FFF2-40B4-BE49-F238E27FC236}">
-                <a16:creationId xmlns:a16="http://schemas.microsoft.com/office/drawing/2014/main" id="{C3D491D1-1E11-4271-94C6-B9088ACA846D}"/>
+                <a16:creationId xmlns:a16="http://schemas.microsoft.com/office/drawing/2014/main" id="{AC3E396D-3702-40A3-A4C6-0EABFAEF776B}"/>
               </a:ext>
             </a:extLst>
           </p:cNvPr>
@@ -10914,7 +10914,7 @@
           <p:cNvPr id="24" name="prod-signal">
             <a:extLst xmlns:a="http://schemas.openxmlformats.org/drawingml/2006/main">
               <a:ext uri="{FF2B5EF4-FFF2-40B4-BE49-F238E27FC236}">
-                <a16:creationId xmlns:a16="http://schemas.microsoft.com/office/drawing/2014/main" id="{88660DE7-559E-4D60-90DE-7286B1067A50}"/>
+                <a16:creationId xmlns:a16="http://schemas.microsoft.com/office/drawing/2014/main" id="{7464A041-26E1-4249-A26D-30F327C6E4BF}"/>
               </a:ext>
             </a:extLst>
           </p:cNvPr>
@@ -10957,7 +10957,7 @@
     </p:spTree>
     <p:extLst>
       <p:ext uri="{BB962C8B-B14F-4D97-AF65-F5344CB8AC3E}">
-        <p14:creationId xmlns:p14="http://schemas.microsoft.com/office/powerpoint/2010/main" val="1773075706"/>
+        <p14:creationId xmlns:p14="http://schemas.microsoft.com/office/powerpoint/2010/main" val="117149853"/>
       </p:ext>
     </p:extLst>
   </p:cSld>
@@ -10988,7 +10988,7 @@
           <p:cNvPr id="1" name="kicker-9">
             <a:extLst xmlns:a="http://schemas.openxmlformats.org/drawingml/2006/main">
               <a:ext uri="{FF2B5EF4-FFF2-40B4-BE49-F238E27FC236}">
-                <a16:creationId xmlns:a16="http://schemas.microsoft.com/office/drawing/2014/main" id="{2D94F6F5-DD13-4078-818B-BDC5147E9E9A}"/>
+                <a16:creationId xmlns:a16="http://schemas.microsoft.com/office/drawing/2014/main" id="{3EB3B0C3-687F-402D-8883-5A0EA62D3D5D}"/>
               </a:ext>
             </a:extLst>
           </p:cNvPr>
@@ -11033,7 +11033,7 @@
           <p:cNvPr id="2" name="title-9">
             <a:extLst xmlns:a="http://schemas.openxmlformats.org/drawingml/2006/main">
               <a:ext uri="{FF2B5EF4-FFF2-40B4-BE49-F238E27FC236}">
-                <a16:creationId xmlns:a16="http://schemas.microsoft.com/office/drawing/2014/main" id="{EF39FC57-3C6C-47A0-AB3A-C340A1BA9E2F}"/>
+                <a16:creationId xmlns:a16="http://schemas.microsoft.com/office/drawing/2014/main" id="{CCC243D2-BE11-4197-A9FA-E9E315A3ACCA}"/>
               </a:ext>
             </a:extLst>
           </p:cNvPr>
@@ -11100,7 +11100,7 @@
           <p:cNvPr id="4" name="number-9">
             <a:extLst xmlns:a="http://schemas.openxmlformats.org/drawingml/2006/main">
               <a:ext uri="{FF2B5EF4-FFF2-40B4-BE49-F238E27FC236}">
-                <a16:creationId xmlns:a16="http://schemas.microsoft.com/office/drawing/2014/main" id="{BCD96466-C752-4F82-AC61-1E59DC82BFC5}"/>
+                <a16:creationId xmlns:a16="http://schemas.microsoft.com/office/drawing/2014/main" id="{79EBE264-AB7F-4A4F-A7BC-57AFFDDC072E}"/>
               </a:ext>
             </a:extLst>
           </p:cNvPr>
@@ -11167,7 +11167,7 @@
           <p:cNvPr id="6" name="trade-fulcrum">
             <a:extLst xmlns:a="http://schemas.openxmlformats.org/drawingml/2006/main">
               <a:ext uri="{FF2B5EF4-FFF2-40B4-BE49-F238E27FC236}">
-                <a16:creationId xmlns:a16="http://schemas.microsoft.com/office/drawing/2014/main" id="{E16D692A-91B6-4BE8-860C-F6ADF13F0387}"/>
+                <a16:creationId xmlns:a16="http://schemas.microsoft.com/office/drawing/2014/main" id="{5CC15D1D-CB80-49C6-B4F6-B9B6D9369F2F}"/>
               </a:ext>
             </a:extLst>
           </p:cNvPr>
@@ -11198,7 +11198,7 @@
           <p:cNvPr id="7" name="trade-left-pan">
             <a:extLst xmlns:a="http://schemas.openxmlformats.org/drawingml/2006/main">
               <a:ext uri="{FF2B5EF4-FFF2-40B4-BE49-F238E27FC236}">
-                <a16:creationId xmlns:a16="http://schemas.microsoft.com/office/drawing/2014/main" id="{E3384CC5-EB6D-47CA-B8B7-24A4F2FCF5EA}"/>
+                <a16:creationId xmlns:a16="http://schemas.microsoft.com/office/drawing/2014/main" id="{7D800A7A-BF75-4C13-A655-AD50D4F8ED0E}"/>
               </a:ext>
             </a:extLst>
           </p:cNvPr>
@@ -11233,7 +11233,7 @@
           <p:cNvPr id="8" name="trade-right-pan">
             <a:extLst xmlns:a="http://schemas.openxmlformats.org/drawingml/2006/main">
               <a:ext uri="{FF2B5EF4-FFF2-40B4-BE49-F238E27FC236}">
-                <a16:creationId xmlns:a16="http://schemas.microsoft.com/office/drawing/2014/main" id="{9FF7BCDB-FE95-48A1-AFE9-3886BAE54832}"/>
+                <a16:creationId xmlns:a16="http://schemas.microsoft.com/office/drawing/2014/main" id="{D08DC4C7-CEE2-481A-AF0A-8AB98C03C98B}"/>
               </a:ext>
             </a:extLst>
           </p:cNvPr>
@@ -11312,7 +11312,7 @@
           <p:cNvPr id="11" name="trade-left-title">
             <a:extLst xmlns:a="http://schemas.openxmlformats.org/drawingml/2006/main">
               <a:ext uri="{FF2B5EF4-FFF2-40B4-BE49-F238E27FC236}">
-                <a16:creationId xmlns:a16="http://schemas.microsoft.com/office/drawing/2014/main" id="{72C15BA1-4629-4A33-A76F-32EC1809175E}"/>
+                <a16:creationId xmlns:a16="http://schemas.microsoft.com/office/drawing/2014/main" id="{F096C754-5986-4009-9198-D4D9119E6049}"/>
               </a:ext>
             </a:extLst>
           </p:cNvPr>
@@ -11357,7 +11357,7 @@
           <p:cNvPr id="12" name="trade-left-body">
             <a:extLst xmlns:a="http://schemas.openxmlformats.org/drawingml/2006/main">
               <a:ext uri="{FF2B5EF4-FFF2-40B4-BE49-F238E27FC236}">
-                <a16:creationId xmlns:a16="http://schemas.microsoft.com/office/drawing/2014/main" id="{F34E4606-3D2C-43E5-99B3-654BBD39E3C3}"/>
+                <a16:creationId xmlns:a16="http://schemas.microsoft.com/office/drawing/2014/main" id="{7DE23672-5F8C-4E2F-8102-75AFE85F9C3F}"/>
               </a:ext>
             </a:extLst>
           </p:cNvPr>
@@ -11404,7 +11404,7 @@
           <p:cNvPr id="13" name="trade-right-title">
             <a:extLst xmlns:a="http://schemas.openxmlformats.org/drawingml/2006/main">
               <a:ext uri="{FF2B5EF4-FFF2-40B4-BE49-F238E27FC236}">
-                <a16:creationId xmlns:a16="http://schemas.microsoft.com/office/drawing/2014/main" id="{AB8355FA-6E22-4980-B90B-9535CA6FC7C6}"/>
+                <a16:creationId xmlns:a16="http://schemas.microsoft.com/office/drawing/2014/main" id="{E295B3A2-A1F3-488B-8AEF-4BFEE197EC1C}"/>
               </a:ext>
             </a:extLst>
           </p:cNvPr>
@@ -11449,7 +11449,7 @@
           <p:cNvPr id="14" name="trade-right-body">
             <a:extLst xmlns:a="http://schemas.openxmlformats.org/drawingml/2006/main">
               <a:ext uri="{FF2B5EF4-FFF2-40B4-BE49-F238E27FC236}">
-                <a16:creationId xmlns:a16="http://schemas.microsoft.com/office/drawing/2014/main" id="{BCF110FB-A0CA-48EA-BAB7-DE3023262C73}"/>
+                <a16:creationId xmlns:a16="http://schemas.microsoft.com/office/drawing/2014/main" id="{FED45BCD-BE5D-44AA-BD62-D6703DE08BB5}"/>
               </a:ext>
             </a:extLst>
           </p:cNvPr>
@@ -11496,7 +11496,7 @@
           <p:cNvPr id="15" name="trade-center">
             <a:extLst xmlns:a="http://schemas.openxmlformats.org/drawingml/2006/main">
               <a:ext uri="{FF2B5EF4-FFF2-40B4-BE49-F238E27FC236}">
-                <a16:creationId xmlns:a16="http://schemas.microsoft.com/office/drawing/2014/main" id="{E329AA25-3236-48E7-BF10-90BDD19810EA}"/>
+                <a16:creationId xmlns:a16="http://schemas.microsoft.com/office/drawing/2014/main" id="{84C136ED-1204-4E83-BDE9-6786C6CC30B8}"/>
               </a:ext>
             </a:extLst>
           </p:cNvPr>
@@ -11541,7 +11541,7 @@
           <p:cNvPr id="16" name="trade-rule">
             <a:extLst xmlns:a="http://schemas.openxmlformats.org/drawingml/2006/main">
               <a:ext uri="{FF2B5EF4-FFF2-40B4-BE49-F238E27FC236}">
-                <a16:creationId xmlns:a16="http://schemas.microsoft.com/office/drawing/2014/main" id="{FE37CE95-CBA2-4682-96DF-DA5ECA51C9E5}"/>
+                <a16:creationId xmlns:a16="http://schemas.microsoft.com/office/drawing/2014/main" id="{E0BA057B-C104-46D3-BBDD-8BA63BEF7BA9}"/>
               </a:ext>
             </a:extLst>
           </p:cNvPr>
@@ -11574,7 +11574,7 @@
           <p:cNvPr id="17" name="trade-rule-text">
             <a:extLst xmlns:a="http://schemas.openxmlformats.org/drawingml/2006/main">
               <a:ext uri="{FF2B5EF4-FFF2-40B4-BE49-F238E27FC236}">
-                <a16:creationId xmlns:a16="http://schemas.microsoft.com/office/drawing/2014/main" id="{06F5DBCC-50F1-4FDC-BC05-EAA0B2719B7F}"/>
+                <a16:creationId xmlns:a16="http://schemas.microsoft.com/office/drawing/2014/main" id="{599F54DC-7CEB-4B81-B4C4-33B324E83128}"/>
               </a:ext>
             </a:extLst>
           </p:cNvPr>
@@ -11617,7 +11617,7 @@
     </p:spTree>
     <p:extLst>
       <p:ext uri="{BB962C8B-B14F-4D97-AF65-F5344CB8AC3E}">
-        <p14:creationId xmlns:p14="http://schemas.microsoft.com/office/powerpoint/2010/main" val="1779146404"/>
+        <p14:creationId xmlns:p14="http://schemas.microsoft.com/office/powerpoint/2010/main" val="899839766"/>
       </p:ext>
     </p:extLst>
   </p:cSld>

</xml_diff>

<commit_message>
Address runtime validation review feedback
</commit_message>
<xml_diff>
--- a/docs/lessons/assets/cah-007-repository-checks.pptx
+++ b/docs/lessons/assets/cah-007-repository-checks.pptx
@@ -2,22 +2,22 @@
 <file path=ppt/presentation.xml><?xml version="1.0" encoding="utf-8"?>
 <p:presentation xmlns:p="http://schemas.openxmlformats.org/presentationml/2006/main">
   <p:sldMasterIdLst>
-    <p:sldMasterId xmlns:r="http://schemas.openxmlformats.org/officeDocument/2006/relationships" id="2147483648" r:id="R937586dc47694e2c"/>
+    <p:sldMasterId xmlns:r="http://schemas.openxmlformats.org/officeDocument/2006/relationships" id="2147483648" r:id="R4bdf20e5ac864355"/>
   </p:sldMasterIdLst>
   <p:notesMasterIdLst>
-    <p:notesMasterId xmlns:r="http://schemas.openxmlformats.org/officeDocument/2006/relationships" r:id="R8aa5f248d4074cc8"/>
+    <p:notesMasterId xmlns:r="http://schemas.openxmlformats.org/officeDocument/2006/relationships" r:id="R9558172af17b4dde"/>
   </p:notesMasterIdLst>
   <p:sldIdLst>
-    <p:sldId xmlns:r="http://schemas.openxmlformats.org/officeDocument/2006/relationships" id="256" r:id="R62f5435192384cf6"/>
-    <p:sldId xmlns:r="http://schemas.openxmlformats.org/officeDocument/2006/relationships" id="257" r:id="Ra32c5fe1879b48fb"/>
-    <p:sldId xmlns:r="http://schemas.openxmlformats.org/officeDocument/2006/relationships" id="258" r:id="Raf750adcd7614f86"/>
-    <p:sldId xmlns:r="http://schemas.openxmlformats.org/officeDocument/2006/relationships" id="259" r:id="R067d5e5b2cc8466c"/>
-    <p:sldId xmlns:r="http://schemas.openxmlformats.org/officeDocument/2006/relationships" id="260" r:id="R85889bdde92c4fba"/>
-    <p:sldId xmlns:r="http://schemas.openxmlformats.org/officeDocument/2006/relationships" id="261" r:id="R93edffad19974c29"/>
-    <p:sldId xmlns:r="http://schemas.openxmlformats.org/officeDocument/2006/relationships" id="262" r:id="Rd62dfa7dabcc43ee"/>
-    <p:sldId xmlns:r="http://schemas.openxmlformats.org/officeDocument/2006/relationships" id="263" r:id="R05aa4f2168354731"/>
-    <p:sldId xmlns:r="http://schemas.openxmlformats.org/officeDocument/2006/relationships" id="264" r:id="R8b14569200ef4154"/>
-    <p:sldId xmlns:r="http://schemas.openxmlformats.org/officeDocument/2006/relationships" id="265" r:id="Rc933d6468b4f4ef8"/>
+    <p:sldId xmlns:r="http://schemas.openxmlformats.org/officeDocument/2006/relationships" id="256" r:id="R37fbbe55f2374acc"/>
+    <p:sldId xmlns:r="http://schemas.openxmlformats.org/officeDocument/2006/relationships" id="257" r:id="R185efa2b73d84ca9"/>
+    <p:sldId xmlns:r="http://schemas.openxmlformats.org/officeDocument/2006/relationships" id="258" r:id="Rdc2007f95d21480a"/>
+    <p:sldId xmlns:r="http://schemas.openxmlformats.org/officeDocument/2006/relationships" id="259" r:id="Re1fdb3361415408c"/>
+    <p:sldId xmlns:r="http://schemas.openxmlformats.org/officeDocument/2006/relationships" id="260" r:id="R6ee9fccb34494900"/>
+    <p:sldId xmlns:r="http://schemas.openxmlformats.org/officeDocument/2006/relationships" id="261" r:id="R149887008ab645b1"/>
+    <p:sldId xmlns:r="http://schemas.openxmlformats.org/officeDocument/2006/relationships" id="262" r:id="R7d17c26d4edf43fc"/>
+    <p:sldId xmlns:r="http://schemas.openxmlformats.org/officeDocument/2006/relationships" id="263" r:id="R6324f25714a740d7"/>
+    <p:sldId xmlns:r="http://schemas.openxmlformats.org/officeDocument/2006/relationships" id="264" r:id="Reed08546372949d8"/>
+    <p:sldId xmlns:r="http://schemas.openxmlformats.org/officeDocument/2006/relationships" id="265" r:id="Rb4d5925cb17b407f"/>
   </p:sldIdLst>
   <p:sldSz cx="12192000" cy="6858000"/>
   <p:notesSz cx="6858000" cy="9144000"/>
@@ -1204,7 +1204,7 @@
   </p:cSld>
   <p:clrMap bg1="lt1" tx1="dk1" bg2="lt2" tx2="dk2" accent1="accent1" accent2="accent2" accent3="accent3" accent4="accent4" accent5="accent5" accent6="accent6" hlink="hlink" folHlink="folHlink"/>
   <p:sldLayoutIdLst>
-    <p:sldLayoutId xmlns:r="http://schemas.openxmlformats.org/officeDocument/2006/relationships" id="2147483649" r:id="R59099ec8fc834eac"/>
+    <p:sldLayoutId xmlns:r="http://schemas.openxmlformats.org/officeDocument/2006/relationships" id="2147483649" r:id="R5913169983a34424"/>
   </p:sldLayoutIdLst>
   <p:txStyles>
     <p:titleStyle>
@@ -1759,7 +1759,7 @@
           <p:nvPr/>
         </p:nvPicPr>
         <p:blipFill>
-          <a:blip xmlns:r="http://schemas.openxmlformats.org/officeDocument/2006/relationships" xmlns:a="http://schemas.openxmlformats.org/drawingml/2006/main" r:embed="Rdf5e09b6da5045bc"/>
+          <a:blip xmlns:r="http://schemas.openxmlformats.org/officeDocument/2006/relationships" xmlns:a="http://schemas.openxmlformats.org/drawingml/2006/main" r:embed="R25caf125a7224983"/>
           <a:srcRect xmlns:a="http://schemas.openxmlformats.org/drawingml/2006/main" l="0" t="27" r="0" b="27"/>
           <a:stretch xmlns:a="http://schemas.openxmlformats.org/drawingml/2006/main">
             <a:fillRect l="0" t="0" r="0" b="0"/>
@@ -1780,7 +1780,7 @@
           <p:cNvPr id="2" name="cover-shade">
             <a:extLst xmlns:a="http://schemas.openxmlformats.org/drawingml/2006/main">
               <a:ext uri="{FF2B5EF4-FFF2-40B4-BE49-F238E27FC236}">
-                <a16:creationId xmlns:a16="http://schemas.microsoft.com/office/drawing/2014/main" id="{5BDFD1DA-BF97-4844-8242-4911C10411F7}"/>
+                <a16:creationId xmlns:a16="http://schemas.microsoft.com/office/drawing/2014/main" id="{C51409D2-7F9A-46E1-B032-BB2E053033DC}"/>
               </a:ext>
             </a:extLst>
           </p:cNvPr>
@@ -1811,7 +1811,7 @@
           <p:cNvPr id="3" name="cover-cyan">
             <a:extLst xmlns:a="http://schemas.openxmlformats.org/drawingml/2006/main">
               <a:ext uri="{FF2B5EF4-FFF2-40B4-BE49-F238E27FC236}">
-                <a16:creationId xmlns:a16="http://schemas.microsoft.com/office/drawing/2014/main" id="{4C4B4D6F-F068-4986-8AAB-4338AB8E154F}"/>
+                <a16:creationId xmlns:a16="http://schemas.microsoft.com/office/drawing/2014/main" id="{D5624BCC-CFE9-4B2B-894A-A39888C8DEF4}"/>
               </a:ext>
             </a:extLst>
           </p:cNvPr>
@@ -1842,7 +1842,7 @@
           <p:cNvPr id="4" name="cover-kicker">
             <a:extLst xmlns:a="http://schemas.openxmlformats.org/drawingml/2006/main">
               <a:ext uri="{FF2B5EF4-FFF2-40B4-BE49-F238E27FC236}">
-                <a16:creationId xmlns:a16="http://schemas.microsoft.com/office/drawing/2014/main" id="{DC70A89E-B9EB-4F3F-A74C-E1D8EF9229FE}"/>
+                <a16:creationId xmlns:a16="http://schemas.microsoft.com/office/drawing/2014/main" id="{40E55C31-F518-4333-BFDB-F265A51250A5}"/>
               </a:ext>
             </a:extLst>
           </p:cNvPr>
@@ -1887,7 +1887,7 @@
           <p:cNvPr id="5" name="cover-title">
             <a:extLst xmlns:a="http://schemas.openxmlformats.org/drawingml/2006/main">
               <a:ext uri="{FF2B5EF4-FFF2-40B4-BE49-F238E27FC236}">
-                <a16:creationId xmlns:a16="http://schemas.microsoft.com/office/drawing/2014/main" id="{59D2C747-A66C-457D-949C-C93B500FF1E5}"/>
+                <a16:creationId xmlns:a16="http://schemas.microsoft.com/office/drawing/2014/main" id="{3BC1D002-5DB4-412F-BCFA-76CC68557C67}"/>
               </a:ext>
             </a:extLst>
           </p:cNvPr>
@@ -1933,7 +1933,7 @@
           <p:cNvPr id="6" name="cover-subtitle">
             <a:extLst xmlns:a="http://schemas.openxmlformats.org/drawingml/2006/main">
               <a:ext uri="{FF2B5EF4-FFF2-40B4-BE49-F238E27FC236}">
-                <a16:creationId xmlns:a16="http://schemas.microsoft.com/office/drawing/2014/main" id="{6939DEEA-3692-4EAE-9EF6-7A6EA74699DB}"/>
+                <a16:creationId xmlns:a16="http://schemas.microsoft.com/office/drawing/2014/main" id="{7ED839B6-E68B-4113-AA01-224D251A952C}"/>
               </a:ext>
             </a:extLst>
           </p:cNvPr>
@@ -1978,7 +1978,7 @@
           <p:cNvPr id="7" name="cover-command">
             <a:extLst xmlns:a="http://schemas.openxmlformats.org/drawingml/2006/main">
               <a:ext uri="{FF2B5EF4-FFF2-40B4-BE49-F238E27FC236}">
-                <a16:creationId xmlns:a16="http://schemas.microsoft.com/office/drawing/2014/main" id="{EEA24576-389D-460A-A10E-9C1AE3C1C788}"/>
+                <a16:creationId xmlns:a16="http://schemas.microsoft.com/office/drawing/2014/main" id="{843E6167-7C74-4CCE-B8F0-AA6304B888BC}"/>
               </a:ext>
             </a:extLst>
           </p:cNvPr>
@@ -2013,7 +2013,7 @@
           <p:cNvPr id="8" name="cover-command-text">
             <a:extLst xmlns:a="http://schemas.openxmlformats.org/drawingml/2006/main">
               <a:ext uri="{FF2B5EF4-FFF2-40B4-BE49-F238E27FC236}">
-                <a16:creationId xmlns:a16="http://schemas.microsoft.com/office/drawing/2014/main" id="{87626A9B-8F7B-4E19-A45C-E0851BA1AD2F}"/>
+                <a16:creationId xmlns:a16="http://schemas.microsoft.com/office/drawing/2014/main" id="{01011B06-F1BE-4C06-B484-16EBF769D306}"/>
               </a:ext>
             </a:extLst>
           </p:cNvPr>
@@ -2058,7 +2058,7 @@
           <p:cNvPr id="9" name="cover-caption">
             <a:extLst xmlns:a="http://schemas.openxmlformats.org/drawingml/2006/main">
               <a:ext uri="{FF2B5EF4-FFF2-40B4-BE49-F238E27FC236}">
-                <a16:creationId xmlns:a16="http://schemas.microsoft.com/office/drawing/2014/main" id="{C6331326-BB35-4037-87A1-A70DAEE292BA}"/>
+                <a16:creationId xmlns:a16="http://schemas.microsoft.com/office/drawing/2014/main" id="{610D8718-510A-467C-85D2-359029A70B11}"/>
               </a:ext>
             </a:extLst>
           </p:cNvPr>
@@ -2103,7 +2103,7 @@
           <p:cNvPr id="10" name="cover-footer">
             <a:extLst xmlns:a="http://schemas.openxmlformats.org/drawingml/2006/main">
               <a:ext uri="{FF2B5EF4-FFF2-40B4-BE49-F238E27FC236}">
-                <a16:creationId xmlns:a16="http://schemas.microsoft.com/office/drawing/2014/main" id="{0B552393-8305-4BBA-BD6A-9E1B4AA6B435}"/>
+                <a16:creationId xmlns:a16="http://schemas.microsoft.com/office/drawing/2014/main" id="{5825094D-C002-4C92-9113-32F97D187184}"/>
               </a:ext>
             </a:extLst>
           </p:cNvPr>
@@ -2146,7 +2146,7 @@
     </p:spTree>
     <p:extLst>
       <p:ext uri="{BB962C8B-B14F-4D97-AF65-F5344CB8AC3E}">
-        <p14:creationId xmlns:p14="http://schemas.microsoft.com/office/powerpoint/2010/main" val="199380473"/>
+        <p14:creationId xmlns:p14="http://schemas.microsoft.com/office/powerpoint/2010/main" val="7017834"/>
       </p:ext>
     </p:extLst>
   </p:cSld>
@@ -2177,7 +2177,7 @@
           <p:cNvPr id="1" name="close-bg">
             <a:extLst xmlns:a="http://schemas.openxmlformats.org/drawingml/2006/main">
               <a:ext uri="{FF2B5EF4-FFF2-40B4-BE49-F238E27FC236}">
-                <a16:creationId xmlns:a16="http://schemas.microsoft.com/office/drawing/2014/main" id="{3AABA33C-357C-4B5E-BFFE-4825DA560ECC}"/>
+                <a16:creationId xmlns:a16="http://schemas.microsoft.com/office/drawing/2014/main" id="{AA5ADDAD-D197-4498-B38B-31B54D95ED76}"/>
               </a:ext>
             </a:extLst>
           </p:cNvPr>
@@ -2252,7 +2252,7 @@
           <p:cNvPr id="4" name="close-arrow">
             <a:extLst xmlns:a="http://schemas.openxmlformats.org/drawingml/2006/main">
               <a:ext uri="{FF2B5EF4-FFF2-40B4-BE49-F238E27FC236}">
-                <a16:creationId xmlns:a16="http://schemas.microsoft.com/office/drawing/2014/main" id="{E3D8B76B-E755-45FF-8B90-5D5428506F1F}"/>
+                <a16:creationId xmlns:a16="http://schemas.microsoft.com/office/drawing/2014/main" id="{54E65A9D-26DC-4623-A46C-F3455C63C129}"/>
               </a:ext>
             </a:extLst>
           </p:cNvPr>
@@ -2283,7 +2283,7 @@
           <p:cNvPr id="5" name="close-check-ring">
             <a:extLst xmlns:a="http://schemas.openxmlformats.org/drawingml/2006/main">
               <a:ext uri="{FF2B5EF4-FFF2-40B4-BE49-F238E27FC236}">
-                <a16:creationId xmlns:a16="http://schemas.microsoft.com/office/drawing/2014/main" id="{7E363D83-AED5-480A-B0B9-982B58B06C2E}"/>
+                <a16:creationId xmlns:a16="http://schemas.microsoft.com/office/drawing/2014/main" id="{2ADFF26E-A1D0-4E10-BF65-460830EEE1F7}"/>
               </a:ext>
             </a:extLst>
           </p:cNvPr>
@@ -2316,7 +2316,7 @@
           <p:cNvPr id="6" name="close-check">
             <a:extLst xmlns:a="http://schemas.openxmlformats.org/drawingml/2006/main">
               <a:ext uri="{FF2B5EF4-FFF2-40B4-BE49-F238E27FC236}">
-                <a16:creationId xmlns:a16="http://schemas.microsoft.com/office/drawing/2014/main" id="{A9EC794F-00D8-497F-A61E-108745FEF9F5}"/>
+                <a16:creationId xmlns:a16="http://schemas.microsoft.com/office/drawing/2014/main" id="{2D3A7605-F9D7-4E67-88AA-7FAB91260468}"/>
               </a:ext>
             </a:extLst>
           </p:cNvPr>
@@ -2361,7 +2361,7 @@
           <p:cNvPr id="7" name="close-kicker">
             <a:extLst xmlns:a="http://schemas.openxmlformats.org/drawingml/2006/main">
               <a:ext uri="{FF2B5EF4-FFF2-40B4-BE49-F238E27FC236}">
-                <a16:creationId xmlns:a16="http://schemas.microsoft.com/office/drawing/2014/main" id="{71E27262-9E22-4E1D-84E4-E76B5CFAD13C}"/>
+                <a16:creationId xmlns:a16="http://schemas.microsoft.com/office/drawing/2014/main" id="{B45269C4-C9F5-48BA-8759-9290F6DD33E0}"/>
               </a:ext>
             </a:extLst>
           </p:cNvPr>
@@ -2406,7 +2406,7 @@
           <p:cNvPr id="8" name="close-title">
             <a:extLst xmlns:a="http://schemas.openxmlformats.org/drawingml/2006/main">
               <a:ext uri="{FF2B5EF4-FFF2-40B4-BE49-F238E27FC236}">
-                <a16:creationId xmlns:a16="http://schemas.microsoft.com/office/drawing/2014/main" id="{C85814F0-B2B5-44E2-AC83-70A6BD879D40}"/>
+                <a16:creationId xmlns:a16="http://schemas.microsoft.com/office/drawing/2014/main" id="{52EB186D-40BB-4EE0-9B61-0FA891A0E3DA}"/>
               </a:ext>
             </a:extLst>
           </p:cNvPr>
@@ -2452,7 +2452,7 @@
           <p:cNvPr id="9" name="close-subtitle">
             <a:extLst xmlns:a="http://schemas.openxmlformats.org/drawingml/2006/main">
               <a:ext uri="{FF2B5EF4-FFF2-40B4-BE49-F238E27FC236}">
-                <a16:creationId xmlns:a16="http://schemas.microsoft.com/office/drawing/2014/main" id="{7FEE0366-51A1-4BFE-8D94-B74B0FBF412B}"/>
+                <a16:creationId xmlns:a16="http://schemas.microsoft.com/office/drawing/2014/main" id="{C3B4E5A5-1D40-4B4C-A141-F2B3F4118F2C}"/>
               </a:ext>
             </a:extLst>
           </p:cNvPr>
@@ -2497,7 +2497,7 @@
           <p:cNvPr id="10" name="close-num-0">
             <a:extLst xmlns:a="http://schemas.openxmlformats.org/drawingml/2006/main">
               <a:ext uri="{FF2B5EF4-FFF2-40B4-BE49-F238E27FC236}">
-                <a16:creationId xmlns:a16="http://schemas.microsoft.com/office/drawing/2014/main" id="{41466FDE-254C-4B25-B8FF-CDFC43E875D1}"/>
+                <a16:creationId xmlns:a16="http://schemas.microsoft.com/office/drawing/2014/main" id="{AF346830-9D8E-481E-82AA-E048543F3197}"/>
               </a:ext>
             </a:extLst>
           </p:cNvPr>
@@ -2542,7 +2542,7 @@
           <p:cNvPr id="11" name="close-body-0">
             <a:extLst xmlns:a="http://schemas.openxmlformats.org/drawingml/2006/main">
               <a:ext uri="{FF2B5EF4-FFF2-40B4-BE49-F238E27FC236}">
-                <a16:creationId xmlns:a16="http://schemas.microsoft.com/office/drawing/2014/main" id="{61C112A0-015F-462D-809A-A0EA8FA836A0}"/>
+                <a16:creationId xmlns:a16="http://schemas.microsoft.com/office/drawing/2014/main" id="{2F8C2C04-3BAC-4298-BB0B-913A8B09F227}"/>
               </a:ext>
             </a:extLst>
           </p:cNvPr>
@@ -2587,7 +2587,7 @@
           <p:cNvPr id="12" name="close-num-1">
             <a:extLst xmlns:a="http://schemas.openxmlformats.org/drawingml/2006/main">
               <a:ext uri="{FF2B5EF4-FFF2-40B4-BE49-F238E27FC236}">
-                <a16:creationId xmlns:a16="http://schemas.microsoft.com/office/drawing/2014/main" id="{1F827BCB-CC22-4470-9C38-E9A593CAE157}"/>
+                <a16:creationId xmlns:a16="http://schemas.microsoft.com/office/drawing/2014/main" id="{04E8D73A-4784-4C0A-9D82-8BDB22E256F0}"/>
               </a:ext>
             </a:extLst>
           </p:cNvPr>
@@ -2632,7 +2632,7 @@
           <p:cNvPr id="13" name="close-body-1">
             <a:extLst xmlns:a="http://schemas.openxmlformats.org/drawingml/2006/main">
               <a:ext uri="{FF2B5EF4-FFF2-40B4-BE49-F238E27FC236}">
-                <a16:creationId xmlns:a16="http://schemas.microsoft.com/office/drawing/2014/main" id="{F6C79B62-3CCE-417A-ACFF-8901B119D46D}"/>
+                <a16:creationId xmlns:a16="http://schemas.microsoft.com/office/drawing/2014/main" id="{531E3A18-AFEE-4612-9E3D-D0F7BD6CDA08}"/>
               </a:ext>
             </a:extLst>
           </p:cNvPr>
@@ -2677,7 +2677,7 @@
           <p:cNvPr id="14" name="close-num-2">
             <a:extLst xmlns:a="http://schemas.openxmlformats.org/drawingml/2006/main">
               <a:ext uri="{FF2B5EF4-FFF2-40B4-BE49-F238E27FC236}">
-                <a16:creationId xmlns:a16="http://schemas.microsoft.com/office/drawing/2014/main" id="{0822D808-C5D4-401C-BB86-D535A241FFC4}"/>
+                <a16:creationId xmlns:a16="http://schemas.microsoft.com/office/drawing/2014/main" id="{5CC891AE-A9C1-41C9-8E35-15A7B1AF79C3}"/>
               </a:ext>
             </a:extLst>
           </p:cNvPr>
@@ -2722,7 +2722,7 @@
           <p:cNvPr id="15" name="close-body-2">
             <a:extLst xmlns:a="http://schemas.openxmlformats.org/drawingml/2006/main">
               <a:ext uri="{FF2B5EF4-FFF2-40B4-BE49-F238E27FC236}">
-                <a16:creationId xmlns:a16="http://schemas.microsoft.com/office/drawing/2014/main" id="{C2952B3F-4140-4A59-BA2B-A1D1AEC0B81F}"/>
+                <a16:creationId xmlns:a16="http://schemas.microsoft.com/office/drawing/2014/main" id="{5B696F0F-E341-4932-A344-E2A8EEA3F409}"/>
               </a:ext>
             </a:extLst>
           </p:cNvPr>
@@ -2767,7 +2767,7 @@
           <p:cNvPr id="16" name="close-next">
             <a:extLst xmlns:a="http://schemas.openxmlformats.org/drawingml/2006/main">
               <a:ext uri="{FF2B5EF4-FFF2-40B4-BE49-F238E27FC236}">
-                <a16:creationId xmlns:a16="http://schemas.microsoft.com/office/drawing/2014/main" id="{34DB04DD-1A8E-44C4-AAC7-2BE34BD2DAA3}"/>
+                <a16:creationId xmlns:a16="http://schemas.microsoft.com/office/drawing/2014/main" id="{FAEB7A47-271C-46DA-B461-2C289F4CB773}"/>
               </a:ext>
             </a:extLst>
           </p:cNvPr>
@@ -2802,7 +2802,7 @@
           <p:cNvPr id="17" name="close-next-kicker">
             <a:extLst xmlns:a="http://schemas.openxmlformats.org/drawingml/2006/main">
               <a:ext uri="{FF2B5EF4-FFF2-40B4-BE49-F238E27FC236}">
-                <a16:creationId xmlns:a16="http://schemas.microsoft.com/office/drawing/2014/main" id="{3E253F1C-3146-4B15-A14D-3ED37F1BD16B}"/>
+                <a16:creationId xmlns:a16="http://schemas.microsoft.com/office/drawing/2014/main" id="{D3296212-1854-4434-BCDD-8C3A0817266A}"/>
               </a:ext>
             </a:extLst>
           </p:cNvPr>
@@ -2847,7 +2847,7 @@
           <p:cNvPr id="18" name="close-next-body">
             <a:extLst xmlns:a="http://schemas.openxmlformats.org/drawingml/2006/main">
               <a:ext uri="{FF2B5EF4-FFF2-40B4-BE49-F238E27FC236}">
-                <a16:creationId xmlns:a16="http://schemas.microsoft.com/office/drawing/2014/main" id="{923535E1-DAEB-4372-A3D8-3DD13C6D69C6}"/>
+                <a16:creationId xmlns:a16="http://schemas.microsoft.com/office/drawing/2014/main" id="{B56B292A-3907-4578-8C1B-BCD539F788A1}"/>
               </a:ext>
             </a:extLst>
           </p:cNvPr>
@@ -2892,7 +2892,7 @@
           <p:cNvPr id="19" name="close-fun">
             <a:extLst xmlns:a="http://schemas.openxmlformats.org/drawingml/2006/main">
               <a:ext uri="{FF2B5EF4-FFF2-40B4-BE49-F238E27FC236}">
-                <a16:creationId xmlns:a16="http://schemas.microsoft.com/office/drawing/2014/main" id="{BE0C9C2A-EED7-49A2-9C85-01F46CF74104}"/>
+                <a16:creationId xmlns:a16="http://schemas.microsoft.com/office/drawing/2014/main" id="{236B32BD-CC74-42C5-9F0D-7ED8962F141A}"/>
               </a:ext>
             </a:extLst>
           </p:cNvPr>
@@ -2935,7 +2935,7 @@
     </p:spTree>
     <p:extLst>
       <p:ext uri="{BB962C8B-B14F-4D97-AF65-F5344CB8AC3E}">
-        <p14:creationId xmlns:p14="http://schemas.microsoft.com/office/powerpoint/2010/main" val="52754784"/>
+        <p14:creationId xmlns:p14="http://schemas.microsoft.com/office/powerpoint/2010/main" val="1507179353"/>
       </p:ext>
     </p:extLst>
   </p:cSld>
@@ -2966,7 +2966,7 @@
           <p:cNvPr id="1" name="kicker-2">
             <a:extLst xmlns:a="http://schemas.openxmlformats.org/drawingml/2006/main">
               <a:ext uri="{FF2B5EF4-FFF2-40B4-BE49-F238E27FC236}">
-                <a16:creationId xmlns:a16="http://schemas.microsoft.com/office/drawing/2014/main" id="{B296A870-BCE9-480D-8066-4F87D202CFCB}"/>
+                <a16:creationId xmlns:a16="http://schemas.microsoft.com/office/drawing/2014/main" id="{5C42869D-58C9-4E35-98A7-AAC34463C234}"/>
               </a:ext>
             </a:extLst>
           </p:cNvPr>
@@ -3011,7 +3011,7 @@
           <p:cNvPr id="2" name="title-2">
             <a:extLst xmlns:a="http://schemas.openxmlformats.org/drawingml/2006/main">
               <a:ext uri="{FF2B5EF4-FFF2-40B4-BE49-F238E27FC236}">
-                <a16:creationId xmlns:a16="http://schemas.microsoft.com/office/drawing/2014/main" id="{ED1181EB-9F0B-43AA-A721-CD7FECF160F0}"/>
+                <a16:creationId xmlns:a16="http://schemas.microsoft.com/office/drawing/2014/main" id="{89BBB2FA-D1F8-4E00-9771-7512B79C3363}"/>
               </a:ext>
             </a:extLst>
           </p:cNvPr>
@@ -3078,7 +3078,7 @@
           <p:cNvPr id="4" name="number-2">
             <a:extLst xmlns:a="http://schemas.openxmlformats.org/drawingml/2006/main">
               <a:ext uri="{FF2B5EF4-FFF2-40B4-BE49-F238E27FC236}">
-                <a16:creationId xmlns:a16="http://schemas.microsoft.com/office/drawing/2014/main" id="{EB016D1B-1163-4285-96DD-5A6FBFF11392}"/>
+                <a16:creationId xmlns:a16="http://schemas.microsoft.com/office/drawing/2014/main" id="{BF49BC89-713E-4909-A492-2935637B23E3}"/>
               </a:ext>
             </a:extLst>
           </p:cNvPr>
@@ -3145,7 +3145,7 @@
           <p:cNvPr id="6" name="solo-dot-0">
             <a:extLst xmlns:a="http://schemas.openxmlformats.org/drawingml/2006/main">
               <a:ext uri="{FF2B5EF4-FFF2-40B4-BE49-F238E27FC236}">
-                <a16:creationId xmlns:a16="http://schemas.microsoft.com/office/drawing/2014/main" id="{6CF75D15-B394-4143-B947-74C17CBC15BD}"/>
+                <a16:creationId xmlns:a16="http://schemas.microsoft.com/office/drawing/2014/main" id="{FC0C1EF2-97EC-4EF4-A507-56368286BC87}"/>
               </a:ext>
             </a:extLst>
           </p:cNvPr>
@@ -3198,7 +3198,7 @@
           <p:cNvPr id="8" name="solo-dot-1">
             <a:extLst xmlns:a="http://schemas.openxmlformats.org/drawingml/2006/main">
               <a:ext uri="{FF2B5EF4-FFF2-40B4-BE49-F238E27FC236}">
-                <a16:creationId xmlns:a16="http://schemas.microsoft.com/office/drawing/2014/main" id="{29FE0531-ED15-461B-B4DC-A33BEACBB316}"/>
+                <a16:creationId xmlns:a16="http://schemas.microsoft.com/office/drawing/2014/main" id="{2C9533B8-C3F1-44DA-B47C-D8DE1DE446A8}"/>
               </a:ext>
             </a:extLst>
           </p:cNvPr>
@@ -3251,7 +3251,7 @@
           <p:cNvPr id="10" name="solo-dot-2">
             <a:extLst xmlns:a="http://schemas.openxmlformats.org/drawingml/2006/main">
               <a:ext uri="{FF2B5EF4-FFF2-40B4-BE49-F238E27FC236}">
-                <a16:creationId xmlns:a16="http://schemas.microsoft.com/office/drawing/2014/main" id="{C87B4676-C91E-4DF4-ACD2-9B4E9D836031}"/>
+                <a16:creationId xmlns:a16="http://schemas.microsoft.com/office/drawing/2014/main" id="{57588140-44E3-4ADC-803D-7799A0BD91A3}"/>
               </a:ext>
             </a:extLst>
           </p:cNvPr>
@@ -3304,7 +3304,7 @@
           <p:cNvPr id="12" name="solo-dot-3">
             <a:extLst xmlns:a="http://schemas.openxmlformats.org/drawingml/2006/main">
               <a:ext uri="{FF2B5EF4-FFF2-40B4-BE49-F238E27FC236}">
-                <a16:creationId xmlns:a16="http://schemas.microsoft.com/office/drawing/2014/main" id="{9D65D914-57F4-400A-A5EC-96C58E9D90C9}"/>
+                <a16:creationId xmlns:a16="http://schemas.microsoft.com/office/drawing/2014/main" id="{F07C621C-F269-4069-9971-EB8D259EFDDC}"/>
               </a:ext>
             </a:extLst>
           </p:cNvPr>
@@ -3357,7 +3357,7 @@
           <p:cNvPr id="14" name="solo-dot-4">
             <a:extLst xmlns:a="http://schemas.openxmlformats.org/drawingml/2006/main">
               <a:ext uri="{FF2B5EF4-FFF2-40B4-BE49-F238E27FC236}">
-                <a16:creationId xmlns:a16="http://schemas.microsoft.com/office/drawing/2014/main" id="{2C25E82D-953E-4487-AE04-D9D0150A5A80}"/>
+                <a16:creationId xmlns:a16="http://schemas.microsoft.com/office/drawing/2014/main" id="{C430AD1C-881C-4C8A-9D51-6800393E24DD}"/>
               </a:ext>
             </a:extLst>
           </p:cNvPr>
@@ -3410,7 +3410,7 @@
           <p:cNvPr id="16" name="solo-dot-5">
             <a:extLst xmlns:a="http://schemas.openxmlformats.org/drawingml/2006/main">
               <a:ext uri="{FF2B5EF4-FFF2-40B4-BE49-F238E27FC236}">
-                <a16:creationId xmlns:a16="http://schemas.microsoft.com/office/drawing/2014/main" id="{14698919-E8C6-42F3-A459-4B1F9256A780}"/>
+                <a16:creationId xmlns:a16="http://schemas.microsoft.com/office/drawing/2014/main" id="{09DDF6BF-3635-4072-9B56-4BA6ADE36429}"/>
               </a:ext>
             </a:extLst>
           </p:cNvPr>
@@ -3463,7 +3463,7 @@
           <p:cNvPr id="18" name="solo-dot-6">
             <a:extLst xmlns:a="http://schemas.openxmlformats.org/drawingml/2006/main">
               <a:ext uri="{FF2B5EF4-FFF2-40B4-BE49-F238E27FC236}">
-                <a16:creationId xmlns:a16="http://schemas.microsoft.com/office/drawing/2014/main" id="{2ACC0418-1661-4EBF-9892-68FBCA9E09A8}"/>
+                <a16:creationId xmlns:a16="http://schemas.microsoft.com/office/drawing/2014/main" id="{2C2C25D0-96AA-48A0-BD87-B9DF05C3C760}"/>
               </a:ext>
             </a:extLst>
           </p:cNvPr>
@@ -3516,7 +3516,7 @@
           <p:cNvPr id="20" name="orchestra-arrow">
             <a:extLst xmlns:a="http://schemas.openxmlformats.org/drawingml/2006/main">
               <a:ext uri="{FF2B5EF4-FFF2-40B4-BE49-F238E27FC236}">
-                <a16:creationId xmlns:a16="http://schemas.microsoft.com/office/drawing/2014/main" id="{75551FD0-60D3-45C0-A34A-C9BB54DAF516}"/>
+                <a16:creationId xmlns:a16="http://schemas.microsoft.com/office/drawing/2014/main" id="{D791E011-A7DD-49A8-B848-7EBEAF583D8F}"/>
               </a:ext>
             </a:extLst>
           </p:cNvPr>
@@ -3547,7 +3547,7 @@
           <p:cNvPr id="21" name="orchestra-check-ring">
             <a:extLst xmlns:a="http://schemas.openxmlformats.org/drawingml/2006/main">
               <a:ext uri="{FF2B5EF4-FFF2-40B4-BE49-F238E27FC236}">
-                <a16:creationId xmlns:a16="http://schemas.microsoft.com/office/drawing/2014/main" id="{6F6EEF39-EDD0-4549-8992-4F6665500DEC}"/>
+                <a16:creationId xmlns:a16="http://schemas.microsoft.com/office/drawing/2014/main" id="{D7BBCC37-8335-4616-92D1-5A4AAADBA23B}"/>
               </a:ext>
             </a:extLst>
           </p:cNvPr>
@@ -3580,7 +3580,7 @@
           <p:cNvPr id="22" name="orchestra-check">
             <a:extLst xmlns:a="http://schemas.openxmlformats.org/drawingml/2006/main">
               <a:ext uri="{FF2B5EF4-FFF2-40B4-BE49-F238E27FC236}">
-                <a16:creationId xmlns:a16="http://schemas.microsoft.com/office/drawing/2014/main" id="{049916D1-13B2-4FF5-84EF-2438E3001394}"/>
+                <a16:creationId xmlns:a16="http://schemas.microsoft.com/office/drawing/2014/main" id="{BC231EC2-A022-4C07-8BFA-067BB7BDD5E3}"/>
               </a:ext>
             </a:extLst>
           </p:cNvPr>
@@ -3625,7 +3625,7 @@
           <p:cNvPr id="23" name="orchestra-baton">
             <a:extLst xmlns:a="http://schemas.openxmlformats.org/drawingml/2006/main">
               <a:ext uri="{FF2B5EF4-FFF2-40B4-BE49-F238E27FC236}">
-                <a16:creationId xmlns:a16="http://schemas.microsoft.com/office/drawing/2014/main" id="{EE1FAFA9-BBB5-4CD3-B7EE-E054E5832081}"/>
+                <a16:creationId xmlns:a16="http://schemas.microsoft.com/office/drawing/2014/main" id="{2513138B-BFC1-4830-A4A5-246F0CDCF5A7}"/>
               </a:ext>
             </a:extLst>
           </p:cNvPr>
@@ -3656,7 +3656,7 @@
           <p:cNvPr id="24" name="orchestra-baton-tip">
             <a:extLst xmlns:a="http://schemas.openxmlformats.org/drawingml/2006/main">
               <a:ext uri="{FF2B5EF4-FFF2-40B4-BE49-F238E27FC236}">
-                <a16:creationId xmlns:a16="http://schemas.microsoft.com/office/drawing/2014/main" id="{4E250688-980D-4F5E-B6FE-653D2885CA3B}"/>
+                <a16:creationId xmlns:a16="http://schemas.microsoft.com/office/drawing/2014/main" id="{4105C363-D66B-449C-8E48-42ED9A6BD753}"/>
               </a:ext>
             </a:extLst>
           </p:cNvPr>
@@ -3687,7 +3687,7 @@
           <p:cNvPr id="25" name="solo-label-0">
             <a:extLst xmlns:a="http://schemas.openxmlformats.org/drawingml/2006/main">
               <a:ext uri="{FF2B5EF4-FFF2-40B4-BE49-F238E27FC236}">
-                <a16:creationId xmlns:a16="http://schemas.microsoft.com/office/drawing/2014/main" id="{4EE5637D-8919-4BF4-8727-76DF66B89999}"/>
+                <a16:creationId xmlns:a16="http://schemas.microsoft.com/office/drawing/2014/main" id="{118A08B2-56A5-4B4E-9565-E79AD2198BC3}"/>
               </a:ext>
             </a:extLst>
           </p:cNvPr>
@@ -3732,7 +3732,7 @@
           <p:cNvPr id="26" name="solo-note-0">
             <a:extLst xmlns:a="http://schemas.openxmlformats.org/drawingml/2006/main">
               <a:ext uri="{FF2B5EF4-FFF2-40B4-BE49-F238E27FC236}">
-                <a16:creationId xmlns:a16="http://schemas.microsoft.com/office/drawing/2014/main" id="{2F6CF753-83B8-408A-95FC-B73058CD5C52}"/>
+                <a16:creationId xmlns:a16="http://schemas.microsoft.com/office/drawing/2014/main" id="{D1F7ABED-56A8-40C6-B25A-7B260B21189A}"/>
               </a:ext>
             </a:extLst>
           </p:cNvPr>
@@ -3777,7 +3777,7 @@
           <p:cNvPr id="27" name="solo-label-1">
             <a:extLst xmlns:a="http://schemas.openxmlformats.org/drawingml/2006/main">
               <a:ext uri="{FF2B5EF4-FFF2-40B4-BE49-F238E27FC236}">
-                <a16:creationId xmlns:a16="http://schemas.microsoft.com/office/drawing/2014/main" id="{EADCFF07-2056-420A-B441-4A53C9299582}"/>
+                <a16:creationId xmlns:a16="http://schemas.microsoft.com/office/drawing/2014/main" id="{3AB0D319-0D84-40C0-9BED-483F9C321F1F}"/>
               </a:ext>
             </a:extLst>
           </p:cNvPr>
@@ -3822,7 +3822,7 @@
           <p:cNvPr id="28" name="solo-note-1">
             <a:extLst xmlns:a="http://schemas.openxmlformats.org/drawingml/2006/main">
               <a:ext uri="{FF2B5EF4-FFF2-40B4-BE49-F238E27FC236}">
-                <a16:creationId xmlns:a16="http://schemas.microsoft.com/office/drawing/2014/main" id="{93799AC8-0652-4949-B4B1-3FCADB058722}"/>
+                <a16:creationId xmlns:a16="http://schemas.microsoft.com/office/drawing/2014/main" id="{91F2AA3C-A71E-4484-857D-B88B9509B2AE}"/>
               </a:ext>
             </a:extLst>
           </p:cNvPr>
@@ -3867,7 +3867,7 @@
           <p:cNvPr id="29" name="solo-label-2">
             <a:extLst xmlns:a="http://schemas.openxmlformats.org/drawingml/2006/main">
               <a:ext uri="{FF2B5EF4-FFF2-40B4-BE49-F238E27FC236}">
-                <a16:creationId xmlns:a16="http://schemas.microsoft.com/office/drawing/2014/main" id="{4D436F39-C79E-470E-AE5B-61D8514AA2AF}"/>
+                <a16:creationId xmlns:a16="http://schemas.microsoft.com/office/drawing/2014/main" id="{5C9E05A4-F507-45C5-BAF8-E6EAFF45E931}"/>
               </a:ext>
             </a:extLst>
           </p:cNvPr>
@@ -3912,7 +3912,7 @@
           <p:cNvPr id="30" name="solo-note-2">
             <a:extLst xmlns:a="http://schemas.openxmlformats.org/drawingml/2006/main">
               <a:ext uri="{FF2B5EF4-FFF2-40B4-BE49-F238E27FC236}">
-                <a16:creationId xmlns:a16="http://schemas.microsoft.com/office/drawing/2014/main" id="{BC9641F3-9F86-4E13-B6D4-ED3C0744C43E}"/>
+                <a16:creationId xmlns:a16="http://schemas.microsoft.com/office/drawing/2014/main" id="{55281D87-44F0-4FBA-878A-48D5B47CAFB8}"/>
               </a:ext>
             </a:extLst>
           </p:cNvPr>
@@ -3957,7 +3957,7 @@
           <p:cNvPr id="31" name="solo-label-3">
             <a:extLst xmlns:a="http://schemas.openxmlformats.org/drawingml/2006/main">
               <a:ext uri="{FF2B5EF4-FFF2-40B4-BE49-F238E27FC236}">
-                <a16:creationId xmlns:a16="http://schemas.microsoft.com/office/drawing/2014/main" id="{E27DE9B7-A061-45F1-A338-AE2285A1B47E}"/>
+                <a16:creationId xmlns:a16="http://schemas.microsoft.com/office/drawing/2014/main" id="{3C09475B-C8C4-47CA-9E10-5EB407BC019C}"/>
               </a:ext>
             </a:extLst>
           </p:cNvPr>
@@ -4002,7 +4002,7 @@
           <p:cNvPr id="32" name="solo-note-3">
             <a:extLst xmlns:a="http://schemas.openxmlformats.org/drawingml/2006/main">
               <a:ext uri="{FF2B5EF4-FFF2-40B4-BE49-F238E27FC236}">
-                <a16:creationId xmlns:a16="http://schemas.microsoft.com/office/drawing/2014/main" id="{C61B03C8-FE15-44CC-8B31-F0471B656812}"/>
+                <a16:creationId xmlns:a16="http://schemas.microsoft.com/office/drawing/2014/main" id="{99F5F917-C878-4CC8-A12F-D227FD0F6FB5}"/>
               </a:ext>
             </a:extLst>
           </p:cNvPr>
@@ -4047,7 +4047,7 @@
           <p:cNvPr id="33" name="solo-label-4">
             <a:extLst xmlns:a="http://schemas.openxmlformats.org/drawingml/2006/main">
               <a:ext uri="{FF2B5EF4-FFF2-40B4-BE49-F238E27FC236}">
-                <a16:creationId xmlns:a16="http://schemas.microsoft.com/office/drawing/2014/main" id="{3833DB86-3AF9-4486-8CAB-07E2EA57E229}"/>
+                <a16:creationId xmlns:a16="http://schemas.microsoft.com/office/drawing/2014/main" id="{31147CE2-ED70-4B1D-BA44-1858953BBA79}"/>
               </a:ext>
             </a:extLst>
           </p:cNvPr>
@@ -4092,7 +4092,7 @@
           <p:cNvPr id="34" name="solo-note-4">
             <a:extLst xmlns:a="http://schemas.openxmlformats.org/drawingml/2006/main">
               <a:ext uri="{FF2B5EF4-FFF2-40B4-BE49-F238E27FC236}">
-                <a16:creationId xmlns:a16="http://schemas.microsoft.com/office/drawing/2014/main" id="{E1040F11-1205-4312-ADF5-E96C9B917AD0}"/>
+                <a16:creationId xmlns:a16="http://schemas.microsoft.com/office/drawing/2014/main" id="{96F07D35-6454-4BE0-B7C8-C2AE12EFF767}"/>
               </a:ext>
             </a:extLst>
           </p:cNvPr>
@@ -4137,7 +4137,7 @@
           <p:cNvPr id="35" name="solo-label-5">
             <a:extLst xmlns:a="http://schemas.openxmlformats.org/drawingml/2006/main">
               <a:ext uri="{FF2B5EF4-FFF2-40B4-BE49-F238E27FC236}">
-                <a16:creationId xmlns:a16="http://schemas.microsoft.com/office/drawing/2014/main" id="{CE04CF43-E9E2-477A-9E87-1F7E62EDA12F}"/>
+                <a16:creationId xmlns:a16="http://schemas.microsoft.com/office/drawing/2014/main" id="{BF55B5D9-F296-498B-B8AB-B622DDE8D72E}"/>
               </a:ext>
             </a:extLst>
           </p:cNvPr>
@@ -4182,7 +4182,7 @@
           <p:cNvPr id="36" name="solo-note-5">
             <a:extLst xmlns:a="http://schemas.openxmlformats.org/drawingml/2006/main">
               <a:ext uri="{FF2B5EF4-FFF2-40B4-BE49-F238E27FC236}">
-                <a16:creationId xmlns:a16="http://schemas.microsoft.com/office/drawing/2014/main" id="{994EBB4B-2337-4A98-B5AA-72FA6ED13F10}"/>
+                <a16:creationId xmlns:a16="http://schemas.microsoft.com/office/drawing/2014/main" id="{AE20D876-4E85-4F2F-97AF-A8524D37C914}"/>
               </a:ext>
             </a:extLst>
           </p:cNvPr>
@@ -4227,7 +4227,7 @@
           <p:cNvPr id="37" name="solo-label-6">
             <a:extLst xmlns:a="http://schemas.openxmlformats.org/drawingml/2006/main">
               <a:ext uri="{FF2B5EF4-FFF2-40B4-BE49-F238E27FC236}">
-                <a16:creationId xmlns:a16="http://schemas.microsoft.com/office/drawing/2014/main" id="{ADFE73AE-DF5F-44D5-AB33-E1F5D4BF3639}"/>
+                <a16:creationId xmlns:a16="http://schemas.microsoft.com/office/drawing/2014/main" id="{F51C2505-363D-43B9-8613-73A7AD1080F9}"/>
               </a:ext>
             </a:extLst>
           </p:cNvPr>
@@ -4272,7 +4272,7 @@
           <p:cNvPr id="38" name="solo-note-6">
             <a:extLst xmlns:a="http://schemas.openxmlformats.org/drawingml/2006/main">
               <a:ext uri="{FF2B5EF4-FFF2-40B4-BE49-F238E27FC236}">
-                <a16:creationId xmlns:a16="http://schemas.microsoft.com/office/drawing/2014/main" id="{146DA8D3-D661-4797-A4E4-BFE0783A85DF}"/>
+                <a16:creationId xmlns:a16="http://schemas.microsoft.com/office/drawing/2014/main" id="{9909E5EA-6801-4F22-946D-FE87AC0F3D59}"/>
               </a:ext>
             </a:extLst>
           </p:cNvPr>
@@ -4317,7 +4317,7 @@
           <p:cNvPr id="39" name="orchestra-caption">
             <a:extLst xmlns:a="http://schemas.openxmlformats.org/drawingml/2006/main">
               <a:ext uri="{FF2B5EF4-FFF2-40B4-BE49-F238E27FC236}">
-                <a16:creationId xmlns:a16="http://schemas.microsoft.com/office/drawing/2014/main" id="{409939DC-0DF0-493A-8162-C85E809FB48F}"/>
+                <a16:creationId xmlns:a16="http://schemas.microsoft.com/office/drawing/2014/main" id="{2E77C6CB-4159-4300-B4C4-F8FE2C1533D0}"/>
               </a:ext>
             </a:extLst>
           </p:cNvPr>
@@ -4363,7 +4363,7 @@
           <p:cNvPr id="40" name="orchestra-punchline">
             <a:extLst xmlns:a="http://schemas.openxmlformats.org/drawingml/2006/main">
               <a:ext uri="{FF2B5EF4-FFF2-40B4-BE49-F238E27FC236}">
-                <a16:creationId xmlns:a16="http://schemas.microsoft.com/office/drawing/2014/main" id="{89E419F9-B295-4411-BF94-5F1BAD5A2408}"/>
+                <a16:creationId xmlns:a16="http://schemas.microsoft.com/office/drawing/2014/main" id="{7121D0DD-A83C-4929-B4C5-ABC20A03FC3B}"/>
               </a:ext>
             </a:extLst>
           </p:cNvPr>
@@ -4394,7 +4394,7 @@
           <p:cNvPr id="41" name="orchestra-punchline-text">
             <a:extLst xmlns:a="http://schemas.openxmlformats.org/drawingml/2006/main">
               <a:ext uri="{FF2B5EF4-FFF2-40B4-BE49-F238E27FC236}">
-                <a16:creationId xmlns:a16="http://schemas.microsoft.com/office/drawing/2014/main" id="{8F24F51E-6CD2-4B29-93F2-F25D319B7747}"/>
+                <a16:creationId xmlns:a16="http://schemas.microsoft.com/office/drawing/2014/main" id="{3BE58A16-4559-4C89-87D8-3E4C811EE687}"/>
               </a:ext>
             </a:extLst>
           </p:cNvPr>
@@ -4437,7 +4437,7 @@
     </p:spTree>
     <p:extLst>
       <p:ext uri="{BB962C8B-B14F-4D97-AF65-F5344CB8AC3E}">
-        <p14:creationId xmlns:p14="http://schemas.microsoft.com/office/powerpoint/2010/main" val="1187932504"/>
+        <p14:creationId xmlns:p14="http://schemas.microsoft.com/office/powerpoint/2010/main" val="245974069"/>
       </p:ext>
     </p:extLst>
   </p:cSld>
@@ -4468,7 +4468,7 @@
           <p:cNvPr id="1" name="kicker-3">
             <a:extLst xmlns:a="http://schemas.openxmlformats.org/drawingml/2006/main">
               <a:ext uri="{FF2B5EF4-FFF2-40B4-BE49-F238E27FC236}">
-                <a16:creationId xmlns:a16="http://schemas.microsoft.com/office/drawing/2014/main" id="{55DBA4A9-FE9D-4DAF-B462-73A961299489}"/>
+                <a16:creationId xmlns:a16="http://schemas.microsoft.com/office/drawing/2014/main" id="{D3FDDD57-DB2E-41DA-8752-366B4EF93A13}"/>
               </a:ext>
             </a:extLst>
           </p:cNvPr>
@@ -4513,7 +4513,7 @@
           <p:cNvPr id="2" name="title-3">
             <a:extLst xmlns:a="http://schemas.openxmlformats.org/drawingml/2006/main">
               <a:ext uri="{FF2B5EF4-FFF2-40B4-BE49-F238E27FC236}">
-                <a16:creationId xmlns:a16="http://schemas.microsoft.com/office/drawing/2014/main" id="{DC728A72-C715-4920-9B19-FD198FE2E0E4}"/>
+                <a16:creationId xmlns:a16="http://schemas.microsoft.com/office/drawing/2014/main" id="{3655271D-FB24-406D-8413-6B72BB9EAB84}"/>
               </a:ext>
             </a:extLst>
           </p:cNvPr>
@@ -4548,14 +4548,14 @@
               </a:defRPr>
             </a:pPr>
             <a:r>
-              <a:t>Eleven named stations make failures attributable</a:t>
+              <a:t>Twelve named stations make failures attributable</a:t>
             </a:r>
           </a:p>
         </p:txBody>
       </p:sp>
       <p:cxnSp>
         <p:nvCxnSpPr>
-          <p:cNvPr id="43" name="header-rule-3"/>
+          <p:cNvPr id="45" name="header-rule-3"/>
           <p:cNvCxnSpPr/>
           <p:nvPr/>
         </p:nvCxnSpPr>
@@ -4580,7 +4580,7 @@
           <p:cNvPr id="4" name="number-3">
             <a:extLst xmlns:a="http://schemas.openxmlformats.org/drawingml/2006/main">
               <a:ext uri="{FF2B5EF4-FFF2-40B4-BE49-F238E27FC236}">
-                <a16:creationId xmlns:a16="http://schemas.microsoft.com/office/drawing/2014/main" id="{75C656D6-1A5C-42EE-90D8-7A5208D8D9DA}"/>
+                <a16:creationId xmlns:a16="http://schemas.microsoft.com/office/drawing/2014/main" id="{DE6557B3-4786-47B8-8C76-4DDB498E4119}"/>
               </a:ext>
             </a:extLst>
           </p:cNvPr>
@@ -4622,7 +4622,7 @@
       </p:sp>
       <p:cxnSp>
         <p:nvCxnSpPr>
-          <p:cNvPr id="45" name="station-line-0"/>
+          <p:cNvPr id="47" name="station-line-0"/>
           <p:cNvCxnSpPr/>
           <p:nvPr/>
         </p:nvCxnSpPr>
@@ -4647,7 +4647,7 @@
           <p:cNvPr id="6" name="station-group-0">
             <a:extLst xmlns:a="http://schemas.openxmlformats.org/drawingml/2006/main">
               <a:ext uri="{FF2B5EF4-FFF2-40B4-BE49-F238E27FC236}">
-                <a16:creationId xmlns:a16="http://schemas.microsoft.com/office/drawing/2014/main" id="{273F3606-6C61-4293-AA89-8ED3443F4B5D}"/>
+                <a16:creationId xmlns:a16="http://schemas.microsoft.com/office/drawing/2014/main" id="{277B4ED2-0600-4286-9AA5-9F664201FA36}"/>
               </a:ext>
             </a:extLst>
           </p:cNvPr>
@@ -4692,7 +4692,7 @@
           <p:cNvPr id="7" name="station-dot-0-0">
             <a:extLst xmlns:a="http://schemas.openxmlformats.org/drawingml/2006/main">
               <a:ext uri="{FF2B5EF4-FFF2-40B4-BE49-F238E27FC236}">
-                <a16:creationId xmlns:a16="http://schemas.microsoft.com/office/drawing/2014/main" id="{46663232-0D28-4F31-8E04-92C83DECEFCE}"/>
+                <a16:creationId xmlns:a16="http://schemas.microsoft.com/office/drawing/2014/main" id="{06FF9650-B08E-4DBF-BCAE-A14407C4E010}"/>
               </a:ext>
             </a:extLst>
           </p:cNvPr>
@@ -4725,7 +4725,7 @@
           <p:cNvPr id="8" name="station-label-0-0">
             <a:extLst xmlns:a="http://schemas.openxmlformats.org/drawingml/2006/main">
               <a:ext uri="{FF2B5EF4-FFF2-40B4-BE49-F238E27FC236}">
-                <a16:creationId xmlns:a16="http://schemas.microsoft.com/office/drawing/2014/main" id="{CC0D9648-2CE7-4BAE-BE13-063AF1BC2DC3}"/>
+                <a16:creationId xmlns:a16="http://schemas.microsoft.com/office/drawing/2014/main" id="{15F79A4F-D362-4892-8A45-89C8A1E7D935}"/>
               </a:ext>
             </a:extLst>
           </p:cNvPr>
@@ -4770,7 +4770,7 @@
           <p:cNvPr id="9" name="station-dot-0-1">
             <a:extLst xmlns:a="http://schemas.openxmlformats.org/drawingml/2006/main">
               <a:ext uri="{FF2B5EF4-FFF2-40B4-BE49-F238E27FC236}">
-                <a16:creationId xmlns:a16="http://schemas.microsoft.com/office/drawing/2014/main" id="{9CA86018-EAB8-4A81-9A1A-D04E79D75E5A}"/>
+                <a16:creationId xmlns:a16="http://schemas.microsoft.com/office/drawing/2014/main" id="{7B0E1E7D-F6D1-442B-BF93-F92C7C11D90C}"/>
               </a:ext>
             </a:extLst>
           </p:cNvPr>
@@ -4803,7 +4803,7 @@
           <p:cNvPr id="10" name="station-label-0-1">
             <a:extLst xmlns:a="http://schemas.openxmlformats.org/drawingml/2006/main">
               <a:ext uri="{FF2B5EF4-FFF2-40B4-BE49-F238E27FC236}">
-                <a16:creationId xmlns:a16="http://schemas.microsoft.com/office/drawing/2014/main" id="{9FAE0214-0824-4025-8A8B-AEE364979EE3}"/>
+                <a16:creationId xmlns:a16="http://schemas.microsoft.com/office/drawing/2014/main" id="{7F4BDC57-4760-4225-979B-5F048217AFB3}"/>
               </a:ext>
             </a:extLst>
           </p:cNvPr>
@@ -4848,7 +4848,7 @@
           <p:cNvPr id="11" name="station-dot-0-2">
             <a:extLst xmlns:a="http://schemas.openxmlformats.org/drawingml/2006/main">
               <a:ext uri="{FF2B5EF4-FFF2-40B4-BE49-F238E27FC236}">
-                <a16:creationId xmlns:a16="http://schemas.microsoft.com/office/drawing/2014/main" id="{7DFE8E46-1279-4244-A6D0-18B8710A37A1}"/>
+                <a16:creationId xmlns:a16="http://schemas.microsoft.com/office/drawing/2014/main" id="{1097D9F4-28DB-4CB8-9F80-1EE26451F43A}"/>
               </a:ext>
             </a:extLst>
           </p:cNvPr>
@@ -4881,7 +4881,7 @@
           <p:cNvPr id="12" name="station-label-0-2">
             <a:extLst xmlns:a="http://schemas.openxmlformats.org/drawingml/2006/main">
               <a:ext uri="{FF2B5EF4-FFF2-40B4-BE49-F238E27FC236}">
-                <a16:creationId xmlns:a16="http://schemas.microsoft.com/office/drawing/2014/main" id="{600AFBD3-E2FE-49E9-83D3-C8DD29462A3E}"/>
+                <a16:creationId xmlns:a16="http://schemas.microsoft.com/office/drawing/2014/main" id="{841485D9-7496-4B0C-A2CD-33A8B53D9A41}"/>
               </a:ext>
             </a:extLst>
           </p:cNvPr>
@@ -4926,7 +4926,7 @@
           <p:cNvPr id="13" name="station-dot-0-3">
             <a:extLst xmlns:a="http://schemas.openxmlformats.org/drawingml/2006/main">
               <a:ext uri="{FF2B5EF4-FFF2-40B4-BE49-F238E27FC236}">
-                <a16:creationId xmlns:a16="http://schemas.microsoft.com/office/drawing/2014/main" id="{17508F93-96C5-4666-97BA-DB148C69A173}"/>
+                <a16:creationId xmlns:a16="http://schemas.microsoft.com/office/drawing/2014/main" id="{C0A78CC6-393F-4692-BA15-D3D97A6353E4}"/>
               </a:ext>
             </a:extLst>
           </p:cNvPr>
@@ -4959,7 +4959,7 @@
           <p:cNvPr id="14" name="station-label-0-3">
             <a:extLst xmlns:a="http://schemas.openxmlformats.org/drawingml/2006/main">
               <a:ext uri="{FF2B5EF4-FFF2-40B4-BE49-F238E27FC236}">
-                <a16:creationId xmlns:a16="http://schemas.microsoft.com/office/drawing/2014/main" id="{CE08F5C4-07EF-4CC6-89C6-18FE3826DFD5}"/>
+                <a16:creationId xmlns:a16="http://schemas.microsoft.com/office/drawing/2014/main" id="{76176960-F6F0-4307-B565-43F5449AE0D7}"/>
               </a:ext>
             </a:extLst>
           </p:cNvPr>
@@ -5001,7 +5001,7 @@
       </p:sp>
       <p:cxnSp>
         <p:nvCxnSpPr>
-          <p:cNvPr id="55" name="station-line-1"/>
+          <p:cNvPr id="57" name="station-line-1"/>
           <p:cNvCxnSpPr/>
           <p:nvPr/>
         </p:nvCxnSpPr>
@@ -5026,7 +5026,7 @@
           <p:cNvPr id="16" name="station-group-1">
             <a:extLst xmlns:a="http://schemas.openxmlformats.org/drawingml/2006/main">
               <a:ext uri="{FF2B5EF4-FFF2-40B4-BE49-F238E27FC236}">
-                <a16:creationId xmlns:a16="http://schemas.microsoft.com/office/drawing/2014/main" id="{7352ADFF-2631-47F6-9C85-699BAE4D7BF2}"/>
+                <a16:creationId xmlns:a16="http://schemas.microsoft.com/office/drawing/2014/main" id="{6B6F04CB-1522-402D-B0A2-EB37AF6DD6F6}"/>
               </a:ext>
             </a:extLst>
           </p:cNvPr>
@@ -5071,7 +5071,7 @@
           <p:cNvPr id="17" name="station-dot-1-0">
             <a:extLst xmlns:a="http://schemas.openxmlformats.org/drawingml/2006/main">
               <a:ext uri="{FF2B5EF4-FFF2-40B4-BE49-F238E27FC236}">
-                <a16:creationId xmlns:a16="http://schemas.microsoft.com/office/drawing/2014/main" id="{BDAACEBE-695C-44E6-A056-BE1385A54E26}"/>
+                <a16:creationId xmlns:a16="http://schemas.microsoft.com/office/drawing/2014/main" id="{3EF9CD01-1021-45E8-9752-C42F8B472E6F}"/>
               </a:ext>
             </a:extLst>
           </p:cNvPr>
@@ -5104,7 +5104,7 @@
           <p:cNvPr id="18" name="station-label-1-0">
             <a:extLst xmlns:a="http://schemas.openxmlformats.org/drawingml/2006/main">
               <a:ext uri="{FF2B5EF4-FFF2-40B4-BE49-F238E27FC236}">
-                <a16:creationId xmlns:a16="http://schemas.microsoft.com/office/drawing/2014/main" id="{C1FEDACF-2214-4578-A247-21F321CCDDDF}"/>
+                <a16:creationId xmlns:a16="http://schemas.microsoft.com/office/drawing/2014/main" id="{14E2EB19-D54D-4CFC-A172-4D5F0E17C9DD}"/>
               </a:ext>
             </a:extLst>
           </p:cNvPr>
@@ -5149,7 +5149,7 @@
           <p:cNvPr id="19" name="station-dot-1-1">
             <a:extLst xmlns:a="http://schemas.openxmlformats.org/drawingml/2006/main">
               <a:ext uri="{FF2B5EF4-FFF2-40B4-BE49-F238E27FC236}">
-                <a16:creationId xmlns:a16="http://schemas.microsoft.com/office/drawing/2014/main" id="{994FABFE-D23B-46D9-A9BC-14811B304D70}"/>
+                <a16:creationId xmlns:a16="http://schemas.microsoft.com/office/drawing/2014/main" id="{851CE4B1-07F1-4A43-BB5B-B8945669358B}"/>
               </a:ext>
             </a:extLst>
           </p:cNvPr>
@@ -5182,7 +5182,7 @@
           <p:cNvPr id="20" name="station-label-1-1">
             <a:extLst xmlns:a="http://schemas.openxmlformats.org/drawingml/2006/main">
               <a:ext uri="{FF2B5EF4-FFF2-40B4-BE49-F238E27FC236}">
-                <a16:creationId xmlns:a16="http://schemas.microsoft.com/office/drawing/2014/main" id="{27A8E026-9447-4DAB-A8F9-5DC974512F47}"/>
+                <a16:creationId xmlns:a16="http://schemas.microsoft.com/office/drawing/2014/main" id="{11E50755-D47F-4CAC-B1B3-7FA8C4FA735A}"/>
               </a:ext>
             </a:extLst>
           </p:cNvPr>
@@ -5224,7 +5224,7 @@
       </p:sp>
       <p:cxnSp>
         <p:nvCxnSpPr>
-          <p:cNvPr id="61" name="station-line-2"/>
+          <p:cNvPr id="63" name="station-line-2"/>
           <p:cNvCxnSpPr/>
           <p:nvPr/>
         </p:nvCxnSpPr>
@@ -5249,7 +5249,7 @@
           <p:cNvPr id="22" name="station-group-2">
             <a:extLst xmlns:a="http://schemas.openxmlformats.org/drawingml/2006/main">
               <a:ext uri="{FF2B5EF4-FFF2-40B4-BE49-F238E27FC236}">
-                <a16:creationId xmlns:a16="http://schemas.microsoft.com/office/drawing/2014/main" id="{0FB1A39E-5FB6-4727-9B91-5F144B1813F3}"/>
+                <a16:creationId xmlns:a16="http://schemas.microsoft.com/office/drawing/2014/main" id="{3AA5F6DC-4196-4FDB-B333-9427F351FE76}"/>
               </a:ext>
             </a:extLst>
           </p:cNvPr>
@@ -5284,7 +5284,7 @@
               </a:defRPr>
             </a:pPr>
             <a:r>
-              <a:t>TUI CORE  •  3</a:t>
+              <a:t>TUI CORE  •  4</a:t>
             </a:r>
           </a:p>
         </p:txBody>
@@ -5294,7 +5294,7 @@
           <p:cNvPr id="23" name="station-dot-2-0">
             <a:extLst xmlns:a="http://schemas.openxmlformats.org/drawingml/2006/main">
               <a:ext uri="{FF2B5EF4-FFF2-40B4-BE49-F238E27FC236}">
-                <a16:creationId xmlns:a16="http://schemas.microsoft.com/office/drawing/2014/main" id="{AB7EC97D-A4CA-4325-82C3-E70524C9EE27}"/>
+                <a16:creationId xmlns:a16="http://schemas.microsoft.com/office/drawing/2014/main" id="{DB292F1F-5126-447D-A60E-7502D7BDCBD4}"/>
               </a:ext>
             </a:extLst>
           </p:cNvPr>
@@ -5327,7 +5327,7 @@
           <p:cNvPr id="24" name="station-label-2-0">
             <a:extLst xmlns:a="http://schemas.openxmlformats.org/drawingml/2006/main">
               <a:ext uri="{FF2B5EF4-FFF2-40B4-BE49-F238E27FC236}">
-                <a16:creationId xmlns:a16="http://schemas.microsoft.com/office/drawing/2014/main" id="{970F7E8E-2CCD-4F2E-9C22-954A33781152}"/>
+                <a16:creationId xmlns:a16="http://schemas.microsoft.com/office/drawing/2014/main" id="{B5850E79-7E42-4BE5-8B8B-69DC353FFFAC}"/>
               </a:ext>
             </a:extLst>
           </p:cNvPr>
@@ -5362,7 +5362,7 @@
               </a:defRPr>
             </a:pPr>
             <a:r>
-              <a:t>typecheck</a:t>
+              <a:t>runtime range</a:t>
             </a:r>
           </a:p>
         </p:txBody>
@@ -5372,18 +5372,18 @@
           <p:cNvPr id="25" name="station-dot-2-1">
             <a:extLst xmlns:a="http://schemas.openxmlformats.org/drawingml/2006/main">
               <a:ext uri="{FF2B5EF4-FFF2-40B4-BE49-F238E27FC236}">
-                <a16:creationId xmlns:a16="http://schemas.microsoft.com/office/drawing/2014/main" id="{B8B23E87-9DE0-4C01-B522-7D30155233A6}"/>
-              </a:ext>
-            </a:extLst>
-          </p:cNvPr>
-          <p:cNvSpPr>
-            <a:spLocks xmlns:a="http://schemas.openxmlformats.org/drawingml/2006/main" noGrp="1"/>
-          </p:cNvSpPr>
-          <p:nvPr/>
-        </p:nvSpPr>
-        <p:spPr>
-          <a:xfrm xmlns:a="http://schemas.openxmlformats.org/drawingml/2006/main">
-            <a:off x="6972300" y="3876675"/>
+                <a16:creationId xmlns:a16="http://schemas.microsoft.com/office/drawing/2014/main" id="{96A95DE7-70AB-4840-B5B0-2763D3541EEC}"/>
+              </a:ext>
+            </a:extLst>
+          </p:cNvPr>
+          <p:cNvSpPr>
+            <a:spLocks xmlns:a="http://schemas.openxmlformats.org/drawingml/2006/main" noGrp="1"/>
+          </p:cNvSpPr>
+          <p:nvPr/>
+        </p:nvSpPr>
+        <p:spPr>
+          <a:xfrm xmlns:a="http://schemas.openxmlformats.org/drawingml/2006/main">
+            <a:off x="5641975" y="3876675"/>
             <a:ext cx="285750" cy="285750"/>
           </a:xfrm>
           <a:prstGeom xmlns:a="http://schemas.openxmlformats.org/drawingml/2006/main" prst="ellipse">
@@ -5405,18 +5405,18 @@
           <p:cNvPr id="26" name="station-label-2-1">
             <a:extLst xmlns:a="http://schemas.openxmlformats.org/drawingml/2006/main">
               <a:ext uri="{FF2B5EF4-FFF2-40B4-BE49-F238E27FC236}">
-                <a16:creationId xmlns:a16="http://schemas.microsoft.com/office/drawing/2014/main" id="{48902407-B540-4FCC-8D30-FC7D6739B5A8}"/>
-              </a:ext>
-            </a:extLst>
-          </p:cNvPr>
-          <p:cNvSpPr>
-            <a:spLocks xmlns:a="http://schemas.openxmlformats.org/drawingml/2006/main" noGrp="1"/>
-          </p:cNvSpPr>
-          <p:nvPr/>
-        </p:nvSpPr>
-        <p:spPr>
-          <a:xfrm xmlns:a="http://schemas.openxmlformats.org/drawingml/2006/main">
-            <a:off x="6124575" y="4133850"/>
+                <a16:creationId xmlns:a16="http://schemas.microsoft.com/office/drawing/2014/main" id="{4A5A3303-1C10-4793-965E-21BA95495CC1}"/>
+              </a:ext>
+            </a:extLst>
+          </p:cNvPr>
+          <p:cNvSpPr>
+            <a:spLocks xmlns:a="http://schemas.openxmlformats.org/drawingml/2006/main" noGrp="1"/>
+          </p:cNvSpPr>
+          <p:nvPr/>
+        </p:nvSpPr>
+        <p:spPr>
+          <a:xfrm xmlns:a="http://schemas.openxmlformats.org/drawingml/2006/main">
+            <a:off x="4794250" y="4133850"/>
             <a:ext cx="1981200" cy="285750"/>
           </a:xfrm>
           <a:prstGeom xmlns:a="http://schemas.openxmlformats.org/drawingml/2006/main" prst="rect">
@@ -5440,7 +5440,7 @@
               </a:defRPr>
             </a:pPr>
             <a:r>
-              <a:t>lint</a:t>
+              <a:t>typecheck</a:t>
             </a:r>
           </a:p>
         </p:txBody>
@@ -5450,18 +5450,18 @@
           <p:cNvPr id="27" name="station-dot-2-2">
             <a:extLst xmlns:a="http://schemas.openxmlformats.org/drawingml/2006/main">
               <a:ext uri="{FF2B5EF4-FFF2-40B4-BE49-F238E27FC236}">
-                <a16:creationId xmlns:a16="http://schemas.microsoft.com/office/drawing/2014/main" id="{74AFFCC7-92D6-41CB-BA8E-BB89D0A3308C}"/>
-              </a:ext>
-            </a:extLst>
-          </p:cNvPr>
-          <p:cNvSpPr>
-            <a:spLocks xmlns:a="http://schemas.openxmlformats.org/drawingml/2006/main" noGrp="1"/>
-          </p:cNvSpPr>
-          <p:nvPr/>
-        </p:nvSpPr>
-        <p:spPr>
-          <a:xfrm xmlns:a="http://schemas.openxmlformats.org/drawingml/2006/main">
-            <a:off x="10963275" y="3876675"/>
+                <a16:creationId xmlns:a16="http://schemas.microsoft.com/office/drawing/2014/main" id="{D430F59B-7469-4455-87B4-A30697CF3BCD}"/>
+              </a:ext>
+            </a:extLst>
+          </p:cNvPr>
+          <p:cNvSpPr>
+            <a:spLocks xmlns:a="http://schemas.openxmlformats.org/drawingml/2006/main" noGrp="1"/>
+          </p:cNvSpPr>
+          <p:nvPr/>
+        </p:nvSpPr>
+        <p:spPr>
+          <a:xfrm xmlns:a="http://schemas.openxmlformats.org/drawingml/2006/main">
+            <a:off x="8302625" y="3876675"/>
             <a:ext cx="285750" cy="285750"/>
           </a:xfrm>
           <a:prstGeom xmlns:a="http://schemas.openxmlformats.org/drawingml/2006/main" prst="ellipse">
@@ -5483,7 +5483,85 @@
           <p:cNvPr id="28" name="station-label-2-2">
             <a:extLst xmlns:a="http://schemas.openxmlformats.org/drawingml/2006/main">
               <a:ext uri="{FF2B5EF4-FFF2-40B4-BE49-F238E27FC236}">
-                <a16:creationId xmlns:a16="http://schemas.microsoft.com/office/drawing/2014/main" id="{FC1830F8-5D1B-40F9-BFF4-7FF1D296A51B}"/>
+                <a16:creationId xmlns:a16="http://schemas.microsoft.com/office/drawing/2014/main" id="{3CF31333-7584-4B82-B0B3-86CCC81E7D64}"/>
+              </a:ext>
+            </a:extLst>
+          </p:cNvPr>
+          <p:cNvSpPr>
+            <a:spLocks xmlns:a="http://schemas.openxmlformats.org/drawingml/2006/main" noGrp="1"/>
+          </p:cNvSpPr>
+          <p:nvPr/>
+        </p:nvSpPr>
+        <p:spPr>
+          <a:xfrm xmlns:a="http://schemas.openxmlformats.org/drawingml/2006/main">
+            <a:off x="7454900" y="4133850"/>
+            <a:ext cx="1981200" cy="285750"/>
+          </a:xfrm>
+          <a:prstGeom xmlns:a="http://schemas.openxmlformats.org/drawingml/2006/main" prst="rect">
+            <a:avLst/>
+          </a:prstGeom>
+        </p:spPr>
+        <p:txBody>
+          <a:bodyPr xmlns:a="http://schemas.openxmlformats.org/drawingml/2006/main" wrap="square" lIns="0" tIns="0" rIns="0" bIns="0" anchor="t">
+            <a:normAutofit fontScale="100000"/>
+          </a:bodyPr>
+          <a:lstStyle xmlns:a="http://schemas.openxmlformats.org/drawingml/2006/main"/>
+          <a:p xmlns:a="http://schemas.openxmlformats.org/drawingml/2006/main">
+            <a:pPr algn="ctr">
+              <a:defRPr sz="1200" b="1">
+                <a:solidFill>
+                  <a:srgbClr val="0B1F33"/>
+                </a:solidFill>
+                <a:latin typeface="Aptos"/>
+                <a:ea typeface="Aptos"/>
+                <a:cs typeface="Aptos"/>
+              </a:defRPr>
+            </a:pPr>
+            <a:r>
+              <a:t>lint</a:t>
+            </a:r>
+          </a:p>
+        </p:txBody>
+      </p:sp>
+      <p:sp>
+        <p:nvSpPr>
+          <p:cNvPr id="29" name="station-dot-2-3">
+            <a:extLst xmlns:a="http://schemas.openxmlformats.org/drawingml/2006/main">
+              <a:ext uri="{FF2B5EF4-FFF2-40B4-BE49-F238E27FC236}">
+                <a16:creationId xmlns:a16="http://schemas.microsoft.com/office/drawing/2014/main" id="{F83811FD-78B3-4E49-8EE4-AA7C0CA98884}"/>
+              </a:ext>
+            </a:extLst>
+          </p:cNvPr>
+          <p:cNvSpPr>
+            <a:spLocks xmlns:a="http://schemas.openxmlformats.org/drawingml/2006/main" noGrp="1"/>
+          </p:cNvSpPr>
+          <p:nvPr/>
+        </p:nvSpPr>
+        <p:spPr>
+          <a:xfrm xmlns:a="http://schemas.openxmlformats.org/drawingml/2006/main">
+            <a:off x="10963275" y="3876675"/>
+            <a:ext cx="285750" cy="285750"/>
+          </a:xfrm>
+          <a:prstGeom xmlns:a="http://schemas.openxmlformats.org/drawingml/2006/main" prst="ellipse">
+            <a:avLst/>
+          </a:prstGeom>
+          <a:solidFill xmlns:a="http://schemas.openxmlformats.org/drawingml/2006/main">
+            <a:srgbClr val="FF6B6B"/>
+          </a:solidFill>
+          <a:ln xmlns:a="http://schemas.openxmlformats.org/drawingml/2006/main" w="38100">
+            <a:solidFill>
+              <a:srgbClr val="FFF8ED"/>
+            </a:solidFill>
+            <a:prstDash val="solid"/>
+          </a:ln>
+        </p:spPr>
+      </p:sp>
+      <p:sp>
+        <p:nvSpPr>
+          <p:cNvPr id="30" name="station-label-2-3">
+            <a:extLst xmlns:a="http://schemas.openxmlformats.org/drawingml/2006/main">
+              <a:ext uri="{FF2B5EF4-FFF2-40B4-BE49-F238E27FC236}">
+                <a16:creationId xmlns:a16="http://schemas.microsoft.com/office/drawing/2014/main" id="{1C35D5CD-758E-4402-9C15-F1ACE1E371E5}"/>
               </a:ext>
             </a:extLst>
           </p:cNvPr>
@@ -5525,7 +5603,7 @@
       </p:sp>
       <p:cxnSp>
         <p:nvCxnSpPr>
-          <p:cNvPr id="69" name="station-line-3"/>
+          <p:cNvPr id="73" name="station-line-3"/>
           <p:cNvCxnSpPr/>
           <p:nvPr/>
         </p:nvCxnSpPr>
@@ -5547,10 +5625,10 @@
       </p:cxnSp>
       <p:sp>
         <p:nvSpPr>
-          <p:cNvPr id="30" name="station-group-3">
-            <a:extLst xmlns:a="http://schemas.openxmlformats.org/drawingml/2006/main">
-              <a:ext uri="{FF2B5EF4-FFF2-40B4-BE49-F238E27FC236}">
-                <a16:creationId xmlns:a16="http://schemas.microsoft.com/office/drawing/2014/main" id="{DF6C3A9D-A98F-48A3-9104-A27A358E3866}"/>
+          <p:cNvPr id="32" name="station-group-3">
+            <a:extLst xmlns:a="http://schemas.openxmlformats.org/drawingml/2006/main">
+              <a:ext uri="{FF2B5EF4-FFF2-40B4-BE49-F238E27FC236}">
+                <a16:creationId xmlns:a16="http://schemas.microsoft.com/office/drawing/2014/main" id="{3217E0E2-AB2E-461D-BAF3-B98A9407E7F7}"/>
               </a:ext>
             </a:extLst>
           </p:cNvPr>
@@ -5592,10 +5670,10 @@
       </p:sp>
       <p:sp>
         <p:nvSpPr>
-          <p:cNvPr id="31" name="station-dot-3-0">
-            <a:extLst xmlns:a="http://schemas.openxmlformats.org/drawingml/2006/main">
-              <a:ext uri="{FF2B5EF4-FFF2-40B4-BE49-F238E27FC236}">
-                <a16:creationId xmlns:a16="http://schemas.microsoft.com/office/drawing/2014/main" id="{A6E5158B-69C8-4EF4-87D9-B1822B6F550C}"/>
+          <p:cNvPr id="33" name="station-dot-3-0">
+            <a:extLst xmlns:a="http://schemas.openxmlformats.org/drawingml/2006/main">
+              <a:ext uri="{FF2B5EF4-FFF2-40B4-BE49-F238E27FC236}">
+                <a16:creationId xmlns:a16="http://schemas.microsoft.com/office/drawing/2014/main" id="{A8C054B6-4E41-4A3A-B1BA-8F969674B062}"/>
               </a:ext>
             </a:extLst>
           </p:cNvPr>
@@ -5625,10 +5703,10 @@
       </p:sp>
       <p:sp>
         <p:nvSpPr>
-          <p:cNvPr id="32" name="station-label-3-0">
-            <a:extLst xmlns:a="http://schemas.openxmlformats.org/drawingml/2006/main">
-              <a:ext uri="{FF2B5EF4-FFF2-40B4-BE49-F238E27FC236}">
-                <a16:creationId xmlns:a16="http://schemas.microsoft.com/office/drawing/2014/main" id="{B777981A-C2C4-460B-8203-637B6216A0AA}"/>
+          <p:cNvPr id="34" name="station-label-3-0">
+            <a:extLst xmlns:a="http://schemas.openxmlformats.org/drawingml/2006/main">
+              <a:ext uri="{FF2B5EF4-FFF2-40B4-BE49-F238E27FC236}">
+                <a16:creationId xmlns:a16="http://schemas.microsoft.com/office/drawing/2014/main" id="{38A8FFB4-B318-42A7-B8BA-90DBCC00268F}"/>
               </a:ext>
             </a:extLst>
           </p:cNvPr>
@@ -5670,10 +5748,10 @@
       </p:sp>
       <p:sp>
         <p:nvSpPr>
-          <p:cNvPr id="33" name="station-dot-3-1">
-            <a:extLst xmlns:a="http://schemas.openxmlformats.org/drawingml/2006/main">
-              <a:ext uri="{FF2B5EF4-FFF2-40B4-BE49-F238E27FC236}">
-                <a16:creationId xmlns:a16="http://schemas.microsoft.com/office/drawing/2014/main" id="{E077724A-F211-46B5-A8BE-7266255E0794}"/>
+          <p:cNvPr id="35" name="station-dot-3-1">
+            <a:extLst xmlns:a="http://schemas.openxmlformats.org/drawingml/2006/main">
+              <a:ext uri="{FF2B5EF4-FFF2-40B4-BE49-F238E27FC236}">
+                <a16:creationId xmlns:a16="http://schemas.microsoft.com/office/drawing/2014/main" id="{81467B94-8131-40BD-BF73-5D950F2C0C3C}"/>
               </a:ext>
             </a:extLst>
           </p:cNvPr>
@@ -5703,10 +5781,10 @@
       </p:sp>
       <p:sp>
         <p:nvSpPr>
-          <p:cNvPr id="34" name="station-label-3-1">
-            <a:extLst xmlns:a="http://schemas.openxmlformats.org/drawingml/2006/main">
-              <a:ext uri="{FF2B5EF4-FFF2-40B4-BE49-F238E27FC236}">
-                <a16:creationId xmlns:a16="http://schemas.microsoft.com/office/drawing/2014/main" id="{C9F941D9-C393-47CD-B59C-D19F7C893BD8}"/>
+          <p:cNvPr id="36" name="station-label-3-1">
+            <a:extLst xmlns:a="http://schemas.openxmlformats.org/drawingml/2006/main">
+              <a:ext uri="{FF2B5EF4-FFF2-40B4-BE49-F238E27FC236}">
+                <a16:creationId xmlns:a16="http://schemas.microsoft.com/office/drawing/2014/main" id="{A31EA028-4B6B-4FE7-AA2F-9F79BC9021A8}"/>
               </a:ext>
             </a:extLst>
           </p:cNvPr>
@@ -5748,10 +5826,10 @@
       </p:sp>
       <p:sp>
         <p:nvSpPr>
-          <p:cNvPr id="35" name="spine-fail">
-            <a:extLst xmlns:a="http://schemas.openxmlformats.org/drawingml/2006/main">
-              <a:ext uri="{FF2B5EF4-FFF2-40B4-BE49-F238E27FC236}">
-                <a16:creationId xmlns:a16="http://schemas.microsoft.com/office/drawing/2014/main" id="{035A0273-A8B1-4B92-BFC2-25E9D1DC3546}"/>
+          <p:cNvPr id="37" name="spine-fail">
+            <a:extLst xmlns:a="http://schemas.openxmlformats.org/drawingml/2006/main">
+              <a:ext uri="{FF2B5EF4-FFF2-40B4-BE49-F238E27FC236}">
+                <a16:creationId xmlns:a16="http://schemas.microsoft.com/office/drawing/2014/main" id="{A390A73B-0A53-40A1-9F8D-7177C94A1785}"/>
               </a:ext>
             </a:extLst>
           </p:cNvPr>
@@ -5783,10 +5861,10 @@
       </p:sp>
       <p:sp>
         <p:nvSpPr>
-          <p:cNvPr id="36" name="spine-fail-icon">
-            <a:extLst xmlns:a="http://schemas.openxmlformats.org/drawingml/2006/main">
-              <a:ext uri="{FF2B5EF4-FFF2-40B4-BE49-F238E27FC236}">
-                <a16:creationId xmlns:a16="http://schemas.microsoft.com/office/drawing/2014/main" id="{B9862960-81A9-45A2-90F6-01708BC1084C}"/>
+          <p:cNvPr id="38" name="spine-fail-icon">
+            <a:extLst xmlns:a="http://schemas.openxmlformats.org/drawingml/2006/main">
+              <a:ext uri="{FF2B5EF4-FFF2-40B4-BE49-F238E27FC236}">
+                <a16:creationId xmlns:a16="http://schemas.microsoft.com/office/drawing/2014/main" id="{5BEF443E-4CA5-41F9-BE48-4E39F9ED5560}"/>
               </a:ext>
             </a:extLst>
           </p:cNvPr>
@@ -5828,10 +5906,10 @@
       </p:sp>
       <p:sp>
         <p:nvSpPr>
-          <p:cNvPr id="37" name="spine-fail-text">
-            <a:extLst xmlns:a="http://schemas.openxmlformats.org/drawingml/2006/main">
-              <a:ext uri="{FF2B5EF4-FFF2-40B4-BE49-F238E27FC236}">
-                <a16:creationId xmlns:a16="http://schemas.microsoft.com/office/drawing/2014/main" id="{021803D5-5944-4194-B27D-8F85E9C3F085}"/>
+          <p:cNvPr id="39" name="spine-fail-text">
+            <a:extLst xmlns:a="http://schemas.openxmlformats.org/drawingml/2006/main">
+              <a:ext uri="{FF2B5EF4-FFF2-40B4-BE49-F238E27FC236}">
+                <a16:creationId xmlns:a16="http://schemas.microsoft.com/office/drawing/2014/main" id="{FC379A67-E93C-4700-9676-3449293F8E85}"/>
               </a:ext>
             </a:extLst>
           </p:cNvPr>
@@ -5874,10 +5952,10 @@
       </p:sp>
       <p:sp>
         <p:nvSpPr>
-          <p:cNvPr id="38" name="spine-pass">
-            <a:extLst xmlns:a="http://schemas.openxmlformats.org/drawingml/2006/main">
-              <a:ext uri="{FF2B5EF4-FFF2-40B4-BE49-F238E27FC236}">
-                <a16:creationId xmlns:a16="http://schemas.microsoft.com/office/drawing/2014/main" id="{0B7D5DAE-74F8-4978-B5F1-5C57F026D4F5}"/>
+          <p:cNvPr id="40" name="spine-pass">
+            <a:extLst xmlns:a="http://schemas.openxmlformats.org/drawingml/2006/main">
+              <a:ext uri="{FF2B5EF4-FFF2-40B4-BE49-F238E27FC236}">
+                <a16:creationId xmlns:a16="http://schemas.microsoft.com/office/drawing/2014/main" id="{712B6AE3-5EF8-431C-AD1F-35C695C56646}"/>
               </a:ext>
             </a:extLst>
           </p:cNvPr>
@@ -5909,10 +5987,10 @@
       </p:sp>
       <p:sp>
         <p:nvSpPr>
-          <p:cNvPr id="39" name="spine-pass-icon">
-            <a:extLst xmlns:a="http://schemas.openxmlformats.org/drawingml/2006/main">
-              <a:ext uri="{FF2B5EF4-FFF2-40B4-BE49-F238E27FC236}">
-                <a16:creationId xmlns:a16="http://schemas.microsoft.com/office/drawing/2014/main" id="{2E8D5B72-D79B-41A9-9251-9F95D25181E2}"/>
+          <p:cNvPr id="41" name="spine-pass-icon">
+            <a:extLst xmlns:a="http://schemas.openxmlformats.org/drawingml/2006/main">
+              <a:ext uri="{FF2B5EF4-FFF2-40B4-BE49-F238E27FC236}">
+                <a16:creationId xmlns:a16="http://schemas.microsoft.com/office/drawing/2014/main" id="{A14FAEC4-04C2-460F-B7D6-23EB823E9484}"/>
               </a:ext>
             </a:extLst>
           </p:cNvPr>
@@ -5954,10 +6032,10 @@
       </p:sp>
       <p:sp>
         <p:nvSpPr>
-          <p:cNvPr id="40" name="spine-pass-text">
-            <a:extLst xmlns:a="http://schemas.openxmlformats.org/drawingml/2006/main">
-              <a:ext uri="{FF2B5EF4-FFF2-40B4-BE49-F238E27FC236}">
-                <a16:creationId xmlns:a16="http://schemas.microsoft.com/office/drawing/2014/main" id="{30FAE219-CEA2-476D-8B58-FE9996E83D32}"/>
+          <p:cNvPr id="42" name="spine-pass-text">
+            <a:extLst xmlns:a="http://schemas.openxmlformats.org/drawingml/2006/main">
+              <a:ext uri="{FF2B5EF4-FFF2-40B4-BE49-F238E27FC236}">
+                <a16:creationId xmlns:a16="http://schemas.microsoft.com/office/drawing/2014/main" id="{5119D3E2-6218-4041-9C52-8469072900E2}"/>
               </a:ext>
             </a:extLst>
           </p:cNvPr>
@@ -5992,7 +6070,7 @@
               </a:defRPr>
             </a:pPr>
             <a:r>
-              <a:t>Only after station 11:
+              <a:t>Only after station 12:
 All repository checks passed.</a:t>
             </a:r>
           </a:p>
@@ -6001,7 +6079,7 @@
     </p:spTree>
     <p:extLst>
       <p:ext uri="{BB962C8B-B14F-4D97-AF65-F5344CB8AC3E}">
-        <p14:creationId xmlns:p14="http://schemas.microsoft.com/office/powerpoint/2010/main" val="2062341230"/>
+        <p14:creationId xmlns:p14="http://schemas.microsoft.com/office/powerpoint/2010/main" val="1613139421"/>
       </p:ext>
     </p:extLst>
   </p:cSld>
@@ -6032,7 +6110,7 @@
           <p:cNvPr id="1" name="kicker-4">
             <a:extLst xmlns:a="http://schemas.openxmlformats.org/drawingml/2006/main">
               <a:ext uri="{FF2B5EF4-FFF2-40B4-BE49-F238E27FC236}">
-                <a16:creationId xmlns:a16="http://schemas.microsoft.com/office/drawing/2014/main" id="{AFA36575-BE3F-494C-A3BB-784D24E41E3E}"/>
+                <a16:creationId xmlns:a16="http://schemas.microsoft.com/office/drawing/2014/main" id="{F6F424F2-7DE8-42F6-B433-AA7327AB899E}"/>
               </a:ext>
             </a:extLst>
           </p:cNvPr>
@@ -6077,7 +6155,7 @@
           <p:cNvPr id="2" name="title-4">
             <a:extLst xmlns:a="http://schemas.openxmlformats.org/drawingml/2006/main">
               <a:ext uri="{FF2B5EF4-FFF2-40B4-BE49-F238E27FC236}">
-                <a16:creationId xmlns:a16="http://schemas.microsoft.com/office/drawing/2014/main" id="{315ADD27-6B2A-4424-ACC7-9686AC848093}"/>
+                <a16:creationId xmlns:a16="http://schemas.microsoft.com/office/drawing/2014/main" id="{1C8F3F67-C2A2-4C88-9668-11B08F3CC88F}"/>
               </a:ext>
             </a:extLst>
           </p:cNvPr>
@@ -6144,7 +6222,7 @@
           <p:cNvPr id="4" name="number-4">
             <a:extLst xmlns:a="http://schemas.openxmlformats.org/drawingml/2006/main">
               <a:ext uri="{FF2B5EF4-FFF2-40B4-BE49-F238E27FC236}">
-                <a16:creationId xmlns:a16="http://schemas.microsoft.com/office/drawing/2014/main" id="{6D5CFFE5-ACA5-4745-B2D8-3D2612E7137E}"/>
+                <a16:creationId xmlns:a16="http://schemas.microsoft.com/office/drawing/2014/main" id="{F9BABAC7-85DB-437F-AD1B-66AA061AFE8F}"/>
               </a:ext>
             </a:extLst>
           </p:cNvPr>
@@ -6211,7 +6289,7 @@
           <p:cNvPr id="6" name="airlock-arrow">
             <a:extLst xmlns:a="http://schemas.openxmlformats.org/drawingml/2006/main">
               <a:ext uri="{FF2B5EF4-FFF2-40B4-BE49-F238E27FC236}">
-                <a16:creationId xmlns:a16="http://schemas.microsoft.com/office/drawing/2014/main" id="{3E14D694-E811-47A2-A6C9-D3FC54523E6A}"/>
+                <a16:creationId xmlns:a16="http://schemas.microsoft.com/office/drawing/2014/main" id="{7F6A8592-08AD-4BB4-8331-7E59293A9C0D}"/>
               </a:ext>
             </a:extLst>
           </p:cNvPr>
@@ -6242,7 +6320,7 @@
           <p:cNvPr id="7" name="setup-island">
             <a:extLst xmlns:a="http://schemas.openxmlformats.org/drawingml/2006/main">
               <a:ext uri="{FF2B5EF4-FFF2-40B4-BE49-F238E27FC236}">
-                <a16:creationId xmlns:a16="http://schemas.microsoft.com/office/drawing/2014/main" id="{0B7EF870-6AA3-49A6-9811-3F1DD7BF398A}"/>
+                <a16:creationId xmlns:a16="http://schemas.microsoft.com/office/drawing/2014/main" id="{6487F895-B21E-4660-8CC0-24B4EDDB88D9}"/>
               </a:ext>
             </a:extLst>
           </p:cNvPr>
@@ -6277,7 +6355,7 @@
           <p:cNvPr id="8" name="check-island">
             <a:extLst xmlns:a="http://schemas.openxmlformats.org/drawingml/2006/main">
               <a:ext uri="{FF2B5EF4-FFF2-40B4-BE49-F238E27FC236}">
-                <a16:creationId xmlns:a16="http://schemas.microsoft.com/office/drawing/2014/main" id="{17A99439-E441-49B7-BFC0-D4AD88E205D0}"/>
+                <a16:creationId xmlns:a16="http://schemas.microsoft.com/office/drawing/2014/main" id="{6380725A-6868-4C83-B490-E999C48AC42F}"/>
               </a:ext>
             </a:extLst>
           </p:cNvPr>
@@ -6312,7 +6390,7 @@
           <p:cNvPr id="9" name="airlock-door">
             <a:extLst xmlns:a="http://schemas.openxmlformats.org/drawingml/2006/main">
               <a:ext uri="{FF2B5EF4-FFF2-40B4-BE49-F238E27FC236}">
-                <a16:creationId xmlns:a16="http://schemas.microsoft.com/office/drawing/2014/main" id="{29EA2643-C09F-4FA3-9464-B41F5746CDA7}"/>
+                <a16:creationId xmlns:a16="http://schemas.microsoft.com/office/drawing/2014/main" id="{97F3945D-2AC4-4C27-AAE6-5C4BB9275210}"/>
               </a:ext>
             </a:extLst>
           </p:cNvPr>
@@ -6343,7 +6421,7 @@
           <p:cNvPr id="10" name="airlock-lock">
             <a:extLst xmlns:a="http://schemas.openxmlformats.org/drawingml/2006/main">
               <a:ext uri="{FF2B5EF4-FFF2-40B4-BE49-F238E27FC236}">
-                <a16:creationId xmlns:a16="http://schemas.microsoft.com/office/drawing/2014/main" id="{3354A0AB-FA91-44DE-A576-A76875E9CB79}"/>
+                <a16:creationId xmlns:a16="http://schemas.microsoft.com/office/drawing/2014/main" id="{6A068D43-0F3F-40D4-9075-ADD085B4DF9C}"/>
               </a:ext>
             </a:extLst>
           </p:cNvPr>
@@ -6374,7 +6452,7 @@
           <p:cNvPr id="11" name="airlock-keyhole">
             <a:extLst xmlns:a="http://schemas.openxmlformats.org/drawingml/2006/main">
               <a:ext uri="{FF2B5EF4-FFF2-40B4-BE49-F238E27FC236}">
-                <a16:creationId xmlns:a16="http://schemas.microsoft.com/office/drawing/2014/main" id="{3471CDBF-BE90-4BF6-BF49-39DA285828B1}"/>
+                <a16:creationId xmlns:a16="http://schemas.microsoft.com/office/drawing/2014/main" id="{F8A3D4D4-94E5-4976-A86D-2F4A37696F23}"/>
               </a:ext>
             </a:extLst>
           </p:cNvPr>
@@ -6405,7 +6483,7 @@
           <p:cNvPr id="12" name="airlock-cross">
             <a:extLst xmlns:a="http://schemas.openxmlformats.org/drawingml/2006/main">
               <a:ext uri="{FF2B5EF4-FFF2-40B4-BE49-F238E27FC236}">
-                <a16:creationId xmlns:a16="http://schemas.microsoft.com/office/drawing/2014/main" id="{FDDBC0D5-0B4D-41E4-AC74-6252014D6A15}"/>
+                <a16:creationId xmlns:a16="http://schemas.microsoft.com/office/drawing/2014/main" id="{E620ED9F-92C9-411A-A9EE-3543F4F5F202}"/>
               </a:ext>
             </a:extLst>
           </p:cNvPr>
@@ -6450,7 +6528,7 @@
           <p:cNvPr id="13" name="setup-label">
             <a:extLst xmlns:a="http://schemas.openxmlformats.org/drawingml/2006/main">
               <a:ext uri="{FF2B5EF4-FFF2-40B4-BE49-F238E27FC236}">
-                <a16:creationId xmlns:a16="http://schemas.microsoft.com/office/drawing/2014/main" id="{8C519B78-92A1-421D-BE1A-ED989BF195E7}"/>
+                <a16:creationId xmlns:a16="http://schemas.microsoft.com/office/drawing/2014/main" id="{1B90450C-ACEB-400C-A3D9-AE28192C7A1F}"/>
               </a:ext>
             </a:extLst>
           </p:cNvPr>
@@ -6495,7 +6573,7 @@
           <p:cNvPr id="14" name="setup-title">
             <a:extLst xmlns:a="http://schemas.openxmlformats.org/drawingml/2006/main">
               <a:ext uri="{FF2B5EF4-FFF2-40B4-BE49-F238E27FC236}">
-                <a16:creationId xmlns:a16="http://schemas.microsoft.com/office/drawing/2014/main" id="{D3E7CFC8-B2A5-4E3C-9FAA-B84CE18467C1}"/>
+                <a16:creationId xmlns:a16="http://schemas.microsoft.com/office/drawing/2014/main" id="{5B8E1887-B160-43B0-8146-0EAD48924AE4}"/>
               </a:ext>
             </a:extLst>
           </p:cNvPr>
@@ -6540,7 +6618,7 @@
           <p:cNvPr id="15" name="setup-command-1">
             <a:extLst xmlns:a="http://schemas.openxmlformats.org/drawingml/2006/main">
               <a:ext uri="{FF2B5EF4-FFF2-40B4-BE49-F238E27FC236}">
-                <a16:creationId xmlns:a16="http://schemas.microsoft.com/office/drawing/2014/main" id="{A5A32461-C557-4B35-B31C-1783AA762670}"/>
+                <a16:creationId xmlns:a16="http://schemas.microsoft.com/office/drawing/2014/main" id="{FE928729-A5A9-4523-A3BB-A710E3381395}"/>
               </a:ext>
             </a:extLst>
           </p:cNvPr>
@@ -6585,7 +6663,7 @@
           <p:cNvPr id="16" name="setup-command-2">
             <a:extLst xmlns:a="http://schemas.openxmlformats.org/drawingml/2006/main">
               <a:ext uri="{FF2B5EF4-FFF2-40B4-BE49-F238E27FC236}">
-                <a16:creationId xmlns:a16="http://schemas.microsoft.com/office/drawing/2014/main" id="{45F03783-538C-4FA6-805A-EDD63299E600}"/>
+                <a16:creationId xmlns:a16="http://schemas.microsoft.com/office/drawing/2014/main" id="{0F5396A2-6904-47D2-9B26-2799784C5EEC}"/>
               </a:ext>
             </a:extLst>
           </p:cNvPr>
@@ -6630,7 +6708,7 @@
           <p:cNvPr id="17" name="setup-command-3">
             <a:extLst xmlns:a="http://schemas.openxmlformats.org/drawingml/2006/main">
               <a:ext uri="{FF2B5EF4-FFF2-40B4-BE49-F238E27FC236}">
-                <a16:creationId xmlns:a16="http://schemas.microsoft.com/office/drawing/2014/main" id="{A5B0A69D-69A8-4EA0-94C9-D2751A03A536}"/>
+                <a16:creationId xmlns:a16="http://schemas.microsoft.com/office/drawing/2014/main" id="{DB1F42E9-6D44-4377-8592-1BFA3D37E472}"/>
               </a:ext>
             </a:extLst>
           </p:cNvPr>
@@ -6675,7 +6753,7 @@
           <p:cNvPr id="18" name="setup-caption">
             <a:extLst xmlns:a="http://schemas.openxmlformats.org/drawingml/2006/main">
               <a:ext uri="{FF2B5EF4-FFF2-40B4-BE49-F238E27FC236}">
-                <a16:creationId xmlns:a16="http://schemas.microsoft.com/office/drawing/2014/main" id="{223F6D90-FB63-4883-9341-DCA4CB90206C}"/>
+                <a16:creationId xmlns:a16="http://schemas.microsoft.com/office/drawing/2014/main" id="{E4454C72-FC53-4CC4-BB60-81FDD4EF49E2}"/>
               </a:ext>
             </a:extLst>
           </p:cNvPr>
@@ -6721,7 +6799,7 @@
           <p:cNvPr id="19" name="check-label">
             <a:extLst xmlns:a="http://schemas.openxmlformats.org/drawingml/2006/main">
               <a:ext uri="{FF2B5EF4-FFF2-40B4-BE49-F238E27FC236}">
-                <a16:creationId xmlns:a16="http://schemas.microsoft.com/office/drawing/2014/main" id="{94C8EB80-B3B5-4A72-8134-F6318C769D5C}"/>
+                <a16:creationId xmlns:a16="http://schemas.microsoft.com/office/drawing/2014/main" id="{B5BBAFB7-5D7E-4B5A-BD55-5D46DFE97E84}"/>
               </a:ext>
             </a:extLst>
           </p:cNvPr>
@@ -6766,7 +6844,7 @@
           <p:cNvPr id="20" name="check-title">
             <a:extLst xmlns:a="http://schemas.openxmlformats.org/drawingml/2006/main">
               <a:ext uri="{FF2B5EF4-FFF2-40B4-BE49-F238E27FC236}">
-                <a16:creationId xmlns:a16="http://schemas.microsoft.com/office/drawing/2014/main" id="{8CAA68FC-DA01-489B-9F9C-E19AC5883BF6}"/>
+                <a16:creationId xmlns:a16="http://schemas.microsoft.com/office/drawing/2014/main" id="{57FDEFAB-AB87-4E47-B10A-5BC31640A19A}"/>
               </a:ext>
             </a:extLst>
           </p:cNvPr>
@@ -6811,19 +6889,19 @@
           <p:cNvPr id="21" name="check-list">
             <a:extLst xmlns:a="http://schemas.openxmlformats.org/drawingml/2006/main">
               <a:ext uri="{FF2B5EF4-FFF2-40B4-BE49-F238E27FC236}">
-                <a16:creationId xmlns:a16="http://schemas.microsoft.com/office/drawing/2014/main" id="{2CD5F18C-59FE-4336-9BE7-19CA1BBEF7A3}"/>
-              </a:ext>
-            </a:extLst>
-          </p:cNvPr>
-          <p:cNvSpPr>
-            <a:spLocks xmlns:a="http://schemas.openxmlformats.org/drawingml/2006/main" noGrp="1"/>
-          </p:cNvSpPr>
-          <p:nvPr/>
-        </p:nvSpPr>
-        <p:spPr>
-          <a:xfrm xmlns:a="http://schemas.openxmlformats.org/drawingml/2006/main">
-            <a:off x="8362950" y="3409950"/>
-            <a:ext cx="2952750" cy="1466850"/>
+                <a16:creationId xmlns:a16="http://schemas.microsoft.com/office/drawing/2014/main" id="{3C1CE623-FF29-497C-89C9-378AC14B61DE}"/>
+              </a:ext>
+            </a:extLst>
+          </p:cNvPr>
+          <p:cNvSpPr>
+            <a:spLocks xmlns:a="http://schemas.openxmlformats.org/drawingml/2006/main" noGrp="1"/>
+          </p:cNvSpPr>
+          <p:nvPr/>
+        </p:nvSpPr>
+        <p:spPr>
+          <a:xfrm xmlns:a="http://schemas.openxmlformats.org/drawingml/2006/main">
+            <a:off x="8362950" y="3333750"/>
+            <a:ext cx="2952750" cy="1657350"/>
           </a:xfrm>
           <a:prstGeom xmlns:a="http://schemas.openxmlformats.org/drawingml/2006/main" prst="rect">
             <a:avLst/>
@@ -6836,7 +6914,7 @@
           <a:lstStyle xmlns:a="http://schemas.openxmlformats.org/drawingml/2006/main"/>
           <a:p xmlns:a="http://schemas.openxmlformats.org/drawingml/2006/main">
             <a:pPr algn="l">
-              <a:defRPr sz="1275" b="1">
+              <a:defRPr sz="1200" b="1">
                 <a:solidFill>
                   <a:srgbClr val="0B1F33"/>
                 </a:solidFill>
@@ -6846,11 +6924,12 @@
               </a:defRPr>
             </a:pPr>
             <a:r>
-              <a:t>credentials unset
+              <a:t>secrets + uv selectors unset
 network guards active
 uv sync --check
 uv run --no-sync
-offline + frozen</a:t>
+offline + frozen
+Node range checked</a:t>
             </a:r>
           </a:p>
         </p:txBody>
@@ -6860,7 +6939,7 @@
           <p:cNvPr id="22" name="airlock-caption">
             <a:extLst xmlns:a="http://schemas.openxmlformats.org/drawingml/2006/main">
               <a:ext uri="{FF2B5EF4-FFF2-40B4-BE49-F238E27FC236}">
-                <a16:creationId xmlns:a16="http://schemas.microsoft.com/office/drawing/2014/main" id="{EDF7069D-D88F-4B17-9074-9FFDCDECF386}"/>
+                <a16:creationId xmlns:a16="http://schemas.microsoft.com/office/drawing/2014/main" id="{F4715C34-45D4-468F-967D-3B42FB7BF4A4}"/>
               </a:ext>
             </a:extLst>
           </p:cNvPr>
@@ -6905,7 +6984,7 @@
           <p:cNvPr id="23" name="airlock-note">
             <a:extLst xmlns:a="http://schemas.openxmlformats.org/drawingml/2006/main">
               <a:ext uri="{FF2B5EF4-FFF2-40B4-BE49-F238E27FC236}">
-                <a16:creationId xmlns:a16="http://schemas.microsoft.com/office/drawing/2014/main" id="{FDCBB07C-CB75-4A65-9AF9-612ABDA9AE86}"/>
+                <a16:creationId xmlns:a16="http://schemas.microsoft.com/office/drawing/2014/main" id="{9AFEF94B-B638-43D4-8295-C958EC73E103}"/>
               </a:ext>
             </a:extLst>
           </p:cNvPr>
@@ -6948,7 +7027,7 @@
     </p:spTree>
     <p:extLst>
       <p:ext uri="{BB962C8B-B14F-4D97-AF65-F5344CB8AC3E}">
-        <p14:creationId xmlns:p14="http://schemas.microsoft.com/office/powerpoint/2010/main" val="748579617"/>
+        <p14:creationId xmlns:p14="http://schemas.microsoft.com/office/powerpoint/2010/main" val="1242886728"/>
       </p:ext>
     </p:extLst>
   </p:cSld>
@@ -6979,7 +7058,7 @@
           <p:cNvPr id="1" name="kicker-5">
             <a:extLst xmlns:a="http://schemas.openxmlformats.org/drawingml/2006/main">
               <a:ext uri="{FF2B5EF4-FFF2-40B4-BE49-F238E27FC236}">
-                <a16:creationId xmlns:a16="http://schemas.microsoft.com/office/drawing/2014/main" id="{ACC9000A-9E81-4766-A108-904C43AE35D1}"/>
+                <a16:creationId xmlns:a16="http://schemas.microsoft.com/office/drawing/2014/main" id="{0F26C233-5346-45B4-A22C-7375FD5B04EA}"/>
               </a:ext>
             </a:extLst>
           </p:cNvPr>
@@ -7024,7 +7103,7 @@
           <p:cNvPr id="2" name="title-5">
             <a:extLst xmlns:a="http://schemas.openxmlformats.org/drawingml/2006/main">
               <a:ext uri="{FF2B5EF4-FFF2-40B4-BE49-F238E27FC236}">
-                <a16:creationId xmlns:a16="http://schemas.microsoft.com/office/drawing/2014/main" id="{8E25ACF5-EC3D-4F55-9EA1-791A8D3DF88E}"/>
+                <a16:creationId xmlns:a16="http://schemas.microsoft.com/office/drawing/2014/main" id="{D964EDF8-D1B9-4D7C-B40C-D6A76FF39B5A}"/>
               </a:ext>
             </a:extLst>
           </p:cNvPr>
@@ -7091,7 +7170,7 @@
           <p:cNvPr id="4" name="number-5">
             <a:extLst xmlns:a="http://schemas.openxmlformats.org/drawingml/2006/main">
               <a:ext uri="{FF2B5EF4-FFF2-40B4-BE49-F238E27FC236}">
-                <a16:creationId xmlns:a16="http://schemas.microsoft.com/office/drawing/2014/main" id="{7210FB53-02E1-4FC4-90E5-649F000A0440}"/>
+                <a16:creationId xmlns:a16="http://schemas.microsoft.com/office/drawing/2014/main" id="{FD3F5A2A-DDB1-4AD8-ADBD-9B8FECACC446}"/>
               </a:ext>
             </a:extLst>
           </p:cNvPr>
@@ -7246,7 +7325,7 @@
           <p:cNvPr id="10" name="seam-ring-0">
             <a:extLst xmlns:a="http://schemas.openxmlformats.org/drawingml/2006/main">
               <a:ext uri="{FF2B5EF4-FFF2-40B4-BE49-F238E27FC236}">
-                <a16:creationId xmlns:a16="http://schemas.microsoft.com/office/drawing/2014/main" id="{2231DDC8-F88C-4D27-9782-9699BEDCE5B5}"/>
+                <a16:creationId xmlns:a16="http://schemas.microsoft.com/office/drawing/2014/main" id="{71C75564-55C8-4F0B-B3E0-981328EB0F40}"/>
               </a:ext>
             </a:extLst>
           </p:cNvPr>
@@ -7279,7 +7358,7 @@
           <p:cNvPr id="11" name="seam-box-0">
             <a:extLst xmlns:a="http://schemas.openxmlformats.org/drawingml/2006/main">
               <a:ext uri="{FF2B5EF4-FFF2-40B4-BE49-F238E27FC236}">
-                <a16:creationId xmlns:a16="http://schemas.microsoft.com/office/drawing/2014/main" id="{FCF2D998-0B3E-4FCD-AD9A-ED3CC64AD56A}"/>
+                <a16:creationId xmlns:a16="http://schemas.microsoft.com/office/drawing/2014/main" id="{839548C1-18C8-45F7-855B-3AAE2AE902C3}"/>
               </a:ext>
             </a:extLst>
           </p:cNvPr>
@@ -7314,7 +7393,7 @@
           <p:cNvPr id="12" name="seam-heading-0">
             <a:extLst xmlns:a="http://schemas.openxmlformats.org/drawingml/2006/main">
               <a:ext uri="{FF2B5EF4-FFF2-40B4-BE49-F238E27FC236}">
-                <a16:creationId xmlns:a16="http://schemas.microsoft.com/office/drawing/2014/main" id="{A45D7DAF-12AF-42CF-972E-D2893D7EDFCB}"/>
+                <a16:creationId xmlns:a16="http://schemas.microsoft.com/office/drawing/2014/main" id="{1ACB93FB-148A-43C9-8C46-1C08ED4250E0}"/>
               </a:ext>
             </a:extLst>
           </p:cNvPr>
@@ -7359,7 +7438,7 @@
           <p:cNvPr id="13" name="seam-body-0">
             <a:extLst xmlns:a="http://schemas.openxmlformats.org/drawingml/2006/main">
               <a:ext uri="{FF2B5EF4-FFF2-40B4-BE49-F238E27FC236}">
-                <a16:creationId xmlns:a16="http://schemas.microsoft.com/office/drawing/2014/main" id="{A085F50C-665F-4EF3-A10A-57DE06DE730A}"/>
+                <a16:creationId xmlns:a16="http://schemas.microsoft.com/office/drawing/2014/main" id="{5AA5C08B-E975-4F94-A006-3B2CB8F21D2E}"/>
               </a:ext>
             </a:extLst>
           </p:cNvPr>
@@ -7405,7 +7484,7 @@
           <p:cNvPr id="14" name="seam-ring-1">
             <a:extLst xmlns:a="http://schemas.openxmlformats.org/drawingml/2006/main">
               <a:ext uri="{FF2B5EF4-FFF2-40B4-BE49-F238E27FC236}">
-                <a16:creationId xmlns:a16="http://schemas.microsoft.com/office/drawing/2014/main" id="{1A064165-8BA7-44BC-84FD-04F8DBFC5DE2}"/>
+                <a16:creationId xmlns:a16="http://schemas.microsoft.com/office/drawing/2014/main" id="{58A1043A-B9D1-41BC-99B4-34248ECF4F60}"/>
               </a:ext>
             </a:extLst>
           </p:cNvPr>
@@ -7438,7 +7517,7 @@
           <p:cNvPr id="15" name="seam-box-1">
             <a:extLst xmlns:a="http://schemas.openxmlformats.org/drawingml/2006/main">
               <a:ext uri="{FF2B5EF4-FFF2-40B4-BE49-F238E27FC236}">
-                <a16:creationId xmlns:a16="http://schemas.microsoft.com/office/drawing/2014/main" id="{CFF31DAC-64B7-4556-9C00-BFA6ADAAAA2C}"/>
+                <a16:creationId xmlns:a16="http://schemas.microsoft.com/office/drawing/2014/main" id="{CEBC216C-E7A7-4896-8A51-0DCCD987F229}"/>
               </a:ext>
             </a:extLst>
           </p:cNvPr>
@@ -7473,7 +7552,7 @@
           <p:cNvPr id="16" name="seam-heading-1">
             <a:extLst xmlns:a="http://schemas.openxmlformats.org/drawingml/2006/main">
               <a:ext uri="{FF2B5EF4-FFF2-40B4-BE49-F238E27FC236}">
-                <a16:creationId xmlns:a16="http://schemas.microsoft.com/office/drawing/2014/main" id="{D5F62FF8-3758-4C09-88D2-322D3E27145A}"/>
+                <a16:creationId xmlns:a16="http://schemas.microsoft.com/office/drawing/2014/main" id="{B569BFB8-C341-4F9D-9C78-4DDA82AEA8A7}"/>
               </a:ext>
             </a:extLst>
           </p:cNvPr>
@@ -7518,7 +7597,7 @@
           <p:cNvPr id="17" name="seam-body-1">
             <a:extLst xmlns:a="http://schemas.openxmlformats.org/drawingml/2006/main">
               <a:ext uri="{FF2B5EF4-FFF2-40B4-BE49-F238E27FC236}">
-                <a16:creationId xmlns:a16="http://schemas.microsoft.com/office/drawing/2014/main" id="{29CF7D31-32C4-4CE9-8EEA-4A2D3B2AFAE6}"/>
+                <a16:creationId xmlns:a16="http://schemas.microsoft.com/office/drawing/2014/main" id="{3CC950DF-8E90-4AA7-81FA-B069B5EB00AF}"/>
               </a:ext>
             </a:extLst>
           </p:cNvPr>
@@ -7564,7 +7643,7 @@
           <p:cNvPr id="18" name="seam-ring-2">
             <a:extLst xmlns:a="http://schemas.openxmlformats.org/drawingml/2006/main">
               <a:ext uri="{FF2B5EF4-FFF2-40B4-BE49-F238E27FC236}">
-                <a16:creationId xmlns:a16="http://schemas.microsoft.com/office/drawing/2014/main" id="{48A8A6D5-8573-4773-9F89-A31DCEE55093}"/>
+                <a16:creationId xmlns:a16="http://schemas.microsoft.com/office/drawing/2014/main" id="{6A0680D3-488D-4650-99DA-2C552171A8FA}"/>
               </a:ext>
             </a:extLst>
           </p:cNvPr>
@@ -7597,7 +7676,7 @@
           <p:cNvPr id="19" name="seam-box-2">
             <a:extLst xmlns:a="http://schemas.openxmlformats.org/drawingml/2006/main">
               <a:ext uri="{FF2B5EF4-FFF2-40B4-BE49-F238E27FC236}">
-                <a16:creationId xmlns:a16="http://schemas.microsoft.com/office/drawing/2014/main" id="{EE5DBF93-F037-446D-A846-1B61AAB62D78}"/>
+                <a16:creationId xmlns:a16="http://schemas.microsoft.com/office/drawing/2014/main" id="{736044D5-68AB-4962-9754-77954FECB132}"/>
               </a:ext>
             </a:extLst>
           </p:cNvPr>
@@ -7632,7 +7711,7 @@
           <p:cNvPr id="20" name="seam-heading-2">
             <a:extLst xmlns:a="http://schemas.openxmlformats.org/drawingml/2006/main">
               <a:ext uri="{FF2B5EF4-FFF2-40B4-BE49-F238E27FC236}">
-                <a16:creationId xmlns:a16="http://schemas.microsoft.com/office/drawing/2014/main" id="{68DE0423-1E76-4064-BE4A-9918DBF3D08A}"/>
+                <a16:creationId xmlns:a16="http://schemas.microsoft.com/office/drawing/2014/main" id="{186BA8EC-C488-4BD6-93CE-6286ACAAB993}"/>
               </a:ext>
             </a:extLst>
           </p:cNvPr>
@@ -7677,7 +7756,7 @@
           <p:cNvPr id="21" name="seam-body-2">
             <a:extLst xmlns:a="http://schemas.openxmlformats.org/drawingml/2006/main">
               <a:ext uri="{FF2B5EF4-FFF2-40B4-BE49-F238E27FC236}">
-                <a16:creationId xmlns:a16="http://schemas.microsoft.com/office/drawing/2014/main" id="{87C70017-D59C-4CB5-8A66-87DB20987301}"/>
+                <a16:creationId xmlns:a16="http://schemas.microsoft.com/office/drawing/2014/main" id="{8D295C20-2DC5-4042-B6EF-AEB4F12E732D}"/>
               </a:ext>
             </a:extLst>
           </p:cNvPr>
@@ -7723,7 +7802,7 @@
           <p:cNvPr id="22" name="seam-ring-3">
             <a:extLst xmlns:a="http://schemas.openxmlformats.org/drawingml/2006/main">
               <a:ext uri="{FF2B5EF4-FFF2-40B4-BE49-F238E27FC236}">
-                <a16:creationId xmlns:a16="http://schemas.microsoft.com/office/drawing/2014/main" id="{B7AC35AB-2413-4EF4-995D-9454511027A6}"/>
+                <a16:creationId xmlns:a16="http://schemas.microsoft.com/office/drawing/2014/main" id="{576468ED-6794-4D1A-8923-9B6E57430348}"/>
               </a:ext>
             </a:extLst>
           </p:cNvPr>
@@ -7756,7 +7835,7 @@
           <p:cNvPr id="23" name="seam-box-3">
             <a:extLst xmlns:a="http://schemas.openxmlformats.org/drawingml/2006/main">
               <a:ext uri="{FF2B5EF4-FFF2-40B4-BE49-F238E27FC236}">
-                <a16:creationId xmlns:a16="http://schemas.microsoft.com/office/drawing/2014/main" id="{CDBCAF35-5BAC-42BD-A35D-AA8859C516E8}"/>
+                <a16:creationId xmlns:a16="http://schemas.microsoft.com/office/drawing/2014/main" id="{D3A208C5-8443-48CA-97DC-0AA3AB580C97}"/>
               </a:ext>
             </a:extLst>
           </p:cNvPr>
@@ -7791,7 +7870,7 @@
           <p:cNvPr id="24" name="seam-heading-3">
             <a:extLst xmlns:a="http://schemas.openxmlformats.org/drawingml/2006/main">
               <a:ext uri="{FF2B5EF4-FFF2-40B4-BE49-F238E27FC236}">
-                <a16:creationId xmlns:a16="http://schemas.microsoft.com/office/drawing/2014/main" id="{CDCE6591-E675-49E6-B02F-8275644D4A0B}"/>
+                <a16:creationId xmlns:a16="http://schemas.microsoft.com/office/drawing/2014/main" id="{39A3253D-79CB-453F-B023-F6F3F977758C}"/>
               </a:ext>
             </a:extLst>
           </p:cNvPr>
@@ -7836,7 +7915,7 @@
           <p:cNvPr id="25" name="seam-body-3">
             <a:extLst xmlns:a="http://schemas.openxmlformats.org/drawingml/2006/main">
               <a:ext uri="{FF2B5EF4-FFF2-40B4-BE49-F238E27FC236}">
-                <a16:creationId xmlns:a16="http://schemas.microsoft.com/office/drawing/2014/main" id="{910D7018-7295-4CCA-BD99-3351AD74D9EF}"/>
+                <a16:creationId xmlns:a16="http://schemas.microsoft.com/office/drawing/2014/main" id="{5E76392D-4C8E-4AC8-88CF-F538D997FA1A}"/>
               </a:ext>
             </a:extLst>
           </p:cNvPr>
@@ -7882,7 +7961,7 @@
           <p:cNvPr id="26" name="seam-python">
             <a:extLst xmlns:a="http://schemas.openxmlformats.org/drawingml/2006/main">
               <a:ext uri="{FF2B5EF4-FFF2-40B4-BE49-F238E27FC236}">
-                <a16:creationId xmlns:a16="http://schemas.microsoft.com/office/drawing/2014/main" id="{256E6958-ACA4-4D4A-86DA-1B13E5351DF8}"/>
+                <a16:creationId xmlns:a16="http://schemas.microsoft.com/office/drawing/2014/main" id="{A9653239-0C46-48D8-AC1C-B78D1E374AFD}"/>
               </a:ext>
             </a:extLst>
           </p:cNvPr>
@@ -7927,7 +8006,7 @@
           <p:cNvPr id="27" name="seam-tui">
             <a:extLst xmlns:a="http://schemas.openxmlformats.org/drawingml/2006/main">
               <a:ext uri="{FF2B5EF4-FFF2-40B4-BE49-F238E27FC236}">
-                <a16:creationId xmlns:a16="http://schemas.microsoft.com/office/drawing/2014/main" id="{D0AC0B8E-3B7E-43F6-B09B-C2C6616D8E06}"/>
+                <a16:creationId xmlns:a16="http://schemas.microsoft.com/office/drawing/2014/main" id="{181AC79D-4AFA-4301-AB2A-8DA6B838A34B}"/>
               </a:ext>
             </a:extLst>
           </p:cNvPr>
@@ -7972,7 +8051,7 @@
           <p:cNvPr id="28" name="seam-footer">
             <a:extLst xmlns:a="http://schemas.openxmlformats.org/drawingml/2006/main">
               <a:ext uri="{FF2B5EF4-FFF2-40B4-BE49-F238E27FC236}">
-                <a16:creationId xmlns:a16="http://schemas.microsoft.com/office/drawing/2014/main" id="{77AC4F11-CEDA-492A-984F-621F1C031C1E}"/>
+                <a16:creationId xmlns:a16="http://schemas.microsoft.com/office/drawing/2014/main" id="{A0E21A75-8D17-4863-A33F-1BCB55BE0DDB}"/>
               </a:ext>
             </a:extLst>
           </p:cNvPr>
@@ -8003,7 +8082,7 @@
           <p:cNvPr id="29" name="seam-footer-text">
             <a:extLst xmlns:a="http://schemas.openxmlformats.org/drawingml/2006/main">
               <a:ext uri="{FF2B5EF4-FFF2-40B4-BE49-F238E27FC236}">
-                <a16:creationId xmlns:a16="http://schemas.microsoft.com/office/drawing/2014/main" id="{F5749E4C-E42B-4B24-B73B-F5850C700CD8}"/>
+                <a16:creationId xmlns:a16="http://schemas.microsoft.com/office/drawing/2014/main" id="{E6DA395C-4CB3-44C7-A1B5-F610BC01D327}"/>
               </a:ext>
             </a:extLst>
           </p:cNvPr>
@@ -8046,7 +8125,7 @@
     </p:spTree>
     <p:extLst>
       <p:ext uri="{BB962C8B-B14F-4D97-AF65-F5344CB8AC3E}">
-        <p14:creationId xmlns:p14="http://schemas.microsoft.com/office/powerpoint/2010/main" val="1627273324"/>
+        <p14:creationId xmlns:p14="http://schemas.microsoft.com/office/powerpoint/2010/main" val="667763739"/>
       </p:ext>
     </p:extLst>
   </p:cSld>
@@ -8077,7 +8156,7 @@
           <p:cNvPr id="1" name="kicker-6">
             <a:extLst xmlns:a="http://schemas.openxmlformats.org/drawingml/2006/main">
               <a:ext uri="{FF2B5EF4-FFF2-40B4-BE49-F238E27FC236}">
-                <a16:creationId xmlns:a16="http://schemas.microsoft.com/office/drawing/2014/main" id="{43F55FFE-4C74-4B70-91A8-CC6F628AD909}"/>
+                <a16:creationId xmlns:a16="http://schemas.microsoft.com/office/drawing/2014/main" id="{278606C3-5140-4EDC-8E11-3F4DAC95D967}"/>
               </a:ext>
             </a:extLst>
           </p:cNvPr>
@@ -8122,7 +8201,7 @@
           <p:cNvPr id="2" name="title-6">
             <a:extLst xmlns:a="http://schemas.openxmlformats.org/drawingml/2006/main">
               <a:ext uri="{FF2B5EF4-FFF2-40B4-BE49-F238E27FC236}">
-                <a16:creationId xmlns:a16="http://schemas.microsoft.com/office/drawing/2014/main" id="{BB8CC27F-2D9B-44DA-A0BC-75379114B54F}"/>
+                <a16:creationId xmlns:a16="http://schemas.microsoft.com/office/drawing/2014/main" id="{4E5696B2-BA85-457C-A37E-A77D4CCFEC14}"/>
               </a:ext>
             </a:extLst>
           </p:cNvPr>
@@ -8189,7 +8268,7 @@
           <p:cNvPr id="4" name="number-6">
             <a:extLst xmlns:a="http://schemas.openxmlformats.org/drawingml/2006/main">
               <a:ext uri="{FF2B5EF4-FFF2-40B4-BE49-F238E27FC236}">
-                <a16:creationId xmlns:a16="http://schemas.microsoft.com/office/drawing/2014/main" id="{D2B7F43C-B93B-4F34-BE71-C76A9E8183CE}"/>
+                <a16:creationId xmlns:a16="http://schemas.microsoft.com/office/drawing/2014/main" id="{EE307751-C9B8-43AA-9ED4-78B569C62742}"/>
               </a:ext>
             </a:extLst>
           </p:cNvPr>
@@ -8234,7 +8313,7 @@
           <p:cNvPr id="5" name="ci-arrow">
             <a:extLst xmlns:a="http://schemas.openxmlformats.org/drawingml/2006/main">
               <a:ext uri="{FF2B5EF4-FFF2-40B4-BE49-F238E27FC236}">
-                <a16:creationId xmlns:a16="http://schemas.microsoft.com/office/drawing/2014/main" id="{E7665944-6F2A-4B85-8220-1661B7A1658F}"/>
+                <a16:creationId xmlns:a16="http://schemas.microsoft.com/office/drawing/2014/main" id="{6B6547A5-D035-441A-AF9E-882E4FE27A21}"/>
               </a:ext>
             </a:extLst>
           </p:cNvPr>
@@ -8287,7 +8366,7 @@
           <p:cNvPr id="7" name="ci-setup">
             <a:extLst xmlns:a="http://schemas.openxmlformats.org/drawingml/2006/main">
               <a:ext uri="{FF2B5EF4-FFF2-40B4-BE49-F238E27FC236}">
-                <a16:creationId xmlns:a16="http://schemas.microsoft.com/office/drawing/2014/main" id="{AFF22DDB-C244-4FE4-8513-EAF8D51029B8}"/>
+                <a16:creationId xmlns:a16="http://schemas.microsoft.com/office/drawing/2014/main" id="{A0C7BD2B-CC4C-4FA7-98CC-3BC328661FC1}"/>
               </a:ext>
             </a:extLst>
           </p:cNvPr>
@@ -8322,7 +8401,7 @@
           <p:cNvPr id="8" name="ci-command">
             <a:extLst xmlns:a="http://schemas.openxmlformats.org/drawingml/2006/main">
               <a:ext uri="{FF2B5EF4-FFF2-40B4-BE49-F238E27FC236}">
-                <a16:creationId xmlns:a16="http://schemas.microsoft.com/office/drawing/2014/main" id="{BAFEB842-801E-4161-9795-8CCCA1CA5F6F}"/>
+                <a16:creationId xmlns:a16="http://schemas.microsoft.com/office/drawing/2014/main" id="{0ACEAF70-FA5C-4225-B575-D34D14FBEA09}"/>
               </a:ext>
             </a:extLst>
           </p:cNvPr>
@@ -8357,7 +8436,7 @@
           <p:cNvPr id="9" name="ci-left-kicker">
             <a:extLst xmlns:a="http://schemas.openxmlformats.org/drawingml/2006/main">
               <a:ext uri="{FF2B5EF4-FFF2-40B4-BE49-F238E27FC236}">
-                <a16:creationId xmlns:a16="http://schemas.microsoft.com/office/drawing/2014/main" id="{AA6E9DED-439F-43DA-87E3-5A5FCF808C6D}"/>
+                <a16:creationId xmlns:a16="http://schemas.microsoft.com/office/drawing/2014/main" id="{ADE21992-1791-46EA-8D3F-E07A9760DE03}"/>
               </a:ext>
             </a:extLst>
           </p:cNvPr>
@@ -8402,7 +8481,7 @@
           <p:cNvPr id="10" name="ci-left-title">
             <a:extLst xmlns:a="http://schemas.openxmlformats.org/drawingml/2006/main">
               <a:ext uri="{FF2B5EF4-FFF2-40B4-BE49-F238E27FC236}">
-                <a16:creationId xmlns:a16="http://schemas.microsoft.com/office/drawing/2014/main" id="{E0E81428-26AD-4DF9-994F-4CE7ACA7F6E0}"/>
+                <a16:creationId xmlns:a16="http://schemas.microsoft.com/office/drawing/2014/main" id="{999159A8-ED1C-4E22-8B7E-30558394CDE0}"/>
               </a:ext>
             </a:extLst>
           </p:cNvPr>
@@ -8447,7 +8526,7 @@
           <p:cNvPr id="11" name="ci-left-list">
             <a:extLst xmlns:a="http://schemas.openxmlformats.org/drawingml/2006/main">
               <a:ext uri="{FF2B5EF4-FFF2-40B4-BE49-F238E27FC236}">
-                <a16:creationId xmlns:a16="http://schemas.microsoft.com/office/drawing/2014/main" id="{F17598B5-4449-4CD6-8312-593706C41176}"/>
+                <a16:creationId xmlns:a16="http://schemas.microsoft.com/office/drawing/2014/main" id="{24C55C1A-4C5F-4348-9B18-29BA5AAC4B3F}"/>
               </a:ext>
             </a:extLst>
           </p:cNvPr>
@@ -8497,7 +8576,7 @@
           <p:cNvPr id="12" name="ci-right-kicker">
             <a:extLst xmlns:a="http://schemas.openxmlformats.org/drawingml/2006/main">
               <a:ext uri="{FF2B5EF4-FFF2-40B4-BE49-F238E27FC236}">
-                <a16:creationId xmlns:a16="http://schemas.microsoft.com/office/drawing/2014/main" id="{E89578F9-8347-465C-9E5B-2D2D5E096C7F}"/>
+                <a16:creationId xmlns:a16="http://schemas.microsoft.com/office/drawing/2014/main" id="{37E486E6-1B4D-43CA-ADCB-17CCFBCD63D4}"/>
               </a:ext>
             </a:extLst>
           </p:cNvPr>
@@ -8542,7 +8621,7 @@
           <p:cNvPr id="13" name="ci-right-command">
             <a:extLst xmlns:a="http://schemas.openxmlformats.org/drawingml/2006/main">
               <a:ext uri="{FF2B5EF4-FFF2-40B4-BE49-F238E27FC236}">
-                <a16:creationId xmlns:a16="http://schemas.microsoft.com/office/drawing/2014/main" id="{7A6AE12A-2702-41A4-A9AC-8BA2CC49C1F5}"/>
+                <a16:creationId xmlns:a16="http://schemas.microsoft.com/office/drawing/2014/main" id="{AC1CFE81-3BD7-4CCA-A750-BB123EC3333F}"/>
               </a:ext>
             </a:extLst>
           </p:cNvPr>
@@ -8609,7 +8688,7 @@
           <p:cNvPr id="15" name="ci-right-caption">
             <a:extLst xmlns:a="http://schemas.openxmlformats.org/drawingml/2006/main">
               <a:ext uri="{FF2B5EF4-FFF2-40B4-BE49-F238E27FC236}">
-                <a16:creationId xmlns:a16="http://schemas.microsoft.com/office/drawing/2014/main" id="{7FB31738-5C50-418E-B87E-E7C6C4D759BA}"/>
+                <a16:creationId xmlns:a16="http://schemas.microsoft.com/office/drawing/2014/main" id="{87402B3A-EDE8-4519-AEA8-DE1CBB937C22}"/>
               </a:ext>
             </a:extLst>
           </p:cNvPr>
@@ -8655,7 +8734,7 @@
           <p:cNvPr id="16" name="ci-footer">
             <a:extLst xmlns:a="http://schemas.openxmlformats.org/drawingml/2006/main">
               <a:ext uri="{FF2B5EF4-FFF2-40B4-BE49-F238E27FC236}">
-                <a16:creationId xmlns:a16="http://schemas.microsoft.com/office/drawing/2014/main" id="{97543948-42D6-4E4A-A559-8DEA26373DAE}"/>
+                <a16:creationId xmlns:a16="http://schemas.microsoft.com/office/drawing/2014/main" id="{C6C597C2-9F7C-49BD-BA9F-6BBEE96104F2}"/>
               </a:ext>
             </a:extLst>
           </p:cNvPr>
@@ -8698,7 +8777,7 @@
     </p:spTree>
     <p:extLst>
       <p:ext uri="{BB962C8B-B14F-4D97-AF65-F5344CB8AC3E}">
-        <p14:creationId xmlns:p14="http://schemas.microsoft.com/office/powerpoint/2010/main" val="1879814007"/>
+        <p14:creationId xmlns:p14="http://schemas.microsoft.com/office/powerpoint/2010/main" val="904808368"/>
       </p:ext>
     </p:extLst>
   </p:cSld>
@@ -8729,7 +8808,7 @@
           <p:cNvPr id="1" name="kicker-7">
             <a:extLst xmlns:a="http://schemas.openxmlformats.org/drawingml/2006/main">
               <a:ext uri="{FF2B5EF4-FFF2-40B4-BE49-F238E27FC236}">
-                <a16:creationId xmlns:a16="http://schemas.microsoft.com/office/drawing/2014/main" id="{2D4C6F90-3C5E-4521-A91F-F8CBFD9EB6D8}"/>
+                <a16:creationId xmlns:a16="http://schemas.microsoft.com/office/drawing/2014/main" id="{09CDB642-97E2-4CFE-8246-7195E15D5201}"/>
               </a:ext>
             </a:extLst>
           </p:cNvPr>
@@ -8774,7 +8853,7 @@
           <p:cNvPr id="2" name="title-7">
             <a:extLst xmlns:a="http://schemas.openxmlformats.org/drawingml/2006/main">
               <a:ext uri="{FF2B5EF4-FFF2-40B4-BE49-F238E27FC236}">
-                <a16:creationId xmlns:a16="http://schemas.microsoft.com/office/drawing/2014/main" id="{299A68C4-68EB-4338-954E-BEAE4E6BF9AE}"/>
+                <a16:creationId xmlns:a16="http://schemas.microsoft.com/office/drawing/2014/main" id="{68A35B2E-FAA6-42EC-9167-2C58603FCD9D}"/>
               </a:ext>
             </a:extLst>
           </p:cNvPr>
@@ -8841,7 +8920,7 @@
           <p:cNvPr id="4" name="number-7">
             <a:extLst xmlns:a="http://schemas.openxmlformats.org/drawingml/2006/main">
               <a:ext uri="{FF2B5EF4-FFF2-40B4-BE49-F238E27FC236}">
-                <a16:creationId xmlns:a16="http://schemas.microsoft.com/office/drawing/2014/main" id="{77B105FB-B62B-41B8-A488-590505C68CC5}"/>
+                <a16:creationId xmlns:a16="http://schemas.microsoft.com/office/drawing/2014/main" id="{2664DB54-6D45-4D5C-BF23-36D79EA26901}"/>
               </a:ext>
             </a:extLst>
           </p:cNvPr>
@@ -8908,7 +8987,7 @@
           <p:cNvPr id="6" name="lab-bulb-0">
             <a:extLst xmlns:a="http://schemas.openxmlformats.org/drawingml/2006/main">
               <a:ext uri="{FF2B5EF4-FFF2-40B4-BE49-F238E27FC236}">
-                <a16:creationId xmlns:a16="http://schemas.microsoft.com/office/drawing/2014/main" id="{9D788C39-56F3-49E7-A02F-21765266C560}"/>
+                <a16:creationId xmlns:a16="http://schemas.microsoft.com/office/drawing/2014/main" id="{2411ABBE-DBF3-4357-B36C-FE881A5FF01C}"/>
               </a:ext>
             </a:extLst>
           </p:cNvPr>
@@ -8939,7 +9018,7 @@
           <p:cNvPr id="7" name="lab-flag-0">
             <a:extLst xmlns:a="http://schemas.openxmlformats.org/drawingml/2006/main">
               <a:ext uri="{FF2B5EF4-FFF2-40B4-BE49-F238E27FC236}">
-                <a16:creationId xmlns:a16="http://schemas.microsoft.com/office/drawing/2014/main" id="{45EA7C0E-12C1-4882-943D-BAC59FC1424F}"/>
+                <a16:creationId xmlns:a16="http://schemas.microsoft.com/office/drawing/2014/main" id="{57AEBF9B-6014-48E8-90E3-9E3D6027A570}"/>
               </a:ext>
             </a:extLst>
           </p:cNvPr>
@@ -8974,7 +9053,7 @@
           <p:cNvPr id="8" name="lab-icon-0">
             <a:extLst xmlns:a="http://schemas.openxmlformats.org/drawingml/2006/main">
               <a:ext uri="{FF2B5EF4-FFF2-40B4-BE49-F238E27FC236}">
-                <a16:creationId xmlns:a16="http://schemas.microsoft.com/office/drawing/2014/main" id="{2905D9BB-FC0A-4A7D-BDCB-91F8F1365322}"/>
+                <a16:creationId xmlns:a16="http://schemas.microsoft.com/office/drawing/2014/main" id="{1A6610FD-58F4-4B29-854F-E8C5487CD886}"/>
               </a:ext>
             </a:extLst>
           </p:cNvPr>
@@ -9019,7 +9098,7 @@
           <p:cNvPr id="9" name="lab-heading-0">
             <a:extLst xmlns:a="http://schemas.openxmlformats.org/drawingml/2006/main">
               <a:ext uri="{FF2B5EF4-FFF2-40B4-BE49-F238E27FC236}">
-                <a16:creationId xmlns:a16="http://schemas.microsoft.com/office/drawing/2014/main" id="{E4BC36A4-D45E-4506-8186-926BC10684D2}"/>
+                <a16:creationId xmlns:a16="http://schemas.microsoft.com/office/drawing/2014/main" id="{D97DE98B-0A19-4C57-803C-D0CC2C6CC966}"/>
               </a:ext>
             </a:extLst>
           </p:cNvPr>
@@ -9064,7 +9143,7 @@
           <p:cNvPr id="10" name="lab-failure-0">
             <a:extLst xmlns:a="http://schemas.openxmlformats.org/drawingml/2006/main">
               <a:ext uri="{FF2B5EF4-FFF2-40B4-BE49-F238E27FC236}">
-                <a16:creationId xmlns:a16="http://schemas.microsoft.com/office/drawing/2014/main" id="{51C57580-99DB-4F4D-B00C-3D601BF3DB7E}"/>
+                <a16:creationId xmlns:a16="http://schemas.microsoft.com/office/drawing/2014/main" id="{31B212D9-60AD-46E2-B9E7-BA954C2D70F6}"/>
               </a:ext>
             </a:extLst>
           </p:cNvPr>
@@ -9109,7 +9188,7 @@
           <p:cNvPr id="11" name="lab-stop-0">
             <a:extLst xmlns:a="http://schemas.openxmlformats.org/drawingml/2006/main">
               <a:ext uri="{FF2B5EF4-FFF2-40B4-BE49-F238E27FC236}">
-                <a16:creationId xmlns:a16="http://schemas.microsoft.com/office/drawing/2014/main" id="{6910B525-8A47-4986-B7BE-765B9A8103B6}"/>
+                <a16:creationId xmlns:a16="http://schemas.microsoft.com/office/drawing/2014/main" id="{BA8300C0-2512-4BAB-8F07-C864761AEDA7}"/>
               </a:ext>
             </a:extLst>
           </p:cNvPr>
@@ -9176,7 +9255,7 @@
           <p:cNvPr id="13" name="lab-bulb-1">
             <a:extLst xmlns:a="http://schemas.openxmlformats.org/drawingml/2006/main">
               <a:ext uri="{FF2B5EF4-FFF2-40B4-BE49-F238E27FC236}">
-                <a16:creationId xmlns:a16="http://schemas.microsoft.com/office/drawing/2014/main" id="{76879BCB-897B-417B-9846-8C018DF9E153}"/>
+                <a16:creationId xmlns:a16="http://schemas.microsoft.com/office/drawing/2014/main" id="{85031734-8AFE-4883-9AFD-33DE566D7E3C}"/>
               </a:ext>
             </a:extLst>
           </p:cNvPr>
@@ -9207,7 +9286,7 @@
           <p:cNvPr id="14" name="lab-flag-1">
             <a:extLst xmlns:a="http://schemas.openxmlformats.org/drawingml/2006/main">
               <a:ext uri="{FF2B5EF4-FFF2-40B4-BE49-F238E27FC236}">
-                <a16:creationId xmlns:a16="http://schemas.microsoft.com/office/drawing/2014/main" id="{F6EC77D6-9CE5-4DE8-856D-EAC26F7BE4D0}"/>
+                <a16:creationId xmlns:a16="http://schemas.microsoft.com/office/drawing/2014/main" id="{BC8A423A-1535-4134-AF92-4E2BB26C930D}"/>
               </a:ext>
             </a:extLst>
           </p:cNvPr>
@@ -9242,7 +9321,7 @@
           <p:cNvPr id="15" name="lab-icon-1">
             <a:extLst xmlns:a="http://schemas.openxmlformats.org/drawingml/2006/main">
               <a:ext uri="{FF2B5EF4-FFF2-40B4-BE49-F238E27FC236}">
-                <a16:creationId xmlns:a16="http://schemas.microsoft.com/office/drawing/2014/main" id="{C7687521-86E8-4A10-A665-AF94703D7B99}"/>
+                <a16:creationId xmlns:a16="http://schemas.microsoft.com/office/drawing/2014/main" id="{8DD01D1F-A41F-4F35-B089-0D0BAA41BACC}"/>
               </a:ext>
             </a:extLst>
           </p:cNvPr>
@@ -9287,7 +9366,7 @@
           <p:cNvPr id="16" name="lab-heading-1">
             <a:extLst xmlns:a="http://schemas.openxmlformats.org/drawingml/2006/main">
               <a:ext uri="{FF2B5EF4-FFF2-40B4-BE49-F238E27FC236}">
-                <a16:creationId xmlns:a16="http://schemas.microsoft.com/office/drawing/2014/main" id="{83E0A27D-61DA-45F7-A6EF-507B02203A7A}"/>
+                <a16:creationId xmlns:a16="http://schemas.microsoft.com/office/drawing/2014/main" id="{41CEE8E3-3180-4FA1-BD4B-9F645FA19D64}"/>
               </a:ext>
             </a:extLst>
           </p:cNvPr>
@@ -9332,7 +9411,7 @@
           <p:cNvPr id="17" name="lab-failure-1">
             <a:extLst xmlns:a="http://schemas.openxmlformats.org/drawingml/2006/main">
               <a:ext uri="{FF2B5EF4-FFF2-40B4-BE49-F238E27FC236}">
-                <a16:creationId xmlns:a16="http://schemas.microsoft.com/office/drawing/2014/main" id="{6003D00E-1995-41A8-863B-392749563E80}"/>
+                <a16:creationId xmlns:a16="http://schemas.microsoft.com/office/drawing/2014/main" id="{A690F62A-51E2-4808-9CEA-4E86BB117C7A}"/>
               </a:ext>
             </a:extLst>
           </p:cNvPr>
@@ -9377,7 +9456,7 @@
           <p:cNvPr id="18" name="lab-stop-1">
             <a:extLst xmlns:a="http://schemas.openxmlformats.org/drawingml/2006/main">
               <a:ext uri="{FF2B5EF4-FFF2-40B4-BE49-F238E27FC236}">
-                <a16:creationId xmlns:a16="http://schemas.microsoft.com/office/drawing/2014/main" id="{5A9517D1-AE02-46FF-917B-7880539B8678}"/>
+                <a16:creationId xmlns:a16="http://schemas.microsoft.com/office/drawing/2014/main" id="{465E1A24-A5E9-4B93-BF0F-8F17E4465135}"/>
               </a:ext>
             </a:extLst>
           </p:cNvPr>
@@ -9444,7 +9523,7 @@
           <p:cNvPr id="20" name="lab-bulb-2">
             <a:extLst xmlns:a="http://schemas.openxmlformats.org/drawingml/2006/main">
               <a:ext uri="{FF2B5EF4-FFF2-40B4-BE49-F238E27FC236}">
-                <a16:creationId xmlns:a16="http://schemas.microsoft.com/office/drawing/2014/main" id="{3337612A-BE39-4634-B189-E0B44B376230}"/>
+                <a16:creationId xmlns:a16="http://schemas.microsoft.com/office/drawing/2014/main" id="{B5513251-7AF6-486C-BE88-D88FB44E0632}"/>
               </a:ext>
             </a:extLst>
           </p:cNvPr>
@@ -9475,7 +9554,7 @@
           <p:cNvPr id="21" name="lab-flag-2">
             <a:extLst xmlns:a="http://schemas.openxmlformats.org/drawingml/2006/main">
               <a:ext uri="{FF2B5EF4-FFF2-40B4-BE49-F238E27FC236}">
-                <a16:creationId xmlns:a16="http://schemas.microsoft.com/office/drawing/2014/main" id="{ED08948B-AF7B-4329-8BEE-6F75E04A4B3C}"/>
+                <a16:creationId xmlns:a16="http://schemas.microsoft.com/office/drawing/2014/main" id="{CEEFFC62-A1BC-47D6-AE83-5B307CDCCA87}"/>
               </a:ext>
             </a:extLst>
           </p:cNvPr>
@@ -9510,7 +9589,7 @@
           <p:cNvPr id="22" name="lab-icon-2">
             <a:extLst xmlns:a="http://schemas.openxmlformats.org/drawingml/2006/main">
               <a:ext uri="{FF2B5EF4-FFF2-40B4-BE49-F238E27FC236}">
-                <a16:creationId xmlns:a16="http://schemas.microsoft.com/office/drawing/2014/main" id="{7BE493FF-0C4E-4E4C-8D1F-E06E572844F9}"/>
+                <a16:creationId xmlns:a16="http://schemas.microsoft.com/office/drawing/2014/main" id="{D632D152-88E8-4693-8E58-D354A64495AA}"/>
               </a:ext>
             </a:extLst>
           </p:cNvPr>
@@ -9555,7 +9634,7 @@
           <p:cNvPr id="23" name="lab-heading-2">
             <a:extLst xmlns:a="http://schemas.openxmlformats.org/drawingml/2006/main">
               <a:ext uri="{FF2B5EF4-FFF2-40B4-BE49-F238E27FC236}">
-                <a16:creationId xmlns:a16="http://schemas.microsoft.com/office/drawing/2014/main" id="{C798A91D-1945-4A1E-BD8B-70E609AF5F2C}"/>
+                <a16:creationId xmlns:a16="http://schemas.microsoft.com/office/drawing/2014/main" id="{F56A76B6-461B-4BF4-AE34-24106673F180}"/>
               </a:ext>
             </a:extLst>
           </p:cNvPr>
@@ -9600,7 +9679,7 @@
           <p:cNvPr id="24" name="lab-failure-2">
             <a:extLst xmlns:a="http://schemas.openxmlformats.org/drawingml/2006/main">
               <a:ext uri="{FF2B5EF4-FFF2-40B4-BE49-F238E27FC236}">
-                <a16:creationId xmlns:a16="http://schemas.microsoft.com/office/drawing/2014/main" id="{932404CE-1042-4753-ABB4-981DECB20239}"/>
+                <a16:creationId xmlns:a16="http://schemas.microsoft.com/office/drawing/2014/main" id="{09DC6094-80D6-43A1-873D-C93971E9B3DA}"/>
               </a:ext>
             </a:extLst>
           </p:cNvPr>
@@ -9645,7 +9724,7 @@
           <p:cNvPr id="25" name="lab-stop-2">
             <a:extLst xmlns:a="http://schemas.openxmlformats.org/drawingml/2006/main">
               <a:ext uri="{FF2B5EF4-FFF2-40B4-BE49-F238E27FC236}">
-                <a16:creationId xmlns:a16="http://schemas.microsoft.com/office/drawing/2014/main" id="{327CC484-FBF7-4C1E-A383-0740CAEF22C0}"/>
+                <a16:creationId xmlns:a16="http://schemas.microsoft.com/office/drawing/2014/main" id="{9C7F3928-2F7F-45FA-A85E-D77C255D248C}"/>
               </a:ext>
             </a:extLst>
           </p:cNvPr>
@@ -9712,7 +9791,7 @@
           <p:cNvPr id="27" name="lab-bulb-3">
             <a:extLst xmlns:a="http://schemas.openxmlformats.org/drawingml/2006/main">
               <a:ext uri="{FF2B5EF4-FFF2-40B4-BE49-F238E27FC236}">
-                <a16:creationId xmlns:a16="http://schemas.microsoft.com/office/drawing/2014/main" id="{FA5B6E49-6066-4BFA-B4C8-B6652D701E44}"/>
+                <a16:creationId xmlns:a16="http://schemas.microsoft.com/office/drawing/2014/main" id="{3B2E4F49-FD28-498E-AEAD-42CDFA0D1144}"/>
               </a:ext>
             </a:extLst>
           </p:cNvPr>
@@ -9743,7 +9822,7 @@
           <p:cNvPr id="28" name="lab-flag-3">
             <a:extLst xmlns:a="http://schemas.openxmlformats.org/drawingml/2006/main">
               <a:ext uri="{FF2B5EF4-FFF2-40B4-BE49-F238E27FC236}">
-                <a16:creationId xmlns:a16="http://schemas.microsoft.com/office/drawing/2014/main" id="{93D469C5-094C-451F-A002-2A83B01BEC13}"/>
+                <a16:creationId xmlns:a16="http://schemas.microsoft.com/office/drawing/2014/main" id="{779C9628-8022-4758-94F4-7918584CF5BC}"/>
               </a:ext>
             </a:extLst>
           </p:cNvPr>
@@ -9778,7 +9857,7 @@
           <p:cNvPr id="29" name="lab-icon-3">
             <a:extLst xmlns:a="http://schemas.openxmlformats.org/drawingml/2006/main">
               <a:ext uri="{FF2B5EF4-FFF2-40B4-BE49-F238E27FC236}">
-                <a16:creationId xmlns:a16="http://schemas.microsoft.com/office/drawing/2014/main" id="{80B33F51-3995-423D-A120-6B7A13D339C6}"/>
+                <a16:creationId xmlns:a16="http://schemas.microsoft.com/office/drawing/2014/main" id="{79D9517E-3437-4C6D-B80D-9B73BC883D2A}"/>
               </a:ext>
             </a:extLst>
           </p:cNvPr>
@@ -9823,7 +9902,7 @@
           <p:cNvPr id="30" name="lab-heading-3">
             <a:extLst xmlns:a="http://schemas.openxmlformats.org/drawingml/2006/main">
               <a:ext uri="{FF2B5EF4-FFF2-40B4-BE49-F238E27FC236}">
-                <a16:creationId xmlns:a16="http://schemas.microsoft.com/office/drawing/2014/main" id="{0E60649B-C720-450C-AE9D-FE9C78FA19EC}"/>
+                <a16:creationId xmlns:a16="http://schemas.microsoft.com/office/drawing/2014/main" id="{44B4D6A6-67E5-4E35-AAE4-948063088E21}"/>
               </a:ext>
             </a:extLst>
           </p:cNvPr>
@@ -9868,7 +9947,7 @@
           <p:cNvPr id="31" name="lab-failure-3">
             <a:extLst xmlns:a="http://schemas.openxmlformats.org/drawingml/2006/main">
               <a:ext uri="{FF2B5EF4-FFF2-40B4-BE49-F238E27FC236}">
-                <a16:creationId xmlns:a16="http://schemas.microsoft.com/office/drawing/2014/main" id="{789A3FEC-2E2F-4DE7-8E93-5E15B0B36C6A}"/>
+                <a16:creationId xmlns:a16="http://schemas.microsoft.com/office/drawing/2014/main" id="{BA378E5D-4BA4-4E8B-B823-108CDB6E4359}"/>
               </a:ext>
             </a:extLst>
           </p:cNvPr>
@@ -9913,7 +9992,7 @@
           <p:cNvPr id="32" name="lab-stop-3">
             <a:extLst xmlns:a="http://schemas.openxmlformats.org/drawingml/2006/main">
               <a:ext uri="{FF2B5EF4-FFF2-40B4-BE49-F238E27FC236}">
-                <a16:creationId xmlns:a16="http://schemas.microsoft.com/office/drawing/2014/main" id="{8A1CD6C5-8353-4C98-B71B-8D73B21C5709}"/>
+                <a16:creationId xmlns:a16="http://schemas.microsoft.com/office/drawing/2014/main" id="{1F94556B-7347-4007-9DA1-645E09F43553}"/>
               </a:ext>
             </a:extLst>
           </p:cNvPr>
@@ -9958,7 +10037,7 @@
           <p:cNvPr id="33" name="lab-command">
             <a:extLst xmlns:a="http://schemas.openxmlformats.org/drawingml/2006/main">
               <a:ext uri="{FF2B5EF4-FFF2-40B4-BE49-F238E27FC236}">
-                <a16:creationId xmlns:a16="http://schemas.microsoft.com/office/drawing/2014/main" id="{9391FDAE-547D-48BF-AC1B-26FC08F34040}"/>
+                <a16:creationId xmlns:a16="http://schemas.microsoft.com/office/drawing/2014/main" id="{85E7061D-A202-465C-A484-19B26D0DBA65}"/>
               </a:ext>
             </a:extLst>
           </p:cNvPr>
@@ -9991,7 +10070,7 @@
           <p:cNvPr id="34" name="lab-command-text">
             <a:extLst xmlns:a="http://schemas.openxmlformats.org/drawingml/2006/main">
               <a:ext uri="{FF2B5EF4-FFF2-40B4-BE49-F238E27FC236}">
-                <a16:creationId xmlns:a16="http://schemas.microsoft.com/office/drawing/2014/main" id="{73AB8276-1B92-4AC8-8D14-E3786C762F13}"/>
+                <a16:creationId xmlns:a16="http://schemas.microsoft.com/office/drawing/2014/main" id="{7755AF30-4C7C-4022-9F53-F607D413F7A7}"/>
               </a:ext>
             </a:extLst>
           </p:cNvPr>
@@ -10036,7 +10115,7 @@
           <p:cNvPr id="35" name="lab-note">
             <a:extLst xmlns:a="http://schemas.openxmlformats.org/drawingml/2006/main">
               <a:ext uri="{FF2B5EF4-FFF2-40B4-BE49-F238E27FC236}">
-                <a16:creationId xmlns:a16="http://schemas.microsoft.com/office/drawing/2014/main" id="{D6B2464F-87A8-4E21-8E67-60B7B7FE1C12}"/>
+                <a16:creationId xmlns:a16="http://schemas.microsoft.com/office/drawing/2014/main" id="{087FF9AC-262D-4C46-862D-99AA15BDAC10}"/>
               </a:ext>
             </a:extLst>
           </p:cNvPr>
@@ -10079,7 +10158,7 @@
     </p:spTree>
     <p:extLst>
       <p:ext uri="{BB962C8B-B14F-4D97-AF65-F5344CB8AC3E}">
-        <p14:creationId xmlns:p14="http://schemas.microsoft.com/office/powerpoint/2010/main" val="940679249"/>
+        <p14:creationId xmlns:p14="http://schemas.microsoft.com/office/powerpoint/2010/main" val="518252057"/>
       </p:ext>
     </p:extLst>
   </p:cSld>
@@ -10110,7 +10189,7 @@
           <p:cNvPr id="1" name="kicker-8">
             <a:extLst xmlns:a="http://schemas.openxmlformats.org/drawingml/2006/main">
               <a:ext uri="{FF2B5EF4-FFF2-40B4-BE49-F238E27FC236}">
-                <a16:creationId xmlns:a16="http://schemas.microsoft.com/office/drawing/2014/main" id="{6CEFDD92-1674-4B4F-BA58-7BF0184B2112}"/>
+                <a16:creationId xmlns:a16="http://schemas.microsoft.com/office/drawing/2014/main" id="{F5C22F35-9933-4A5C-939A-12828C2409AB}"/>
               </a:ext>
             </a:extLst>
           </p:cNvPr>
@@ -10155,7 +10234,7 @@
           <p:cNvPr id="2" name="title-8">
             <a:extLst xmlns:a="http://schemas.openxmlformats.org/drawingml/2006/main">
               <a:ext uri="{FF2B5EF4-FFF2-40B4-BE49-F238E27FC236}">
-                <a16:creationId xmlns:a16="http://schemas.microsoft.com/office/drawing/2014/main" id="{E55C992D-E9D1-4AE3-8DC7-4EE2E9D24644}"/>
+                <a16:creationId xmlns:a16="http://schemas.microsoft.com/office/drawing/2014/main" id="{63EF820B-3124-42B1-A46A-378EC0816EC5}"/>
               </a:ext>
             </a:extLst>
           </p:cNvPr>
@@ -10222,7 +10301,7 @@
           <p:cNvPr id="4" name="number-8">
             <a:extLst xmlns:a="http://schemas.openxmlformats.org/drawingml/2006/main">
               <a:ext uri="{FF2B5EF4-FFF2-40B4-BE49-F238E27FC236}">
-                <a16:creationId xmlns:a16="http://schemas.microsoft.com/office/drawing/2014/main" id="{AC5CBD75-7B38-4BC5-900A-EAC21CC24ACB}"/>
+                <a16:creationId xmlns:a16="http://schemas.microsoft.com/office/drawing/2014/main" id="{68EAA4A3-450E-4DEB-B5E4-8C9CB4573FFD}"/>
               </a:ext>
             </a:extLst>
           </p:cNvPr>
@@ -10421,7 +10500,7 @@
           <p:cNvPr id="12" name="prod-local-dot">
             <a:extLst xmlns:a="http://schemas.openxmlformats.org/drawingml/2006/main">
               <a:ext uri="{FF2B5EF4-FFF2-40B4-BE49-F238E27FC236}">
-                <a16:creationId xmlns:a16="http://schemas.microsoft.com/office/drawing/2014/main" id="{AA14D6F4-D1DD-422B-9E28-3DAA784E3876}"/>
+                <a16:creationId xmlns:a16="http://schemas.microsoft.com/office/drawing/2014/main" id="{21D622BE-E0C9-416D-A55F-A0F5A9F965D9}"/>
               </a:ext>
             </a:extLst>
           </p:cNvPr>
@@ -10452,7 +10531,7 @@
           <p:cNvPr id="13" name="prod-ci-dot">
             <a:extLst xmlns:a="http://schemas.openxmlformats.org/drawingml/2006/main">
               <a:ext uri="{FF2B5EF4-FFF2-40B4-BE49-F238E27FC236}">
-                <a16:creationId xmlns:a16="http://schemas.microsoft.com/office/drawing/2014/main" id="{AF489A07-DE02-46C2-98D2-01D5B47CE838}"/>
+                <a16:creationId xmlns:a16="http://schemas.microsoft.com/office/drawing/2014/main" id="{FF968E55-914A-467F-99CF-08FD8E94D389}"/>
               </a:ext>
             </a:extLst>
           </p:cNvPr>
@@ -10483,7 +10562,7 @@
           <p:cNvPr id="14" name="prod-scale-dot">
             <a:extLst xmlns:a="http://schemas.openxmlformats.org/drawingml/2006/main">
               <a:ext uri="{FF2B5EF4-FFF2-40B4-BE49-F238E27FC236}">
-                <a16:creationId xmlns:a16="http://schemas.microsoft.com/office/drawing/2014/main" id="{3E37ACA5-7812-4B12-BA06-4EDE9F4F9A61}"/>
+                <a16:creationId xmlns:a16="http://schemas.microsoft.com/office/drawing/2014/main" id="{62D84512-8A2E-4C5B-BAE0-28FBE8E8541E}"/>
               </a:ext>
             </a:extLst>
           </p:cNvPr>
@@ -10514,7 +10593,7 @@
           <p:cNvPr id="15" name="prod-enterprise-dot">
             <a:extLst xmlns:a="http://schemas.openxmlformats.org/drawingml/2006/main">
               <a:ext uri="{FF2B5EF4-FFF2-40B4-BE49-F238E27FC236}">
-                <a16:creationId xmlns:a16="http://schemas.microsoft.com/office/drawing/2014/main" id="{FD104B5C-ADB8-4DC6-9F3D-559DC20B47C0}"/>
+                <a16:creationId xmlns:a16="http://schemas.microsoft.com/office/drawing/2014/main" id="{F18AF40D-7E58-4A9B-B49F-5FD2F9B55B85}"/>
               </a:ext>
             </a:extLst>
           </p:cNvPr>
@@ -10545,7 +10624,7 @@
           <p:cNvPr id="16" name="prod-local-title">
             <a:extLst xmlns:a="http://schemas.openxmlformats.org/drawingml/2006/main">
               <a:ext uri="{FF2B5EF4-FFF2-40B4-BE49-F238E27FC236}">
-                <a16:creationId xmlns:a16="http://schemas.microsoft.com/office/drawing/2014/main" id="{E221F8D6-C6D7-46F6-BEE6-DCF84AC97BEB}"/>
+                <a16:creationId xmlns:a16="http://schemas.microsoft.com/office/drawing/2014/main" id="{EB4BEC01-83C6-43B5-9122-32B219FC819F}"/>
               </a:ext>
             </a:extLst>
           </p:cNvPr>
@@ -10590,7 +10669,7 @@
           <p:cNvPr id="17" name="prod-local-body">
             <a:extLst xmlns:a="http://schemas.openxmlformats.org/drawingml/2006/main">
               <a:ext uri="{FF2B5EF4-FFF2-40B4-BE49-F238E27FC236}">
-                <a16:creationId xmlns:a16="http://schemas.microsoft.com/office/drawing/2014/main" id="{20EAEDAB-E265-4DDB-AD7D-590E11BD8FD1}"/>
+                <a16:creationId xmlns:a16="http://schemas.microsoft.com/office/drawing/2014/main" id="{F2C738DF-26D1-4F04-9788-DC84FE1B0F15}"/>
               </a:ext>
             </a:extLst>
           </p:cNvPr>
@@ -10637,7 +10716,7 @@
           <p:cNvPr id="18" name="prod-ci-title">
             <a:extLst xmlns:a="http://schemas.openxmlformats.org/drawingml/2006/main">
               <a:ext uri="{FF2B5EF4-FFF2-40B4-BE49-F238E27FC236}">
-                <a16:creationId xmlns:a16="http://schemas.microsoft.com/office/drawing/2014/main" id="{D6B83A3C-3DD7-49EA-8C1B-BA5BCE0DB643}"/>
+                <a16:creationId xmlns:a16="http://schemas.microsoft.com/office/drawing/2014/main" id="{6A1FBB77-A85C-47AB-9EDA-FEC0E4E45BEE}"/>
               </a:ext>
             </a:extLst>
           </p:cNvPr>
@@ -10682,7 +10761,7 @@
           <p:cNvPr id="19" name="prod-ci-body">
             <a:extLst xmlns:a="http://schemas.openxmlformats.org/drawingml/2006/main">
               <a:ext uri="{FF2B5EF4-FFF2-40B4-BE49-F238E27FC236}">
-                <a16:creationId xmlns:a16="http://schemas.microsoft.com/office/drawing/2014/main" id="{DD286C9C-AED6-4F06-855B-F4ECEFA54173}"/>
+                <a16:creationId xmlns:a16="http://schemas.microsoft.com/office/drawing/2014/main" id="{6AF17FE8-AE3D-47C6-A3E3-73B9A72064DE}"/>
               </a:ext>
             </a:extLst>
           </p:cNvPr>
@@ -10729,7 +10808,7 @@
           <p:cNvPr id="20" name="prod-scale-title">
             <a:extLst xmlns:a="http://schemas.openxmlformats.org/drawingml/2006/main">
               <a:ext uri="{FF2B5EF4-FFF2-40B4-BE49-F238E27FC236}">
-                <a16:creationId xmlns:a16="http://schemas.microsoft.com/office/drawing/2014/main" id="{1BE5E2C0-88AF-42DA-8D07-4110BA165912}"/>
+                <a16:creationId xmlns:a16="http://schemas.microsoft.com/office/drawing/2014/main" id="{BCE32D1F-7AD4-4BCA-B456-0208FFEB2A0E}"/>
               </a:ext>
             </a:extLst>
           </p:cNvPr>
@@ -10774,7 +10853,7 @@
           <p:cNvPr id="21" name="prod-scale-body">
             <a:extLst xmlns:a="http://schemas.openxmlformats.org/drawingml/2006/main">
               <a:ext uri="{FF2B5EF4-FFF2-40B4-BE49-F238E27FC236}">
-                <a16:creationId xmlns:a16="http://schemas.microsoft.com/office/drawing/2014/main" id="{2CCA0B26-BD09-49E8-9BBE-6798BA92635E}"/>
+                <a16:creationId xmlns:a16="http://schemas.microsoft.com/office/drawing/2014/main" id="{44497F6A-11B6-45F7-9E06-9886723FBCF9}"/>
               </a:ext>
             </a:extLst>
           </p:cNvPr>
@@ -10821,7 +10900,7 @@
           <p:cNvPr id="22" name="prod-enterprise-title">
             <a:extLst xmlns:a="http://schemas.openxmlformats.org/drawingml/2006/main">
               <a:ext uri="{FF2B5EF4-FFF2-40B4-BE49-F238E27FC236}">
-                <a16:creationId xmlns:a16="http://schemas.microsoft.com/office/drawing/2014/main" id="{1ADFFF3D-D7F6-4ABC-9DFA-DC7E4EA3F76A}"/>
+                <a16:creationId xmlns:a16="http://schemas.microsoft.com/office/drawing/2014/main" id="{EDB9EDBE-877C-46AE-8996-CD6F34E029A1}"/>
               </a:ext>
             </a:extLst>
           </p:cNvPr>
@@ -10866,7 +10945,7 @@
           <p:cNvPr id="23" name="prod-enterprise-body">
             <a:extLst xmlns:a="http://schemas.openxmlformats.org/drawingml/2006/main">
               <a:ext uri="{FF2B5EF4-FFF2-40B4-BE49-F238E27FC236}">
-                <a16:creationId xmlns:a16="http://schemas.microsoft.com/office/drawing/2014/main" id="{AC3E396D-3702-40A3-A4C6-0EABFAEF776B}"/>
+                <a16:creationId xmlns:a16="http://schemas.microsoft.com/office/drawing/2014/main" id="{B53F5AF0-AE2B-4580-9FB2-8F48E6C766AA}"/>
               </a:ext>
             </a:extLst>
           </p:cNvPr>
@@ -10914,7 +10993,7 @@
           <p:cNvPr id="24" name="prod-signal">
             <a:extLst xmlns:a="http://schemas.openxmlformats.org/drawingml/2006/main">
               <a:ext uri="{FF2B5EF4-FFF2-40B4-BE49-F238E27FC236}">
-                <a16:creationId xmlns:a16="http://schemas.microsoft.com/office/drawing/2014/main" id="{7464A041-26E1-4249-A26D-30F327C6E4BF}"/>
+                <a16:creationId xmlns:a16="http://schemas.microsoft.com/office/drawing/2014/main" id="{A994A405-CE39-44D3-84C9-29F7AF1836E9}"/>
               </a:ext>
             </a:extLst>
           </p:cNvPr>
@@ -10957,7 +11036,7 @@
     </p:spTree>
     <p:extLst>
       <p:ext uri="{BB962C8B-B14F-4D97-AF65-F5344CB8AC3E}">
-        <p14:creationId xmlns:p14="http://schemas.microsoft.com/office/powerpoint/2010/main" val="117149853"/>
+        <p14:creationId xmlns:p14="http://schemas.microsoft.com/office/powerpoint/2010/main" val="469346657"/>
       </p:ext>
     </p:extLst>
   </p:cSld>
@@ -10988,7 +11067,7 @@
           <p:cNvPr id="1" name="kicker-9">
             <a:extLst xmlns:a="http://schemas.openxmlformats.org/drawingml/2006/main">
               <a:ext uri="{FF2B5EF4-FFF2-40B4-BE49-F238E27FC236}">
-                <a16:creationId xmlns:a16="http://schemas.microsoft.com/office/drawing/2014/main" id="{3EB3B0C3-687F-402D-8883-5A0EA62D3D5D}"/>
+                <a16:creationId xmlns:a16="http://schemas.microsoft.com/office/drawing/2014/main" id="{9A78AA41-08B6-4F1A-8205-D6C9247D148B}"/>
               </a:ext>
             </a:extLst>
           </p:cNvPr>
@@ -11033,7 +11112,7 @@
           <p:cNvPr id="2" name="title-9">
             <a:extLst xmlns:a="http://schemas.openxmlformats.org/drawingml/2006/main">
               <a:ext uri="{FF2B5EF4-FFF2-40B4-BE49-F238E27FC236}">
-                <a16:creationId xmlns:a16="http://schemas.microsoft.com/office/drawing/2014/main" id="{CCC243D2-BE11-4197-A9FA-E9E315A3ACCA}"/>
+                <a16:creationId xmlns:a16="http://schemas.microsoft.com/office/drawing/2014/main" id="{A2B441AE-5538-4E8F-AC02-F6C5D6C4F17E}"/>
               </a:ext>
             </a:extLst>
           </p:cNvPr>
@@ -11100,7 +11179,7 @@
           <p:cNvPr id="4" name="number-9">
             <a:extLst xmlns:a="http://schemas.openxmlformats.org/drawingml/2006/main">
               <a:ext uri="{FF2B5EF4-FFF2-40B4-BE49-F238E27FC236}">
-                <a16:creationId xmlns:a16="http://schemas.microsoft.com/office/drawing/2014/main" id="{79EBE264-AB7F-4A4F-A7BC-57AFFDDC072E}"/>
+                <a16:creationId xmlns:a16="http://schemas.microsoft.com/office/drawing/2014/main" id="{4372260C-FBCE-4F6E-A56B-F2AEFC25CF93}"/>
               </a:ext>
             </a:extLst>
           </p:cNvPr>
@@ -11167,7 +11246,7 @@
           <p:cNvPr id="6" name="trade-fulcrum">
             <a:extLst xmlns:a="http://schemas.openxmlformats.org/drawingml/2006/main">
               <a:ext uri="{FF2B5EF4-FFF2-40B4-BE49-F238E27FC236}">
-                <a16:creationId xmlns:a16="http://schemas.microsoft.com/office/drawing/2014/main" id="{5CC15D1D-CB80-49C6-B4F6-B9B6D9369F2F}"/>
+                <a16:creationId xmlns:a16="http://schemas.microsoft.com/office/drawing/2014/main" id="{142EB844-9FD3-4AC9-8E4D-489E5AC5EBEE}"/>
               </a:ext>
             </a:extLst>
           </p:cNvPr>
@@ -11198,7 +11277,7 @@
           <p:cNvPr id="7" name="trade-left-pan">
             <a:extLst xmlns:a="http://schemas.openxmlformats.org/drawingml/2006/main">
               <a:ext uri="{FF2B5EF4-FFF2-40B4-BE49-F238E27FC236}">
-                <a16:creationId xmlns:a16="http://schemas.microsoft.com/office/drawing/2014/main" id="{7D800A7A-BF75-4C13-A655-AD50D4F8ED0E}"/>
+                <a16:creationId xmlns:a16="http://schemas.microsoft.com/office/drawing/2014/main" id="{B5F198DE-C8DE-422D-88BA-500B0707167F}"/>
               </a:ext>
             </a:extLst>
           </p:cNvPr>
@@ -11233,7 +11312,7 @@
           <p:cNvPr id="8" name="trade-right-pan">
             <a:extLst xmlns:a="http://schemas.openxmlformats.org/drawingml/2006/main">
               <a:ext uri="{FF2B5EF4-FFF2-40B4-BE49-F238E27FC236}">
-                <a16:creationId xmlns:a16="http://schemas.microsoft.com/office/drawing/2014/main" id="{D08DC4C7-CEE2-481A-AF0A-8AB98C03C98B}"/>
+                <a16:creationId xmlns:a16="http://schemas.microsoft.com/office/drawing/2014/main" id="{1F111CE5-EE9B-4182-8A2F-32911BCFB31A}"/>
               </a:ext>
             </a:extLst>
           </p:cNvPr>
@@ -11312,7 +11391,7 @@
           <p:cNvPr id="11" name="trade-left-title">
             <a:extLst xmlns:a="http://schemas.openxmlformats.org/drawingml/2006/main">
               <a:ext uri="{FF2B5EF4-FFF2-40B4-BE49-F238E27FC236}">
-                <a16:creationId xmlns:a16="http://schemas.microsoft.com/office/drawing/2014/main" id="{F096C754-5986-4009-9198-D4D9119E6049}"/>
+                <a16:creationId xmlns:a16="http://schemas.microsoft.com/office/drawing/2014/main" id="{0F70CB1D-2B55-4872-AEA9-CB088ED62FA1}"/>
               </a:ext>
             </a:extLst>
           </p:cNvPr>
@@ -11357,7 +11436,7 @@
           <p:cNvPr id="12" name="trade-left-body">
             <a:extLst xmlns:a="http://schemas.openxmlformats.org/drawingml/2006/main">
               <a:ext uri="{FF2B5EF4-FFF2-40B4-BE49-F238E27FC236}">
-                <a16:creationId xmlns:a16="http://schemas.microsoft.com/office/drawing/2014/main" id="{7DE23672-5F8C-4E2F-8102-75AFE85F9C3F}"/>
+                <a16:creationId xmlns:a16="http://schemas.microsoft.com/office/drawing/2014/main" id="{1561F458-E211-4B5A-AE86-A7CF72D7C333}"/>
               </a:ext>
             </a:extLst>
           </p:cNvPr>
@@ -11404,7 +11483,7 @@
           <p:cNvPr id="13" name="trade-right-title">
             <a:extLst xmlns:a="http://schemas.openxmlformats.org/drawingml/2006/main">
               <a:ext uri="{FF2B5EF4-FFF2-40B4-BE49-F238E27FC236}">
-                <a16:creationId xmlns:a16="http://schemas.microsoft.com/office/drawing/2014/main" id="{E295B3A2-A1F3-488B-8AEF-4BFEE197EC1C}"/>
+                <a16:creationId xmlns:a16="http://schemas.microsoft.com/office/drawing/2014/main" id="{640A4039-23CE-44EE-AB28-4F4396615CE9}"/>
               </a:ext>
             </a:extLst>
           </p:cNvPr>
@@ -11449,7 +11528,7 @@
           <p:cNvPr id="14" name="trade-right-body">
             <a:extLst xmlns:a="http://schemas.openxmlformats.org/drawingml/2006/main">
               <a:ext uri="{FF2B5EF4-FFF2-40B4-BE49-F238E27FC236}">
-                <a16:creationId xmlns:a16="http://schemas.microsoft.com/office/drawing/2014/main" id="{FED45BCD-BE5D-44AA-BD62-D6703DE08BB5}"/>
+                <a16:creationId xmlns:a16="http://schemas.microsoft.com/office/drawing/2014/main" id="{F2FB0327-FC50-4809-BA51-8E4F9302EA70}"/>
               </a:ext>
             </a:extLst>
           </p:cNvPr>
@@ -11496,7 +11575,7 @@
           <p:cNvPr id="15" name="trade-center">
             <a:extLst xmlns:a="http://schemas.openxmlformats.org/drawingml/2006/main">
               <a:ext uri="{FF2B5EF4-FFF2-40B4-BE49-F238E27FC236}">
-                <a16:creationId xmlns:a16="http://schemas.microsoft.com/office/drawing/2014/main" id="{84C136ED-1204-4E83-BDE9-6786C6CC30B8}"/>
+                <a16:creationId xmlns:a16="http://schemas.microsoft.com/office/drawing/2014/main" id="{AD2DF5A0-250B-4F43-A156-3453D975A468}"/>
               </a:ext>
             </a:extLst>
           </p:cNvPr>
@@ -11541,7 +11620,7 @@
           <p:cNvPr id="16" name="trade-rule">
             <a:extLst xmlns:a="http://schemas.openxmlformats.org/drawingml/2006/main">
               <a:ext uri="{FF2B5EF4-FFF2-40B4-BE49-F238E27FC236}">
-                <a16:creationId xmlns:a16="http://schemas.microsoft.com/office/drawing/2014/main" id="{E0BA057B-C104-46D3-BBDD-8BA63BEF7BA9}"/>
+                <a16:creationId xmlns:a16="http://schemas.microsoft.com/office/drawing/2014/main" id="{6BF9F27B-ADF0-4FF6-B825-2C215AB7EDE3}"/>
               </a:ext>
             </a:extLst>
           </p:cNvPr>
@@ -11574,7 +11653,7 @@
           <p:cNvPr id="17" name="trade-rule-text">
             <a:extLst xmlns:a="http://schemas.openxmlformats.org/drawingml/2006/main">
               <a:ext uri="{FF2B5EF4-FFF2-40B4-BE49-F238E27FC236}">
-                <a16:creationId xmlns:a16="http://schemas.microsoft.com/office/drawing/2014/main" id="{599F54DC-7CEB-4B81-B4C4-33B324E83128}"/>
+                <a16:creationId xmlns:a16="http://schemas.microsoft.com/office/drawing/2014/main" id="{3D551A24-FE5D-4BD4-BFC6-F1FDAA02AC9B}"/>
               </a:ext>
             </a:extLst>
           </p:cNvPr>
@@ -11617,7 +11696,7 @@
     </p:spTree>
     <p:extLst>
       <p:ext uri="{BB962C8B-B14F-4D97-AF65-F5344CB8AC3E}">
-        <p14:creationId xmlns:p14="http://schemas.microsoft.com/office/powerpoint/2010/main" val="899839766"/>
+        <p14:creationId xmlns:p14="http://schemas.microsoft.com/office/powerpoint/2010/main" val="1865897427"/>
       </p:ext>
     </p:extLst>
   </p:cSld>

</xml_diff>

<commit_message>
Address remaining repository policy feedback
</commit_message>
<xml_diff>
--- a/docs/lessons/assets/cah-007-repository-checks.pptx
+++ b/docs/lessons/assets/cah-007-repository-checks.pptx
@@ -2,22 +2,22 @@
 <file path=ppt/presentation.xml><?xml version="1.0" encoding="utf-8"?>
 <p:presentation xmlns:p="http://schemas.openxmlformats.org/presentationml/2006/main">
   <p:sldMasterIdLst>
-    <p:sldMasterId xmlns:r="http://schemas.openxmlformats.org/officeDocument/2006/relationships" id="2147483648" r:id="R4bdf20e5ac864355"/>
+    <p:sldMasterId xmlns:r="http://schemas.openxmlformats.org/officeDocument/2006/relationships" id="2147483648" r:id="R7c8ae2ab08944da5"/>
   </p:sldMasterIdLst>
   <p:notesMasterIdLst>
-    <p:notesMasterId xmlns:r="http://schemas.openxmlformats.org/officeDocument/2006/relationships" r:id="R9558172af17b4dde"/>
+    <p:notesMasterId xmlns:r="http://schemas.openxmlformats.org/officeDocument/2006/relationships" r:id="R4c49b321f6414beb"/>
   </p:notesMasterIdLst>
   <p:sldIdLst>
-    <p:sldId xmlns:r="http://schemas.openxmlformats.org/officeDocument/2006/relationships" id="256" r:id="R37fbbe55f2374acc"/>
-    <p:sldId xmlns:r="http://schemas.openxmlformats.org/officeDocument/2006/relationships" id="257" r:id="R185efa2b73d84ca9"/>
-    <p:sldId xmlns:r="http://schemas.openxmlformats.org/officeDocument/2006/relationships" id="258" r:id="Rdc2007f95d21480a"/>
-    <p:sldId xmlns:r="http://schemas.openxmlformats.org/officeDocument/2006/relationships" id="259" r:id="Re1fdb3361415408c"/>
-    <p:sldId xmlns:r="http://schemas.openxmlformats.org/officeDocument/2006/relationships" id="260" r:id="R6ee9fccb34494900"/>
-    <p:sldId xmlns:r="http://schemas.openxmlformats.org/officeDocument/2006/relationships" id="261" r:id="R149887008ab645b1"/>
-    <p:sldId xmlns:r="http://schemas.openxmlformats.org/officeDocument/2006/relationships" id="262" r:id="R7d17c26d4edf43fc"/>
-    <p:sldId xmlns:r="http://schemas.openxmlformats.org/officeDocument/2006/relationships" id="263" r:id="R6324f25714a740d7"/>
-    <p:sldId xmlns:r="http://schemas.openxmlformats.org/officeDocument/2006/relationships" id="264" r:id="Reed08546372949d8"/>
-    <p:sldId xmlns:r="http://schemas.openxmlformats.org/officeDocument/2006/relationships" id="265" r:id="Rb4d5925cb17b407f"/>
+    <p:sldId xmlns:r="http://schemas.openxmlformats.org/officeDocument/2006/relationships" id="256" r:id="Rcaf1f98cc52a4650"/>
+    <p:sldId xmlns:r="http://schemas.openxmlformats.org/officeDocument/2006/relationships" id="257" r:id="R8e47bcd06cfc44e2"/>
+    <p:sldId xmlns:r="http://schemas.openxmlformats.org/officeDocument/2006/relationships" id="258" r:id="R1a206211cbb04f42"/>
+    <p:sldId xmlns:r="http://schemas.openxmlformats.org/officeDocument/2006/relationships" id="259" r:id="R1809465e63e0441d"/>
+    <p:sldId xmlns:r="http://schemas.openxmlformats.org/officeDocument/2006/relationships" id="260" r:id="Rcd543f31d9e6423c"/>
+    <p:sldId xmlns:r="http://schemas.openxmlformats.org/officeDocument/2006/relationships" id="261" r:id="R2d75f5530de84bd8"/>
+    <p:sldId xmlns:r="http://schemas.openxmlformats.org/officeDocument/2006/relationships" id="262" r:id="R26e1e5b194a147d8"/>
+    <p:sldId xmlns:r="http://schemas.openxmlformats.org/officeDocument/2006/relationships" id="263" r:id="R245161d70b324114"/>
+    <p:sldId xmlns:r="http://schemas.openxmlformats.org/officeDocument/2006/relationships" id="264" r:id="R33d4e136d3534443"/>
+    <p:sldId xmlns:r="http://schemas.openxmlformats.org/officeDocument/2006/relationships" id="265" r:id="Re34bdf1fbdff400e"/>
   </p:sldIdLst>
   <p:sldSz cx="12192000" cy="6858000"/>
   <p:notesSz cx="6858000" cy="9144000"/>
@@ -1204,7 +1204,7 @@
   </p:cSld>
   <p:clrMap bg1="lt1" tx1="dk1" bg2="lt2" tx2="dk2" accent1="accent1" accent2="accent2" accent3="accent3" accent4="accent4" accent5="accent5" accent6="accent6" hlink="hlink" folHlink="folHlink"/>
   <p:sldLayoutIdLst>
-    <p:sldLayoutId xmlns:r="http://schemas.openxmlformats.org/officeDocument/2006/relationships" id="2147483649" r:id="R5913169983a34424"/>
+    <p:sldLayoutId xmlns:r="http://schemas.openxmlformats.org/officeDocument/2006/relationships" id="2147483649" r:id="Rbb4f2a47c05a4cb1"/>
   </p:sldLayoutIdLst>
   <p:txStyles>
     <p:titleStyle>
@@ -1759,7 +1759,7 @@
           <p:nvPr/>
         </p:nvPicPr>
         <p:blipFill>
-          <a:blip xmlns:r="http://schemas.openxmlformats.org/officeDocument/2006/relationships" xmlns:a="http://schemas.openxmlformats.org/drawingml/2006/main" r:embed="R25caf125a7224983"/>
+          <a:blip xmlns:r="http://schemas.openxmlformats.org/officeDocument/2006/relationships" xmlns:a="http://schemas.openxmlformats.org/drawingml/2006/main" r:embed="R61c031cefc26441f"/>
           <a:srcRect xmlns:a="http://schemas.openxmlformats.org/drawingml/2006/main" l="0" t="27" r="0" b="27"/>
           <a:stretch xmlns:a="http://schemas.openxmlformats.org/drawingml/2006/main">
             <a:fillRect l="0" t="0" r="0" b="0"/>
@@ -1780,7 +1780,7 @@
           <p:cNvPr id="2" name="cover-shade">
             <a:extLst xmlns:a="http://schemas.openxmlformats.org/drawingml/2006/main">
               <a:ext uri="{FF2B5EF4-FFF2-40B4-BE49-F238E27FC236}">
-                <a16:creationId xmlns:a16="http://schemas.microsoft.com/office/drawing/2014/main" id="{C51409D2-7F9A-46E1-B032-BB2E053033DC}"/>
+                <a16:creationId xmlns:a16="http://schemas.microsoft.com/office/drawing/2014/main" id="{48B9104D-4BEC-4764-A0B2-60A2D78B623C}"/>
               </a:ext>
             </a:extLst>
           </p:cNvPr>
@@ -1811,7 +1811,7 @@
           <p:cNvPr id="3" name="cover-cyan">
             <a:extLst xmlns:a="http://schemas.openxmlformats.org/drawingml/2006/main">
               <a:ext uri="{FF2B5EF4-FFF2-40B4-BE49-F238E27FC236}">
-                <a16:creationId xmlns:a16="http://schemas.microsoft.com/office/drawing/2014/main" id="{D5624BCC-CFE9-4B2B-894A-A39888C8DEF4}"/>
+                <a16:creationId xmlns:a16="http://schemas.microsoft.com/office/drawing/2014/main" id="{02357F6C-DDBB-4103-BAD9-F678942EBAC5}"/>
               </a:ext>
             </a:extLst>
           </p:cNvPr>
@@ -1842,7 +1842,7 @@
           <p:cNvPr id="4" name="cover-kicker">
             <a:extLst xmlns:a="http://schemas.openxmlformats.org/drawingml/2006/main">
               <a:ext uri="{FF2B5EF4-FFF2-40B4-BE49-F238E27FC236}">
-                <a16:creationId xmlns:a16="http://schemas.microsoft.com/office/drawing/2014/main" id="{40E55C31-F518-4333-BFDB-F265A51250A5}"/>
+                <a16:creationId xmlns:a16="http://schemas.microsoft.com/office/drawing/2014/main" id="{CA8A9DBF-5F7C-49EE-8A4B-0A73A891E894}"/>
               </a:ext>
             </a:extLst>
           </p:cNvPr>
@@ -1887,7 +1887,7 @@
           <p:cNvPr id="5" name="cover-title">
             <a:extLst xmlns:a="http://schemas.openxmlformats.org/drawingml/2006/main">
               <a:ext uri="{FF2B5EF4-FFF2-40B4-BE49-F238E27FC236}">
-                <a16:creationId xmlns:a16="http://schemas.microsoft.com/office/drawing/2014/main" id="{3BC1D002-5DB4-412F-BCFA-76CC68557C67}"/>
+                <a16:creationId xmlns:a16="http://schemas.microsoft.com/office/drawing/2014/main" id="{CE627CB6-D122-41A0-8A91-CC0B37C1F366}"/>
               </a:ext>
             </a:extLst>
           </p:cNvPr>
@@ -1933,7 +1933,7 @@
           <p:cNvPr id="6" name="cover-subtitle">
             <a:extLst xmlns:a="http://schemas.openxmlformats.org/drawingml/2006/main">
               <a:ext uri="{FF2B5EF4-FFF2-40B4-BE49-F238E27FC236}">
-                <a16:creationId xmlns:a16="http://schemas.microsoft.com/office/drawing/2014/main" id="{7ED839B6-E68B-4113-AA01-224D251A952C}"/>
+                <a16:creationId xmlns:a16="http://schemas.microsoft.com/office/drawing/2014/main" id="{8D599453-F721-4C8E-B962-6F43114ABF15}"/>
               </a:ext>
             </a:extLst>
           </p:cNvPr>
@@ -1978,7 +1978,7 @@
           <p:cNvPr id="7" name="cover-command">
             <a:extLst xmlns:a="http://schemas.openxmlformats.org/drawingml/2006/main">
               <a:ext uri="{FF2B5EF4-FFF2-40B4-BE49-F238E27FC236}">
-                <a16:creationId xmlns:a16="http://schemas.microsoft.com/office/drawing/2014/main" id="{843E6167-7C74-4CCE-B8F0-AA6304B888BC}"/>
+                <a16:creationId xmlns:a16="http://schemas.microsoft.com/office/drawing/2014/main" id="{B4D8F38D-D7B1-4B7C-A06B-B072F51E3FF6}"/>
               </a:ext>
             </a:extLst>
           </p:cNvPr>
@@ -2013,7 +2013,7 @@
           <p:cNvPr id="8" name="cover-command-text">
             <a:extLst xmlns:a="http://schemas.openxmlformats.org/drawingml/2006/main">
               <a:ext uri="{FF2B5EF4-FFF2-40B4-BE49-F238E27FC236}">
-                <a16:creationId xmlns:a16="http://schemas.microsoft.com/office/drawing/2014/main" id="{01011B06-F1BE-4C06-B484-16EBF769D306}"/>
+                <a16:creationId xmlns:a16="http://schemas.microsoft.com/office/drawing/2014/main" id="{4B44EAD8-2986-43AF-B61E-B0A2E2DB50AD}"/>
               </a:ext>
             </a:extLst>
           </p:cNvPr>
@@ -2058,7 +2058,7 @@
           <p:cNvPr id="9" name="cover-caption">
             <a:extLst xmlns:a="http://schemas.openxmlformats.org/drawingml/2006/main">
               <a:ext uri="{FF2B5EF4-FFF2-40B4-BE49-F238E27FC236}">
-                <a16:creationId xmlns:a16="http://schemas.microsoft.com/office/drawing/2014/main" id="{610D8718-510A-467C-85D2-359029A70B11}"/>
+                <a16:creationId xmlns:a16="http://schemas.microsoft.com/office/drawing/2014/main" id="{36D239EC-006E-4F6C-BA23-F30C4CDA149F}"/>
               </a:ext>
             </a:extLst>
           </p:cNvPr>
@@ -2103,7 +2103,7 @@
           <p:cNvPr id="10" name="cover-footer">
             <a:extLst xmlns:a="http://schemas.openxmlformats.org/drawingml/2006/main">
               <a:ext uri="{FF2B5EF4-FFF2-40B4-BE49-F238E27FC236}">
-                <a16:creationId xmlns:a16="http://schemas.microsoft.com/office/drawing/2014/main" id="{5825094D-C002-4C92-9113-32F97D187184}"/>
+                <a16:creationId xmlns:a16="http://schemas.microsoft.com/office/drawing/2014/main" id="{0D1D789F-A33B-4993-B321-5991B8C375EF}"/>
               </a:ext>
             </a:extLst>
           </p:cNvPr>
@@ -2146,7 +2146,7 @@
     </p:spTree>
     <p:extLst>
       <p:ext uri="{BB962C8B-B14F-4D97-AF65-F5344CB8AC3E}">
-        <p14:creationId xmlns:p14="http://schemas.microsoft.com/office/powerpoint/2010/main" val="7017834"/>
+        <p14:creationId xmlns:p14="http://schemas.microsoft.com/office/powerpoint/2010/main" val="227699399"/>
       </p:ext>
     </p:extLst>
   </p:cSld>
@@ -2177,7 +2177,7 @@
           <p:cNvPr id="1" name="close-bg">
             <a:extLst xmlns:a="http://schemas.openxmlformats.org/drawingml/2006/main">
               <a:ext uri="{FF2B5EF4-FFF2-40B4-BE49-F238E27FC236}">
-                <a16:creationId xmlns:a16="http://schemas.microsoft.com/office/drawing/2014/main" id="{AA5ADDAD-D197-4498-B38B-31B54D95ED76}"/>
+                <a16:creationId xmlns:a16="http://schemas.microsoft.com/office/drawing/2014/main" id="{D9733515-092A-4933-81A9-203B41C40255}"/>
               </a:ext>
             </a:extLst>
           </p:cNvPr>
@@ -2252,7 +2252,7 @@
           <p:cNvPr id="4" name="close-arrow">
             <a:extLst xmlns:a="http://schemas.openxmlformats.org/drawingml/2006/main">
               <a:ext uri="{FF2B5EF4-FFF2-40B4-BE49-F238E27FC236}">
-                <a16:creationId xmlns:a16="http://schemas.microsoft.com/office/drawing/2014/main" id="{54E65A9D-26DC-4623-A46C-F3455C63C129}"/>
+                <a16:creationId xmlns:a16="http://schemas.microsoft.com/office/drawing/2014/main" id="{A897502A-748E-4A44-A065-4A73A480CD55}"/>
               </a:ext>
             </a:extLst>
           </p:cNvPr>
@@ -2283,7 +2283,7 @@
           <p:cNvPr id="5" name="close-check-ring">
             <a:extLst xmlns:a="http://schemas.openxmlformats.org/drawingml/2006/main">
               <a:ext uri="{FF2B5EF4-FFF2-40B4-BE49-F238E27FC236}">
-                <a16:creationId xmlns:a16="http://schemas.microsoft.com/office/drawing/2014/main" id="{2ADFF26E-A1D0-4E10-BF65-460830EEE1F7}"/>
+                <a16:creationId xmlns:a16="http://schemas.microsoft.com/office/drawing/2014/main" id="{519DB2A4-86D2-4350-86E3-48AC1A4449F5}"/>
               </a:ext>
             </a:extLst>
           </p:cNvPr>
@@ -2316,7 +2316,7 @@
           <p:cNvPr id="6" name="close-check">
             <a:extLst xmlns:a="http://schemas.openxmlformats.org/drawingml/2006/main">
               <a:ext uri="{FF2B5EF4-FFF2-40B4-BE49-F238E27FC236}">
-                <a16:creationId xmlns:a16="http://schemas.microsoft.com/office/drawing/2014/main" id="{2D3A7605-F9D7-4E67-88AA-7FAB91260468}"/>
+                <a16:creationId xmlns:a16="http://schemas.microsoft.com/office/drawing/2014/main" id="{08EA8315-FDF0-439E-9758-90E2937AB010}"/>
               </a:ext>
             </a:extLst>
           </p:cNvPr>
@@ -2361,7 +2361,7 @@
           <p:cNvPr id="7" name="close-kicker">
             <a:extLst xmlns:a="http://schemas.openxmlformats.org/drawingml/2006/main">
               <a:ext uri="{FF2B5EF4-FFF2-40B4-BE49-F238E27FC236}">
-                <a16:creationId xmlns:a16="http://schemas.microsoft.com/office/drawing/2014/main" id="{B45269C4-C9F5-48BA-8759-9290F6DD33E0}"/>
+                <a16:creationId xmlns:a16="http://schemas.microsoft.com/office/drawing/2014/main" id="{C9654D29-BAC5-42DB-89EF-6E5622576FC3}"/>
               </a:ext>
             </a:extLst>
           </p:cNvPr>
@@ -2406,7 +2406,7 @@
           <p:cNvPr id="8" name="close-title">
             <a:extLst xmlns:a="http://schemas.openxmlformats.org/drawingml/2006/main">
               <a:ext uri="{FF2B5EF4-FFF2-40B4-BE49-F238E27FC236}">
-                <a16:creationId xmlns:a16="http://schemas.microsoft.com/office/drawing/2014/main" id="{52EB186D-40BB-4EE0-9B61-0FA891A0E3DA}"/>
+                <a16:creationId xmlns:a16="http://schemas.microsoft.com/office/drawing/2014/main" id="{6D0C7E3C-2367-4788-832B-CD0971C93E97}"/>
               </a:ext>
             </a:extLst>
           </p:cNvPr>
@@ -2452,7 +2452,7 @@
           <p:cNvPr id="9" name="close-subtitle">
             <a:extLst xmlns:a="http://schemas.openxmlformats.org/drawingml/2006/main">
               <a:ext uri="{FF2B5EF4-FFF2-40B4-BE49-F238E27FC236}">
-                <a16:creationId xmlns:a16="http://schemas.microsoft.com/office/drawing/2014/main" id="{C3B4E5A5-1D40-4B4C-A141-F2B3F4118F2C}"/>
+                <a16:creationId xmlns:a16="http://schemas.microsoft.com/office/drawing/2014/main" id="{E224CC97-950B-45E1-8624-301124D76BF0}"/>
               </a:ext>
             </a:extLst>
           </p:cNvPr>
@@ -2497,7 +2497,7 @@
           <p:cNvPr id="10" name="close-num-0">
             <a:extLst xmlns:a="http://schemas.openxmlformats.org/drawingml/2006/main">
               <a:ext uri="{FF2B5EF4-FFF2-40B4-BE49-F238E27FC236}">
-                <a16:creationId xmlns:a16="http://schemas.microsoft.com/office/drawing/2014/main" id="{AF346830-9D8E-481E-82AA-E048543F3197}"/>
+                <a16:creationId xmlns:a16="http://schemas.microsoft.com/office/drawing/2014/main" id="{80C4883C-DE5B-4175-AB99-39783F5FC40F}"/>
               </a:ext>
             </a:extLst>
           </p:cNvPr>
@@ -2542,7 +2542,7 @@
           <p:cNvPr id="11" name="close-body-0">
             <a:extLst xmlns:a="http://schemas.openxmlformats.org/drawingml/2006/main">
               <a:ext uri="{FF2B5EF4-FFF2-40B4-BE49-F238E27FC236}">
-                <a16:creationId xmlns:a16="http://schemas.microsoft.com/office/drawing/2014/main" id="{2F8C2C04-3BAC-4298-BB0B-913A8B09F227}"/>
+                <a16:creationId xmlns:a16="http://schemas.microsoft.com/office/drawing/2014/main" id="{A3DF6494-6C7B-4645-8BE6-03D25DA5DC31}"/>
               </a:ext>
             </a:extLst>
           </p:cNvPr>
@@ -2587,7 +2587,7 @@
           <p:cNvPr id="12" name="close-num-1">
             <a:extLst xmlns:a="http://schemas.openxmlformats.org/drawingml/2006/main">
               <a:ext uri="{FF2B5EF4-FFF2-40B4-BE49-F238E27FC236}">
-                <a16:creationId xmlns:a16="http://schemas.microsoft.com/office/drawing/2014/main" id="{04E8D73A-4784-4C0A-9D82-8BDB22E256F0}"/>
+                <a16:creationId xmlns:a16="http://schemas.microsoft.com/office/drawing/2014/main" id="{DD7CCFF4-FDBB-46EE-882E-1F8E9F0A357E}"/>
               </a:ext>
             </a:extLst>
           </p:cNvPr>
@@ -2632,7 +2632,7 @@
           <p:cNvPr id="13" name="close-body-1">
             <a:extLst xmlns:a="http://schemas.openxmlformats.org/drawingml/2006/main">
               <a:ext uri="{FF2B5EF4-FFF2-40B4-BE49-F238E27FC236}">
-                <a16:creationId xmlns:a16="http://schemas.microsoft.com/office/drawing/2014/main" id="{531E3A18-AFEE-4612-9E3D-D0F7BD6CDA08}"/>
+                <a16:creationId xmlns:a16="http://schemas.microsoft.com/office/drawing/2014/main" id="{E135F0D4-1773-4E6E-982F-6D2F688D81D1}"/>
               </a:ext>
             </a:extLst>
           </p:cNvPr>
@@ -2677,7 +2677,7 @@
           <p:cNvPr id="14" name="close-num-2">
             <a:extLst xmlns:a="http://schemas.openxmlformats.org/drawingml/2006/main">
               <a:ext uri="{FF2B5EF4-FFF2-40B4-BE49-F238E27FC236}">
-                <a16:creationId xmlns:a16="http://schemas.microsoft.com/office/drawing/2014/main" id="{5CC891AE-A9C1-41C9-8E35-15A7B1AF79C3}"/>
+                <a16:creationId xmlns:a16="http://schemas.microsoft.com/office/drawing/2014/main" id="{BBA98648-F391-4F26-837A-1C3619140F9D}"/>
               </a:ext>
             </a:extLst>
           </p:cNvPr>
@@ -2722,7 +2722,7 @@
           <p:cNvPr id="15" name="close-body-2">
             <a:extLst xmlns:a="http://schemas.openxmlformats.org/drawingml/2006/main">
               <a:ext uri="{FF2B5EF4-FFF2-40B4-BE49-F238E27FC236}">
-                <a16:creationId xmlns:a16="http://schemas.microsoft.com/office/drawing/2014/main" id="{5B696F0F-E341-4932-A344-E2A8EEA3F409}"/>
+                <a16:creationId xmlns:a16="http://schemas.microsoft.com/office/drawing/2014/main" id="{DB709DC9-18AB-4685-875C-15733CD50D9B}"/>
               </a:ext>
             </a:extLst>
           </p:cNvPr>
@@ -2767,7 +2767,7 @@
           <p:cNvPr id="16" name="close-next">
             <a:extLst xmlns:a="http://schemas.openxmlformats.org/drawingml/2006/main">
               <a:ext uri="{FF2B5EF4-FFF2-40B4-BE49-F238E27FC236}">
-                <a16:creationId xmlns:a16="http://schemas.microsoft.com/office/drawing/2014/main" id="{FAEB7A47-271C-46DA-B461-2C289F4CB773}"/>
+                <a16:creationId xmlns:a16="http://schemas.microsoft.com/office/drawing/2014/main" id="{D500070A-0B52-4A40-BAE4-2AFA65386FFF}"/>
               </a:ext>
             </a:extLst>
           </p:cNvPr>
@@ -2802,7 +2802,7 @@
           <p:cNvPr id="17" name="close-next-kicker">
             <a:extLst xmlns:a="http://schemas.openxmlformats.org/drawingml/2006/main">
               <a:ext uri="{FF2B5EF4-FFF2-40B4-BE49-F238E27FC236}">
-                <a16:creationId xmlns:a16="http://schemas.microsoft.com/office/drawing/2014/main" id="{D3296212-1854-4434-BCDD-8C3A0817266A}"/>
+                <a16:creationId xmlns:a16="http://schemas.microsoft.com/office/drawing/2014/main" id="{09B6911B-CDE6-47E1-8ED5-86B552734F5A}"/>
               </a:ext>
             </a:extLst>
           </p:cNvPr>
@@ -2847,7 +2847,7 @@
           <p:cNvPr id="18" name="close-next-body">
             <a:extLst xmlns:a="http://schemas.openxmlformats.org/drawingml/2006/main">
               <a:ext uri="{FF2B5EF4-FFF2-40B4-BE49-F238E27FC236}">
-                <a16:creationId xmlns:a16="http://schemas.microsoft.com/office/drawing/2014/main" id="{B56B292A-3907-4578-8C1B-BCD539F788A1}"/>
+                <a16:creationId xmlns:a16="http://schemas.microsoft.com/office/drawing/2014/main" id="{FED20119-7710-4D2D-8F52-3A554E66EF7E}"/>
               </a:ext>
             </a:extLst>
           </p:cNvPr>
@@ -2892,7 +2892,7 @@
           <p:cNvPr id="19" name="close-fun">
             <a:extLst xmlns:a="http://schemas.openxmlformats.org/drawingml/2006/main">
               <a:ext uri="{FF2B5EF4-FFF2-40B4-BE49-F238E27FC236}">
-                <a16:creationId xmlns:a16="http://schemas.microsoft.com/office/drawing/2014/main" id="{236B32BD-CC74-42C5-9F0D-7ED8962F141A}"/>
+                <a16:creationId xmlns:a16="http://schemas.microsoft.com/office/drawing/2014/main" id="{9CA15C33-B5C7-4745-B9CF-8007EE4E564E}"/>
               </a:ext>
             </a:extLst>
           </p:cNvPr>
@@ -2935,7 +2935,7 @@
     </p:spTree>
     <p:extLst>
       <p:ext uri="{BB962C8B-B14F-4D97-AF65-F5344CB8AC3E}">
-        <p14:creationId xmlns:p14="http://schemas.microsoft.com/office/powerpoint/2010/main" val="1507179353"/>
+        <p14:creationId xmlns:p14="http://schemas.microsoft.com/office/powerpoint/2010/main" val="422683568"/>
       </p:ext>
     </p:extLst>
   </p:cSld>
@@ -2966,7 +2966,7 @@
           <p:cNvPr id="1" name="kicker-2">
             <a:extLst xmlns:a="http://schemas.openxmlformats.org/drawingml/2006/main">
               <a:ext uri="{FF2B5EF4-FFF2-40B4-BE49-F238E27FC236}">
-                <a16:creationId xmlns:a16="http://schemas.microsoft.com/office/drawing/2014/main" id="{5C42869D-58C9-4E35-98A7-AAC34463C234}"/>
+                <a16:creationId xmlns:a16="http://schemas.microsoft.com/office/drawing/2014/main" id="{F13E861A-CE48-4A45-9D7C-BDAB3499F1AA}"/>
               </a:ext>
             </a:extLst>
           </p:cNvPr>
@@ -3011,7 +3011,7 @@
           <p:cNvPr id="2" name="title-2">
             <a:extLst xmlns:a="http://schemas.openxmlformats.org/drawingml/2006/main">
               <a:ext uri="{FF2B5EF4-FFF2-40B4-BE49-F238E27FC236}">
-                <a16:creationId xmlns:a16="http://schemas.microsoft.com/office/drawing/2014/main" id="{89BBB2FA-D1F8-4E00-9771-7512B79C3363}"/>
+                <a16:creationId xmlns:a16="http://schemas.microsoft.com/office/drawing/2014/main" id="{F1481226-E28A-4928-8D44-83A9B92A1C66}"/>
               </a:ext>
             </a:extLst>
           </p:cNvPr>
@@ -3078,7 +3078,7 @@
           <p:cNvPr id="4" name="number-2">
             <a:extLst xmlns:a="http://schemas.openxmlformats.org/drawingml/2006/main">
               <a:ext uri="{FF2B5EF4-FFF2-40B4-BE49-F238E27FC236}">
-                <a16:creationId xmlns:a16="http://schemas.microsoft.com/office/drawing/2014/main" id="{BF49BC89-713E-4909-A492-2935637B23E3}"/>
+                <a16:creationId xmlns:a16="http://schemas.microsoft.com/office/drawing/2014/main" id="{635962CD-11F2-457F-B95A-795290B82FFF}"/>
               </a:ext>
             </a:extLst>
           </p:cNvPr>
@@ -3145,7 +3145,7 @@
           <p:cNvPr id="6" name="solo-dot-0">
             <a:extLst xmlns:a="http://schemas.openxmlformats.org/drawingml/2006/main">
               <a:ext uri="{FF2B5EF4-FFF2-40B4-BE49-F238E27FC236}">
-                <a16:creationId xmlns:a16="http://schemas.microsoft.com/office/drawing/2014/main" id="{FC0C1EF2-97EC-4EF4-A507-56368286BC87}"/>
+                <a16:creationId xmlns:a16="http://schemas.microsoft.com/office/drawing/2014/main" id="{70AEB3F5-19B8-4328-A4C4-779273291B7F}"/>
               </a:ext>
             </a:extLst>
           </p:cNvPr>
@@ -3198,7 +3198,7 @@
           <p:cNvPr id="8" name="solo-dot-1">
             <a:extLst xmlns:a="http://schemas.openxmlformats.org/drawingml/2006/main">
               <a:ext uri="{FF2B5EF4-FFF2-40B4-BE49-F238E27FC236}">
-                <a16:creationId xmlns:a16="http://schemas.microsoft.com/office/drawing/2014/main" id="{2C9533B8-C3F1-44DA-B47C-D8DE1DE446A8}"/>
+                <a16:creationId xmlns:a16="http://schemas.microsoft.com/office/drawing/2014/main" id="{F6B0C44F-9A60-4E94-86F5-74D680A0C77E}"/>
               </a:ext>
             </a:extLst>
           </p:cNvPr>
@@ -3251,7 +3251,7 @@
           <p:cNvPr id="10" name="solo-dot-2">
             <a:extLst xmlns:a="http://schemas.openxmlformats.org/drawingml/2006/main">
               <a:ext uri="{FF2B5EF4-FFF2-40B4-BE49-F238E27FC236}">
-                <a16:creationId xmlns:a16="http://schemas.microsoft.com/office/drawing/2014/main" id="{57588140-44E3-4ADC-803D-7799A0BD91A3}"/>
+                <a16:creationId xmlns:a16="http://schemas.microsoft.com/office/drawing/2014/main" id="{745C3F76-711E-4206-A6CA-DEF96BCD7089}"/>
               </a:ext>
             </a:extLst>
           </p:cNvPr>
@@ -3304,7 +3304,7 @@
           <p:cNvPr id="12" name="solo-dot-3">
             <a:extLst xmlns:a="http://schemas.openxmlformats.org/drawingml/2006/main">
               <a:ext uri="{FF2B5EF4-FFF2-40B4-BE49-F238E27FC236}">
-                <a16:creationId xmlns:a16="http://schemas.microsoft.com/office/drawing/2014/main" id="{F07C621C-F269-4069-9971-EB8D259EFDDC}"/>
+                <a16:creationId xmlns:a16="http://schemas.microsoft.com/office/drawing/2014/main" id="{94178FCD-84C2-484A-B577-7627D10AE0B2}"/>
               </a:ext>
             </a:extLst>
           </p:cNvPr>
@@ -3357,7 +3357,7 @@
           <p:cNvPr id="14" name="solo-dot-4">
             <a:extLst xmlns:a="http://schemas.openxmlformats.org/drawingml/2006/main">
               <a:ext uri="{FF2B5EF4-FFF2-40B4-BE49-F238E27FC236}">
-                <a16:creationId xmlns:a16="http://schemas.microsoft.com/office/drawing/2014/main" id="{C430AD1C-881C-4C8A-9D51-6800393E24DD}"/>
+                <a16:creationId xmlns:a16="http://schemas.microsoft.com/office/drawing/2014/main" id="{9730B528-F193-4D04-A21B-2538CE9334D0}"/>
               </a:ext>
             </a:extLst>
           </p:cNvPr>
@@ -3410,7 +3410,7 @@
           <p:cNvPr id="16" name="solo-dot-5">
             <a:extLst xmlns:a="http://schemas.openxmlformats.org/drawingml/2006/main">
               <a:ext uri="{FF2B5EF4-FFF2-40B4-BE49-F238E27FC236}">
-                <a16:creationId xmlns:a16="http://schemas.microsoft.com/office/drawing/2014/main" id="{09DDF6BF-3635-4072-9B56-4BA6ADE36429}"/>
+                <a16:creationId xmlns:a16="http://schemas.microsoft.com/office/drawing/2014/main" id="{6C5307F1-52C6-4F0F-9094-E6891F8EF4C3}"/>
               </a:ext>
             </a:extLst>
           </p:cNvPr>
@@ -3463,7 +3463,7 @@
           <p:cNvPr id="18" name="solo-dot-6">
             <a:extLst xmlns:a="http://schemas.openxmlformats.org/drawingml/2006/main">
               <a:ext uri="{FF2B5EF4-FFF2-40B4-BE49-F238E27FC236}">
-                <a16:creationId xmlns:a16="http://schemas.microsoft.com/office/drawing/2014/main" id="{2C2C25D0-96AA-48A0-BD87-B9DF05C3C760}"/>
+                <a16:creationId xmlns:a16="http://schemas.microsoft.com/office/drawing/2014/main" id="{76389E90-A8FE-43F5-AB5B-1BEE74989615}"/>
               </a:ext>
             </a:extLst>
           </p:cNvPr>
@@ -3516,7 +3516,7 @@
           <p:cNvPr id="20" name="orchestra-arrow">
             <a:extLst xmlns:a="http://schemas.openxmlformats.org/drawingml/2006/main">
               <a:ext uri="{FF2B5EF4-FFF2-40B4-BE49-F238E27FC236}">
-                <a16:creationId xmlns:a16="http://schemas.microsoft.com/office/drawing/2014/main" id="{D791E011-A7DD-49A8-B848-7EBEAF583D8F}"/>
+                <a16:creationId xmlns:a16="http://schemas.microsoft.com/office/drawing/2014/main" id="{D9B13D8A-1E3F-4BE0-863D-B510E8365969}"/>
               </a:ext>
             </a:extLst>
           </p:cNvPr>
@@ -3547,7 +3547,7 @@
           <p:cNvPr id="21" name="orchestra-check-ring">
             <a:extLst xmlns:a="http://schemas.openxmlformats.org/drawingml/2006/main">
               <a:ext uri="{FF2B5EF4-FFF2-40B4-BE49-F238E27FC236}">
-                <a16:creationId xmlns:a16="http://schemas.microsoft.com/office/drawing/2014/main" id="{D7BBCC37-8335-4616-92D1-5A4AAADBA23B}"/>
+                <a16:creationId xmlns:a16="http://schemas.microsoft.com/office/drawing/2014/main" id="{ABD1E7DA-E2AA-40E0-8EE5-A7DAC4A6428C}"/>
               </a:ext>
             </a:extLst>
           </p:cNvPr>
@@ -3580,7 +3580,7 @@
           <p:cNvPr id="22" name="orchestra-check">
             <a:extLst xmlns:a="http://schemas.openxmlformats.org/drawingml/2006/main">
               <a:ext uri="{FF2B5EF4-FFF2-40B4-BE49-F238E27FC236}">
-                <a16:creationId xmlns:a16="http://schemas.microsoft.com/office/drawing/2014/main" id="{BC231EC2-A022-4C07-8BFA-067BB7BDD5E3}"/>
+                <a16:creationId xmlns:a16="http://schemas.microsoft.com/office/drawing/2014/main" id="{D0179F97-6921-4216-BA40-0168D7F459A3}"/>
               </a:ext>
             </a:extLst>
           </p:cNvPr>
@@ -3625,7 +3625,7 @@
           <p:cNvPr id="23" name="orchestra-baton">
             <a:extLst xmlns:a="http://schemas.openxmlformats.org/drawingml/2006/main">
               <a:ext uri="{FF2B5EF4-FFF2-40B4-BE49-F238E27FC236}">
-                <a16:creationId xmlns:a16="http://schemas.microsoft.com/office/drawing/2014/main" id="{2513138B-BFC1-4830-A4A5-246F0CDCF5A7}"/>
+                <a16:creationId xmlns:a16="http://schemas.microsoft.com/office/drawing/2014/main" id="{17DFA952-4003-4E91-9FFC-A13EA7C1AC6E}"/>
               </a:ext>
             </a:extLst>
           </p:cNvPr>
@@ -3656,7 +3656,7 @@
           <p:cNvPr id="24" name="orchestra-baton-tip">
             <a:extLst xmlns:a="http://schemas.openxmlformats.org/drawingml/2006/main">
               <a:ext uri="{FF2B5EF4-FFF2-40B4-BE49-F238E27FC236}">
-                <a16:creationId xmlns:a16="http://schemas.microsoft.com/office/drawing/2014/main" id="{4105C363-D66B-449C-8E48-42ED9A6BD753}"/>
+                <a16:creationId xmlns:a16="http://schemas.microsoft.com/office/drawing/2014/main" id="{1115659C-8374-48A3-AC11-15CBAE6BCB49}"/>
               </a:ext>
             </a:extLst>
           </p:cNvPr>
@@ -3687,7 +3687,7 @@
           <p:cNvPr id="25" name="solo-label-0">
             <a:extLst xmlns:a="http://schemas.openxmlformats.org/drawingml/2006/main">
               <a:ext uri="{FF2B5EF4-FFF2-40B4-BE49-F238E27FC236}">
-                <a16:creationId xmlns:a16="http://schemas.microsoft.com/office/drawing/2014/main" id="{118A08B2-56A5-4B4E-9565-E79AD2198BC3}"/>
+                <a16:creationId xmlns:a16="http://schemas.microsoft.com/office/drawing/2014/main" id="{94E6D9FC-ADB1-4E33-8680-792F9AB0883D}"/>
               </a:ext>
             </a:extLst>
           </p:cNvPr>
@@ -3732,7 +3732,7 @@
           <p:cNvPr id="26" name="solo-note-0">
             <a:extLst xmlns:a="http://schemas.openxmlformats.org/drawingml/2006/main">
               <a:ext uri="{FF2B5EF4-FFF2-40B4-BE49-F238E27FC236}">
-                <a16:creationId xmlns:a16="http://schemas.microsoft.com/office/drawing/2014/main" id="{D1F7ABED-56A8-40C6-B25A-7B260B21189A}"/>
+                <a16:creationId xmlns:a16="http://schemas.microsoft.com/office/drawing/2014/main" id="{3CE955DE-7DCF-4B4F-899F-09F2129BA4AE}"/>
               </a:ext>
             </a:extLst>
           </p:cNvPr>
@@ -3777,7 +3777,7 @@
           <p:cNvPr id="27" name="solo-label-1">
             <a:extLst xmlns:a="http://schemas.openxmlformats.org/drawingml/2006/main">
               <a:ext uri="{FF2B5EF4-FFF2-40B4-BE49-F238E27FC236}">
-                <a16:creationId xmlns:a16="http://schemas.microsoft.com/office/drawing/2014/main" id="{3AB0D319-0D84-40C0-9BED-483F9C321F1F}"/>
+                <a16:creationId xmlns:a16="http://schemas.microsoft.com/office/drawing/2014/main" id="{0DEAB74E-CEAB-4C36-A559-00A7FD626C58}"/>
               </a:ext>
             </a:extLst>
           </p:cNvPr>
@@ -3822,7 +3822,7 @@
           <p:cNvPr id="28" name="solo-note-1">
             <a:extLst xmlns:a="http://schemas.openxmlformats.org/drawingml/2006/main">
               <a:ext uri="{FF2B5EF4-FFF2-40B4-BE49-F238E27FC236}">
-                <a16:creationId xmlns:a16="http://schemas.microsoft.com/office/drawing/2014/main" id="{91F2AA3C-A71E-4484-857D-B88B9509B2AE}"/>
+                <a16:creationId xmlns:a16="http://schemas.microsoft.com/office/drawing/2014/main" id="{6B82810F-AAC9-408C-9467-0EE50B3240BF}"/>
               </a:ext>
             </a:extLst>
           </p:cNvPr>
@@ -3867,7 +3867,7 @@
           <p:cNvPr id="29" name="solo-label-2">
             <a:extLst xmlns:a="http://schemas.openxmlformats.org/drawingml/2006/main">
               <a:ext uri="{FF2B5EF4-FFF2-40B4-BE49-F238E27FC236}">
-                <a16:creationId xmlns:a16="http://schemas.microsoft.com/office/drawing/2014/main" id="{5C9E05A4-F507-45C5-BAF8-E6EAFF45E931}"/>
+                <a16:creationId xmlns:a16="http://schemas.microsoft.com/office/drawing/2014/main" id="{4D8486E6-C548-404C-B5BD-7FDBCBE4170B}"/>
               </a:ext>
             </a:extLst>
           </p:cNvPr>
@@ -3912,7 +3912,7 @@
           <p:cNvPr id="30" name="solo-note-2">
             <a:extLst xmlns:a="http://schemas.openxmlformats.org/drawingml/2006/main">
               <a:ext uri="{FF2B5EF4-FFF2-40B4-BE49-F238E27FC236}">
-                <a16:creationId xmlns:a16="http://schemas.microsoft.com/office/drawing/2014/main" id="{55281D87-44F0-4FBA-878A-48D5B47CAFB8}"/>
+                <a16:creationId xmlns:a16="http://schemas.microsoft.com/office/drawing/2014/main" id="{679EA49A-04E6-4098-B265-3C3F81B6BA19}"/>
               </a:ext>
             </a:extLst>
           </p:cNvPr>
@@ -3957,7 +3957,7 @@
           <p:cNvPr id="31" name="solo-label-3">
             <a:extLst xmlns:a="http://schemas.openxmlformats.org/drawingml/2006/main">
               <a:ext uri="{FF2B5EF4-FFF2-40B4-BE49-F238E27FC236}">
-                <a16:creationId xmlns:a16="http://schemas.microsoft.com/office/drawing/2014/main" id="{3C09475B-C8C4-47CA-9E10-5EB407BC019C}"/>
+                <a16:creationId xmlns:a16="http://schemas.microsoft.com/office/drawing/2014/main" id="{E0A1E942-0180-4F88-BF05-58FD2E554606}"/>
               </a:ext>
             </a:extLst>
           </p:cNvPr>
@@ -4002,7 +4002,7 @@
           <p:cNvPr id="32" name="solo-note-3">
             <a:extLst xmlns:a="http://schemas.openxmlformats.org/drawingml/2006/main">
               <a:ext uri="{FF2B5EF4-FFF2-40B4-BE49-F238E27FC236}">
-                <a16:creationId xmlns:a16="http://schemas.microsoft.com/office/drawing/2014/main" id="{99F5F917-C878-4CC8-A12F-D227FD0F6FB5}"/>
+                <a16:creationId xmlns:a16="http://schemas.microsoft.com/office/drawing/2014/main" id="{4A46CC3C-6C80-448F-94AB-4267AF021FFB}"/>
               </a:ext>
             </a:extLst>
           </p:cNvPr>
@@ -4047,7 +4047,7 @@
           <p:cNvPr id="33" name="solo-label-4">
             <a:extLst xmlns:a="http://schemas.openxmlformats.org/drawingml/2006/main">
               <a:ext uri="{FF2B5EF4-FFF2-40B4-BE49-F238E27FC236}">
-                <a16:creationId xmlns:a16="http://schemas.microsoft.com/office/drawing/2014/main" id="{31147CE2-ED70-4B1D-BA44-1858953BBA79}"/>
+                <a16:creationId xmlns:a16="http://schemas.microsoft.com/office/drawing/2014/main" id="{F80D80FE-8537-43B8-A38D-5B516D3B7EA8}"/>
               </a:ext>
             </a:extLst>
           </p:cNvPr>
@@ -4092,7 +4092,7 @@
           <p:cNvPr id="34" name="solo-note-4">
             <a:extLst xmlns:a="http://schemas.openxmlformats.org/drawingml/2006/main">
               <a:ext uri="{FF2B5EF4-FFF2-40B4-BE49-F238E27FC236}">
-                <a16:creationId xmlns:a16="http://schemas.microsoft.com/office/drawing/2014/main" id="{96F07D35-6454-4BE0-B7C8-C2AE12EFF767}"/>
+                <a16:creationId xmlns:a16="http://schemas.microsoft.com/office/drawing/2014/main" id="{38F25B6B-46EE-401B-9239-35EDFA362784}"/>
               </a:ext>
             </a:extLst>
           </p:cNvPr>
@@ -4137,7 +4137,7 @@
           <p:cNvPr id="35" name="solo-label-5">
             <a:extLst xmlns:a="http://schemas.openxmlformats.org/drawingml/2006/main">
               <a:ext uri="{FF2B5EF4-FFF2-40B4-BE49-F238E27FC236}">
-                <a16:creationId xmlns:a16="http://schemas.microsoft.com/office/drawing/2014/main" id="{BF55B5D9-F296-498B-B8AB-B622DDE8D72E}"/>
+                <a16:creationId xmlns:a16="http://schemas.microsoft.com/office/drawing/2014/main" id="{DE7DA7C1-DEE4-4AEA-9B70-29736D129033}"/>
               </a:ext>
             </a:extLst>
           </p:cNvPr>
@@ -4182,7 +4182,7 @@
           <p:cNvPr id="36" name="solo-note-5">
             <a:extLst xmlns:a="http://schemas.openxmlformats.org/drawingml/2006/main">
               <a:ext uri="{FF2B5EF4-FFF2-40B4-BE49-F238E27FC236}">
-                <a16:creationId xmlns:a16="http://schemas.microsoft.com/office/drawing/2014/main" id="{AE20D876-4E85-4F2F-97AF-A8524D37C914}"/>
+                <a16:creationId xmlns:a16="http://schemas.microsoft.com/office/drawing/2014/main" id="{45B2C683-1DC0-4036-A22E-4A0562E6D162}"/>
               </a:ext>
             </a:extLst>
           </p:cNvPr>
@@ -4227,7 +4227,7 @@
           <p:cNvPr id="37" name="solo-label-6">
             <a:extLst xmlns:a="http://schemas.openxmlformats.org/drawingml/2006/main">
               <a:ext uri="{FF2B5EF4-FFF2-40B4-BE49-F238E27FC236}">
-                <a16:creationId xmlns:a16="http://schemas.microsoft.com/office/drawing/2014/main" id="{F51C2505-363D-43B9-8613-73A7AD1080F9}"/>
+                <a16:creationId xmlns:a16="http://schemas.microsoft.com/office/drawing/2014/main" id="{7C64470F-0D7F-43E2-97B4-62EB2869D553}"/>
               </a:ext>
             </a:extLst>
           </p:cNvPr>
@@ -4272,7 +4272,7 @@
           <p:cNvPr id="38" name="solo-note-6">
             <a:extLst xmlns:a="http://schemas.openxmlformats.org/drawingml/2006/main">
               <a:ext uri="{FF2B5EF4-FFF2-40B4-BE49-F238E27FC236}">
-                <a16:creationId xmlns:a16="http://schemas.microsoft.com/office/drawing/2014/main" id="{9909E5EA-6801-4F22-946D-FE87AC0F3D59}"/>
+                <a16:creationId xmlns:a16="http://schemas.microsoft.com/office/drawing/2014/main" id="{09E41C78-F3ED-4051-B199-EDA031820ACF}"/>
               </a:ext>
             </a:extLst>
           </p:cNvPr>
@@ -4317,7 +4317,7 @@
           <p:cNvPr id="39" name="orchestra-caption">
             <a:extLst xmlns:a="http://schemas.openxmlformats.org/drawingml/2006/main">
               <a:ext uri="{FF2B5EF4-FFF2-40B4-BE49-F238E27FC236}">
-                <a16:creationId xmlns:a16="http://schemas.microsoft.com/office/drawing/2014/main" id="{2E77C6CB-4159-4300-B4C4-F8FE2C1533D0}"/>
+                <a16:creationId xmlns:a16="http://schemas.microsoft.com/office/drawing/2014/main" id="{5C9CA11B-CB6B-4CE2-95A4-FE5BED3D9631}"/>
               </a:ext>
             </a:extLst>
           </p:cNvPr>
@@ -4363,7 +4363,7 @@
           <p:cNvPr id="40" name="orchestra-punchline">
             <a:extLst xmlns:a="http://schemas.openxmlformats.org/drawingml/2006/main">
               <a:ext uri="{FF2B5EF4-FFF2-40B4-BE49-F238E27FC236}">
-                <a16:creationId xmlns:a16="http://schemas.microsoft.com/office/drawing/2014/main" id="{7121D0DD-A83C-4929-B4C5-ABC20A03FC3B}"/>
+                <a16:creationId xmlns:a16="http://schemas.microsoft.com/office/drawing/2014/main" id="{F74B36AC-1666-4EFA-B210-0A72211CEA70}"/>
               </a:ext>
             </a:extLst>
           </p:cNvPr>
@@ -4394,7 +4394,7 @@
           <p:cNvPr id="41" name="orchestra-punchline-text">
             <a:extLst xmlns:a="http://schemas.openxmlformats.org/drawingml/2006/main">
               <a:ext uri="{FF2B5EF4-FFF2-40B4-BE49-F238E27FC236}">
-                <a16:creationId xmlns:a16="http://schemas.microsoft.com/office/drawing/2014/main" id="{3BE58A16-4559-4C89-87D8-3E4C811EE687}"/>
+                <a16:creationId xmlns:a16="http://schemas.microsoft.com/office/drawing/2014/main" id="{F0CB5465-7BD7-4F5A-96C6-C306E321D124}"/>
               </a:ext>
             </a:extLst>
           </p:cNvPr>
@@ -4437,7 +4437,7 @@
     </p:spTree>
     <p:extLst>
       <p:ext uri="{BB962C8B-B14F-4D97-AF65-F5344CB8AC3E}">
-        <p14:creationId xmlns:p14="http://schemas.microsoft.com/office/powerpoint/2010/main" val="245974069"/>
+        <p14:creationId xmlns:p14="http://schemas.microsoft.com/office/powerpoint/2010/main" val="214642696"/>
       </p:ext>
     </p:extLst>
   </p:cSld>
@@ -4468,7 +4468,7 @@
           <p:cNvPr id="1" name="kicker-3">
             <a:extLst xmlns:a="http://schemas.openxmlformats.org/drawingml/2006/main">
               <a:ext uri="{FF2B5EF4-FFF2-40B4-BE49-F238E27FC236}">
-                <a16:creationId xmlns:a16="http://schemas.microsoft.com/office/drawing/2014/main" id="{D3FDDD57-DB2E-41DA-8752-366B4EF93A13}"/>
+                <a16:creationId xmlns:a16="http://schemas.microsoft.com/office/drawing/2014/main" id="{9704145A-946D-49ED-8D66-D1BB7752666A}"/>
               </a:ext>
             </a:extLst>
           </p:cNvPr>
@@ -4513,7 +4513,7 @@
           <p:cNvPr id="2" name="title-3">
             <a:extLst xmlns:a="http://schemas.openxmlformats.org/drawingml/2006/main">
               <a:ext uri="{FF2B5EF4-FFF2-40B4-BE49-F238E27FC236}">
-                <a16:creationId xmlns:a16="http://schemas.microsoft.com/office/drawing/2014/main" id="{3655271D-FB24-406D-8413-6B72BB9EAB84}"/>
+                <a16:creationId xmlns:a16="http://schemas.microsoft.com/office/drawing/2014/main" id="{ACF9545D-87D2-4433-819C-0B90FEF853DF}"/>
               </a:ext>
             </a:extLst>
           </p:cNvPr>
@@ -4580,7 +4580,7 @@
           <p:cNvPr id="4" name="number-3">
             <a:extLst xmlns:a="http://schemas.openxmlformats.org/drawingml/2006/main">
               <a:ext uri="{FF2B5EF4-FFF2-40B4-BE49-F238E27FC236}">
-                <a16:creationId xmlns:a16="http://schemas.microsoft.com/office/drawing/2014/main" id="{DE6557B3-4786-47B8-8C76-4DDB498E4119}"/>
+                <a16:creationId xmlns:a16="http://schemas.microsoft.com/office/drawing/2014/main" id="{E37B7AE2-AABD-4966-AD3B-C8114D2760C7}"/>
               </a:ext>
             </a:extLst>
           </p:cNvPr>
@@ -4647,7 +4647,7 @@
           <p:cNvPr id="6" name="station-group-0">
             <a:extLst xmlns:a="http://schemas.openxmlformats.org/drawingml/2006/main">
               <a:ext uri="{FF2B5EF4-FFF2-40B4-BE49-F238E27FC236}">
-                <a16:creationId xmlns:a16="http://schemas.microsoft.com/office/drawing/2014/main" id="{277B4ED2-0600-4286-9AA5-9F664201FA36}"/>
+                <a16:creationId xmlns:a16="http://schemas.microsoft.com/office/drawing/2014/main" id="{DEE0A94A-1B72-4CC1-915F-17204C92B17D}"/>
               </a:ext>
             </a:extLst>
           </p:cNvPr>
@@ -4692,7 +4692,7 @@
           <p:cNvPr id="7" name="station-dot-0-0">
             <a:extLst xmlns:a="http://schemas.openxmlformats.org/drawingml/2006/main">
               <a:ext uri="{FF2B5EF4-FFF2-40B4-BE49-F238E27FC236}">
-                <a16:creationId xmlns:a16="http://schemas.microsoft.com/office/drawing/2014/main" id="{06FF9650-B08E-4DBF-BCAE-A14407C4E010}"/>
+                <a16:creationId xmlns:a16="http://schemas.microsoft.com/office/drawing/2014/main" id="{4E9295DA-5B61-4954-913B-1FD7F894FDD6}"/>
               </a:ext>
             </a:extLst>
           </p:cNvPr>
@@ -4725,7 +4725,7 @@
           <p:cNvPr id="8" name="station-label-0-0">
             <a:extLst xmlns:a="http://schemas.openxmlformats.org/drawingml/2006/main">
               <a:ext uri="{FF2B5EF4-FFF2-40B4-BE49-F238E27FC236}">
-                <a16:creationId xmlns:a16="http://schemas.microsoft.com/office/drawing/2014/main" id="{15F79A4F-D362-4892-8A45-89C8A1E7D935}"/>
+                <a16:creationId xmlns:a16="http://schemas.microsoft.com/office/drawing/2014/main" id="{0576F06D-57A6-42DF-9B27-E8137A514F7A}"/>
               </a:ext>
             </a:extLst>
           </p:cNvPr>
@@ -4770,7 +4770,7 @@
           <p:cNvPr id="9" name="station-dot-0-1">
             <a:extLst xmlns:a="http://schemas.openxmlformats.org/drawingml/2006/main">
               <a:ext uri="{FF2B5EF4-FFF2-40B4-BE49-F238E27FC236}">
-                <a16:creationId xmlns:a16="http://schemas.microsoft.com/office/drawing/2014/main" id="{7B0E1E7D-F6D1-442B-BF93-F92C7C11D90C}"/>
+                <a16:creationId xmlns:a16="http://schemas.microsoft.com/office/drawing/2014/main" id="{DFAFF552-0623-4C07-BC61-01CE29C5AA8D}"/>
               </a:ext>
             </a:extLst>
           </p:cNvPr>
@@ -4803,7 +4803,7 @@
           <p:cNvPr id="10" name="station-label-0-1">
             <a:extLst xmlns:a="http://schemas.openxmlformats.org/drawingml/2006/main">
               <a:ext uri="{FF2B5EF4-FFF2-40B4-BE49-F238E27FC236}">
-                <a16:creationId xmlns:a16="http://schemas.microsoft.com/office/drawing/2014/main" id="{7F4BDC57-4760-4225-979B-5F048217AFB3}"/>
+                <a16:creationId xmlns:a16="http://schemas.microsoft.com/office/drawing/2014/main" id="{2F1659A0-FCB1-4E7A-9534-C9F52CAA1382}"/>
               </a:ext>
             </a:extLst>
           </p:cNvPr>
@@ -4848,7 +4848,7 @@
           <p:cNvPr id="11" name="station-dot-0-2">
             <a:extLst xmlns:a="http://schemas.openxmlformats.org/drawingml/2006/main">
               <a:ext uri="{FF2B5EF4-FFF2-40B4-BE49-F238E27FC236}">
-                <a16:creationId xmlns:a16="http://schemas.microsoft.com/office/drawing/2014/main" id="{1097D9F4-28DB-4CB8-9F80-1EE26451F43A}"/>
+                <a16:creationId xmlns:a16="http://schemas.microsoft.com/office/drawing/2014/main" id="{1F2C4DD0-8A51-4F42-B5E6-9ED53BCFF0B9}"/>
               </a:ext>
             </a:extLst>
           </p:cNvPr>
@@ -4881,7 +4881,7 @@
           <p:cNvPr id="12" name="station-label-0-2">
             <a:extLst xmlns:a="http://schemas.openxmlformats.org/drawingml/2006/main">
               <a:ext uri="{FF2B5EF4-FFF2-40B4-BE49-F238E27FC236}">
-                <a16:creationId xmlns:a16="http://schemas.microsoft.com/office/drawing/2014/main" id="{841485D9-7496-4B0C-A2CD-33A8B53D9A41}"/>
+                <a16:creationId xmlns:a16="http://schemas.microsoft.com/office/drawing/2014/main" id="{2E7C08E8-C3FD-418E-89C5-08A8A13BD290}"/>
               </a:ext>
             </a:extLst>
           </p:cNvPr>
@@ -4926,7 +4926,7 @@
           <p:cNvPr id="13" name="station-dot-0-3">
             <a:extLst xmlns:a="http://schemas.openxmlformats.org/drawingml/2006/main">
               <a:ext uri="{FF2B5EF4-FFF2-40B4-BE49-F238E27FC236}">
-                <a16:creationId xmlns:a16="http://schemas.microsoft.com/office/drawing/2014/main" id="{C0A78CC6-393F-4692-BA15-D3D97A6353E4}"/>
+                <a16:creationId xmlns:a16="http://schemas.microsoft.com/office/drawing/2014/main" id="{46BA9746-CB9B-49C9-AA33-C04823C87F92}"/>
               </a:ext>
             </a:extLst>
           </p:cNvPr>
@@ -4959,7 +4959,7 @@
           <p:cNvPr id="14" name="station-label-0-3">
             <a:extLst xmlns:a="http://schemas.openxmlformats.org/drawingml/2006/main">
               <a:ext uri="{FF2B5EF4-FFF2-40B4-BE49-F238E27FC236}">
-                <a16:creationId xmlns:a16="http://schemas.microsoft.com/office/drawing/2014/main" id="{76176960-F6F0-4307-B565-43F5449AE0D7}"/>
+                <a16:creationId xmlns:a16="http://schemas.microsoft.com/office/drawing/2014/main" id="{DF14B8DA-8984-4CE3-8099-8996D6E04707}"/>
               </a:ext>
             </a:extLst>
           </p:cNvPr>
@@ -5026,7 +5026,7 @@
           <p:cNvPr id="16" name="station-group-1">
             <a:extLst xmlns:a="http://schemas.openxmlformats.org/drawingml/2006/main">
               <a:ext uri="{FF2B5EF4-FFF2-40B4-BE49-F238E27FC236}">
-                <a16:creationId xmlns:a16="http://schemas.microsoft.com/office/drawing/2014/main" id="{6B6F04CB-1522-402D-B0A2-EB37AF6DD6F6}"/>
+                <a16:creationId xmlns:a16="http://schemas.microsoft.com/office/drawing/2014/main" id="{F79756DC-62EC-4EA0-9ADF-FA361A7E60F0}"/>
               </a:ext>
             </a:extLst>
           </p:cNvPr>
@@ -5061,7 +5061,7 @@
               </a:defRPr>
             </a:pPr>
             <a:r>
-              <a:t>TRUST BOUNDARY  •  2</a:t>
+              <a:t>TRUST BOUNDARY  •  3</a:t>
             </a:r>
           </a:p>
         </p:txBody>
@@ -5071,7 +5071,7 @@
           <p:cNvPr id="17" name="station-dot-1-0">
             <a:extLst xmlns:a="http://schemas.openxmlformats.org/drawingml/2006/main">
               <a:ext uri="{FF2B5EF4-FFF2-40B4-BE49-F238E27FC236}">
-                <a16:creationId xmlns:a16="http://schemas.microsoft.com/office/drawing/2014/main" id="{3EF9CD01-1021-45E8-9752-C42F8B472E6F}"/>
+                <a16:creationId xmlns:a16="http://schemas.microsoft.com/office/drawing/2014/main" id="{C0F411C0-7BB2-4A80-B0DC-AF0AC71B79C2}"/>
               </a:ext>
             </a:extLst>
           </p:cNvPr>
@@ -5104,7 +5104,7 @@
           <p:cNvPr id="18" name="station-label-1-0">
             <a:extLst xmlns:a="http://schemas.openxmlformats.org/drawingml/2006/main">
               <a:ext uri="{FF2B5EF4-FFF2-40B4-BE49-F238E27FC236}">
-                <a16:creationId xmlns:a16="http://schemas.microsoft.com/office/drawing/2014/main" id="{14E2EB19-D54D-4CFC-A172-4D5F0E17C9DD}"/>
+                <a16:creationId xmlns:a16="http://schemas.microsoft.com/office/drawing/2014/main" id="{94E32B0F-1FFD-4EA9-A394-EB95812182A6}"/>
               </a:ext>
             </a:extLst>
           </p:cNvPr>
@@ -5149,18 +5149,18 @@
           <p:cNvPr id="19" name="station-dot-1-1">
             <a:extLst xmlns:a="http://schemas.openxmlformats.org/drawingml/2006/main">
               <a:ext uri="{FF2B5EF4-FFF2-40B4-BE49-F238E27FC236}">
-                <a16:creationId xmlns:a16="http://schemas.microsoft.com/office/drawing/2014/main" id="{851CE4B1-07F1-4A43-BB5B-B8945669358B}"/>
-              </a:ext>
-            </a:extLst>
-          </p:cNvPr>
-          <p:cNvSpPr>
-            <a:spLocks xmlns:a="http://schemas.openxmlformats.org/drawingml/2006/main" noGrp="1"/>
-          </p:cNvSpPr>
-          <p:nvPr/>
-        </p:nvSpPr>
-        <p:spPr>
-          <a:xfrm xmlns:a="http://schemas.openxmlformats.org/drawingml/2006/main">
-            <a:off x="10963275" y="3000375"/>
+                <a16:creationId xmlns:a16="http://schemas.microsoft.com/office/drawing/2014/main" id="{E91342C3-02A5-4F92-8BCA-C71949E1EC09}"/>
+              </a:ext>
+            </a:extLst>
+          </p:cNvPr>
+          <p:cNvSpPr>
+            <a:spLocks xmlns:a="http://schemas.openxmlformats.org/drawingml/2006/main" noGrp="1"/>
+          </p:cNvSpPr>
+          <p:nvPr/>
+        </p:nvSpPr>
+        <p:spPr>
+          <a:xfrm xmlns:a="http://schemas.openxmlformats.org/drawingml/2006/main">
+            <a:off x="6972300" y="3000375"/>
             <a:ext cx="285750" cy="285750"/>
           </a:xfrm>
           <a:prstGeom xmlns:a="http://schemas.openxmlformats.org/drawingml/2006/main" prst="ellipse">
@@ -5182,7 +5182,85 @@
           <p:cNvPr id="20" name="station-label-1-1">
             <a:extLst xmlns:a="http://schemas.openxmlformats.org/drawingml/2006/main">
               <a:ext uri="{FF2B5EF4-FFF2-40B4-BE49-F238E27FC236}">
-                <a16:creationId xmlns:a16="http://schemas.microsoft.com/office/drawing/2014/main" id="{11E50755-D47F-4CAC-B1B3-7FA8C4FA735A}"/>
+                <a16:creationId xmlns:a16="http://schemas.microsoft.com/office/drawing/2014/main" id="{781D9F3E-4E7C-4794-8A96-643D7DED927D}"/>
+              </a:ext>
+            </a:extLst>
+          </p:cNvPr>
+          <p:cNvSpPr>
+            <a:spLocks xmlns:a="http://schemas.openxmlformats.org/drawingml/2006/main" noGrp="1"/>
+          </p:cNvSpPr>
+          <p:nvPr/>
+        </p:nvSpPr>
+        <p:spPr>
+          <a:xfrm xmlns:a="http://schemas.openxmlformats.org/drawingml/2006/main">
+            <a:off x="6124575" y="3257550"/>
+            <a:ext cx="1981200" cy="285750"/>
+          </a:xfrm>
+          <a:prstGeom xmlns:a="http://schemas.openxmlformats.org/drawingml/2006/main" prst="rect">
+            <a:avLst/>
+          </a:prstGeom>
+        </p:spPr>
+        <p:txBody>
+          <a:bodyPr xmlns:a="http://schemas.openxmlformats.org/drawingml/2006/main" wrap="square" lIns="0" tIns="0" rIns="0" bIns="0" anchor="t">
+            <a:normAutofit fontScale="100000"/>
+          </a:bodyPr>
+          <a:lstStyle xmlns:a="http://schemas.openxmlformats.org/drawingml/2006/main"/>
+          <a:p xmlns:a="http://schemas.openxmlformats.org/drawingml/2006/main">
+            <a:pPr algn="ctr">
+              <a:defRPr sz="1200" b="1">
+                <a:solidFill>
+                  <a:srgbClr val="0B1F33"/>
+                </a:solidFill>
+                <a:latin typeface="Aptos"/>
+                <a:ea typeface="Aptos"/>
+                <a:cs typeface="Aptos"/>
+              </a:defRPr>
+            </a:pPr>
+            <a:r>
+              <a:t>runtime range</a:t>
+            </a:r>
+          </a:p>
+        </p:txBody>
+      </p:sp>
+      <p:sp>
+        <p:nvSpPr>
+          <p:cNvPr id="21" name="station-dot-1-2">
+            <a:extLst xmlns:a="http://schemas.openxmlformats.org/drawingml/2006/main">
+              <a:ext uri="{FF2B5EF4-FFF2-40B4-BE49-F238E27FC236}">
+                <a16:creationId xmlns:a16="http://schemas.microsoft.com/office/drawing/2014/main" id="{61AE0848-5F9C-4891-AA89-D2755CE3B99C}"/>
+              </a:ext>
+            </a:extLst>
+          </p:cNvPr>
+          <p:cNvSpPr>
+            <a:spLocks xmlns:a="http://schemas.openxmlformats.org/drawingml/2006/main" noGrp="1"/>
+          </p:cNvSpPr>
+          <p:nvPr/>
+        </p:nvSpPr>
+        <p:spPr>
+          <a:xfrm xmlns:a="http://schemas.openxmlformats.org/drawingml/2006/main">
+            <a:off x="10963275" y="3000375"/>
+            <a:ext cx="285750" cy="285750"/>
+          </a:xfrm>
+          <a:prstGeom xmlns:a="http://schemas.openxmlformats.org/drawingml/2006/main" prst="ellipse">
+            <a:avLst/>
+          </a:prstGeom>
+          <a:solidFill xmlns:a="http://schemas.openxmlformats.org/drawingml/2006/main">
+            <a:srgbClr val="8B5CF6"/>
+          </a:solidFill>
+          <a:ln xmlns:a="http://schemas.openxmlformats.org/drawingml/2006/main" w="38100">
+            <a:solidFill>
+              <a:srgbClr val="FFF8ED"/>
+            </a:solidFill>
+            <a:prstDash val="solid"/>
+          </a:ln>
+        </p:spPr>
+      </p:sp>
+      <p:sp>
+        <p:nvSpPr>
+          <p:cNvPr id="22" name="station-label-1-2">
+            <a:extLst xmlns:a="http://schemas.openxmlformats.org/drawingml/2006/main">
+              <a:ext uri="{FF2B5EF4-FFF2-40B4-BE49-F238E27FC236}">
+                <a16:creationId xmlns:a16="http://schemas.microsoft.com/office/drawing/2014/main" id="{5FB8DC0C-790A-4BE6-89AB-D71A203A156D}"/>
               </a:ext>
             </a:extLst>
           </p:cNvPr>
@@ -5224,7 +5302,7 @@
       </p:sp>
       <p:cxnSp>
         <p:nvCxnSpPr>
-          <p:cNvPr id="63" name="station-line-2"/>
+          <p:cNvPr id="65" name="station-line-2"/>
           <p:cNvCxnSpPr/>
           <p:nvPr/>
         </p:nvCxnSpPr>
@@ -5246,10 +5324,10 @@
       </p:cxnSp>
       <p:sp>
         <p:nvSpPr>
-          <p:cNvPr id="22" name="station-group-2">
-            <a:extLst xmlns:a="http://schemas.openxmlformats.org/drawingml/2006/main">
-              <a:ext uri="{FF2B5EF4-FFF2-40B4-BE49-F238E27FC236}">
-                <a16:creationId xmlns:a16="http://schemas.microsoft.com/office/drawing/2014/main" id="{3AA5F6DC-4196-4FDB-B333-9427F351FE76}"/>
+          <p:cNvPr id="24" name="station-group-2">
+            <a:extLst xmlns:a="http://schemas.openxmlformats.org/drawingml/2006/main">
+              <a:ext uri="{FF2B5EF4-FFF2-40B4-BE49-F238E27FC236}">
+                <a16:creationId xmlns:a16="http://schemas.microsoft.com/office/drawing/2014/main" id="{50191F53-087D-4C2E-B9C0-56ACCDFC2ED9}"/>
               </a:ext>
             </a:extLst>
           </p:cNvPr>
@@ -5284,17 +5362,17 @@
               </a:defRPr>
             </a:pPr>
             <a:r>
-              <a:t>TUI CORE  •  4</a:t>
-            </a:r>
-          </a:p>
-        </p:txBody>
-      </p:sp>
-      <p:sp>
-        <p:nvSpPr>
-          <p:cNvPr id="23" name="station-dot-2-0">
-            <a:extLst xmlns:a="http://schemas.openxmlformats.org/drawingml/2006/main">
-              <a:ext uri="{FF2B5EF4-FFF2-40B4-BE49-F238E27FC236}">
-                <a16:creationId xmlns:a16="http://schemas.microsoft.com/office/drawing/2014/main" id="{DB292F1F-5126-447D-A60E-7502D7BDCBD4}"/>
+              <a:t>TUI CORE  •  3</a:t>
+            </a:r>
+          </a:p>
+        </p:txBody>
+      </p:sp>
+      <p:sp>
+        <p:nvSpPr>
+          <p:cNvPr id="25" name="station-dot-2-0">
+            <a:extLst xmlns:a="http://schemas.openxmlformats.org/drawingml/2006/main">
+              <a:ext uri="{FF2B5EF4-FFF2-40B4-BE49-F238E27FC236}">
+                <a16:creationId xmlns:a16="http://schemas.microsoft.com/office/drawing/2014/main" id="{D1A434A3-088A-4F1F-83BA-8A982308D211}"/>
               </a:ext>
             </a:extLst>
           </p:cNvPr>
@@ -5324,10 +5402,10 @@
       </p:sp>
       <p:sp>
         <p:nvSpPr>
-          <p:cNvPr id="24" name="station-label-2-0">
-            <a:extLst xmlns:a="http://schemas.openxmlformats.org/drawingml/2006/main">
-              <a:ext uri="{FF2B5EF4-FFF2-40B4-BE49-F238E27FC236}">
-                <a16:creationId xmlns:a16="http://schemas.microsoft.com/office/drawing/2014/main" id="{B5850E79-7E42-4BE5-8B8B-69DC353FFFAC}"/>
+          <p:cNvPr id="26" name="station-label-2-0">
+            <a:extLst xmlns:a="http://schemas.openxmlformats.org/drawingml/2006/main">
+              <a:ext uri="{FF2B5EF4-FFF2-40B4-BE49-F238E27FC236}">
+                <a16:creationId xmlns:a16="http://schemas.microsoft.com/office/drawing/2014/main" id="{3A9AF87B-05A9-461F-8234-14B910B33419}"/>
               </a:ext>
             </a:extLst>
           </p:cNvPr>
@@ -5362,28 +5440,28 @@
               </a:defRPr>
             </a:pPr>
             <a:r>
-              <a:t>runtime range</a:t>
-            </a:r>
-          </a:p>
-        </p:txBody>
-      </p:sp>
-      <p:sp>
-        <p:nvSpPr>
-          <p:cNvPr id="25" name="station-dot-2-1">
-            <a:extLst xmlns:a="http://schemas.openxmlformats.org/drawingml/2006/main">
-              <a:ext uri="{FF2B5EF4-FFF2-40B4-BE49-F238E27FC236}">
-                <a16:creationId xmlns:a16="http://schemas.microsoft.com/office/drawing/2014/main" id="{96A95DE7-70AB-4840-B5B0-2763D3541EEC}"/>
-              </a:ext>
-            </a:extLst>
-          </p:cNvPr>
-          <p:cNvSpPr>
-            <a:spLocks xmlns:a="http://schemas.openxmlformats.org/drawingml/2006/main" noGrp="1"/>
-          </p:cNvSpPr>
-          <p:nvPr/>
-        </p:nvSpPr>
-        <p:spPr>
-          <a:xfrm xmlns:a="http://schemas.openxmlformats.org/drawingml/2006/main">
-            <a:off x="5641975" y="3876675"/>
+              <a:t>typecheck</a:t>
+            </a:r>
+          </a:p>
+        </p:txBody>
+      </p:sp>
+      <p:sp>
+        <p:nvSpPr>
+          <p:cNvPr id="27" name="station-dot-2-1">
+            <a:extLst xmlns:a="http://schemas.openxmlformats.org/drawingml/2006/main">
+              <a:ext uri="{FF2B5EF4-FFF2-40B4-BE49-F238E27FC236}">
+                <a16:creationId xmlns:a16="http://schemas.microsoft.com/office/drawing/2014/main" id="{13B268AD-EC51-468D-99FF-8FF6F50BB979}"/>
+              </a:ext>
+            </a:extLst>
+          </p:cNvPr>
+          <p:cNvSpPr>
+            <a:spLocks xmlns:a="http://schemas.openxmlformats.org/drawingml/2006/main" noGrp="1"/>
+          </p:cNvSpPr>
+          <p:nvPr/>
+        </p:nvSpPr>
+        <p:spPr>
+          <a:xfrm xmlns:a="http://schemas.openxmlformats.org/drawingml/2006/main">
+            <a:off x="6972300" y="3876675"/>
             <a:ext cx="285750" cy="285750"/>
           </a:xfrm>
           <a:prstGeom xmlns:a="http://schemas.openxmlformats.org/drawingml/2006/main" prst="ellipse">
@@ -5402,21 +5480,21 @@
       </p:sp>
       <p:sp>
         <p:nvSpPr>
-          <p:cNvPr id="26" name="station-label-2-1">
-            <a:extLst xmlns:a="http://schemas.openxmlformats.org/drawingml/2006/main">
-              <a:ext uri="{FF2B5EF4-FFF2-40B4-BE49-F238E27FC236}">
-                <a16:creationId xmlns:a16="http://schemas.microsoft.com/office/drawing/2014/main" id="{4A5A3303-1C10-4793-965E-21BA95495CC1}"/>
-              </a:ext>
-            </a:extLst>
-          </p:cNvPr>
-          <p:cNvSpPr>
-            <a:spLocks xmlns:a="http://schemas.openxmlformats.org/drawingml/2006/main" noGrp="1"/>
-          </p:cNvSpPr>
-          <p:nvPr/>
-        </p:nvSpPr>
-        <p:spPr>
-          <a:xfrm xmlns:a="http://schemas.openxmlformats.org/drawingml/2006/main">
-            <a:off x="4794250" y="4133850"/>
+          <p:cNvPr id="28" name="station-label-2-1">
+            <a:extLst xmlns:a="http://schemas.openxmlformats.org/drawingml/2006/main">
+              <a:ext uri="{FF2B5EF4-FFF2-40B4-BE49-F238E27FC236}">
+                <a16:creationId xmlns:a16="http://schemas.microsoft.com/office/drawing/2014/main" id="{ACC11BB7-BF31-4D71-B121-60CC05ED3623}"/>
+              </a:ext>
+            </a:extLst>
+          </p:cNvPr>
+          <p:cNvSpPr>
+            <a:spLocks xmlns:a="http://schemas.openxmlformats.org/drawingml/2006/main" noGrp="1"/>
+          </p:cNvSpPr>
+          <p:nvPr/>
+        </p:nvSpPr>
+        <p:spPr>
+          <a:xfrm xmlns:a="http://schemas.openxmlformats.org/drawingml/2006/main">
+            <a:off x="6124575" y="4133850"/>
             <a:ext cx="1981200" cy="285750"/>
           </a:xfrm>
           <a:prstGeom xmlns:a="http://schemas.openxmlformats.org/drawingml/2006/main" prst="rect">
@@ -5440,28 +5518,28 @@
               </a:defRPr>
             </a:pPr>
             <a:r>
-              <a:t>typecheck</a:t>
-            </a:r>
-          </a:p>
-        </p:txBody>
-      </p:sp>
-      <p:sp>
-        <p:nvSpPr>
-          <p:cNvPr id="27" name="station-dot-2-2">
-            <a:extLst xmlns:a="http://schemas.openxmlformats.org/drawingml/2006/main">
-              <a:ext uri="{FF2B5EF4-FFF2-40B4-BE49-F238E27FC236}">
-                <a16:creationId xmlns:a16="http://schemas.microsoft.com/office/drawing/2014/main" id="{D430F59B-7469-4455-87B4-A30697CF3BCD}"/>
-              </a:ext>
-            </a:extLst>
-          </p:cNvPr>
-          <p:cNvSpPr>
-            <a:spLocks xmlns:a="http://schemas.openxmlformats.org/drawingml/2006/main" noGrp="1"/>
-          </p:cNvSpPr>
-          <p:nvPr/>
-        </p:nvSpPr>
-        <p:spPr>
-          <a:xfrm xmlns:a="http://schemas.openxmlformats.org/drawingml/2006/main">
-            <a:off x="8302625" y="3876675"/>
+              <a:t>lint</a:t>
+            </a:r>
+          </a:p>
+        </p:txBody>
+      </p:sp>
+      <p:sp>
+        <p:nvSpPr>
+          <p:cNvPr id="29" name="station-dot-2-2">
+            <a:extLst xmlns:a="http://schemas.openxmlformats.org/drawingml/2006/main">
+              <a:ext uri="{FF2B5EF4-FFF2-40B4-BE49-F238E27FC236}">
+                <a16:creationId xmlns:a16="http://schemas.microsoft.com/office/drawing/2014/main" id="{1B0F2ED9-D3F0-4C0C-AFC6-5E13EF40400B}"/>
+              </a:ext>
+            </a:extLst>
+          </p:cNvPr>
+          <p:cNvSpPr>
+            <a:spLocks xmlns:a="http://schemas.openxmlformats.org/drawingml/2006/main" noGrp="1"/>
+          </p:cNvSpPr>
+          <p:nvPr/>
+        </p:nvSpPr>
+        <p:spPr>
+          <a:xfrm xmlns:a="http://schemas.openxmlformats.org/drawingml/2006/main">
+            <a:off x="10963275" y="3876675"/>
             <a:ext cx="285750" cy="285750"/>
           </a:xfrm>
           <a:prstGeom xmlns:a="http://schemas.openxmlformats.org/drawingml/2006/main" prst="ellipse">
@@ -5480,88 +5558,10 @@
       </p:sp>
       <p:sp>
         <p:nvSpPr>
-          <p:cNvPr id="28" name="station-label-2-2">
-            <a:extLst xmlns:a="http://schemas.openxmlformats.org/drawingml/2006/main">
-              <a:ext uri="{FF2B5EF4-FFF2-40B4-BE49-F238E27FC236}">
-                <a16:creationId xmlns:a16="http://schemas.microsoft.com/office/drawing/2014/main" id="{3CF31333-7584-4B82-B0B3-86CCC81E7D64}"/>
-              </a:ext>
-            </a:extLst>
-          </p:cNvPr>
-          <p:cNvSpPr>
-            <a:spLocks xmlns:a="http://schemas.openxmlformats.org/drawingml/2006/main" noGrp="1"/>
-          </p:cNvSpPr>
-          <p:nvPr/>
-        </p:nvSpPr>
-        <p:spPr>
-          <a:xfrm xmlns:a="http://schemas.openxmlformats.org/drawingml/2006/main">
-            <a:off x="7454900" y="4133850"/>
-            <a:ext cx="1981200" cy="285750"/>
-          </a:xfrm>
-          <a:prstGeom xmlns:a="http://schemas.openxmlformats.org/drawingml/2006/main" prst="rect">
-            <a:avLst/>
-          </a:prstGeom>
-        </p:spPr>
-        <p:txBody>
-          <a:bodyPr xmlns:a="http://schemas.openxmlformats.org/drawingml/2006/main" wrap="square" lIns="0" tIns="0" rIns="0" bIns="0" anchor="t">
-            <a:normAutofit fontScale="100000"/>
-          </a:bodyPr>
-          <a:lstStyle xmlns:a="http://schemas.openxmlformats.org/drawingml/2006/main"/>
-          <a:p xmlns:a="http://schemas.openxmlformats.org/drawingml/2006/main">
-            <a:pPr algn="ctr">
-              <a:defRPr sz="1200" b="1">
-                <a:solidFill>
-                  <a:srgbClr val="0B1F33"/>
-                </a:solidFill>
-                <a:latin typeface="Aptos"/>
-                <a:ea typeface="Aptos"/>
-                <a:cs typeface="Aptos"/>
-              </a:defRPr>
-            </a:pPr>
-            <a:r>
-              <a:t>lint</a:t>
-            </a:r>
-          </a:p>
-        </p:txBody>
-      </p:sp>
-      <p:sp>
-        <p:nvSpPr>
-          <p:cNvPr id="29" name="station-dot-2-3">
-            <a:extLst xmlns:a="http://schemas.openxmlformats.org/drawingml/2006/main">
-              <a:ext uri="{FF2B5EF4-FFF2-40B4-BE49-F238E27FC236}">
-                <a16:creationId xmlns:a16="http://schemas.microsoft.com/office/drawing/2014/main" id="{F83811FD-78B3-4E49-8EE4-AA7C0CA98884}"/>
-              </a:ext>
-            </a:extLst>
-          </p:cNvPr>
-          <p:cNvSpPr>
-            <a:spLocks xmlns:a="http://schemas.openxmlformats.org/drawingml/2006/main" noGrp="1"/>
-          </p:cNvSpPr>
-          <p:nvPr/>
-        </p:nvSpPr>
-        <p:spPr>
-          <a:xfrm xmlns:a="http://schemas.openxmlformats.org/drawingml/2006/main">
-            <a:off x="10963275" y="3876675"/>
-            <a:ext cx="285750" cy="285750"/>
-          </a:xfrm>
-          <a:prstGeom xmlns:a="http://schemas.openxmlformats.org/drawingml/2006/main" prst="ellipse">
-            <a:avLst/>
-          </a:prstGeom>
-          <a:solidFill xmlns:a="http://schemas.openxmlformats.org/drawingml/2006/main">
-            <a:srgbClr val="FF6B6B"/>
-          </a:solidFill>
-          <a:ln xmlns:a="http://schemas.openxmlformats.org/drawingml/2006/main" w="38100">
-            <a:solidFill>
-              <a:srgbClr val="FFF8ED"/>
-            </a:solidFill>
-            <a:prstDash val="solid"/>
-          </a:ln>
-        </p:spPr>
-      </p:sp>
-      <p:sp>
-        <p:nvSpPr>
-          <p:cNvPr id="30" name="station-label-2-3">
-            <a:extLst xmlns:a="http://schemas.openxmlformats.org/drawingml/2006/main">
-              <a:ext uri="{FF2B5EF4-FFF2-40B4-BE49-F238E27FC236}">
-                <a16:creationId xmlns:a16="http://schemas.microsoft.com/office/drawing/2014/main" id="{1C35D5CD-758E-4402-9C15-F1ACE1E371E5}"/>
+          <p:cNvPr id="30" name="station-label-2-2">
+            <a:extLst xmlns:a="http://schemas.openxmlformats.org/drawingml/2006/main">
+              <a:ext uri="{FF2B5EF4-FFF2-40B4-BE49-F238E27FC236}">
+                <a16:creationId xmlns:a16="http://schemas.microsoft.com/office/drawing/2014/main" id="{AA13F74A-86EA-431D-912A-12BE3DABC729}"/>
               </a:ext>
             </a:extLst>
           </p:cNvPr>
@@ -5628,7 +5628,7 @@
           <p:cNvPr id="32" name="station-group-3">
             <a:extLst xmlns:a="http://schemas.openxmlformats.org/drawingml/2006/main">
               <a:ext uri="{FF2B5EF4-FFF2-40B4-BE49-F238E27FC236}">
-                <a16:creationId xmlns:a16="http://schemas.microsoft.com/office/drawing/2014/main" id="{3217E0E2-AB2E-461D-BAF3-B98A9407E7F7}"/>
+                <a16:creationId xmlns:a16="http://schemas.microsoft.com/office/drawing/2014/main" id="{8E845335-ECF0-4B5A-A048-91BB12719ED5}"/>
               </a:ext>
             </a:extLst>
           </p:cNvPr>
@@ -5673,7 +5673,7 @@
           <p:cNvPr id="33" name="station-dot-3-0">
             <a:extLst xmlns:a="http://schemas.openxmlformats.org/drawingml/2006/main">
               <a:ext uri="{FF2B5EF4-FFF2-40B4-BE49-F238E27FC236}">
-                <a16:creationId xmlns:a16="http://schemas.microsoft.com/office/drawing/2014/main" id="{A8C054B6-4E41-4A3A-B1BA-8F969674B062}"/>
+                <a16:creationId xmlns:a16="http://schemas.microsoft.com/office/drawing/2014/main" id="{69EC5887-96C9-4681-B41A-5022EC9B4ED9}"/>
               </a:ext>
             </a:extLst>
           </p:cNvPr>
@@ -5706,7 +5706,7 @@
           <p:cNvPr id="34" name="station-label-3-0">
             <a:extLst xmlns:a="http://schemas.openxmlformats.org/drawingml/2006/main">
               <a:ext uri="{FF2B5EF4-FFF2-40B4-BE49-F238E27FC236}">
-                <a16:creationId xmlns:a16="http://schemas.microsoft.com/office/drawing/2014/main" id="{38A8FFB4-B318-42A7-B8BA-90DBCC00268F}"/>
+                <a16:creationId xmlns:a16="http://schemas.microsoft.com/office/drawing/2014/main" id="{0E91970D-0FC6-4E7D-B4A6-E9E55FB4396B}"/>
               </a:ext>
             </a:extLst>
           </p:cNvPr>
@@ -5751,7 +5751,7 @@
           <p:cNvPr id="35" name="station-dot-3-1">
             <a:extLst xmlns:a="http://schemas.openxmlformats.org/drawingml/2006/main">
               <a:ext uri="{FF2B5EF4-FFF2-40B4-BE49-F238E27FC236}">
-                <a16:creationId xmlns:a16="http://schemas.microsoft.com/office/drawing/2014/main" id="{81467B94-8131-40BD-BF73-5D950F2C0C3C}"/>
+                <a16:creationId xmlns:a16="http://schemas.microsoft.com/office/drawing/2014/main" id="{F4CA50EA-8963-4A10-9C36-669A848B2C6C}"/>
               </a:ext>
             </a:extLst>
           </p:cNvPr>
@@ -5784,7 +5784,7 @@
           <p:cNvPr id="36" name="station-label-3-1">
             <a:extLst xmlns:a="http://schemas.openxmlformats.org/drawingml/2006/main">
               <a:ext uri="{FF2B5EF4-FFF2-40B4-BE49-F238E27FC236}">
-                <a16:creationId xmlns:a16="http://schemas.microsoft.com/office/drawing/2014/main" id="{A31EA028-4B6B-4FE7-AA2F-9F79BC9021A8}"/>
+                <a16:creationId xmlns:a16="http://schemas.microsoft.com/office/drawing/2014/main" id="{E2FD756C-FAEC-42CF-B4E0-A37D101158C1}"/>
               </a:ext>
             </a:extLst>
           </p:cNvPr>
@@ -5829,7 +5829,7 @@
           <p:cNvPr id="37" name="spine-fail">
             <a:extLst xmlns:a="http://schemas.openxmlformats.org/drawingml/2006/main">
               <a:ext uri="{FF2B5EF4-FFF2-40B4-BE49-F238E27FC236}">
-                <a16:creationId xmlns:a16="http://schemas.microsoft.com/office/drawing/2014/main" id="{A390A73B-0A53-40A1-9F8D-7177C94A1785}"/>
+                <a16:creationId xmlns:a16="http://schemas.microsoft.com/office/drawing/2014/main" id="{ABF1CC79-E8FA-4F40-AE1E-99DC591B58F8}"/>
               </a:ext>
             </a:extLst>
           </p:cNvPr>
@@ -5864,7 +5864,7 @@
           <p:cNvPr id="38" name="spine-fail-icon">
             <a:extLst xmlns:a="http://schemas.openxmlformats.org/drawingml/2006/main">
               <a:ext uri="{FF2B5EF4-FFF2-40B4-BE49-F238E27FC236}">
-                <a16:creationId xmlns:a16="http://schemas.microsoft.com/office/drawing/2014/main" id="{5BEF443E-4CA5-41F9-BE48-4E39F9ED5560}"/>
+                <a16:creationId xmlns:a16="http://schemas.microsoft.com/office/drawing/2014/main" id="{DFC743C6-94D3-4AB4-813D-DEFFD40B4333}"/>
               </a:ext>
             </a:extLst>
           </p:cNvPr>
@@ -5909,7 +5909,7 @@
           <p:cNvPr id="39" name="spine-fail-text">
             <a:extLst xmlns:a="http://schemas.openxmlformats.org/drawingml/2006/main">
               <a:ext uri="{FF2B5EF4-FFF2-40B4-BE49-F238E27FC236}">
-                <a16:creationId xmlns:a16="http://schemas.microsoft.com/office/drawing/2014/main" id="{FC379A67-E93C-4700-9676-3449293F8E85}"/>
+                <a16:creationId xmlns:a16="http://schemas.microsoft.com/office/drawing/2014/main" id="{3D67A7A9-A81D-4FF0-9D67-D8FC0E18BE3B}"/>
               </a:ext>
             </a:extLst>
           </p:cNvPr>
@@ -5955,7 +5955,7 @@
           <p:cNvPr id="40" name="spine-pass">
             <a:extLst xmlns:a="http://schemas.openxmlformats.org/drawingml/2006/main">
               <a:ext uri="{FF2B5EF4-FFF2-40B4-BE49-F238E27FC236}">
-                <a16:creationId xmlns:a16="http://schemas.microsoft.com/office/drawing/2014/main" id="{712B6AE3-5EF8-431C-AD1F-35C695C56646}"/>
+                <a16:creationId xmlns:a16="http://schemas.microsoft.com/office/drawing/2014/main" id="{B1B0AB00-A59F-49CC-A1C6-A84146A6A54E}"/>
               </a:ext>
             </a:extLst>
           </p:cNvPr>
@@ -5990,7 +5990,7 @@
           <p:cNvPr id="41" name="spine-pass-icon">
             <a:extLst xmlns:a="http://schemas.openxmlformats.org/drawingml/2006/main">
               <a:ext uri="{FF2B5EF4-FFF2-40B4-BE49-F238E27FC236}">
-                <a16:creationId xmlns:a16="http://schemas.microsoft.com/office/drawing/2014/main" id="{A14FAEC4-04C2-460F-B7D6-23EB823E9484}"/>
+                <a16:creationId xmlns:a16="http://schemas.microsoft.com/office/drawing/2014/main" id="{72219157-2562-468D-B61C-E71C5F895359}"/>
               </a:ext>
             </a:extLst>
           </p:cNvPr>
@@ -6035,7 +6035,7 @@
           <p:cNvPr id="42" name="spine-pass-text">
             <a:extLst xmlns:a="http://schemas.openxmlformats.org/drawingml/2006/main">
               <a:ext uri="{FF2B5EF4-FFF2-40B4-BE49-F238E27FC236}">
-                <a16:creationId xmlns:a16="http://schemas.microsoft.com/office/drawing/2014/main" id="{5119D3E2-6218-4041-9C52-8469072900E2}"/>
+                <a16:creationId xmlns:a16="http://schemas.microsoft.com/office/drawing/2014/main" id="{158E72D3-CEB4-46F5-8399-CA8CE419AEEC}"/>
               </a:ext>
             </a:extLst>
           </p:cNvPr>
@@ -6079,7 +6079,7 @@
     </p:spTree>
     <p:extLst>
       <p:ext uri="{BB962C8B-B14F-4D97-AF65-F5344CB8AC3E}">
-        <p14:creationId xmlns:p14="http://schemas.microsoft.com/office/powerpoint/2010/main" val="1613139421"/>
+        <p14:creationId xmlns:p14="http://schemas.microsoft.com/office/powerpoint/2010/main" val="2019188977"/>
       </p:ext>
     </p:extLst>
   </p:cSld>
@@ -6110,7 +6110,7 @@
           <p:cNvPr id="1" name="kicker-4">
             <a:extLst xmlns:a="http://schemas.openxmlformats.org/drawingml/2006/main">
               <a:ext uri="{FF2B5EF4-FFF2-40B4-BE49-F238E27FC236}">
-                <a16:creationId xmlns:a16="http://schemas.microsoft.com/office/drawing/2014/main" id="{F6F424F2-7DE8-42F6-B433-AA7327AB899E}"/>
+                <a16:creationId xmlns:a16="http://schemas.microsoft.com/office/drawing/2014/main" id="{EE867DA1-11BA-481E-B2E3-AB5F35065411}"/>
               </a:ext>
             </a:extLst>
           </p:cNvPr>
@@ -6155,7 +6155,7 @@
           <p:cNvPr id="2" name="title-4">
             <a:extLst xmlns:a="http://schemas.openxmlformats.org/drawingml/2006/main">
               <a:ext uri="{FF2B5EF4-FFF2-40B4-BE49-F238E27FC236}">
-                <a16:creationId xmlns:a16="http://schemas.microsoft.com/office/drawing/2014/main" id="{1C8F3F67-C2A2-4C88-9668-11B08F3CC88F}"/>
+                <a16:creationId xmlns:a16="http://schemas.microsoft.com/office/drawing/2014/main" id="{0D181097-3C15-4289-8E87-36A47645BF27}"/>
               </a:ext>
             </a:extLst>
           </p:cNvPr>
@@ -6222,7 +6222,7 @@
           <p:cNvPr id="4" name="number-4">
             <a:extLst xmlns:a="http://schemas.openxmlformats.org/drawingml/2006/main">
               <a:ext uri="{FF2B5EF4-FFF2-40B4-BE49-F238E27FC236}">
-                <a16:creationId xmlns:a16="http://schemas.microsoft.com/office/drawing/2014/main" id="{F9BABAC7-85DB-437F-AD1B-66AA061AFE8F}"/>
+                <a16:creationId xmlns:a16="http://schemas.microsoft.com/office/drawing/2014/main" id="{3B3DF361-5D80-4660-8FF9-5152B9896AD9}"/>
               </a:ext>
             </a:extLst>
           </p:cNvPr>
@@ -6289,7 +6289,7 @@
           <p:cNvPr id="6" name="airlock-arrow">
             <a:extLst xmlns:a="http://schemas.openxmlformats.org/drawingml/2006/main">
               <a:ext uri="{FF2B5EF4-FFF2-40B4-BE49-F238E27FC236}">
-                <a16:creationId xmlns:a16="http://schemas.microsoft.com/office/drawing/2014/main" id="{7F6A8592-08AD-4BB4-8331-7E59293A9C0D}"/>
+                <a16:creationId xmlns:a16="http://schemas.microsoft.com/office/drawing/2014/main" id="{73E845E9-F89C-4D51-A8AA-6DE23BCC9FC5}"/>
               </a:ext>
             </a:extLst>
           </p:cNvPr>
@@ -6320,7 +6320,7 @@
           <p:cNvPr id="7" name="setup-island">
             <a:extLst xmlns:a="http://schemas.openxmlformats.org/drawingml/2006/main">
               <a:ext uri="{FF2B5EF4-FFF2-40B4-BE49-F238E27FC236}">
-                <a16:creationId xmlns:a16="http://schemas.microsoft.com/office/drawing/2014/main" id="{6487F895-B21E-4660-8CC0-24B4EDDB88D9}"/>
+                <a16:creationId xmlns:a16="http://schemas.microsoft.com/office/drawing/2014/main" id="{5BDD744A-AAA5-428D-80B4-5DC321551D27}"/>
               </a:ext>
             </a:extLst>
           </p:cNvPr>
@@ -6355,7 +6355,7 @@
           <p:cNvPr id="8" name="check-island">
             <a:extLst xmlns:a="http://schemas.openxmlformats.org/drawingml/2006/main">
               <a:ext uri="{FF2B5EF4-FFF2-40B4-BE49-F238E27FC236}">
-                <a16:creationId xmlns:a16="http://schemas.microsoft.com/office/drawing/2014/main" id="{6380725A-6868-4C83-B490-E999C48AC42F}"/>
+                <a16:creationId xmlns:a16="http://schemas.microsoft.com/office/drawing/2014/main" id="{92818F74-E609-4F07-A11B-840089BD514C}"/>
               </a:ext>
             </a:extLst>
           </p:cNvPr>
@@ -6390,7 +6390,7 @@
           <p:cNvPr id="9" name="airlock-door">
             <a:extLst xmlns:a="http://schemas.openxmlformats.org/drawingml/2006/main">
               <a:ext uri="{FF2B5EF4-FFF2-40B4-BE49-F238E27FC236}">
-                <a16:creationId xmlns:a16="http://schemas.microsoft.com/office/drawing/2014/main" id="{97F3945D-2AC4-4C27-AAE6-5C4BB9275210}"/>
+                <a16:creationId xmlns:a16="http://schemas.microsoft.com/office/drawing/2014/main" id="{F686EBE9-7AA8-4D09-8EC3-122D8AB6067B}"/>
               </a:ext>
             </a:extLst>
           </p:cNvPr>
@@ -6421,7 +6421,7 @@
           <p:cNvPr id="10" name="airlock-lock">
             <a:extLst xmlns:a="http://schemas.openxmlformats.org/drawingml/2006/main">
               <a:ext uri="{FF2B5EF4-FFF2-40B4-BE49-F238E27FC236}">
-                <a16:creationId xmlns:a16="http://schemas.microsoft.com/office/drawing/2014/main" id="{6A068D43-0F3F-40D4-9075-ADD085B4DF9C}"/>
+                <a16:creationId xmlns:a16="http://schemas.microsoft.com/office/drawing/2014/main" id="{F872E898-4227-4705-9959-72E74E0B8C70}"/>
               </a:ext>
             </a:extLst>
           </p:cNvPr>
@@ -6452,7 +6452,7 @@
           <p:cNvPr id="11" name="airlock-keyhole">
             <a:extLst xmlns:a="http://schemas.openxmlformats.org/drawingml/2006/main">
               <a:ext uri="{FF2B5EF4-FFF2-40B4-BE49-F238E27FC236}">
-                <a16:creationId xmlns:a16="http://schemas.microsoft.com/office/drawing/2014/main" id="{F8A3D4D4-94E5-4976-A86D-2F4A37696F23}"/>
+                <a16:creationId xmlns:a16="http://schemas.microsoft.com/office/drawing/2014/main" id="{21BD504A-95AC-4D92-B25A-46C379941804}"/>
               </a:ext>
             </a:extLst>
           </p:cNvPr>
@@ -6483,7 +6483,7 @@
           <p:cNvPr id="12" name="airlock-cross">
             <a:extLst xmlns:a="http://schemas.openxmlformats.org/drawingml/2006/main">
               <a:ext uri="{FF2B5EF4-FFF2-40B4-BE49-F238E27FC236}">
-                <a16:creationId xmlns:a16="http://schemas.microsoft.com/office/drawing/2014/main" id="{E620ED9F-92C9-411A-A9EE-3543F4F5F202}"/>
+                <a16:creationId xmlns:a16="http://schemas.microsoft.com/office/drawing/2014/main" id="{30F04C34-863F-4E8A-A241-BBA3CD26408D}"/>
               </a:ext>
             </a:extLst>
           </p:cNvPr>
@@ -6528,7 +6528,7 @@
           <p:cNvPr id="13" name="setup-label">
             <a:extLst xmlns:a="http://schemas.openxmlformats.org/drawingml/2006/main">
               <a:ext uri="{FF2B5EF4-FFF2-40B4-BE49-F238E27FC236}">
-                <a16:creationId xmlns:a16="http://schemas.microsoft.com/office/drawing/2014/main" id="{1B90450C-ACEB-400C-A3D9-AE28192C7A1F}"/>
+                <a16:creationId xmlns:a16="http://schemas.microsoft.com/office/drawing/2014/main" id="{6B6DD913-9FEB-47BA-9E7B-475E0357A810}"/>
               </a:ext>
             </a:extLst>
           </p:cNvPr>
@@ -6573,7 +6573,7 @@
           <p:cNvPr id="14" name="setup-title">
             <a:extLst xmlns:a="http://schemas.openxmlformats.org/drawingml/2006/main">
               <a:ext uri="{FF2B5EF4-FFF2-40B4-BE49-F238E27FC236}">
-                <a16:creationId xmlns:a16="http://schemas.microsoft.com/office/drawing/2014/main" id="{5B8E1887-B160-43B0-8146-0EAD48924AE4}"/>
+                <a16:creationId xmlns:a16="http://schemas.microsoft.com/office/drawing/2014/main" id="{9ECDEB21-C513-4A7A-A1CA-FFA9442D4C03}"/>
               </a:ext>
             </a:extLst>
           </p:cNvPr>
@@ -6618,7 +6618,7 @@
           <p:cNvPr id="15" name="setup-command-1">
             <a:extLst xmlns:a="http://schemas.openxmlformats.org/drawingml/2006/main">
               <a:ext uri="{FF2B5EF4-FFF2-40B4-BE49-F238E27FC236}">
-                <a16:creationId xmlns:a16="http://schemas.microsoft.com/office/drawing/2014/main" id="{FE928729-A5A9-4523-A3BB-A710E3381395}"/>
+                <a16:creationId xmlns:a16="http://schemas.microsoft.com/office/drawing/2014/main" id="{01759DCC-BDD7-4ED2-9448-A64BF7CC1C31}"/>
               </a:ext>
             </a:extLst>
           </p:cNvPr>
@@ -6663,7 +6663,7 @@
           <p:cNvPr id="16" name="setup-command-2">
             <a:extLst xmlns:a="http://schemas.openxmlformats.org/drawingml/2006/main">
               <a:ext uri="{FF2B5EF4-FFF2-40B4-BE49-F238E27FC236}">
-                <a16:creationId xmlns:a16="http://schemas.microsoft.com/office/drawing/2014/main" id="{0F5396A2-6904-47D2-9B26-2799784C5EEC}"/>
+                <a16:creationId xmlns:a16="http://schemas.microsoft.com/office/drawing/2014/main" id="{4EDE3BA4-7DF1-49DF-8E4F-5BDD24943112}"/>
               </a:ext>
             </a:extLst>
           </p:cNvPr>
@@ -6708,7 +6708,7 @@
           <p:cNvPr id="17" name="setup-command-3">
             <a:extLst xmlns:a="http://schemas.openxmlformats.org/drawingml/2006/main">
               <a:ext uri="{FF2B5EF4-FFF2-40B4-BE49-F238E27FC236}">
-                <a16:creationId xmlns:a16="http://schemas.microsoft.com/office/drawing/2014/main" id="{DB1F42E9-6D44-4377-8592-1BFA3D37E472}"/>
+                <a16:creationId xmlns:a16="http://schemas.microsoft.com/office/drawing/2014/main" id="{70561901-4B36-4635-B2C6-6B3075D67B99}"/>
               </a:ext>
             </a:extLst>
           </p:cNvPr>
@@ -6753,7 +6753,7 @@
           <p:cNvPr id="18" name="setup-caption">
             <a:extLst xmlns:a="http://schemas.openxmlformats.org/drawingml/2006/main">
               <a:ext uri="{FF2B5EF4-FFF2-40B4-BE49-F238E27FC236}">
-                <a16:creationId xmlns:a16="http://schemas.microsoft.com/office/drawing/2014/main" id="{E4454C72-FC53-4CC4-BB60-81FDD4EF49E2}"/>
+                <a16:creationId xmlns:a16="http://schemas.microsoft.com/office/drawing/2014/main" id="{0C193E68-B1CB-495C-AFAA-488E79F3ABF7}"/>
               </a:ext>
             </a:extLst>
           </p:cNvPr>
@@ -6799,7 +6799,7 @@
           <p:cNvPr id="19" name="check-label">
             <a:extLst xmlns:a="http://schemas.openxmlformats.org/drawingml/2006/main">
               <a:ext uri="{FF2B5EF4-FFF2-40B4-BE49-F238E27FC236}">
-                <a16:creationId xmlns:a16="http://schemas.microsoft.com/office/drawing/2014/main" id="{B5BBAFB7-5D7E-4B5A-BD55-5D46DFE97E84}"/>
+                <a16:creationId xmlns:a16="http://schemas.microsoft.com/office/drawing/2014/main" id="{68810C40-9F56-44CA-A8B7-7F0BFB34F68B}"/>
               </a:ext>
             </a:extLst>
           </p:cNvPr>
@@ -6844,7 +6844,7 @@
           <p:cNvPr id="20" name="check-title">
             <a:extLst xmlns:a="http://schemas.openxmlformats.org/drawingml/2006/main">
               <a:ext uri="{FF2B5EF4-FFF2-40B4-BE49-F238E27FC236}">
-                <a16:creationId xmlns:a16="http://schemas.microsoft.com/office/drawing/2014/main" id="{57FDEFAB-AB87-4E47-B10A-5BC31640A19A}"/>
+                <a16:creationId xmlns:a16="http://schemas.microsoft.com/office/drawing/2014/main" id="{21158826-EC56-49D4-91F6-106DAB7122D9}"/>
               </a:ext>
             </a:extLst>
           </p:cNvPr>
@@ -6889,7 +6889,7 @@
           <p:cNvPr id="21" name="check-list">
             <a:extLst xmlns:a="http://schemas.openxmlformats.org/drawingml/2006/main">
               <a:ext uri="{FF2B5EF4-FFF2-40B4-BE49-F238E27FC236}">
-                <a16:creationId xmlns:a16="http://schemas.microsoft.com/office/drawing/2014/main" id="{3C1CE623-FF29-497C-89C9-378AC14B61DE}"/>
+                <a16:creationId xmlns:a16="http://schemas.microsoft.com/office/drawing/2014/main" id="{7097798F-0236-465B-A27E-816391675B9E}"/>
               </a:ext>
             </a:extLst>
           </p:cNvPr>
@@ -6929,7 +6929,7 @@
 uv sync --check
 uv run --no-sync
 offline + frozen
-Node range checked</a:t>
+Node before every npm</a:t>
             </a:r>
           </a:p>
         </p:txBody>
@@ -6939,7 +6939,7 @@
           <p:cNvPr id="22" name="airlock-caption">
             <a:extLst xmlns:a="http://schemas.openxmlformats.org/drawingml/2006/main">
               <a:ext uri="{FF2B5EF4-FFF2-40B4-BE49-F238E27FC236}">
-                <a16:creationId xmlns:a16="http://schemas.microsoft.com/office/drawing/2014/main" id="{F4715C34-45D4-468F-967D-3B42FB7BF4A4}"/>
+                <a16:creationId xmlns:a16="http://schemas.microsoft.com/office/drawing/2014/main" id="{50BB6C71-6742-49FD-9B35-5D6AC3E968AC}"/>
               </a:ext>
             </a:extLst>
           </p:cNvPr>
@@ -6984,7 +6984,7 @@
           <p:cNvPr id="23" name="airlock-note">
             <a:extLst xmlns:a="http://schemas.openxmlformats.org/drawingml/2006/main">
               <a:ext uri="{FF2B5EF4-FFF2-40B4-BE49-F238E27FC236}">
-                <a16:creationId xmlns:a16="http://schemas.microsoft.com/office/drawing/2014/main" id="{9AFEF94B-B638-43D4-8295-C958EC73E103}"/>
+                <a16:creationId xmlns:a16="http://schemas.microsoft.com/office/drawing/2014/main" id="{829E7B92-0233-4DBC-84D3-3D72D13E947B}"/>
               </a:ext>
             </a:extLst>
           </p:cNvPr>
@@ -7027,7 +7027,7 @@
     </p:spTree>
     <p:extLst>
       <p:ext uri="{BB962C8B-B14F-4D97-AF65-F5344CB8AC3E}">
-        <p14:creationId xmlns:p14="http://schemas.microsoft.com/office/powerpoint/2010/main" val="1242886728"/>
+        <p14:creationId xmlns:p14="http://schemas.microsoft.com/office/powerpoint/2010/main" val="1863662902"/>
       </p:ext>
     </p:extLst>
   </p:cSld>
@@ -7058,7 +7058,7 @@
           <p:cNvPr id="1" name="kicker-5">
             <a:extLst xmlns:a="http://schemas.openxmlformats.org/drawingml/2006/main">
               <a:ext uri="{FF2B5EF4-FFF2-40B4-BE49-F238E27FC236}">
-                <a16:creationId xmlns:a16="http://schemas.microsoft.com/office/drawing/2014/main" id="{0F26C233-5346-45B4-A22C-7375FD5B04EA}"/>
+                <a16:creationId xmlns:a16="http://schemas.microsoft.com/office/drawing/2014/main" id="{927DE81C-2204-44D8-BF56-758D30D39F79}"/>
               </a:ext>
             </a:extLst>
           </p:cNvPr>
@@ -7103,7 +7103,7 @@
           <p:cNvPr id="2" name="title-5">
             <a:extLst xmlns:a="http://schemas.openxmlformats.org/drawingml/2006/main">
               <a:ext uri="{FF2B5EF4-FFF2-40B4-BE49-F238E27FC236}">
-                <a16:creationId xmlns:a16="http://schemas.microsoft.com/office/drawing/2014/main" id="{D964EDF8-D1B9-4D7C-B40C-D6A76FF39B5A}"/>
+                <a16:creationId xmlns:a16="http://schemas.microsoft.com/office/drawing/2014/main" id="{313A451B-3C16-49D6-A277-F937281CCC5A}"/>
               </a:ext>
             </a:extLst>
           </p:cNvPr>
@@ -7170,7 +7170,7 @@
           <p:cNvPr id="4" name="number-5">
             <a:extLst xmlns:a="http://schemas.openxmlformats.org/drawingml/2006/main">
               <a:ext uri="{FF2B5EF4-FFF2-40B4-BE49-F238E27FC236}">
-                <a16:creationId xmlns:a16="http://schemas.microsoft.com/office/drawing/2014/main" id="{FD3F5A2A-DDB1-4AD8-ADBD-9B8FECACC446}"/>
+                <a16:creationId xmlns:a16="http://schemas.microsoft.com/office/drawing/2014/main" id="{573ECF72-6E2F-419A-85B4-3541D679F38F}"/>
               </a:ext>
             </a:extLst>
           </p:cNvPr>
@@ -7325,7 +7325,7 @@
           <p:cNvPr id="10" name="seam-ring-0">
             <a:extLst xmlns:a="http://schemas.openxmlformats.org/drawingml/2006/main">
               <a:ext uri="{FF2B5EF4-FFF2-40B4-BE49-F238E27FC236}">
-                <a16:creationId xmlns:a16="http://schemas.microsoft.com/office/drawing/2014/main" id="{71C75564-55C8-4F0B-B3E0-981328EB0F40}"/>
+                <a16:creationId xmlns:a16="http://schemas.microsoft.com/office/drawing/2014/main" id="{7AD6D2AD-9F89-4C1F-865A-F5ABCC98BF86}"/>
               </a:ext>
             </a:extLst>
           </p:cNvPr>
@@ -7358,7 +7358,7 @@
           <p:cNvPr id="11" name="seam-box-0">
             <a:extLst xmlns:a="http://schemas.openxmlformats.org/drawingml/2006/main">
               <a:ext uri="{FF2B5EF4-FFF2-40B4-BE49-F238E27FC236}">
-                <a16:creationId xmlns:a16="http://schemas.microsoft.com/office/drawing/2014/main" id="{839548C1-18C8-45F7-855B-3AAE2AE902C3}"/>
+                <a16:creationId xmlns:a16="http://schemas.microsoft.com/office/drawing/2014/main" id="{C64B63AB-629E-4DC5-A151-466FDF71158E}"/>
               </a:ext>
             </a:extLst>
           </p:cNvPr>
@@ -7393,7 +7393,7 @@
           <p:cNvPr id="12" name="seam-heading-0">
             <a:extLst xmlns:a="http://schemas.openxmlformats.org/drawingml/2006/main">
               <a:ext uri="{FF2B5EF4-FFF2-40B4-BE49-F238E27FC236}">
-                <a16:creationId xmlns:a16="http://schemas.microsoft.com/office/drawing/2014/main" id="{1ACB93FB-148A-43C9-8C46-1C08ED4250E0}"/>
+                <a16:creationId xmlns:a16="http://schemas.microsoft.com/office/drawing/2014/main" id="{FA138D26-CFE4-4C57-A592-6AEBE7A13189}"/>
               </a:ext>
             </a:extLst>
           </p:cNvPr>
@@ -7438,7 +7438,7 @@
           <p:cNvPr id="13" name="seam-body-0">
             <a:extLst xmlns:a="http://schemas.openxmlformats.org/drawingml/2006/main">
               <a:ext uri="{FF2B5EF4-FFF2-40B4-BE49-F238E27FC236}">
-                <a16:creationId xmlns:a16="http://schemas.microsoft.com/office/drawing/2014/main" id="{5AA5C08B-E975-4F94-A006-3B2CB8F21D2E}"/>
+                <a16:creationId xmlns:a16="http://schemas.microsoft.com/office/drawing/2014/main" id="{BCF7BC5A-EC58-4206-8C76-9B2009368799}"/>
               </a:ext>
             </a:extLst>
           </p:cNvPr>
@@ -7473,8 +7473,8 @@
               </a:defRPr>
             </a:pPr>
             <a:r>
-              <a:t>Local targets + headings
-must resolve</a:t>
+              <a:t>Tracked + new nonignored
+links must resolve</a:t>
             </a:r>
           </a:p>
         </p:txBody>
@@ -7484,7 +7484,7 @@
           <p:cNvPr id="14" name="seam-ring-1">
             <a:extLst xmlns:a="http://schemas.openxmlformats.org/drawingml/2006/main">
               <a:ext uri="{FF2B5EF4-FFF2-40B4-BE49-F238E27FC236}">
-                <a16:creationId xmlns:a16="http://schemas.microsoft.com/office/drawing/2014/main" id="{58A1043A-B9D1-41BC-99B4-34248ECF4F60}"/>
+                <a16:creationId xmlns:a16="http://schemas.microsoft.com/office/drawing/2014/main" id="{5A30440B-1CF5-414A-B74F-63524F6228ED}"/>
               </a:ext>
             </a:extLst>
           </p:cNvPr>
@@ -7517,7 +7517,7 @@
           <p:cNvPr id="15" name="seam-box-1">
             <a:extLst xmlns:a="http://schemas.openxmlformats.org/drawingml/2006/main">
               <a:ext uri="{FF2B5EF4-FFF2-40B4-BE49-F238E27FC236}">
-                <a16:creationId xmlns:a16="http://schemas.microsoft.com/office/drawing/2014/main" id="{CEBC216C-E7A7-4896-8A51-0DCCD987F229}"/>
+                <a16:creationId xmlns:a16="http://schemas.microsoft.com/office/drawing/2014/main" id="{B333DEF2-2228-4ADE-B78D-045D6B0556B8}"/>
               </a:ext>
             </a:extLst>
           </p:cNvPr>
@@ -7552,7 +7552,7 @@
           <p:cNvPr id="16" name="seam-heading-1">
             <a:extLst xmlns:a="http://schemas.openxmlformats.org/drawingml/2006/main">
               <a:ext uri="{FF2B5EF4-FFF2-40B4-BE49-F238E27FC236}">
-                <a16:creationId xmlns:a16="http://schemas.microsoft.com/office/drawing/2014/main" id="{B569BFB8-C341-4F9D-9C78-4DDA82AEA8A7}"/>
+                <a16:creationId xmlns:a16="http://schemas.microsoft.com/office/drawing/2014/main" id="{6D95671B-4A6B-468E-88E1-4D04E059FAC3}"/>
               </a:ext>
             </a:extLst>
           </p:cNvPr>
@@ -7597,7 +7597,7 @@
           <p:cNvPr id="17" name="seam-body-1">
             <a:extLst xmlns:a="http://schemas.openxmlformats.org/drawingml/2006/main">
               <a:ext uri="{FF2B5EF4-FFF2-40B4-BE49-F238E27FC236}">
-                <a16:creationId xmlns:a16="http://schemas.microsoft.com/office/drawing/2014/main" id="{3CC950DF-8E90-4AA7-81FA-B069B5EB00AF}"/>
+                <a16:creationId xmlns:a16="http://schemas.microsoft.com/office/drawing/2014/main" id="{AE5655B1-2110-4A36-89A8-E34BAEB8F2DA}"/>
               </a:ext>
             </a:extLst>
           </p:cNvPr>
@@ -7632,8 +7632,8 @@
               </a:defRPr>
             </a:pPr>
             <a:r>
-              <a:t>Full lock graph + source
-policy fail synthetically</a:t>
+              <a:t>Lock drift + global fetch
+fail synthetically</a:t>
             </a:r>
           </a:p>
         </p:txBody>
@@ -7643,7 +7643,7 @@
           <p:cNvPr id="18" name="seam-ring-2">
             <a:extLst xmlns:a="http://schemas.openxmlformats.org/drawingml/2006/main">
               <a:ext uri="{FF2B5EF4-FFF2-40B4-BE49-F238E27FC236}">
-                <a16:creationId xmlns:a16="http://schemas.microsoft.com/office/drawing/2014/main" id="{6A0680D3-488D-4650-99DA-2C552171A8FA}"/>
+                <a16:creationId xmlns:a16="http://schemas.microsoft.com/office/drawing/2014/main" id="{7C0D53D5-2D68-43B9-AF3D-BBFE8936545A}"/>
               </a:ext>
             </a:extLst>
           </p:cNvPr>
@@ -7676,7 +7676,7 @@
           <p:cNvPr id="19" name="seam-box-2">
             <a:extLst xmlns:a="http://schemas.openxmlformats.org/drawingml/2006/main">
               <a:ext uri="{FF2B5EF4-FFF2-40B4-BE49-F238E27FC236}">
-                <a16:creationId xmlns:a16="http://schemas.microsoft.com/office/drawing/2014/main" id="{736044D5-68AB-4962-9754-77954FECB132}"/>
+                <a16:creationId xmlns:a16="http://schemas.microsoft.com/office/drawing/2014/main" id="{F5D456EA-8528-4090-B1CB-174D015362C7}"/>
               </a:ext>
             </a:extLst>
           </p:cNvPr>
@@ -7711,7 +7711,7 @@
           <p:cNvPr id="20" name="seam-heading-2">
             <a:extLst xmlns:a="http://schemas.openxmlformats.org/drawingml/2006/main">
               <a:ext uri="{FF2B5EF4-FFF2-40B4-BE49-F238E27FC236}">
-                <a16:creationId xmlns:a16="http://schemas.microsoft.com/office/drawing/2014/main" id="{186BA8EC-C488-4BD6-93CE-6286ACAAB993}"/>
+                <a16:creationId xmlns:a16="http://schemas.microsoft.com/office/drawing/2014/main" id="{50DD9935-1F72-4391-8B65-8B16B5F3F7C3}"/>
               </a:ext>
             </a:extLst>
           </p:cNvPr>
@@ -7756,7 +7756,7 @@
           <p:cNvPr id="21" name="seam-body-2">
             <a:extLst xmlns:a="http://schemas.openxmlformats.org/drawingml/2006/main">
               <a:ext uri="{FF2B5EF4-FFF2-40B4-BE49-F238E27FC236}">
-                <a16:creationId xmlns:a16="http://schemas.microsoft.com/office/drawing/2014/main" id="{8D295C20-2DC5-4042-B6EF-AEB4F12E732D}"/>
+                <a16:creationId xmlns:a16="http://schemas.microsoft.com/office/drawing/2014/main" id="{70273786-0423-4CD7-88AE-3FDB6DCB92C2}"/>
               </a:ext>
             </a:extLst>
           </p:cNvPr>
@@ -7802,7 +7802,7 @@
           <p:cNvPr id="22" name="seam-ring-3">
             <a:extLst xmlns:a="http://schemas.openxmlformats.org/drawingml/2006/main">
               <a:ext uri="{FF2B5EF4-FFF2-40B4-BE49-F238E27FC236}">
-                <a16:creationId xmlns:a16="http://schemas.microsoft.com/office/drawing/2014/main" id="{576468ED-6794-4D1A-8923-9B6E57430348}"/>
+                <a16:creationId xmlns:a16="http://schemas.microsoft.com/office/drawing/2014/main" id="{C968616D-A3D9-4F3D-9617-AB24B69B8235}"/>
               </a:ext>
             </a:extLst>
           </p:cNvPr>
@@ -7835,7 +7835,7 @@
           <p:cNvPr id="23" name="seam-box-3">
             <a:extLst xmlns:a="http://schemas.openxmlformats.org/drawingml/2006/main">
               <a:ext uri="{FF2B5EF4-FFF2-40B4-BE49-F238E27FC236}">
-                <a16:creationId xmlns:a16="http://schemas.microsoft.com/office/drawing/2014/main" id="{D3A208C5-8443-48CA-97DC-0AA3AB580C97}"/>
+                <a16:creationId xmlns:a16="http://schemas.microsoft.com/office/drawing/2014/main" id="{15DA9E64-77D2-4907-9AA5-35F3474E78B3}"/>
               </a:ext>
             </a:extLst>
           </p:cNvPr>
@@ -7870,7 +7870,7 @@
           <p:cNvPr id="24" name="seam-heading-3">
             <a:extLst xmlns:a="http://schemas.openxmlformats.org/drawingml/2006/main">
               <a:ext uri="{FF2B5EF4-FFF2-40B4-BE49-F238E27FC236}">
-                <a16:creationId xmlns:a16="http://schemas.microsoft.com/office/drawing/2014/main" id="{39A3253D-79CB-453F-B023-F6F3F977758C}"/>
+                <a16:creationId xmlns:a16="http://schemas.microsoft.com/office/drawing/2014/main" id="{37A1D6D5-4C5D-45C1-BB4A-88A3E00A9270}"/>
               </a:ext>
             </a:extLst>
           </p:cNvPr>
@@ -7915,7 +7915,7 @@
           <p:cNvPr id="25" name="seam-body-3">
             <a:extLst xmlns:a="http://schemas.openxmlformats.org/drawingml/2006/main">
               <a:ext uri="{FF2B5EF4-FFF2-40B4-BE49-F238E27FC236}">
-                <a16:creationId xmlns:a16="http://schemas.microsoft.com/office/drawing/2014/main" id="{5E76392D-4C8E-4AC8-88CF-F538D997FA1A}"/>
+                <a16:creationId xmlns:a16="http://schemas.microsoft.com/office/drawing/2014/main" id="{96F79852-BD0F-47EB-95E1-77DAB6E4C951}"/>
               </a:ext>
             </a:extLst>
           </p:cNvPr>
@@ -7961,7 +7961,7 @@
           <p:cNvPr id="26" name="seam-python">
             <a:extLst xmlns:a="http://schemas.openxmlformats.org/drawingml/2006/main">
               <a:ext uri="{FF2B5EF4-FFF2-40B4-BE49-F238E27FC236}">
-                <a16:creationId xmlns:a16="http://schemas.microsoft.com/office/drawing/2014/main" id="{A9653239-0C46-48D8-AC1C-B78D1E374AFD}"/>
+                <a16:creationId xmlns:a16="http://schemas.microsoft.com/office/drawing/2014/main" id="{A5E8A943-D6BA-48AC-B0D6-B6CDD70BF7B8}"/>
               </a:ext>
             </a:extLst>
           </p:cNvPr>
@@ -8006,7 +8006,7 @@
           <p:cNvPr id="27" name="seam-tui">
             <a:extLst xmlns:a="http://schemas.openxmlformats.org/drawingml/2006/main">
               <a:ext uri="{FF2B5EF4-FFF2-40B4-BE49-F238E27FC236}">
-                <a16:creationId xmlns:a16="http://schemas.microsoft.com/office/drawing/2014/main" id="{181AC79D-4AFA-4301-AB2A-8DA6B838A34B}"/>
+                <a16:creationId xmlns:a16="http://schemas.microsoft.com/office/drawing/2014/main" id="{323215FF-C1E0-42FD-BBF6-76ADD528C53D}"/>
               </a:ext>
             </a:extLst>
           </p:cNvPr>
@@ -8051,7 +8051,7 @@
           <p:cNvPr id="28" name="seam-footer">
             <a:extLst xmlns:a="http://schemas.openxmlformats.org/drawingml/2006/main">
               <a:ext uri="{FF2B5EF4-FFF2-40B4-BE49-F238E27FC236}">
-                <a16:creationId xmlns:a16="http://schemas.microsoft.com/office/drawing/2014/main" id="{A0E21A75-8D17-4863-A33F-1BCB55BE0DDB}"/>
+                <a16:creationId xmlns:a16="http://schemas.microsoft.com/office/drawing/2014/main" id="{3A09E877-CCBE-4804-951F-B4CB6FB85E92}"/>
               </a:ext>
             </a:extLst>
           </p:cNvPr>
@@ -8082,7 +8082,7 @@
           <p:cNvPr id="29" name="seam-footer-text">
             <a:extLst xmlns:a="http://schemas.openxmlformats.org/drawingml/2006/main">
               <a:ext uri="{FF2B5EF4-FFF2-40B4-BE49-F238E27FC236}">
-                <a16:creationId xmlns:a16="http://schemas.microsoft.com/office/drawing/2014/main" id="{E6DA395C-4CB3-44C7-A1B5-F610BC01D327}"/>
+                <a16:creationId xmlns:a16="http://schemas.microsoft.com/office/drawing/2014/main" id="{6880992F-F657-4046-9564-9E776740C1BC}"/>
               </a:ext>
             </a:extLst>
           </p:cNvPr>
@@ -8125,7 +8125,7 @@
     </p:spTree>
     <p:extLst>
       <p:ext uri="{BB962C8B-B14F-4D97-AF65-F5344CB8AC3E}">
-        <p14:creationId xmlns:p14="http://schemas.microsoft.com/office/powerpoint/2010/main" val="667763739"/>
+        <p14:creationId xmlns:p14="http://schemas.microsoft.com/office/powerpoint/2010/main" val="1346429581"/>
       </p:ext>
     </p:extLst>
   </p:cSld>
@@ -8156,7 +8156,7 @@
           <p:cNvPr id="1" name="kicker-6">
             <a:extLst xmlns:a="http://schemas.openxmlformats.org/drawingml/2006/main">
               <a:ext uri="{FF2B5EF4-FFF2-40B4-BE49-F238E27FC236}">
-                <a16:creationId xmlns:a16="http://schemas.microsoft.com/office/drawing/2014/main" id="{278606C3-5140-4EDC-8E11-3F4DAC95D967}"/>
+                <a16:creationId xmlns:a16="http://schemas.microsoft.com/office/drawing/2014/main" id="{BE9BFC81-3351-4652-BD65-140852FC5AC4}"/>
               </a:ext>
             </a:extLst>
           </p:cNvPr>
@@ -8201,7 +8201,7 @@
           <p:cNvPr id="2" name="title-6">
             <a:extLst xmlns:a="http://schemas.openxmlformats.org/drawingml/2006/main">
               <a:ext uri="{FF2B5EF4-FFF2-40B4-BE49-F238E27FC236}">
-                <a16:creationId xmlns:a16="http://schemas.microsoft.com/office/drawing/2014/main" id="{4E5696B2-BA85-457C-A37E-A77D4CCFEC14}"/>
+                <a16:creationId xmlns:a16="http://schemas.microsoft.com/office/drawing/2014/main" id="{7A23AFC5-9A4D-4130-8277-1FE6EA776B72}"/>
               </a:ext>
             </a:extLst>
           </p:cNvPr>
@@ -8268,7 +8268,7 @@
           <p:cNvPr id="4" name="number-6">
             <a:extLst xmlns:a="http://schemas.openxmlformats.org/drawingml/2006/main">
               <a:ext uri="{FF2B5EF4-FFF2-40B4-BE49-F238E27FC236}">
-                <a16:creationId xmlns:a16="http://schemas.microsoft.com/office/drawing/2014/main" id="{EE307751-C9B8-43AA-9ED4-78B569C62742}"/>
+                <a16:creationId xmlns:a16="http://schemas.microsoft.com/office/drawing/2014/main" id="{194527A8-5D41-42F6-B1E0-36EF20DACEA6}"/>
               </a:ext>
             </a:extLst>
           </p:cNvPr>
@@ -8313,7 +8313,7 @@
           <p:cNvPr id="5" name="ci-arrow">
             <a:extLst xmlns:a="http://schemas.openxmlformats.org/drawingml/2006/main">
               <a:ext uri="{FF2B5EF4-FFF2-40B4-BE49-F238E27FC236}">
-                <a16:creationId xmlns:a16="http://schemas.microsoft.com/office/drawing/2014/main" id="{6B6547A5-D035-441A-AF9E-882E4FE27A21}"/>
+                <a16:creationId xmlns:a16="http://schemas.microsoft.com/office/drawing/2014/main" id="{D5BE6692-9C99-4436-ACFF-7D15F7C529E3}"/>
               </a:ext>
             </a:extLst>
           </p:cNvPr>
@@ -8366,7 +8366,7 @@
           <p:cNvPr id="7" name="ci-setup">
             <a:extLst xmlns:a="http://schemas.openxmlformats.org/drawingml/2006/main">
               <a:ext uri="{FF2B5EF4-FFF2-40B4-BE49-F238E27FC236}">
-                <a16:creationId xmlns:a16="http://schemas.microsoft.com/office/drawing/2014/main" id="{A0C7BD2B-CC4C-4FA7-98CC-3BC328661FC1}"/>
+                <a16:creationId xmlns:a16="http://schemas.microsoft.com/office/drawing/2014/main" id="{DC37FDA7-9311-43B2-BF23-AA1F34E7718F}"/>
               </a:ext>
             </a:extLst>
           </p:cNvPr>
@@ -8401,7 +8401,7 @@
           <p:cNvPr id="8" name="ci-command">
             <a:extLst xmlns:a="http://schemas.openxmlformats.org/drawingml/2006/main">
               <a:ext uri="{FF2B5EF4-FFF2-40B4-BE49-F238E27FC236}">
-                <a16:creationId xmlns:a16="http://schemas.microsoft.com/office/drawing/2014/main" id="{0ACEAF70-FA5C-4225-B575-D34D14FBEA09}"/>
+                <a16:creationId xmlns:a16="http://schemas.microsoft.com/office/drawing/2014/main" id="{47BB37C0-BEC4-4546-8DA3-6D273D2B545B}"/>
               </a:ext>
             </a:extLst>
           </p:cNvPr>
@@ -8436,7 +8436,7 @@
           <p:cNvPr id="9" name="ci-left-kicker">
             <a:extLst xmlns:a="http://schemas.openxmlformats.org/drawingml/2006/main">
               <a:ext uri="{FF2B5EF4-FFF2-40B4-BE49-F238E27FC236}">
-                <a16:creationId xmlns:a16="http://schemas.microsoft.com/office/drawing/2014/main" id="{ADE21992-1791-46EA-8D3F-E07A9760DE03}"/>
+                <a16:creationId xmlns:a16="http://schemas.microsoft.com/office/drawing/2014/main" id="{ACB561E5-1569-4BC6-8537-D045FD0FF556}"/>
               </a:ext>
             </a:extLst>
           </p:cNvPr>
@@ -8481,7 +8481,7 @@
           <p:cNvPr id="10" name="ci-left-title">
             <a:extLst xmlns:a="http://schemas.openxmlformats.org/drawingml/2006/main">
               <a:ext uri="{FF2B5EF4-FFF2-40B4-BE49-F238E27FC236}">
-                <a16:creationId xmlns:a16="http://schemas.microsoft.com/office/drawing/2014/main" id="{999159A8-ED1C-4E22-8B7E-30558394CDE0}"/>
+                <a16:creationId xmlns:a16="http://schemas.microsoft.com/office/drawing/2014/main" id="{7D6FC321-EB62-45BE-A6C2-424355F7B1DF}"/>
               </a:ext>
             </a:extLst>
           </p:cNvPr>
@@ -8526,7 +8526,7 @@
           <p:cNvPr id="11" name="ci-left-list">
             <a:extLst xmlns:a="http://schemas.openxmlformats.org/drawingml/2006/main">
               <a:ext uri="{FF2B5EF4-FFF2-40B4-BE49-F238E27FC236}">
-                <a16:creationId xmlns:a16="http://schemas.microsoft.com/office/drawing/2014/main" id="{24C55C1A-4C5F-4348-9B18-29BA5AAC4B3F}"/>
+                <a16:creationId xmlns:a16="http://schemas.microsoft.com/office/drawing/2014/main" id="{83A3B63A-A940-45FB-9D91-E555AA6A952A}"/>
               </a:ext>
             </a:extLst>
           </p:cNvPr>
@@ -8576,7 +8576,7 @@
           <p:cNvPr id="12" name="ci-right-kicker">
             <a:extLst xmlns:a="http://schemas.openxmlformats.org/drawingml/2006/main">
               <a:ext uri="{FF2B5EF4-FFF2-40B4-BE49-F238E27FC236}">
-                <a16:creationId xmlns:a16="http://schemas.microsoft.com/office/drawing/2014/main" id="{37E486E6-1B4D-43CA-ADCB-17CCFBCD63D4}"/>
+                <a16:creationId xmlns:a16="http://schemas.microsoft.com/office/drawing/2014/main" id="{AA48111F-7303-4D3A-BED1-9AC4F8B33FC8}"/>
               </a:ext>
             </a:extLst>
           </p:cNvPr>
@@ -8621,7 +8621,7 @@
           <p:cNvPr id="13" name="ci-right-command">
             <a:extLst xmlns:a="http://schemas.openxmlformats.org/drawingml/2006/main">
               <a:ext uri="{FF2B5EF4-FFF2-40B4-BE49-F238E27FC236}">
-                <a16:creationId xmlns:a16="http://schemas.microsoft.com/office/drawing/2014/main" id="{AC1CFE81-3BD7-4CCA-A750-BB123EC3333F}"/>
+                <a16:creationId xmlns:a16="http://schemas.microsoft.com/office/drawing/2014/main" id="{82CC3E7F-F3FB-44C8-AC02-F6399BE89ECE}"/>
               </a:ext>
             </a:extLst>
           </p:cNvPr>
@@ -8688,7 +8688,7 @@
           <p:cNvPr id="15" name="ci-right-caption">
             <a:extLst xmlns:a="http://schemas.openxmlformats.org/drawingml/2006/main">
               <a:ext uri="{FF2B5EF4-FFF2-40B4-BE49-F238E27FC236}">
-                <a16:creationId xmlns:a16="http://schemas.microsoft.com/office/drawing/2014/main" id="{87402B3A-EDE8-4519-AEA8-DE1CBB937C22}"/>
+                <a16:creationId xmlns:a16="http://schemas.microsoft.com/office/drawing/2014/main" id="{D5F93619-96E5-44CC-89E2-54BD75F8BC0A}"/>
               </a:ext>
             </a:extLst>
           </p:cNvPr>
@@ -8734,7 +8734,7 @@
           <p:cNvPr id="16" name="ci-footer">
             <a:extLst xmlns:a="http://schemas.openxmlformats.org/drawingml/2006/main">
               <a:ext uri="{FF2B5EF4-FFF2-40B4-BE49-F238E27FC236}">
-                <a16:creationId xmlns:a16="http://schemas.microsoft.com/office/drawing/2014/main" id="{C6C597C2-9F7C-49BD-BA9F-6BBEE96104F2}"/>
+                <a16:creationId xmlns:a16="http://schemas.microsoft.com/office/drawing/2014/main" id="{25AE4F3F-FECF-46FC-8755-D4BCD69C78AA}"/>
               </a:ext>
             </a:extLst>
           </p:cNvPr>
@@ -8777,7 +8777,7 @@
     </p:spTree>
     <p:extLst>
       <p:ext uri="{BB962C8B-B14F-4D97-AF65-F5344CB8AC3E}">
-        <p14:creationId xmlns:p14="http://schemas.microsoft.com/office/powerpoint/2010/main" val="904808368"/>
+        <p14:creationId xmlns:p14="http://schemas.microsoft.com/office/powerpoint/2010/main" val="1591664322"/>
       </p:ext>
     </p:extLst>
   </p:cSld>
@@ -8808,7 +8808,7 @@
           <p:cNvPr id="1" name="kicker-7">
             <a:extLst xmlns:a="http://schemas.openxmlformats.org/drawingml/2006/main">
               <a:ext uri="{FF2B5EF4-FFF2-40B4-BE49-F238E27FC236}">
-                <a16:creationId xmlns:a16="http://schemas.microsoft.com/office/drawing/2014/main" id="{09CDB642-97E2-4CFE-8246-7195E15D5201}"/>
+                <a16:creationId xmlns:a16="http://schemas.microsoft.com/office/drawing/2014/main" id="{59C52C0C-6C7D-4B33-A875-C2029460BBB4}"/>
               </a:ext>
             </a:extLst>
           </p:cNvPr>
@@ -8853,7 +8853,7 @@
           <p:cNvPr id="2" name="title-7">
             <a:extLst xmlns:a="http://schemas.openxmlformats.org/drawingml/2006/main">
               <a:ext uri="{FF2B5EF4-FFF2-40B4-BE49-F238E27FC236}">
-                <a16:creationId xmlns:a16="http://schemas.microsoft.com/office/drawing/2014/main" id="{68A35B2E-FAA6-42EC-9167-2C58603FCD9D}"/>
+                <a16:creationId xmlns:a16="http://schemas.microsoft.com/office/drawing/2014/main" id="{7CF43219-F13B-4BEA-889E-E9D1A8EAD604}"/>
               </a:ext>
             </a:extLst>
           </p:cNvPr>
@@ -8920,7 +8920,7 @@
           <p:cNvPr id="4" name="number-7">
             <a:extLst xmlns:a="http://schemas.openxmlformats.org/drawingml/2006/main">
               <a:ext uri="{FF2B5EF4-FFF2-40B4-BE49-F238E27FC236}">
-                <a16:creationId xmlns:a16="http://schemas.microsoft.com/office/drawing/2014/main" id="{2664DB54-6D45-4D5C-BF23-36D79EA26901}"/>
+                <a16:creationId xmlns:a16="http://schemas.microsoft.com/office/drawing/2014/main" id="{ACFD9E87-4919-47EF-91A0-BC549F6DA93C}"/>
               </a:ext>
             </a:extLst>
           </p:cNvPr>
@@ -8987,7 +8987,7 @@
           <p:cNvPr id="6" name="lab-bulb-0">
             <a:extLst xmlns:a="http://schemas.openxmlformats.org/drawingml/2006/main">
               <a:ext uri="{FF2B5EF4-FFF2-40B4-BE49-F238E27FC236}">
-                <a16:creationId xmlns:a16="http://schemas.microsoft.com/office/drawing/2014/main" id="{2411ABBE-DBF3-4357-B36C-FE881A5FF01C}"/>
+                <a16:creationId xmlns:a16="http://schemas.microsoft.com/office/drawing/2014/main" id="{0D78DA5B-EA89-48B5-AF90-F14C61D7ECFD}"/>
               </a:ext>
             </a:extLst>
           </p:cNvPr>
@@ -9018,7 +9018,7 @@
           <p:cNvPr id="7" name="lab-flag-0">
             <a:extLst xmlns:a="http://schemas.openxmlformats.org/drawingml/2006/main">
               <a:ext uri="{FF2B5EF4-FFF2-40B4-BE49-F238E27FC236}">
-                <a16:creationId xmlns:a16="http://schemas.microsoft.com/office/drawing/2014/main" id="{57AEBF9B-6014-48E8-90E3-9E3D6027A570}"/>
+                <a16:creationId xmlns:a16="http://schemas.microsoft.com/office/drawing/2014/main" id="{1B7B0DDC-D2BB-4450-9FAB-D4AEF7F1B939}"/>
               </a:ext>
             </a:extLst>
           </p:cNvPr>
@@ -9053,7 +9053,7 @@
           <p:cNvPr id="8" name="lab-icon-0">
             <a:extLst xmlns:a="http://schemas.openxmlformats.org/drawingml/2006/main">
               <a:ext uri="{FF2B5EF4-FFF2-40B4-BE49-F238E27FC236}">
-                <a16:creationId xmlns:a16="http://schemas.microsoft.com/office/drawing/2014/main" id="{1A6610FD-58F4-4B29-854F-E8C5487CD886}"/>
+                <a16:creationId xmlns:a16="http://schemas.microsoft.com/office/drawing/2014/main" id="{985FD027-1646-4EDA-9760-530678E997D9}"/>
               </a:ext>
             </a:extLst>
           </p:cNvPr>
@@ -9098,7 +9098,7 @@
           <p:cNvPr id="9" name="lab-heading-0">
             <a:extLst xmlns:a="http://schemas.openxmlformats.org/drawingml/2006/main">
               <a:ext uri="{FF2B5EF4-FFF2-40B4-BE49-F238E27FC236}">
-                <a16:creationId xmlns:a16="http://schemas.microsoft.com/office/drawing/2014/main" id="{D97DE98B-0A19-4C57-803C-D0CC2C6CC966}"/>
+                <a16:creationId xmlns:a16="http://schemas.microsoft.com/office/drawing/2014/main" id="{E1BDD100-2FDC-41DF-9D2C-CFBBA54E5133}"/>
               </a:ext>
             </a:extLst>
           </p:cNvPr>
@@ -9143,7 +9143,7 @@
           <p:cNvPr id="10" name="lab-failure-0">
             <a:extLst xmlns:a="http://schemas.openxmlformats.org/drawingml/2006/main">
               <a:ext uri="{FF2B5EF4-FFF2-40B4-BE49-F238E27FC236}">
-                <a16:creationId xmlns:a16="http://schemas.microsoft.com/office/drawing/2014/main" id="{31B212D9-60AD-46E2-B9E7-BA954C2D70F6}"/>
+                <a16:creationId xmlns:a16="http://schemas.microsoft.com/office/drawing/2014/main" id="{78759DFD-0B99-4841-B1B5-E59ED989F009}"/>
               </a:ext>
             </a:extLst>
           </p:cNvPr>
@@ -9188,7 +9188,7 @@
           <p:cNvPr id="11" name="lab-stop-0">
             <a:extLst xmlns:a="http://schemas.openxmlformats.org/drawingml/2006/main">
               <a:ext uri="{FF2B5EF4-FFF2-40B4-BE49-F238E27FC236}">
-                <a16:creationId xmlns:a16="http://schemas.microsoft.com/office/drawing/2014/main" id="{BA8300C0-2512-4BAB-8F07-C864761AEDA7}"/>
+                <a16:creationId xmlns:a16="http://schemas.microsoft.com/office/drawing/2014/main" id="{D454E353-8ED8-4CE5-B2FB-46EAFE2B0E10}"/>
               </a:ext>
             </a:extLst>
           </p:cNvPr>
@@ -9255,7 +9255,7 @@
           <p:cNvPr id="13" name="lab-bulb-1">
             <a:extLst xmlns:a="http://schemas.openxmlformats.org/drawingml/2006/main">
               <a:ext uri="{FF2B5EF4-FFF2-40B4-BE49-F238E27FC236}">
-                <a16:creationId xmlns:a16="http://schemas.microsoft.com/office/drawing/2014/main" id="{85031734-8AFE-4883-9AFD-33DE566D7E3C}"/>
+                <a16:creationId xmlns:a16="http://schemas.microsoft.com/office/drawing/2014/main" id="{01131EDA-9207-41F5-AFAB-8939A9DA7202}"/>
               </a:ext>
             </a:extLst>
           </p:cNvPr>
@@ -9286,7 +9286,7 @@
           <p:cNvPr id="14" name="lab-flag-1">
             <a:extLst xmlns:a="http://schemas.openxmlformats.org/drawingml/2006/main">
               <a:ext uri="{FF2B5EF4-FFF2-40B4-BE49-F238E27FC236}">
-                <a16:creationId xmlns:a16="http://schemas.microsoft.com/office/drawing/2014/main" id="{BC8A423A-1535-4134-AF92-4E2BB26C930D}"/>
+                <a16:creationId xmlns:a16="http://schemas.microsoft.com/office/drawing/2014/main" id="{B8799F0E-FC21-40B0-87F3-E59A3B5E4C71}"/>
               </a:ext>
             </a:extLst>
           </p:cNvPr>
@@ -9321,7 +9321,7 @@
           <p:cNvPr id="15" name="lab-icon-1">
             <a:extLst xmlns:a="http://schemas.openxmlformats.org/drawingml/2006/main">
               <a:ext uri="{FF2B5EF4-FFF2-40B4-BE49-F238E27FC236}">
-                <a16:creationId xmlns:a16="http://schemas.microsoft.com/office/drawing/2014/main" id="{8DD01D1F-A41F-4F35-B089-0D0BAA41BACC}"/>
+                <a16:creationId xmlns:a16="http://schemas.microsoft.com/office/drawing/2014/main" id="{5ACDC4E9-E3E2-4CA8-A66A-E942DC05F9C0}"/>
               </a:ext>
             </a:extLst>
           </p:cNvPr>
@@ -9366,7 +9366,7 @@
           <p:cNvPr id="16" name="lab-heading-1">
             <a:extLst xmlns:a="http://schemas.openxmlformats.org/drawingml/2006/main">
               <a:ext uri="{FF2B5EF4-FFF2-40B4-BE49-F238E27FC236}">
-                <a16:creationId xmlns:a16="http://schemas.microsoft.com/office/drawing/2014/main" id="{41CEE8E3-3180-4FA1-BD4B-9F645FA19D64}"/>
+                <a16:creationId xmlns:a16="http://schemas.microsoft.com/office/drawing/2014/main" id="{8B449F39-1544-4589-AFE2-E33EB3D1CE6C}"/>
               </a:ext>
             </a:extLst>
           </p:cNvPr>
@@ -9411,7 +9411,7 @@
           <p:cNvPr id="17" name="lab-failure-1">
             <a:extLst xmlns:a="http://schemas.openxmlformats.org/drawingml/2006/main">
               <a:ext uri="{FF2B5EF4-FFF2-40B4-BE49-F238E27FC236}">
-                <a16:creationId xmlns:a16="http://schemas.microsoft.com/office/drawing/2014/main" id="{A690F62A-51E2-4808-9CEA-4E86BB117C7A}"/>
+                <a16:creationId xmlns:a16="http://schemas.microsoft.com/office/drawing/2014/main" id="{008C46D1-C509-4CB1-ADF7-15815B6ACF62}"/>
               </a:ext>
             </a:extLst>
           </p:cNvPr>
@@ -9456,7 +9456,7 @@
           <p:cNvPr id="18" name="lab-stop-1">
             <a:extLst xmlns:a="http://schemas.openxmlformats.org/drawingml/2006/main">
               <a:ext uri="{FF2B5EF4-FFF2-40B4-BE49-F238E27FC236}">
-                <a16:creationId xmlns:a16="http://schemas.microsoft.com/office/drawing/2014/main" id="{465E1A24-A5E9-4B93-BF0F-8F17E4465135}"/>
+                <a16:creationId xmlns:a16="http://schemas.microsoft.com/office/drawing/2014/main" id="{8F08FC97-039E-4676-9115-883960AF3E20}"/>
               </a:ext>
             </a:extLst>
           </p:cNvPr>
@@ -9523,7 +9523,7 @@
           <p:cNvPr id="20" name="lab-bulb-2">
             <a:extLst xmlns:a="http://schemas.openxmlformats.org/drawingml/2006/main">
               <a:ext uri="{FF2B5EF4-FFF2-40B4-BE49-F238E27FC236}">
-                <a16:creationId xmlns:a16="http://schemas.microsoft.com/office/drawing/2014/main" id="{B5513251-7AF6-486C-BE88-D88FB44E0632}"/>
+                <a16:creationId xmlns:a16="http://schemas.microsoft.com/office/drawing/2014/main" id="{B19A20FE-5E64-46E9-82D7-9DC71EFE3F33}"/>
               </a:ext>
             </a:extLst>
           </p:cNvPr>
@@ -9554,7 +9554,7 @@
           <p:cNvPr id="21" name="lab-flag-2">
             <a:extLst xmlns:a="http://schemas.openxmlformats.org/drawingml/2006/main">
               <a:ext uri="{FF2B5EF4-FFF2-40B4-BE49-F238E27FC236}">
-                <a16:creationId xmlns:a16="http://schemas.microsoft.com/office/drawing/2014/main" id="{CEEFFC62-A1BC-47D6-AE83-5B307CDCCA87}"/>
+                <a16:creationId xmlns:a16="http://schemas.microsoft.com/office/drawing/2014/main" id="{230D16AA-E065-482F-A820-82B01D95F9DF}"/>
               </a:ext>
             </a:extLst>
           </p:cNvPr>
@@ -9589,7 +9589,7 @@
           <p:cNvPr id="22" name="lab-icon-2">
             <a:extLst xmlns:a="http://schemas.openxmlformats.org/drawingml/2006/main">
               <a:ext uri="{FF2B5EF4-FFF2-40B4-BE49-F238E27FC236}">
-                <a16:creationId xmlns:a16="http://schemas.microsoft.com/office/drawing/2014/main" id="{D632D152-88E8-4693-8E58-D354A64495AA}"/>
+                <a16:creationId xmlns:a16="http://schemas.microsoft.com/office/drawing/2014/main" id="{26063D89-E02D-43C3-A268-E00992A1CF9B}"/>
               </a:ext>
             </a:extLst>
           </p:cNvPr>
@@ -9634,7 +9634,7 @@
           <p:cNvPr id="23" name="lab-heading-2">
             <a:extLst xmlns:a="http://schemas.openxmlformats.org/drawingml/2006/main">
               <a:ext uri="{FF2B5EF4-FFF2-40B4-BE49-F238E27FC236}">
-                <a16:creationId xmlns:a16="http://schemas.microsoft.com/office/drawing/2014/main" id="{F56A76B6-461B-4BF4-AE34-24106673F180}"/>
+                <a16:creationId xmlns:a16="http://schemas.microsoft.com/office/drawing/2014/main" id="{31250A48-BC05-4F4C-95F9-597C5FFCF8C0}"/>
               </a:ext>
             </a:extLst>
           </p:cNvPr>
@@ -9679,7 +9679,7 @@
           <p:cNvPr id="24" name="lab-failure-2">
             <a:extLst xmlns:a="http://schemas.openxmlformats.org/drawingml/2006/main">
               <a:ext uri="{FF2B5EF4-FFF2-40B4-BE49-F238E27FC236}">
-                <a16:creationId xmlns:a16="http://schemas.microsoft.com/office/drawing/2014/main" id="{09DC6094-80D6-43A1-873D-C93971E9B3DA}"/>
+                <a16:creationId xmlns:a16="http://schemas.microsoft.com/office/drawing/2014/main" id="{21D60362-C771-432B-A061-1C723E99D9A6}"/>
               </a:ext>
             </a:extLst>
           </p:cNvPr>
@@ -9724,7 +9724,7 @@
           <p:cNvPr id="25" name="lab-stop-2">
             <a:extLst xmlns:a="http://schemas.openxmlformats.org/drawingml/2006/main">
               <a:ext uri="{FF2B5EF4-FFF2-40B4-BE49-F238E27FC236}">
-                <a16:creationId xmlns:a16="http://schemas.microsoft.com/office/drawing/2014/main" id="{9C7F3928-2F7F-45FA-A85E-D77C255D248C}"/>
+                <a16:creationId xmlns:a16="http://schemas.microsoft.com/office/drawing/2014/main" id="{6F303FAC-7B5E-4C26-B4F3-AEDF23383C2B}"/>
               </a:ext>
             </a:extLst>
           </p:cNvPr>
@@ -9791,7 +9791,7 @@
           <p:cNvPr id="27" name="lab-bulb-3">
             <a:extLst xmlns:a="http://schemas.openxmlformats.org/drawingml/2006/main">
               <a:ext uri="{FF2B5EF4-FFF2-40B4-BE49-F238E27FC236}">
-                <a16:creationId xmlns:a16="http://schemas.microsoft.com/office/drawing/2014/main" id="{3B2E4F49-FD28-498E-AEAD-42CDFA0D1144}"/>
+                <a16:creationId xmlns:a16="http://schemas.microsoft.com/office/drawing/2014/main" id="{510F63FA-3FD9-4BA3-A746-0298B6A797F2}"/>
               </a:ext>
             </a:extLst>
           </p:cNvPr>
@@ -9822,7 +9822,7 @@
           <p:cNvPr id="28" name="lab-flag-3">
             <a:extLst xmlns:a="http://schemas.openxmlformats.org/drawingml/2006/main">
               <a:ext uri="{FF2B5EF4-FFF2-40B4-BE49-F238E27FC236}">
-                <a16:creationId xmlns:a16="http://schemas.microsoft.com/office/drawing/2014/main" id="{779C9628-8022-4758-94F4-7918584CF5BC}"/>
+                <a16:creationId xmlns:a16="http://schemas.microsoft.com/office/drawing/2014/main" id="{3B7CDE67-DD62-4510-9785-FBB6D2C27FBF}"/>
               </a:ext>
             </a:extLst>
           </p:cNvPr>
@@ -9857,7 +9857,7 @@
           <p:cNvPr id="29" name="lab-icon-3">
             <a:extLst xmlns:a="http://schemas.openxmlformats.org/drawingml/2006/main">
               <a:ext uri="{FF2B5EF4-FFF2-40B4-BE49-F238E27FC236}">
-                <a16:creationId xmlns:a16="http://schemas.microsoft.com/office/drawing/2014/main" id="{79D9517E-3437-4C6D-B80D-9B73BC883D2A}"/>
+                <a16:creationId xmlns:a16="http://schemas.microsoft.com/office/drawing/2014/main" id="{19BB644A-3F63-4DE9-8522-18DA920A7EB8}"/>
               </a:ext>
             </a:extLst>
           </p:cNvPr>
@@ -9902,7 +9902,7 @@
           <p:cNvPr id="30" name="lab-heading-3">
             <a:extLst xmlns:a="http://schemas.openxmlformats.org/drawingml/2006/main">
               <a:ext uri="{FF2B5EF4-FFF2-40B4-BE49-F238E27FC236}">
-                <a16:creationId xmlns:a16="http://schemas.microsoft.com/office/drawing/2014/main" id="{44B4D6A6-67E5-4E35-AAE4-948063088E21}"/>
+                <a16:creationId xmlns:a16="http://schemas.microsoft.com/office/drawing/2014/main" id="{319AC80F-BCCC-48B8-96A8-8F15B5C79A44}"/>
               </a:ext>
             </a:extLst>
           </p:cNvPr>
@@ -9947,7 +9947,7 @@
           <p:cNvPr id="31" name="lab-failure-3">
             <a:extLst xmlns:a="http://schemas.openxmlformats.org/drawingml/2006/main">
               <a:ext uri="{FF2B5EF4-FFF2-40B4-BE49-F238E27FC236}">
-                <a16:creationId xmlns:a16="http://schemas.microsoft.com/office/drawing/2014/main" id="{BA378E5D-4BA4-4E8B-B823-108CDB6E4359}"/>
+                <a16:creationId xmlns:a16="http://schemas.microsoft.com/office/drawing/2014/main" id="{DD5AA037-C81B-4AF6-B558-264DD1F847D9}"/>
               </a:ext>
             </a:extLst>
           </p:cNvPr>
@@ -9992,7 +9992,7 @@
           <p:cNvPr id="32" name="lab-stop-3">
             <a:extLst xmlns:a="http://schemas.openxmlformats.org/drawingml/2006/main">
               <a:ext uri="{FF2B5EF4-FFF2-40B4-BE49-F238E27FC236}">
-                <a16:creationId xmlns:a16="http://schemas.microsoft.com/office/drawing/2014/main" id="{1F94556B-7347-4007-9DA1-645E09F43553}"/>
+                <a16:creationId xmlns:a16="http://schemas.microsoft.com/office/drawing/2014/main" id="{35D9C2A3-D427-4FD3-A84C-858BA78CF8E5}"/>
               </a:ext>
             </a:extLst>
           </p:cNvPr>
@@ -10037,7 +10037,7 @@
           <p:cNvPr id="33" name="lab-command">
             <a:extLst xmlns:a="http://schemas.openxmlformats.org/drawingml/2006/main">
               <a:ext uri="{FF2B5EF4-FFF2-40B4-BE49-F238E27FC236}">
-                <a16:creationId xmlns:a16="http://schemas.microsoft.com/office/drawing/2014/main" id="{85E7061D-A202-465C-A484-19B26D0DBA65}"/>
+                <a16:creationId xmlns:a16="http://schemas.microsoft.com/office/drawing/2014/main" id="{350410C3-997A-4C38-98EF-766CFD4CF080}"/>
               </a:ext>
             </a:extLst>
           </p:cNvPr>
@@ -10070,7 +10070,7 @@
           <p:cNvPr id="34" name="lab-command-text">
             <a:extLst xmlns:a="http://schemas.openxmlformats.org/drawingml/2006/main">
               <a:ext uri="{FF2B5EF4-FFF2-40B4-BE49-F238E27FC236}">
-                <a16:creationId xmlns:a16="http://schemas.microsoft.com/office/drawing/2014/main" id="{7755AF30-4C7C-4022-9F53-F607D413F7A7}"/>
+                <a16:creationId xmlns:a16="http://schemas.microsoft.com/office/drawing/2014/main" id="{F20E06F6-1C0B-4F3C-BD11-14273B3E2D0E}"/>
               </a:ext>
             </a:extLst>
           </p:cNvPr>
@@ -10115,7 +10115,7 @@
           <p:cNvPr id="35" name="lab-note">
             <a:extLst xmlns:a="http://schemas.openxmlformats.org/drawingml/2006/main">
               <a:ext uri="{FF2B5EF4-FFF2-40B4-BE49-F238E27FC236}">
-                <a16:creationId xmlns:a16="http://schemas.microsoft.com/office/drawing/2014/main" id="{087FF9AC-262D-4C46-862D-99AA15BDAC10}"/>
+                <a16:creationId xmlns:a16="http://schemas.microsoft.com/office/drawing/2014/main" id="{14993DA4-7C73-481B-AF82-DA8B15B40E8C}"/>
               </a:ext>
             </a:extLst>
           </p:cNvPr>
@@ -10158,7 +10158,7 @@
     </p:spTree>
     <p:extLst>
       <p:ext uri="{BB962C8B-B14F-4D97-AF65-F5344CB8AC3E}">
-        <p14:creationId xmlns:p14="http://schemas.microsoft.com/office/powerpoint/2010/main" val="518252057"/>
+        <p14:creationId xmlns:p14="http://schemas.microsoft.com/office/powerpoint/2010/main" val="1171574678"/>
       </p:ext>
     </p:extLst>
   </p:cSld>
@@ -10189,7 +10189,7 @@
           <p:cNvPr id="1" name="kicker-8">
             <a:extLst xmlns:a="http://schemas.openxmlformats.org/drawingml/2006/main">
               <a:ext uri="{FF2B5EF4-FFF2-40B4-BE49-F238E27FC236}">
-                <a16:creationId xmlns:a16="http://schemas.microsoft.com/office/drawing/2014/main" id="{F5C22F35-9933-4A5C-939A-12828C2409AB}"/>
+                <a16:creationId xmlns:a16="http://schemas.microsoft.com/office/drawing/2014/main" id="{81A69624-142B-46E8-B9F8-2B4048979D67}"/>
               </a:ext>
             </a:extLst>
           </p:cNvPr>
@@ -10234,7 +10234,7 @@
           <p:cNvPr id="2" name="title-8">
             <a:extLst xmlns:a="http://schemas.openxmlformats.org/drawingml/2006/main">
               <a:ext uri="{FF2B5EF4-FFF2-40B4-BE49-F238E27FC236}">
-                <a16:creationId xmlns:a16="http://schemas.microsoft.com/office/drawing/2014/main" id="{63EF820B-3124-42B1-A46A-378EC0816EC5}"/>
+                <a16:creationId xmlns:a16="http://schemas.microsoft.com/office/drawing/2014/main" id="{413E0D17-9777-45EF-BB1B-9D94DC4FCB1D}"/>
               </a:ext>
             </a:extLst>
           </p:cNvPr>
@@ -10301,7 +10301,7 @@
           <p:cNvPr id="4" name="number-8">
             <a:extLst xmlns:a="http://schemas.openxmlformats.org/drawingml/2006/main">
               <a:ext uri="{FF2B5EF4-FFF2-40B4-BE49-F238E27FC236}">
-                <a16:creationId xmlns:a16="http://schemas.microsoft.com/office/drawing/2014/main" id="{68EAA4A3-450E-4DEB-B5E4-8C9CB4573FFD}"/>
+                <a16:creationId xmlns:a16="http://schemas.microsoft.com/office/drawing/2014/main" id="{1B805A42-4285-49B4-B2FD-221520E3D086}"/>
               </a:ext>
             </a:extLst>
           </p:cNvPr>
@@ -10500,7 +10500,7 @@
           <p:cNvPr id="12" name="prod-local-dot">
             <a:extLst xmlns:a="http://schemas.openxmlformats.org/drawingml/2006/main">
               <a:ext uri="{FF2B5EF4-FFF2-40B4-BE49-F238E27FC236}">
-                <a16:creationId xmlns:a16="http://schemas.microsoft.com/office/drawing/2014/main" id="{21D622BE-E0C9-416D-A55F-A0F5A9F965D9}"/>
+                <a16:creationId xmlns:a16="http://schemas.microsoft.com/office/drawing/2014/main" id="{E2E44350-7929-4C4D-8087-8E869D201745}"/>
               </a:ext>
             </a:extLst>
           </p:cNvPr>
@@ -10531,7 +10531,7 @@
           <p:cNvPr id="13" name="prod-ci-dot">
             <a:extLst xmlns:a="http://schemas.openxmlformats.org/drawingml/2006/main">
               <a:ext uri="{FF2B5EF4-FFF2-40B4-BE49-F238E27FC236}">
-                <a16:creationId xmlns:a16="http://schemas.microsoft.com/office/drawing/2014/main" id="{FF968E55-914A-467F-99CF-08FD8E94D389}"/>
+                <a16:creationId xmlns:a16="http://schemas.microsoft.com/office/drawing/2014/main" id="{FEB87E54-C0C0-4112-8E66-AA8B3C2E28A5}"/>
               </a:ext>
             </a:extLst>
           </p:cNvPr>
@@ -10562,7 +10562,7 @@
           <p:cNvPr id="14" name="prod-scale-dot">
             <a:extLst xmlns:a="http://schemas.openxmlformats.org/drawingml/2006/main">
               <a:ext uri="{FF2B5EF4-FFF2-40B4-BE49-F238E27FC236}">
-                <a16:creationId xmlns:a16="http://schemas.microsoft.com/office/drawing/2014/main" id="{62D84512-8A2E-4C5B-BAE0-28FBE8E8541E}"/>
+                <a16:creationId xmlns:a16="http://schemas.microsoft.com/office/drawing/2014/main" id="{D7432D9D-2392-4C64-8F38-753B95E9507E}"/>
               </a:ext>
             </a:extLst>
           </p:cNvPr>
@@ -10593,7 +10593,7 @@
           <p:cNvPr id="15" name="prod-enterprise-dot">
             <a:extLst xmlns:a="http://schemas.openxmlformats.org/drawingml/2006/main">
               <a:ext uri="{FF2B5EF4-FFF2-40B4-BE49-F238E27FC236}">
-                <a16:creationId xmlns:a16="http://schemas.microsoft.com/office/drawing/2014/main" id="{F18AF40D-7E58-4A9B-B49F-5FD2F9B55B85}"/>
+                <a16:creationId xmlns:a16="http://schemas.microsoft.com/office/drawing/2014/main" id="{150A7CD1-CCA8-4E11-83FF-DFAAFEA6A1FF}"/>
               </a:ext>
             </a:extLst>
           </p:cNvPr>
@@ -10624,7 +10624,7 @@
           <p:cNvPr id="16" name="prod-local-title">
             <a:extLst xmlns:a="http://schemas.openxmlformats.org/drawingml/2006/main">
               <a:ext uri="{FF2B5EF4-FFF2-40B4-BE49-F238E27FC236}">
-                <a16:creationId xmlns:a16="http://schemas.microsoft.com/office/drawing/2014/main" id="{EB4BEC01-83C6-43B5-9122-32B219FC819F}"/>
+                <a16:creationId xmlns:a16="http://schemas.microsoft.com/office/drawing/2014/main" id="{78489327-1ABF-4FD9-B67B-B6C8C19730B6}"/>
               </a:ext>
             </a:extLst>
           </p:cNvPr>
@@ -10669,7 +10669,7 @@
           <p:cNvPr id="17" name="prod-local-body">
             <a:extLst xmlns:a="http://schemas.openxmlformats.org/drawingml/2006/main">
               <a:ext uri="{FF2B5EF4-FFF2-40B4-BE49-F238E27FC236}">
-                <a16:creationId xmlns:a16="http://schemas.microsoft.com/office/drawing/2014/main" id="{F2C738DF-26D1-4F04-9788-DC84FE1B0F15}"/>
+                <a16:creationId xmlns:a16="http://schemas.microsoft.com/office/drawing/2014/main" id="{17A1CEEF-3621-4AF8-A835-CE578456B522}"/>
               </a:ext>
             </a:extLst>
           </p:cNvPr>
@@ -10716,7 +10716,7 @@
           <p:cNvPr id="18" name="prod-ci-title">
             <a:extLst xmlns:a="http://schemas.openxmlformats.org/drawingml/2006/main">
               <a:ext uri="{FF2B5EF4-FFF2-40B4-BE49-F238E27FC236}">
-                <a16:creationId xmlns:a16="http://schemas.microsoft.com/office/drawing/2014/main" id="{6A1FBB77-A85C-47AB-9EDA-FEC0E4E45BEE}"/>
+                <a16:creationId xmlns:a16="http://schemas.microsoft.com/office/drawing/2014/main" id="{CD5011E5-2685-45B0-869A-2E2782ADC366}"/>
               </a:ext>
             </a:extLst>
           </p:cNvPr>
@@ -10761,7 +10761,7 @@
           <p:cNvPr id="19" name="prod-ci-body">
             <a:extLst xmlns:a="http://schemas.openxmlformats.org/drawingml/2006/main">
               <a:ext uri="{FF2B5EF4-FFF2-40B4-BE49-F238E27FC236}">
-                <a16:creationId xmlns:a16="http://schemas.microsoft.com/office/drawing/2014/main" id="{6AF17FE8-AE3D-47C6-A3E3-73B9A72064DE}"/>
+                <a16:creationId xmlns:a16="http://schemas.microsoft.com/office/drawing/2014/main" id="{E48208B1-064F-4350-A150-951D16AE64BC}"/>
               </a:ext>
             </a:extLst>
           </p:cNvPr>
@@ -10808,7 +10808,7 @@
           <p:cNvPr id="20" name="prod-scale-title">
             <a:extLst xmlns:a="http://schemas.openxmlformats.org/drawingml/2006/main">
               <a:ext uri="{FF2B5EF4-FFF2-40B4-BE49-F238E27FC236}">
-                <a16:creationId xmlns:a16="http://schemas.microsoft.com/office/drawing/2014/main" id="{BCE32D1F-7AD4-4BCA-B456-0208FFEB2A0E}"/>
+                <a16:creationId xmlns:a16="http://schemas.microsoft.com/office/drawing/2014/main" id="{9A76AAC5-26B8-479D-B8D6-280D028DFE92}"/>
               </a:ext>
             </a:extLst>
           </p:cNvPr>
@@ -10853,7 +10853,7 @@
           <p:cNvPr id="21" name="prod-scale-body">
             <a:extLst xmlns:a="http://schemas.openxmlformats.org/drawingml/2006/main">
               <a:ext uri="{FF2B5EF4-FFF2-40B4-BE49-F238E27FC236}">
-                <a16:creationId xmlns:a16="http://schemas.microsoft.com/office/drawing/2014/main" id="{44497F6A-11B6-45F7-9E06-9886723FBCF9}"/>
+                <a16:creationId xmlns:a16="http://schemas.microsoft.com/office/drawing/2014/main" id="{5B18DC44-F624-4B1C-A4A1-D288817DDC0A}"/>
               </a:ext>
             </a:extLst>
           </p:cNvPr>
@@ -10900,7 +10900,7 @@
           <p:cNvPr id="22" name="prod-enterprise-title">
             <a:extLst xmlns:a="http://schemas.openxmlformats.org/drawingml/2006/main">
               <a:ext uri="{FF2B5EF4-FFF2-40B4-BE49-F238E27FC236}">
-                <a16:creationId xmlns:a16="http://schemas.microsoft.com/office/drawing/2014/main" id="{EDB9EDBE-877C-46AE-8996-CD6F34E029A1}"/>
+                <a16:creationId xmlns:a16="http://schemas.microsoft.com/office/drawing/2014/main" id="{775FEC3B-544C-4EF5-AEA9-F43A89FE41F3}"/>
               </a:ext>
             </a:extLst>
           </p:cNvPr>
@@ -10945,7 +10945,7 @@
           <p:cNvPr id="23" name="prod-enterprise-body">
             <a:extLst xmlns:a="http://schemas.openxmlformats.org/drawingml/2006/main">
               <a:ext uri="{FF2B5EF4-FFF2-40B4-BE49-F238E27FC236}">
-                <a16:creationId xmlns:a16="http://schemas.microsoft.com/office/drawing/2014/main" id="{B53F5AF0-AE2B-4580-9FB2-8F48E6C766AA}"/>
+                <a16:creationId xmlns:a16="http://schemas.microsoft.com/office/drawing/2014/main" id="{8BCB3467-577E-4353-8185-F41ABDEC0DBA}"/>
               </a:ext>
             </a:extLst>
           </p:cNvPr>
@@ -10993,7 +10993,7 @@
           <p:cNvPr id="24" name="prod-signal">
             <a:extLst xmlns:a="http://schemas.openxmlformats.org/drawingml/2006/main">
               <a:ext uri="{FF2B5EF4-FFF2-40B4-BE49-F238E27FC236}">
-                <a16:creationId xmlns:a16="http://schemas.microsoft.com/office/drawing/2014/main" id="{A994A405-CE39-44D3-84C9-29F7AF1836E9}"/>
+                <a16:creationId xmlns:a16="http://schemas.microsoft.com/office/drawing/2014/main" id="{FF60A89A-5E6F-4378-B7A5-B9C6C9F95E1F}"/>
               </a:ext>
             </a:extLst>
           </p:cNvPr>
@@ -11036,7 +11036,7 @@
     </p:spTree>
     <p:extLst>
       <p:ext uri="{BB962C8B-B14F-4D97-AF65-F5344CB8AC3E}">
-        <p14:creationId xmlns:p14="http://schemas.microsoft.com/office/powerpoint/2010/main" val="469346657"/>
+        <p14:creationId xmlns:p14="http://schemas.microsoft.com/office/powerpoint/2010/main" val="510418698"/>
       </p:ext>
     </p:extLst>
   </p:cSld>
@@ -11067,7 +11067,7 @@
           <p:cNvPr id="1" name="kicker-9">
             <a:extLst xmlns:a="http://schemas.openxmlformats.org/drawingml/2006/main">
               <a:ext uri="{FF2B5EF4-FFF2-40B4-BE49-F238E27FC236}">
-                <a16:creationId xmlns:a16="http://schemas.microsoft.com/office/drawing/2014/main" id="{9A78AA41-08B6-4F1A-8205-D6C9247D148B}"/>
+                <a16:creationId xmlns:a16="http://schemas.microsoft.com/office/drawing/2014/main" id="{18E6AFFA-9379-4102-A0E6-38C1CED51F74}"/>
               </a:ext>
             </a:extLst>
           </p:cNvPr>
@@ -11112,7 +11112,7 @@
           <p:cNvPr id="2" name="title-9">
             <a:extLst xmlns:a="http://schemas.openxmlformats.org/drawingml/2006/main">
               <a:ext uri="{FF2B5EF4-FFF2-40B4-BE49-F238E27FC236}">
-                <a16:creationId xmlns:a16="http://schemas.microsoft.com/office/drawing/2014/main" id="{A2B441AE-5538-4E8F-AC02-F6C5D6C4F17E}"/>
+                <a16:creationId xmlns:a16="http://schemas.microsoft.com/office/drawing/2014/main" id="{D0DA257B-F5DA-4702-B019-633A7F911E54}"/>
               </a:ext>
             </a:extLst>
           </p:cNvPr>
@@ -11179,7 +11179,7 @@
           <p:cNvPr id="4" name="number-9">
             <a:extLst xmlns:a="http://schemas.openxmlformats.org/drawingml/2006/main">
               <a:ext uri="{FF2B5EF4-FFF2-40B4-BE49-F238E27FC236}">
-                <a16:creationId xmlns:a16="http://schemas.microsoft.com/office/drawing/2014/main" id="{4372260C-FBCE-4F6E-A56B-F2AEFC25CF93}"/>
+                <a16:creationId xmlns:a16="http://schemas.microsoft.com/office/drawing/2014/main" id="{5798878F-D9F5-4B47-9A2F-3E96B6A3E8A1}"/>
               </a:ext>
             </a:extLst>
           </p:cNvPr>
@@ -11246,7 +11246,7 @@
           <p:cNvPr id="6" name="trade-fulcrum">
             <a:extLst xmlns:a="http://schemas.openxmlformats.org/drawingml/2006/main">
               <a:ext uri="{FF2B5EF4-FFF2-40B4-BE49-F238E27FC236}">
-                <a16:creationId xmlns:a16="http://schemas.microsoft.com/office/drawing/2014/main" id="{142EB844-9FD3-4AC9-8E4D-489E5AC5EBEE}"/>
+                <a16:creationId xmlns:a16="http://schemas.microsoft.com/office/drawing/2014/main" id="{F1B54760-455C-4E95-8619-4E26E953270E}"/>
               </a:ext>
             </a:extLst>
           </p:cNvPr>
@@ -11277,7 +11277,7 @@
           <p:cNvPr id="7" name="trade-left-pan">
             <a:extLst xmlns:a="http://schemas.openxmlformats.org/drawingml/2006/main">
               <a:ext uri="{FF2B5EF4-FFF2-40B4-BE49-F238E27FC236}">
-                <a16:creationId xmlns:a16="http://schemas.microsoft.com/office/drawing/2014/main" id="{B5F198DE-C8DE-422D-88BA-500B0707167F}"/>
+                <a16:creationId xmlns:a16="http://schemas.microsoft.com/office/drawing/2014/main" id="{62FE0D0E-DB4C-4D2C-BF5A-C341D693F0E4}"/>
               </a:ext>
             </a:extLst>
           </p:cNvPr>
@@ -11312,7 +11312,7 @@
           <p:cNvPr id="8" name="trade-right-pan">
             <a:extLst xmlns:a="http://schemas.openxmlformats.org/drawingml/2006/main">
               <a:ext uri="{FF2B5EF4-FFF2-40B4-BE49-F238E27FC236}">
-                <a16:creationId xmlns:a16="http://schemas.microsoft.com/office/drawing/2014/main" id="{1F111CE5-EE9B-4182-8A2F-32911BCFB31A}"/>
+                <a16:creationId xmlns:a16="http://schemas.microsoft.com/office/drawing/2014/main" id="{12DFCF38-1157-403D-A72B-E36DE67DBFD3}"/>
               </a:ext>
             </a:extLst>
           </p:cNvPr>
@@ -11391,7 +11391,7 @@
           <p:cNvPr id="11" name="trade-left-title">
             <a:extLst xmlns:a="http://schemas.openxmlformats.org/drawingml/2006/main">
               <a:ext uri="{FF2B5EF4-FFF2-40B4-BE49-F238E27FC236}">
-                <a16:creationId xmlns:a16="http://schemas.microsoft.com/office/drawing/2014/main" id="{0F70CB1D-2B55-4872-AEA9-CB088ED62FA1}"/>
+                <a16:creationId xmlns:a16="http://schemas.microsoft.com/office/drawing/2014/main" id="{0881B94D-D7F1-4DFD-8A1D-E83C7869852B}"/>
               </a:ext>
             </a:extLst>
           </p:cNvPr>
@@ -11436,7 +11436,7 @@
           <p:cNvPr id="12" name="trade-left-body">
             <a:extLst xmlns:a="http://schemas.openxmlformats.org/drawingml/2006/main">
               <a:ext uri="{FF2B5EF4-FFF2-40B4-BE49-F238E27FC236}">
-                <a16:creationId xmlns:a16="http://schemas.microsoft.com/office/drawing/2014/main" id="{1561F458-E211-4B5A-AE86-A7CF72D7C333}"/>
+                <a16:creationId xmlns:a16="http://schemas.microsoft.com/office/drawing/2014/main" id="{4EF1D507-6D18-48D4-BE26-3DCE5D895271}"/>
               </a:ext>
             </a:extLst>
           </p:cNvPr>
@@ -11483,7 +11483,7 @@
           <p:cNvPr id="13" name="trade-right-title">
             <a:extLst xmlns:a="http://schemas.openxmlformats.org/drawingml/2006/main">
               <a:ext uri="{FF2B5EF4-FFF2-40B4-BE49-F238E27FC236}">
-                <a16:creationId xmlns:a16="http://schemas.microsoft.com/office/drawing/2014/main" id="{640A4039-23CE-44EE-AB28-4F4396615CE9}"/>
+                <a16:creationId xmlns:a16="http://schemas.microsoft.com/office/drawing/2014/main" id="{C5A919DF-CA74-44C3-86CC-C604DFEA09D0}"/>
               </a:ext>
             </a:extLst>
           </p:cNvPr>
@@ -11528,7 +11528,7 @@
           <p:cNvPr id="14" name="trade-right-body">
             <a:extLst xmlns:a="http://schemas.openxmlformats.org/drawingml/2006/main">
               <a:ext uri="{FF2B5EF4-FFF2-40B4-BE49-F238E27FC236}">
-                <a16:creationId xmlns:a16="http://schemas.microsoft.com/office/drawing/2014/main" id="{F2FB0327-FC50-4809-BA51-8E4F9302EA70}"/>
+                <a16:creationId xmlns:a16="http://schemas.microsoft.com/office/drawing/2014/main" id="{9CF5234A-BD7D-4504-B4DB-387912CD4D2C}"/>
               </a:ext>
             </a:extLst>
           </p:cNvPr>
@@ -11575,7 +11575,7 @@
           <p:cNvPr id="15" name="trade-center">
             <a:extLst xmlns:a="http://schemas.openxmlformats.org/drawingml/2006/main">
               <a:ext uri="{FF2B5EF4-FFF2-40B4-BE49-F238E27FC236}">
-                <a16:creationId xmlns:a16="http://schemas.microsoft.com/office/drawing/2014/main" id="{AD2DF5A0-250B-4F43-A156-3453D975A468}"/>
+                <a16:creationId xmlns:a16="http://schemas.microsoft.com/office/drawing/2014/main" id="{5966E8A1-04CC-400B-BCC9-18E64B2FF167}"/>
               </a:ext>
             </a:extLst>
           </p:cNvPr>
@@ -11620,7 +11620,7 @@
           <p:cNvPr id="16" name="trade-rule">
             <a:extLst xmlns:a="http://schemas.openxmlformats.org/drawingml/2006/main">
               <a:ext uri="{FF2B5EF4-FFF2-40B4-BE49-F238E27FC236}">
-                <a16:creationId xmlns:a16="http://schemas.microsoft.com/office/drawing/2014/main" id="{6BF9F27B-ADF0-4FF6-B825-2C215AB7EDE3}"/>
+                <a16:creationId xmlns:a16="http://schemas.microsoft.com/office/drawing/2014/main" id="{E233CD75-00CF-48B6-8162-9047942E0786}"/>
               </a:ext>
             </a:extLst>
           </p:cNvPr>
@@ -11653,7 +11653,7 @@
           <p:cNvPr id="17" name="trade-rule-text">
             <a:extLst xmlns:a="http://schemas.openxmlformats.org/drawingml/2006/main">
               <a:ext uri="{FF2B5EF4-FFF2-40B4-BE49-F238E27FC236}">
-                <a16:creationId xmlns:a16="http://schemas.microsoft.com/office/drawing/2014/main" id="{3D551A24-FE5D-4BD4-BFC6-F1FDAA02AC9B}"/>
+                <a16:creationId xmlns:a16="http://schemas.microsoft.com/office/drawing/2014/main" id="{605035CC-FD27-48F7-BF30-5F09FC468EF5}"/>
               </a:ext>
             </a:extLst>
           </p:cNvPr>
@@ -11696,7 +11696,7 @@
     </p:spTree>
     <p:extLst>
       <p:ext uri="{BB962C8B-B14F-4D97-AF65-F5344CB8AC3E}">
-        <p14:creationId xmlns:p14="http://schemas.microsoft.com/office/powerpoint/2010/main" val="1865897427"/>
+        <p14:creationId xmlns:p14="http://schemas.microsoft.com/office/powerpoint/2010/main" val="1598033929"/>
       </p:ext>
     </p:extLst>
   </p:cSld>

</xml_diff>